<commit_message>
rebuild Floorplan deck with v4 figures (frameless, tiered fonts, no overflow)
Co-Authored-By: Claude Opus 4.8 <noreply@anthropic.com>
</commit_message>
<xml_diff>
--- a/IC_Backend_Notes/slides/05_Floorplan.pptx
+++ b/IC_Backend_Notes/slides/05_Floorplan.pptx
@@ -4678,8 +4678,8 @@
         </p:blipFill>
         <p:spPr>
           <a:xfrm>
-            <a:off x="5486400" y="1923612"/>
-            <a:ext cx="6263640" cy="4062335"/>
+            <a:off x="5486400" y="2176795"/>
+            <a:ext cx="6263640" cy="3555968"/>
           </a:xfrm>
           <a:prstGeom prst="rect">
             <a:avLst/>
@@ -5077,8 +5077,8 @@
         </p:blipFill>
         <p:spPr>
           <a:xfrm>
-            <a:off x="5486400" y="2220652"/>
-            <a:ext cx="6263640" cy="3468255"/>
+            <a:off x="5486400" y="2341869"/>
+            <a:ext cx="6263640" cy="3225820"/>
           </a:xfrm>
           <a:prstGeom prst="rect">
             <a:avLst/>
@@ -5851,8 +5851,8 @@
         </p:blipFill>
         <p:spPr>
           <a:xfrm>
-            <a:off x="5486400" y="2019284"/>
-            <a:ext cx="6263640" cy="3870991"/>
+            <a:off x="5486400" y="2090778"/>
+            <a:ext cx="6263640" cy="3728003"/>
           </a:xfrm>
           <a:prstGeom prst="rect">
             <a:avLst/>
@@ -7068,8 +7068,8 @@
         </p:blipFill>
         <p:spPr>
           <a:xfrm>
-            <a:off x="5486400" y="2488821"/>
-            <a:ext cx="6263640" cy="2931916"/>
+            <a:off x="5486400" y="2542480"/>
+            <a:ext cx="6263640" cy="2824599"/>
           </a:xfrm>
           <a:prstGeom prst="rect">
             <a:avLst/>
@@ -11265,8 +11265,8 @@
         </p:blipFill>
         <p:spPr>
           <a:xfrm>
-            <a:off x="5486400" y="2584013"/>
-            <a:ext cx="6263640" cy="2741532"/>
+            <a:off x="5486400" y="2631609"/>
+            <a:ext cx="6263640" cy="2646340"/>
           </a:xfrm>
           <a:prstGeom prst="rect">
             <a:avLst/>
@@ -11664,8 +11664,8 @@
         </p:blipFill>
         <p:spPr>
           <a:xfrm>
-            <a:off x="5486400" y="2024435"/>
-            <a:ext cx="6263640" cy="3860689"/>
+            <a:off x="5486400" y="2080142"/>
+            <a:ext cx="6263640" cy="3749274"/>
           </a:xfrm>
           <a:prstGeom prst="rect">
             <a:avLst/>
@@ -12063,8 +12063,8 @@
         </p:blipFill>
         <p:spPr>
           <a:xfrm>
-            <a:off x="5486400" y="1664847"/>
-            <a:ext cx="6263640" cy="4579865"/>
+            <a:off x="5486400" y="2083941"/>
+            <a:ext cx="6263640" cy="3741676"/>
           </a:xfrm>
           <a:prstGeom prst="rect">
             <a:avLst/>
@@ -12462,8 +12462,8 @@
         </p:blipFill>
         <p:spPr>
           <a:xfrm>
-            <a:off x="5486400" y="2215023"/>
-            <a:ext cx="6263640" cy="3479513"/>
+            <a:off x="5486400" y="2313211"/>
+            <a:ext cx="6263640" cy="3283137"/>
           </a:xfrm>
           <a:prstGeom prst="rect">
             <a:avLst/>
@@ -12861,8 +12861,8 @@
         </p:blipFill>
         <p:spPr>
           <a:xfrm>
-            <a:off x="5486400" y="2203245"/>
-            <a:ext cx="6263640" cy="3503069"/>
+            <a:off x="5486400" y="2267357"/>
+            <a:ext cx="6263640" cy="3374845"/>
           </a:xfrm>
           <a:prstGeom prst="rect">
             <a:avLst/>
@@ -13260,8 +13260,8 @@
         </p:blipFill>
         <p:spPr>
           <a:xfrm>
-            <a:off x="5486400" y="1870481"/>
-            <a:ext cx="6263640" cy="4168597"/>
+            <a:off x="5486400" y="2109243"/>
+            <a:ext cx="6263640" cy="3691073"/>
           </a:xfrm>
           <a:prstGeom prst="rect">
             <a:avLst/>
@@ -13659,8 +13659,8 @@
         </p:blipFill>
         <p:spPr>
           <a:xfrm>
-            <a:off x="5486400" y="2031638"/>
-            <a:ext cx="6263640" cy="3846283"/>
+            <a:off x="5486400" y="2110714"/>
+            <a:ext cx="6263640" cy="3688130"/>
           </a:xfrm>
           <a:prstGeom prst="rect">
             <a:avLst/>

</xml_diff>

<commit_message>
figures: card/infographic restyle (f01 chevron-flow, f02/f06/f08 info-cards) per reference standard
Add theme primitives: infocard (pastel card + bold title + colored detail), flowrow (chevron flow w/ highlight), sechead. Rebuild deck if PPTX not locked.

Co-Authored-By: Claude Opus 4.8 <noreply@anthropic.com>
</commit_message>
<xml_diff>
--- a/IC_Backend_Notes/slides/05_Floorplan.pptx
+++ b/IC_Backend_Notes/slides/05_Floorplan.pptx
@@ -11265,8 +11265,8 @@
         </p:blipFill>
         <p:spPr>
           <a:xfrm>
-            <a:off x="5486400" y="2631609"/>
-            <a:ext cx="6263640" cy="2646340"/>
+            <a:off x="5486400" y="2679205"/>
+            <a:ext cx="6263640" cy="2551148"/>
           </a:xfrm>
           <a:prstGeom prst="rect">
             <a:avLst/>
@@ -13260,8 +13260,8 @@
         </p:blipFill>
         <p:spPr>
           <a:xfrm>
-            <a:off x="5486400" y="2109243"/>
-            <a:ext cx="6263640" cy="3691073"/>
+            <a:off x="5486400" y="2267357"/>
+            <a:ext cx="6263640" cy="3374845"/>
           </a:xfrm>
           <a:prstGeom prst="rect">
             <a:avLst/>

</xml_diff>

<commit_message>
figures v5: reshape all to ~4:3/1:1 side-insert; bucket code into notes/05_floorplan/
(1) All 12 figures re-laid-out to 4:3 or 1:1 so they fill a 16:9 slide's right column; flow/list figures use infocard/flowrow card style, spatial diagrams kept. (3) Move diagrams/floorplan.py + decks/floorplan.py into notes/05_floorplan/{figures.py,slides.py} (per-note bucket); fix relative paths via _SK anchor.

Co-Authored-By: Claude Opus 4.8 <noreply@anthropic.com>
</commit_message>
<xml_diff>
--- a/IC_Backend_Notes/slides/05_Floorplan.pptx
+++ b/IC_Backend_Notes/slides/05_Floorplan.pptx
@@ -4678,8 +4678,8 @@
         </p:blipFill>
         <p:spPr>
           <a:xfrm>
-            <a:off x="5486400" y="2176795"/>
-            <a:ext cx="6263640" cy="3555968"/>
+            <a:off x="5486400" y="1676348"/>
+            <a:ext cx="6263640" cy="4556863"/>
           </a:xfrm>
           <a:prstGeom prst="rect">
             <a:avLst/>
@@ -5077,8 +5077,8 @@
         </p:blipFill>
         <p:spPr>
           <a:xfrm>
-            <a:off x="5486400" y="2341869"/>
-            <a:ext cx="6263640" cy="3225820"/>
+            <a:off x="5486400" y="1740229"/>
+            <a:ext cx="6263640" cy="4429101"/>
           </a:xfrm>
           <a:prstGeom prst="rect">
             <a:avLst/>
@@ -5851,8 +5851,8 @@
         </p:blipFill>
         <p:spPr>
           <a:xfrm>
-            <a:off x="5486400" y="2090778"/>
-            <a:ext cx="6263640" cy="3728003"/>
+            <a:off x="5486400" y="1740229"/>
+            <a:ext cx="6263640" cy="4429101"/>
           </a:xfrm>
           <a:prstGeom prst="rect">
             <a:avLst/>
@@ -6250,8 +6250,8 @@
         </p:blipFill>
         <p:spPr>
           <a:xfrm>
-            <a:off x="5486400" y="2331972"/>
-            <a:ext cx="6263640" cy="3245614"/>
+            <a:off x="5486400" y="1711904"/>
+            <a:ext cx="6263640" cy="4485750"/>
           </a:xfrm>
           <a:prstGeom prst="rect">
             <a:avLst/>
@@ -7068,8 +7068,8 @@
         </p:blipFill>
         <p:spPr>
           <a:xfrm>
-            <a:off x="5486400" y="2542480"/>
-            <a:ext cx="6263640" cy="2824599"/>
+            <a:off x="6016777" y="1554480"/>
+            <a:ext cx="5202884" cy="4800600"/>
           </a:xfrm>
           <a:prstGeom prst="rect">
             <a:avLst/>
@@ -11265,8 +11265,8 @@
         </p:blipFill>
         <p:spPr>
           <a:xfrm>
-            <a:off x="5486400" y="2679205"/>
-            <a:ext cx="6263640" cy="2551148"/>
+            <a:off x="5486400" y="1575143"/>
+            <a:ext cx="6263640" cy="4759272"/>
           </a:xfrm>
           <a:prstGeom prst="rect">
             <a:avLst/>
@@ -11664,8 +11664,8 @@
         </p:blipFill>
         <p:spPr>
           <a:xfrm>
-            <a:off x="5486400" y="2080142"/>
-            <a:ext cx="6263640" cy="3749274"/>
+            <a:off x="5486400" y="1597550"/>
+            <a:ext cx="6263640" cy="4714459"/>
           </a:xfrm>
           <a:prstGeom prst="rect">
             <a:avLst/>
@@ -12063,8 +12063,8 @@
         </p:blipFill>
         <p:spPr>
           <a:xfrm>
-            <a:off x="5486400" y="2083941"/>
-            <a:ext cx="6263640" cy="3741676"/>
+            <a:off x="5681540" y="1554480"/>
+            <a:ext cx="5873359" cy="4800600"/>
           </a:xfrm>
           <a:prstGeom prst="rect">
             <a:avLst/>
@@ -12462,8 +12462,8 @@
         </p:blipFill>
         <p:spPr>
           <a:xfrm>
-            <a:off x="5486400" y="2313211"/>
-            <a:ext cx="6263640" cy="3283137"/>
+            <a:off x="5486400" y="1575143"/>
+            <a:ext cx="6263640" cy="4759272"/>
           </a:xfrm>
           <a:prstGeom prst="rect">
             <a:avLst/>
@@ -12861,8 +12861,8 @@
         </p:blipFill>
         <p:spPr>
           <a:xfrm>
-            <a:off x="5486400" y="2267357"/>
-            <a:ext cx="6263640" cy="3374845"/>
+            <a:off x="5486400" y="1575143"/>
+            <a:ext cx="6263640" cy="4759272"/>
           </a:xfrm>
           <a:prstGeom prst="rect">
             <a:avLst/>
@@ -13260,8 +13260,8 @@
         </p:blipFill>
         <p:spPr>
           <a:xfrm>
-            <a:off x="5486400" y="2267357"/>
-            <a:ext cx="6263640" cy="3374845"/>
+            <a:off x="5486400" y="1676348"/>
+            <a:ext cx="6263640" cy="4556863"/>
           </a:xfrm>
           <a:prstGeom prst="rect">
             <a:avLst/>
@@ -13659,8 +13659,8 @@
         </p:blipFill>
         <p:spPr>
           <a:xfrm>
-            <a:off x="5486400" y="2110714"/>
-            <a:ext cx="6263640" cy="3688130"/>
+            <a:off x="5486400" y="1609490"/>
+            <a:ext cx="6263640" cy="4690579"/>
           </a:xfrm>
           <a:prstGeom prst="rect">
             <a:avLst/>

</xml_diff>

<commit_message>
figures: add 3 new figures for text slides; refresh _SlideKit README for bucket structure
(2) New 4:3 figures f13 wire-bond/flip-chip, f14 power-gating header/footer, f15 floorplan iteration loop; wire into slides 11/15/18 (now figure+bullets) and embed in 05_Floorplan.md. Rebuild deck. README rewritten for notes/<NN>/ buckets + card primitives.

Co-Authored-By: Claude Opus 4.8 <noreply@anthropic.com>
</commit_message>
<xml_diff>
--- a/IC_Backend_Notes/slides/05_Floorplan.pptx
+++ b/IC_Backend_Notes/slides/05_Floorplan.pptx
@@ -3793,7 +3793,7 @@
         <p:spPr>
           <a:xfrm>
             <a:off x="640080" y="1600200"/>
-            <a:ext cx="10972800" cy="4846320"/>
+            <a:ext cx="4709160" cy="4846320"/>
           </a:xfrm>
           <a:prstGeom prst="rect">
             <a:avLst/>
@@ -3808,7 +3808,7 @@
           <a:p>
             <a:pPr algn="l">
               <a:lnSpc>
-                <a:spcPct val="125000"/>
+                <a:spcPct val="115000"/>
               </a:lnSpc>
               <a:spcAft>
                 <a:spcPts val="1000"/>
@@ -3829,7 +3829,7 @@
           <a:p>
             <a:pPr algn="l">
               <a:lnSpc>
-                <a:spcPct val="125000"/>
+                <a:spcPct val="115000"/>
               </a:lnSpc>
               <a:spcAft>
                 <a:spcPts val="1000"/>
@@ -3844,13 +3844,13 @@
                 <a:ea typeface="Microsoft YaHei"/>
                 <a:cs typeface="Microsoft YaHei"/>
               </a:rPr>
-              <a:t>▪    考虑信号/电源 Pad 交替、ESD、Corner Pad</a:t>
-            </a:r>
-          </a:p>
-          <a:p>
-            <a:pPr algn="l">
-              <a:lnSpc>
-                <a:spcPct val="125000"/>
+              <a:t>▪  考虑信号/电源 Pad 交替、ESD、Corner Pad</a:t>
+            </a:r>
+          </a:p>
+          <a:p>
+            <a:pPr algn="l">
+              <a:lnSpc>
+                <a:spcPct val="115000"/>
               </a:lnSpc>
               <a:spcAft>
                 <a:spcPts val="1000"/>
@@ -3865,13 +3865,13 @@
                 <a:ea typeface="Microsoft YaHei"/>
                 <a:cs typeface="Microsoft YaHei"/>
               </a:rPr>
-              <a:t>▪  Flip-Chip：信号经 Bump 面阵列从 die 表面引出</a:t>
-            </a:r>
-          </a:p>
-          <a:p>
-            <a:pPr algn="l">
-              <a:lnSpc>
-                <a:spcPct val="125000"/>
+              <a:t>▪  Flip-Chip：信号经 Bump 面阵列引出</a:t>
+            </a:r>
+          </a:p>
+          <a:p>
+            <a:pPr algn="l">
+              <a:lnSpc>
+                <a:spcPct val="115000"/>
               </a:lnSpc>
               <a:spcAft>
                 <a:spcPts val="1000"/>
@@ -3886,13 +3886,13 @@
                 <a:ea typeface="Microsoft YaHei"/>
                 <a:cs typeface="Microsoft YaHei"/>
               </a:rPr>
-              <a:t>▪    常配 RDL 重布线层；是否需要取决封装/凸点布局</a:t>
-            </a:r>
-          </a:p>
-          <a:p>
-            <a:pPr algn="l">
-              <a:lnSpc>
-                <a:spcPct val="125000"/>
+              <a:t>▪  常配 RDL；是否需要取决封装/凸点布局</a:t>
+            </a:r>
+          </a:p>
+          <a:p>
+            <a:pPr algn="l">
+              <a:lnSpc>
+                <a:spcPct val="115000"/>
               </a:lnSpc>
               <a:spcAft>
                 <a:spcPts val="1000"/>
@@ -3907,14 +3907,38 @@
                 <a:ea typeface="Microsoft YaHei"/>
                 <a:cs typeface="Microsoft YaHei"/>
               </a:rPr>
-              <a:t>▪    bump 对齐封装 bump map，控间距与电源/信号比例</a:t>
-            </a:r>
-          </a:p>
-        </p:txBody>
-      </p:sp>
-      <p:sp>
-        <p:nvSpPr>
-          <p:cNvPr id="6" name="TextBox 5"/>
+              <a:t>▪  bump 对齐 bump map，控间距与比例</a:t>
+            </a:r>
+          </a:p>
+        </p:txBody>
+      </p:sp>
+      <p:pic>
+        <p:nvPicPr>
+          <p:cNvPr id="6" name="Picture 5" descr="f13_iopad.png"/>
+          <p:cNvPicPr>
+            <a:picLocks noChangeAspect="1"/>
+          </p:cNvPicPr>
+          <p:nvPr/>
+        </p:nvPicPr>
+        <p:blipFill>
+          <a:blip r:embed="rId2"/>
+          <a:stretch>
+            <a:fillRect/>
+          </a:stretch>
+        </p:blipFill>
+        <p:spPr>
+          <a:xfrm>
+            <a:off x="5486400" y="1752495"/>
+            <a:ext cx="6263640" cy="4404568"/>
+          </a:xfrm>
+          <a:prstGeom prst="rect">
+            <a:avLst/>
+          </a:prstGeom>
+        </p:spPr>
+      </p:pic>
+      <p:sp>
+        <p:nvSpPr>
+          <p:cNvPr id="7" name="TextBox 6"/>
           <p:cNvSpPr txBox="1"/>
           <p:nvPr/>
         </p:nvSpPr>
@@ -3955,7 +3979,7 @@
       </p:sp>
       <p:sp>
         <p:nvSpPr>
-          <p:cNvPr id="7" name="TextBox 6"/>
+          <p:cNvPr id="8" name="TextBox 7"/>
           <p:cNvSpPr txBox="1"/>
           <p:nvPr/>
         </p:nvSpPr>
@@ -5320,7 +5344,7 @@
         <p:spPr>
           <a:xfrm>
             <a:off x="640080" y="1600200"/>
-            <a:ext cx="10972800" cy="4846320"/>
+            <a:ext cx="4709160" cy="4846320"/>
           </a:xfrm>
           <a:prstGeom prst="rect">
             <a:avLst/>
@@ -5335,7 +5359,7 @@
           <a:p>
             <a:pPr algn="l">
               <a:lnSpc>
-                <a:spcPct val="125000"/>
+                <a:spcPct val="115000"/>
               </a:lnSpc>
               <a:spcAft>
                 <a:spcPts val="1000"/>
@@ -5356,7 +5380,7 @@
           <a:p>
             <a:pPr algn="l">
               <a:lnSpc>
-                <a:spcPct val="125000"/>
+                <a:spcPct val="115000"/>
               </a:lnSpc>
               <a:spcAft>
                 <a:spcPts val="1000"/>
@@ -5371,13 +5395,13 @@
                 <a:ea typeface="Microsoft YaHei"/>
                 <a:cs typeface="Microsoft YaHei"/>
               </a:rPr>
-              <a:t>▪  Header(PMOS)：门控 VDD—VVDD，工程上更常用</a:t>
-            </a:r>
-          </a:p>
-          <a:p>
-            <a:pPr algn="l">
-              <a:lnSpc>
-                <a:spcPct val="125000"/>
+              <a:t>▪  Header(PMOS)：门控 VDD—VVDD，更常用</a:t>
+            </a:r>
+          </a:p>
+          <a:p>
+            <a:pPr algn="l">
+              <a:lnSpc>
+                <a:spcPct val="115000"/>
               </a:lnSpc>
               <a:spcAft>
                 <a:spcPts val="1000"/>
@@ -5392,13 +5416,13 @@
                 <a:ea typeface="Microsoft YaHei"/>
                 <a:cs typeface="Microsoft YaHei"/>
               </a:rPr>
-              <a:t>▪  Footer(NMOS)：门控 VVSS—VSS，较少单独使用</a:t>
-            </a:r>
-          </a:p>
-          <a:p>
-            <a:pPr algn="l">
-              <a:lnSpc>
-                <a:spcPct val="125000"/>
+              <a:t>▪  Footer(NMOS)：门控 VVSS—VSS，较少单独用</a:t>
+            </a:r>
+          </a:p>
+          <a:p>
+            <a:pPr algn="l">
+              <a:lnSpc>
+                <a:spcPct val="115000"/>
               </a:lnSpc>
               <a:spcAft>
                 <a:spcPts val="1000"/>
@@ -5413,13 +5437,13 @@
                 <a:ea typeface="Microsoft YaHei"/>
                 <a:cs typeface="Microsoft YaHei"/>
               </a:rPr>
-              <a:t>▪  header + footer 同用罕见</a:t>
-            </a:r>
-          </a:p>
-          <a:p>
-            <a:pPr algn="l">
-              <a:lnSpc>
-                <a:spcPct val="125000"/>
+              <a:t>▪  floorplan 规划 switch 阵列与 enable 菊花链</a:t>
+            </a:r>
+          </a:p>
+          <a:p>
+            <a:pPr algn="l">
+              <a:lnSpc>
+                <a:spcPct val="115000"/>
               </a:lnSpc>
               <a:spcAft>
                 <a:spcPts val="1000"/>
@@ -5434,35 +5458,38 @@
                 <a:ea typeface="Microsoft YaHei"/>
                 <a:cs typeface="Microsoft YaHei"/>
               </a:rPr>
-              <a:t>▪  floorplan 规划 switch 阵列与 enable 菊花链走向</a:t>
-            </a:r>
-          </a:p>
-          <a:p>
-            <a:pPr algn="l">
-              <a:lnSpc>
-                <a:spcPct val="125000"/>
-              </a:lnSpc>
-              <a:spcAft>
-                <a:spcPts val="1000"/>
-              </a:spcAft>
-            </a:pPr>
-            <a:r>
-              <a:rPr sz="1500" b="0">
-                <a:solidFill>
-                  <a:srgbClr val="1E293B"/>
-                </a:solidFill>
-                <a:latin typeface="Microsoft YaHei"/>
-                <a:ea typeface="Microsoft YaHei"/>
-                <a:cs typeface="Microsoft YaHei"/>
-              </a:rPr>
-              <a:t>▪  菊花链分时开启 → 控冲击电流与唤醒时间；规划 always-on PG</a:t>
-            </a:r>
-          </a:p>
-        </p:txBody>
-      </p:sp>
-      <p:sp>
-        <p:nvSpPr>
-          <p:cNvPr id="6" name="TextBox 5"/>
+              <a:t>▪  菊花链分时开启 → 控冲击电流、规划 always-on PG</a:t>
+            </a:r>
+          </a:p>
+        </p:txBody>
+      </p:sp>
+      <p:pic>
+        <p:nvPicPr>
+          <p:cNvPr id="6" name="Picture 5" descr="f14_gating.png"/>
+          <p:cNvPicPr>
+            <a:picLocks noChangeAspect="1"/>
+          </p:cNvPicPr>
+          <p:nvPr/>
+        </p:nvPicPr>
+        <p:blipFill>
+          <a:blip r:embed="rId2"/>
+          <a:stretch>
+            <a:fillRect/>
+          </a:stretch>
+        </p:blipFill>
+        <p:spPr>
+          <a:xfrm>
+            <a:off x="6286894" y="1554480"/>
+            <a:ext cx="4662651" cy="4800600"/>
+          </a:xfrm>
+          <a:prstGeom prst="rect">
+            <a:avLst/>
+          </a:prstGeom>
+        </p:spPr>
+      </p:pic>
+      <p:sp>
+        <p:nvSpPr>
+          <p:cNvPr id="7" name="TextBox 6"/>
           <p:cNvSpPr txBox="1"/>
           <p:nvPr/>
         </p:nvSpPr>
@@ -5503,7 +5530,7 @@
       </p:sp>
       <p:sp>
         <p:nvSpPr>
-          <p:cNvPr id="7" name="TextBox 6"/>
+          <p:cNvPr id="8" name="TextBox 7"/>
           <p:cNvSpPr txBox="1"/>
           <p:nvPr/>
         </p:nvSpPr>
@@ -6493,7 +6520,7 @@
         <p:spPr>
           <a:xfrm>
             <a:off x="640080" y="1600200"/>
-            <a:ext cx="5486400" cy="4846320"/>
+            <a:ext cx="4709160" cy="4846320"/>
           </a:xfrm>
           <a:prstGeom prst="rect">
             <a:avLst/>
@@ -6508,77 +6535,56 @@
           <a:p>
             <a:pPr algn="l">
               <a:lnSpc>
-                <a:spcPct val="120000"/>
-              </a:lnSpc>
-              <a:spcAft>
-                <a:spcPts val="900"/>
-              </a:spcAft>
-            </a:pPr>
-            <a:r>
-              <a:rPr sz="1450" b="0">
-                <a:solidFill>
-                  <a:srgbClr val="1E293B"/>
-                </a:solidFill>
-                <a:latin typeface="Microsoft YaHei"/>
-                <a:ea typeface="Microsoft YaHei"/>
-                <a:cs typeface="Microsoft YaHei"/>
-              </a:rPr>
-              <a:t>▪  拥塞早估：GR 估 GCell 需求/资源 → 拥塞图 + Overflow</a:t>
-            </a:r>
-          </a:p>
-          <a:p>
-            <a:pPr algn="l">
-              <a:lnSpc>
-                <a:spcPct val="120000"/>
-              </a:lnSpc>
-              <a:spcAft>
-                <a:spcPts val="900"/>
-              </a:spcAft>
-            </a:pPr>
-            <a:r>
-              <a:rPr sz="1450" b="0">
-                <a:solidFill>
-                  <a:srgbClr val="1E293B"/>
-                </a:solidFill>
-                <a:latin typeface="Microsoft YaHei"/>
-                <a:ea typeface="Microsoft YaHei"/>
-                <a:cs typeface="Microsoft YaHei"/>
-              </a:rPr>
-              <a:t>▪  全局拥塞：区域整体需求超资源(利用率高/stripe 密)</a:t>
-            </a:r>
-          </a:p>
-          <a:p>
-            <a:pPr algn="l">
-              <a:lnSpc>
-                <a:spcPct val="120000"/>
-              </a:lnSpc>
-              <a:spcAft>
-                <a:spcPts val="900"/>
-              </a:spcAft>
-            </a:pPr>
-            <a:r>
-              <a:rPr sz="1450" b="0">
-                <a:solidFill>
-                  <a:srgbClr val="1E293B"/>
-                </a:solidFill>
-                <a:latin typeface="Microsoft YaHei"/>
-                <a:ea typeface="Microsoft YaHei"/>
-                <a:cs typeface="Microsoft YaHei"/>
-              </a:rPr>
-              <a:t>▪  局部/pin-access 拥塞：引脚密集处可达性</a:t>
-            </a:r>
-          </a:p>
-          <a:p>
-            <a:pPr algn="l">
-              <a:lnSpc>
-                <a:spcPct val="120000"/>
-              </a:lnSpc>
-              <a:spcAft>
-                <a:spcPts val="900"/>
-              </a:spcAft>
-            </a:pPr>
-            <a:r>
-              <a:rPr sz="1450" b="0">
+                <a:spcPct val="115000"/>
+              </a:lnSpc>
+              <a:spcAft>
+                <a:spcPts val="1000"/>
+              </a:spcAft>
+            </a:pPr>
+            <a:r>
+              <a:rPr sz="1500" b="0">
+                <a:solidFill>
+                  <a:srgbClr val="1E293B"/>
+                </a:solidFill>
+                <a:latin typeface="Microsoft YaHei"/>
+                <a:ea typeface="Microsoft YaHei"/>
+                <a:cs typeface="Microsoft YaHei"/>
+              </a:rPr>
+              <a:t>▪  拥塞早估：GR 估 GCell 需求/资源 → 拥塞图</a:t>
+            </a:r>
+          </a:p>
+          <a:p>
+            <a:pPr algn="l">
+              <a:lnSpc>
+                <a:spcPct val="115000"/>
+              </a:lnSpc>
+              <a:spcAft>
+                <a:spcPts val="1000"/>
+              </a:spcAft>
+            </a:pPr>
+            <a:r>
+              <a:rPr sz="1500" b="0">
+                <a:solidFill>
+                  <a:srgbClr val="1E293B"/>
+                </a:solidFill>
+                <a:latin typeface="Microsoft YaHei"/>
+                <a:ea typeface="Microsoft YaHei"/>
+                <a:cs typeface="Microsoft YaHei"/>
+              </a:rPr>
+              <a:t>▪  全局拥塞 vs 局部 / pin-access 拥塞</a:t>
+            </a:r>
+          </a:p>
+          <a:p>
+            <a:pPr algn="l">
+              <a:lnSpc>
+                <a:spcPct val="115000"/>
+              </a:lnSpc>
+              <a:spcAft>
+                <a:spcPts val="1000"/>
+              </a:spcAft>
+            </a:pPr>
+            <a:r>
+              <a:rPr sz="1500" b="0">
                 <a:solidFill>
                   <a:srgbClr val="1E293B"/>
                 </a:solidFill>
@@ -6589,94 +6595,95 @@
               <a:t>▪  热点：macro notch、窄 channel、pin 密集</a:t>
             </a:r>
           </a:p>
-        </p:txBody>
-      </p:sp>
-      <p:sp>
-        <p:nvSpPr>
-          <p:cNvPr id="6" name="TextBox 5"/>
-          <p:cNvSpPr txBox="1"/>
-          <p:nvPr/>
-        </p:nvSpPr>
-        <p:spPr>
-          <a:xfrm>
-            <a:off x="6309360" y="1600200"/>
-            <a:ext cx="5486400" cy="4846320"/>
-          </a:xfrm>
-          <a:prstGeom prst="rect">
-            <a:avLst/>
-          </a:prstGeom>
-          <a:noFill/>
-        </p:spPr>
-        <p:txBody>
-          <a:bodyPr wrap="square" anchor="t" lIns="25400" rIns="25400" tIns="25400" bIns="25400">
-            <a:spAutoFit/>
-          </a:bodyPr>
-          <a:lstStyle/>
-          <a:p>
-            <a:pPr algn="l">
-              <a:lnSpc>
-                <a:spcPct val="120000"/>
-              </a:lnSpc>
-              <a:spcAft>
-                <a:spcPts val="900"/>
-              </a:spcAft>
-            </a:pPr>
-            <a:r>
-              <a:rPr sz="1450" b="0">
-                <a:solidFill>
-                  <a:srgbClr val="1E293B"/>
-                </a:solidFill>
-                <a:latin typeface="Microsoft YaHei"/>
-                <a:ea typeface="Microsoft YaHei"/>
-                <a:cs typeface="Microsoft YaHei"/>
-              </a:rPr>
-              <a:t>▪  缓解：降利用率、加宽 channel、partial blockage、优化 pin</a:t>
-            </a:r>
-          </a:p>
-          <a:p>
-            <a:pPr algn="l">
-              <a:lnSpc>
-                <a:spcPct val="120000"/>
-              </a:lnSpc>
-              <a:spcAft>
-                <a:spcPts val="900"/>
-              </a:spcAft>
-            </a:pPr>
-            <a:r>
-              <a:rPr sz="1450" b="0">
-                <a:solidFill>
-                  <a:srgbClr val="1E293B"/>
-                </a:solidFill>
-                <a:latin typeface="Microsoft YaHei"/>
-                <a:ea typeface="Microsoft YaHei"/>
-                <a:cs typeface="Microsoft YaHei"/>
-              </a:rPr>
-              <a:t>▪  IR 早估：静态 PG 分析定位高压降区，加密 mesh/via</a:t>
-            </a:r>
-          </a:p>
-          <a:p>
-            <a:pPr algn="l">
-              <a:lnSpc>
-                <a:spcPct val="120000"/>
-              </a:lnSpc>
-              <a:spcAft>
-                <a:spcPts val="900"/>
-              </a:spcAft>
-            </a:pPr>
-            <a:r>
-              <a:rPr sz="1450" b="0">
-                <a:solidFill>
-                  <a:srgbClr val="1E293B"/>
-                </a:solidFill>
-                <a:latin typeface="Microsoft YaHei"/>
-                <a:ea typeface="Microsoft YaHei"/>
-                <a:cs typeface="Microsoft YaHei"/>
-              </a:rPr>
-              <a:t>▪  迭代闭环：floorplan → 试布局/GR → 评估 → 回退调整</a:t>
-            </a:r>
-          </a:p>
-        </p:txBody>
-      </p:sp>
+          <a:p>
+            <a:pPr algn="l">
+              <a:lnSpc>
+                <a:spcPct val="115000"/>
+              </a:lnSpc>
+              <a:spcAft>
+                <a:spcPts val="1000"/>
+              </a:spcAft>
+            </a:pPr>
+            <a:r>
+              <a:rPr sz="1500" b="0">
+                <a:solidFill>
+                  <a:srgbClr val="1E293B"/>
+                </a:solidFill>
+                <a:latin typeface="Microsoft YaHei"/>
+                <a:ea typeface="Microsoft YaHei"/>
+                <a:cs typeface="Microsoft YaHei"/>
+              </a:rPr>
+              <a:t>▪  缓解：降利用率、加宽 channel、partial blockage</a:t>
+            </a:r>
+          </a:p>
+          <a:p>
+            <a:pPr algn="l">
+              <a:lnSpc>
+                <a:spcPct val="115000"/>
+              </a:lnSpc>
+              <a:spcAft>
+                <a:spcPts val="1000"/>
+              </a:spcAft>
+            </a:pPr>
+            <a:r>
+              <a:rPr sz="1500" b="0">
+                <a:solidFill>
+                  <a:srgbClr val="1E293B"/>
+                </a:solidFill>
+                <a:latin typeface="Microsoft YaHei"/>
+                <a:ea typeface="Microsoft YaHei"/>
+                <a:cs typeface="Microsoft YaHei"/>
+              </a:rPr>
+              <a:t>▪  IR 早估：静态 PG 分析定位高压降区，加密 mesh</a:t>
+            </a:r>
+          </a:p>
+          <a:p>
+            <a:pPr algn="l">
+              <a:lnSpc>
+                <a:spcPct val="115000"/>
+              </a:lnSpc>
+              <a:spcAft>
+                <a:spcPts val="1000"/>
+              </a:spcAft>
+            </a:pPr>
+            <a:r>
+              <a:rPr sz="1500" b="0">
+                <a:solidFill>
+                  <a:srgbClr val="1E293B"/>
+                </a:solidFill>
+                <a:latin typeface="Microsoft YaHei"/>
+                <a:ea typeface="Microsoft YaHei"/>
+                <a:cs typeface="Microsoft YaHei"/>
+              </a:rPr>
+              <a:t>▪  迭代闭环：floorplan → 试布局/GR → 评估 → 回退</a:t>
+            </a:r>
+          </a:p>
+        </p:txBody>
+      </p:sp>
+      <p:pic>
+        <p:nvPicPr>
+          <p:cNvPr id="6" name="Picture 5" descr="f15_loop.png"/>
+          <p:cNvPicPr>
+            <a:picLocks noChangeAspect="1"/>
+          </p:cNvPicPr>
+          <p:nvPr/>
+        </p:nvPicPr>
+        <p:blipFill>
+          <a:blip r:embed="rId2"/>
+          <a:stretch>
+            <a:fillRect/>
+          </a:stretch>
+        </p:blipFill>
+        <p:spPr>
+          <a:xfrm>
+            <a:off x="5933860" y="1554480"/>
+            <a:ext cx="5368718" cy="4800600"/>
+          </a:xfrm>
+          <a:prstGeom prst="rect">
+            <a:avLst/>
+          </a:prstGeom>
+        </p:spPr>
+      </p:pic>
       <p:sp>
         <p:nvSpPr>
           <p:cNvPr id="7" name="TextBox 6"/>

</xml_diff>

<commit_message>
deck/figures: larger figure fonts (②), numbered progressive slides ③ (S3/S8/S13), topical non-draft subtitles ①, agenda 主线/page overlap fix ⑤
- theme.py: bump FS tiers + primitive default sizes so inserted figures are legible

- deck.py: split 'num' style (①②③), agenda highlight moved clear of page number, preview marker param

- slides.py: restructure S3/S8/S13 to numbered steps; replace casual/meta subtitles with topical ones

Co-Authored-By: Claude Opus 4.8 <noreply@anthropic.com>
</commit_message>
<xml_diff>
--- a/IC_Backend_Notes/slides/05_Floorplan.pptx
+++ b/IC_Backend_Notes/slides/05_Floorplan.pptx
@@ -3551,7 +3551,7 @@
                 <a:ea typeface="Microsoft YaHei"/>
                 <a:cs typeface="Microsoft YaHei"/>
               </a:rPr>
-              <a:t>physical-only cell，floorplan 早期就要规划</a:t>
+              <a:t>不参与逻辑，却关乎 row 与 well 连续</a:t>
             </a:r>
           </a:p>
         </p:txBody>
@@ -4811,7 +4811,7 @@
                 <a:ea typeface="Microsoft YaHei"/>
                 <a:cs typeface="Microsoft YaHei"/>
               </a:rPr>
-              <a:t>PG 网络自上而下</a:t>
+              <a:t>自上而下、由粗到细，逐级连成 PG 网络</a:t>
             </a:r>
           </a:p>
         </p:txBody>
@@ -4899,7 +4899,7 @@
                 <a:ea typeface="Microsoft YaHei"/>
                 <a:cs typeface="Microsoft YaHei"/>
               </a:rPr>
-              <a:t>▪  Power Ring 是绕 core 或 macro 的闭合环，多用顶层粗金属</a:t>
+              <a:t>①  Power Ring：绕 core 或 macro 的闭合环，多用顶层粗金属</a:t>
             </a:r>
           </a:p>
           <a:p>
@@ -4920,7 +4920,7 @@
                 <a:ea typeface="Microsoft YaHei"/>
                 <a:cs typeface="Microsoft YaHei"/>
               </a:rPr>
-              <a:t>▪  Power Stripe 是横跨 core 的粗金属条，用来分担电流</a:t>
+              <a:t>②  Power Stripe：横跨 core 的粗金属条，用来分担电流</a:t>
             </a:r>
           </a:p>
           <a:p>
@@ -4941,7 +4941,7 @@
                 <a:ea typeface="Microsoft YaHei"/>
                 <a:cs typeface="Microsoft YaHei"/>
               </a:rPr>
-              <a:t>▪  Power Mesh 由 stripe 纵横交织成网，以降低等效电阻</a:t>
+              <a:t>③  Power Mesh：stripe 纵横交织成网，降低等效电阻</a:t>
             </a:r>
           </a:p>
           <a:p>
@@ -4962,7 +4962,7 @@
                 <a:ea typeface="Microsoft YaHei"/>
                 <a:cs typeface="Microsoft YaHei"/>
               </a:rPr>
-              <a:t>▪  Std-cell Rail 是沿标准单元行的 M1 供电轨，即 follow-pin</a:t>
+              <a:t>④  Std-cell Rail：沿标准单元行的 M1 供电轨（follow-pin）</a:t>
             </a:r>
           </a:p>
           <a:p>
@@ -4983,28 +4983,7 @@
                 <a:ea typeface="Microsoft YaHei"/>
                 <a:cs typeface="Microsoft YaHei"/>
               </a:rPr>
-              <a:t>▪  Special Route 连接 ring、stripe、pin、pad 并打 via</a:t>
-            </a:r>
-          </a:p>
-          <a:p>
-            <a:pPr algn="l">
-              <a:lnSpc>
-                <a:spcPct val="110000"/>
-              </a:lnSpc>
-              <a:spcAft>
-                <a:spcPts val="800"/>
-              </a:spcAft>
-            </a:pPr>
-            <a:r>
-              <a:rPr sz="1400" b="0">
-                <a:solidFill>
-                  <a:srgbClr val="1A1F2B"/>
-                </a:solidFill>
-                <a:latin typeface="Microsoft YaHei"/>
-                <a:ea typeface="Microsoft YaHei"/>
-                <a:cs typeface="Microsoft YaHei"/>
-              </a:rPr>
-              <a:t>▪  sroute 作用范围广，是 PG 网络成型的关键步骤</a:t>
+              <a:t>⑤  Special Route：连接 ring/stripe/pin/pad 并打 via 成型</a:t>
             </a:r>
           </a:p>
         </p:txBody>
@@ -5254,7 +5233,7 @@
                 <a:ea typeface="Microsoft YaHei"/>
                 <a:cs typeface="Microsoft YaHei"/>
               </a:rPr>
-              <a:t>签核要过的两关</a:t>
+              <a:t>电源完整性的两大约束</a:t>
             </a:r>
           </a:p>
         </p:txBody>
@@ -5468,8 +5447,8 @@
         </p:blipFill>
         <p:spPr>
           <a:xfrm>
-            <a:off x="5486400" y="1740229"/>
-            <a:ext cx="6263640" cy="4429101"/>
+            <a:off x="5486400" y="1766552"/>
+            <a:ext cx="6263640" cy="4376455"/>
           </a:xfrm>
           <a:prstGeom prst="rect">
             <a:avLst/>
@@ -6119,7 +6098,7 @@
                 <a:ea typeface="Microsoft YaHei"/>
                 <a:cs typeface="Microsoft YaHei"/>
               </a:rPr>
-              <a:t>Multi-Voltage</a:t>
+              <a:t>多电压域与 UPF 功耗意图</a:t>
             </a:r>
           </a:p>
         </p:txBody>
@@ -6562,7 +6541,7 @@
                 <a:ea typeface="Microsoft YaHei"/>
                 <a:cs typeface="Microsoft YaHei"/>
               </a:rPr>
-              <a:t>分而治之</a:t>
+              <a:t>层次化划分与时序预算分配</a:t>
             </a:r>
           </a:p>
         </p:txBody>
@@ -7005,7 +6984,7 @@
                 <a:ea typeface="Microsoft YaHei"/>
                 <a:cs typeface="Microsoft YaHei"/>
               </a:rPr>
-              <a:t>Floorplan 不是一遍过</a:t>
+              <a:t>拥塞与 IR 的早期预估、迭代收敛</a:t>
             </a:r>
           </a:p>
         </p:txBody>
@@ -7448,7 +7427,7 @@
                 <a:ea typeface="Microsoft YaHei"/>
                 <a:cs typeface="Microsoft YaHei"/>
               </a:rPr>
-              <a:t>吃什么、吐什么</a:t>
+              <a:t>输入、输出与关键文件作用</a:t>
             </a:r>
           </a:p>
         </p:txBody>
@@ -7899,7 +7878,7 @@
                 <a:ea typeface="Microsoft YaHei"/>
                 <a:cs typeface="Microsoft YaHei"/>
               </a:rPr>
-              <a:t>24 页 · 每节一图/一题，知识点写在页面上</a:t>
+              <a:t>从定位与意义，到电源完整性与迭代收敛</a:t>
             </a:r>
           </a:p>
         </p:txBody>
@@ -8915,8 +8894,8 @@
         </p:nvSpPr>
         <p:spPr>
           <a:xfrm>
-            <a:off x="868680" y="6053328"/>
-            <a:ext cx="10469880" cy="566928"/>
+            <a:off x="868680" y="5742432"/>
+            <a:ext cx="10058400" cy="548640"/>
           </a:xfrm>
           <a:prstGeom prst="roundRect">
             <a:avLst/>
@@ -8961,8 +8940,8 @@
         </p:nvSpPr>
         <p:spPr>
           <a:xfrm>
-            <a:off x="1143000" y="6172200"/>
-            <a:ext cx="10058400" cy="365760"/>
+            <a:off x="1143000" y="5861304"/>
+            <a:ext cx="9692640" cy="365760"/>
           </a:xfrm>
           <a:prstGeom prst="rect">
             <a:avLst/>
@@ -8981,7 +8960,7 @@
               </a:spcAft>
             </a:pPr>
             <a:r>
-              <a:rPr sz="1350" b="1">
+              <a:rPr sz="1300" b="1">
                 <a:solidFill>
                   <a:srgbClr val="8A5212"/>
                 </a:solidFill>
@@ -9215,7 +9194,7 @@
                 <a:ea typeface="Microsoft YaHei"/>
                 <a:cs typeface="Microsoft YaHei"/>
               </a:rPr>
-              <a:t>收敛看指标，出问题反查</a:t>
+              <a:t>关键收敛指标与常见问题对策</a:t>
             </a:r>
           </a:p>
         </p:txBody>
@@ -10875,7 +10854,7 @@
                 <a:ea typeface="Microsoft YaHei"/>
                 <a:cs typeface="Microsoft YaHei"/>
               </a:rPr>
-              <a:t>8 句话带走</a:t>
+              <a:t>八条核心要点回顾</a:t>
             </a:r>
           </a:p>
         </p:txBody>
@@ -11359,7 +11338,7 @@
                 <a:ea typeface="Microsoft YaHei"/>
                 <a:cs typeface="Microsoft YaHei"/>
               </a:rPr>
-              <a:t>16 题自测，逐题回想答案</a:t>
+              <a:t>16 题自测：逐题回想要点</a:t>
             </a:r>
           </a:p>
         </p:txBody>
@@ -12551,7 +12530,7 @@
                 <a:ea typeface="Microsoft YaHei"/>
                 <a:cs typeface="Microsoft YaHei"/>
               </a:rPr>
-              <a:t>物理实现的第一步</a:t>
+              <a:t>综合之后、详细布局之前，把网表落成版图骨架的六项任务</a:t>
             </a:r>
           </a:p>
         </p:txBody>
@@ -12639,7 +12618,7 @@
                 <a:ea typeface="Microsoft YaHei"/>
                 <a:cs typeface="Microsoft YaHei"/>
               </a:rPr>
-              <a:t>▪  Floorplan 是物理实现 P&amp;R 的第一步，先确定版图骨架</a:t>
+              <a:t>①  确定 die 与 core 的整体几何尺寸</a:t>
             </a:r>
           </a:p>
           <a:p>
@@ -12660,7 +12639,7 @@
                 <a:ea typeface="Microsoft YaHei"/>
                 <a:cs typeface="Microsoft YaHei"/>
               </a:rPr>
-              <a:t>▪  它在综合产出门级网表之后、详细布局 Placement 之前</a:t>
+              <a:t>②  决定各 macro 硬核的位置与朝向</a:t>
             </a:r>
           </a:p>
           <a:p>
@@ -12681,7 +12660,7 @@
                 <a:ea typeface="Microsoft YaHei"/>
                 <a:cs typeface="Microsoft YaHei"/>
               </a:rPr>
-              <a:t>▪  此前先做设计导入：读库与网表，加载 SDC 与 UPF</a:t>
+              <a:t>③  规划 IO / Pad / Bump 与引脚分配</a:t>
             </a:r>
           </a:p>
           <a:p>
@@ -12702,7 +12681,7 @@
                 <a:ea typeface="Microsoft YaHei"/>
                 <a:cs typeface="Microsoft YaHei"/>
               </a:rPr>
-              <a:t>▪  首要任务是确定 die 与 core 的整体几何尺寸</a:t>
+              <a:t>④  搭建 PG 电源骨架：环 / 条 / 网 / 轨</a:t>
             </a:r>
           </a:p>
           <a:p>
@@ -12723,7 +12702,7 @@
                 <a:ea typeface="Microsoft YaHei"/>
                 <a:cs typeface="Microsoft YaHei"/>
               </a:rPr>
-              <a:t>▪  再摆放各 macro 位置朝向，规划 IO / Pad / Bump 引脚</a:t>
+              <a:t>⑤  划分多电压域与电压岛边界</a:t>
             </a:r>
           </a:p>
           <a:p>
@@ -12744,28 +12723,7 @@
                 <a:ea typeface="Microsoft YaHei"/>
                 <a:cs typeface="Microsoft YaHei"/>
               </a:rPr>
-              <a:t>▪  然后搭 PG 电源骨架、划电压域、预留各类 blockage</a:t>
-            </a:r>
-          </a:p>
-          <a:p>
-            <a:pPr algn="l">
-              <a:lnSpc>
-                <a:spcPct val="110000"/>
-              </a:lnSpc>
-              <a:spcAft>
-                <a:spcPts val="800"/>
-              </a:spcAft>
-            </a:pPr>
-            <a:r>
-              <a:rPr sz="1400" b="0">
-                <a:solidFill>
-                  <a:srgbClr val="1A1F2B"/>
-                </a:solidFill>
-                <a:latin typeface="Microsoft YaHei"/>
-                <a:ea typeface="Microsoft YaHei"/>
-                <a:cs typeface="Microsoft YaHei"/>
-              </a:rPr>
-              <a:t>▪  本质是把逻辑网表映射成物理布局骨架</a:t>
+              <a:t>⑥  预留各类 blockage 与 halo / keepout</a:t>
             </a:r>
           </a:p>
         </p:txBody>
@@ -13229,8 +13187,8 @@
         </p:blipFill>
         <p:spPr>
           <a:xfrm>
-            <a:off x="5486400" y="1597550"/>
-            <a:ext cx="6263640" cy="4714459"/>
+            <a:off x="5486400" y="1582493"/>
+            <a:ext cx="6263640" cy="4744573"/>
           </a:xfrm>
           <a:prstGeom prst="rect">
             <a:avLst/>
@@ -13901,7 +13859,7 @@
                 <a:ea typeface="Microsoft YaHei"/>
                 <a:cs typeface="Microsoft YaHei"/>
               </a:rPr>
-              <a:t>面积更省的小机关</a:t>
+              <a:t>等高行、site 栅格与翻转共享供电轨</a:t>
             </a:r>
           </a:p>
         </p:txBody>
@@ -14344,7 +14302,7 @@
                 <a:ea typeface="Microsoft YaHei"/>
                 <a:cs typeface="Microsoft YaHei"/>
               </a:rPr>
-              <a:t>两个口径要分清</a:t>
+              <a:t>两种利用率口径与长宽比取向</a:t>
             </a:r>
           </a:p>
         </p:txBody>
@@ -14787,7 +14745,7 @@
                 <a:ea typeface="Microsoft YaHei"/>
                 <a:cs typeface="Microsoft YaHei"/>
               </a:rPr>
-              <a:t>Macro Placement</a:t>
+              <a:t>宏 = 大尺寸硬核（SRAM/PLL/IP），五条摆放原则</a:t>
             </a:r>
           </a:p>
         </p:txBody>
@@ -14875,7 +14833,7 @@
                 <a:ea typeface="Microsoft YaHei"/>
                 <a:cs typeface="Microsoft YaHei"/>
               </a:rPr>
-              <a:t>▪  macro 指 SRAM/PLL/IP 等硬核，尺寸大、形状引脚固定</a:t>
+              <a:t>①  沿边沿角摆放，中间连续区留给标准单元</a:t>
             </a:r>
           </a:p>
           <a:p>
@@ -14896,7 +14854,7 @@
                 <a:ea typeface="Microsoft YaHei"/>
                 <a:cs typeface="Microsoft YaHei"/>
               </a:rPr>
-              <a:t>▪  大 macro 应沿边沿角摆放，中间连续区留给标准单元</a:t>
+              <a:t>②  按数据流就近放置，用 flyline 或 auto placer 指导</a:t>
             </a:r>
           </a:p>
           <a:p>
@@ -14917,7 +14875,7 @@
                 <a:ea typeface="Microsoft YaHei"/>
                 <a:cs typeface="Microsoft YaHei"/>
               </a:rPr>
-              <a:t>▪  按数据流就近放置，用 flyline 飞线或 auto placer 指导</a:t>
+              <a:t>③  宏间预留 channel 走线，或采用 channel-less 紧贴</a:t>
             </a:r>
           </a:p>
           <a:p>
@@ -14938,7 +14896,7 @@
                 <a:ea typeface="Microsoft YaHei"/>
                 <a:cs typeface="Microsoft YaHei"/>
               </a:rPr>
-              <a:t>▪  macro 间预留 channel 走线，或采用 channel-less 紧贴</a:t>
+              <a:t>④  引脚朝向 core，避免信号绕过宏本体</a:t>
             </a:r>
           </a:p>
           <a:p>
@@ -14959,28 +14917,7 @@
                 <a:ea typeface="Microsoft YaHei"/>
                 <a:cs typeface="Microsoft YaHei"/>
               </a:rPr>
-              <a:t>▪  macro 引脚朝向 core，避免信号绕过 macro 本体</a:t>
-            </a:r>
-          </a:p>
-          <a:p>
-            <a:pPr algn="l">
-              <a:lnSpc>
-                <a:spcPct val="110000"/>
-              </a:lnSpc>
-              <a:spcAft>
-                <a:spcPts val="800"/>
-              </a:spcAft>
-            </a:pPr>
-            <a:r>
-              <a:rPr sz="1400" b="0">
-                <a:solidFill>
-                  <a:srgbClr val="1A1F2B"/>
-                </a:solidFill>
-                <a:latin typeface="Microsoft YaHei"/>
-                <a:ea typeface="Microsoft YaHei"/>
-                <a:cs typeface="Microsoft YaHei"/>
-              </a:rPr>
-              <a:t>▪  从 8 种朝向中选定并对称背靠背，对齐成规整阵列</a:t>
+              <a:t>⑤  从 8 种朝向中选定，对称背靠背、对齐成阵列</a:t>
             </a:r>
           </a:p>
         </p:txBody>
@@ -15230,7 +15167,7 @@
                 <a:ea typeface="Microsoft YaHei"/>
                 <a:cs typeface="Microsoft YaHei"/>
               </a:rPr>
-              <a:t>给布线留活路</a:t>
+              <a:t>halo 与三类 blockage，为布线预留空间</a:t>
             </a:r>
           </a:p>
         </p:txBody>

</xml_diff>

<commit_message>
fix(master): strip default 4:3 placeholders (date/footer/<#> overlap) + delete unused layouts → clean single 16:9 layout carrying only the chrome
Co-Authored-By: Claude Opus 4.8 <noreply@anthropic.com>
</commit_message>
<xml_diff>
--- a/IC_Backend_Notes/slides/05_Floorplan.pptx
+++ b/IC_Backend_Notes/slides/05_Floorplan.pptx
@@ -130,1842 +130,6 @@
 </p:presentation>
 </file>
 
-<file path=ppt/slideLayouts/slideLayout1.xml><?xml version="1.0" encoding="utf-8"?>
-<p:sldLayout xmlns:a="http://schemas.openxmlformats.org/drawingml/2006/main" xmlns:r="http://schemas.openxmlformats.org/officeDocument/2006/relationships" xmlns:p="http://schemas.openxmlformats.org/presentationml/2006/main" type="title" preserve="1">
-  <p:cSld name="Title Slide">
-    <p:spTree>
-      <p:nvGrpSpPr>
-        <p:cNvPr id="1" name=""/>
-        <p:cNvGrpSpPr/>
-        <p:nvPr/>
-      </p:nvGrpSpPr>
-      <p:grpSpPr>
-        <a:xfrm>
-          <a:off x="0" y="0"/>
-          <a:ext cx="0" cy="0"/>
-          <a:chOff x="0" y="0"/>
-          <a:chExt cx="0" cy="0"/>
-        </a:xfrm>
-      </p:grpSpPr>
-      <p:sp>
-        <p:nvSpPr>
-          <p:cNvPr id="2" name="Title 1"/>
-          <p:cNvSpPr>
-            <a:spLocks noGrp="1"/>
-          </p:cNvSpPr>
-          <p:nvPr>
-            <p:ph type="ctrTitle"/>
-          </p:nvPr>
-        </p:nvSpPr>
-        <p:spPr>
-          <a:xfrm>
-            <a:off x="685800" y="2130425"/>
-            <a:ext cx="7772400" cy="1470025"/>
-          </a:xfrm>
-        </p:spPr>
-        <p:txBody>
-          <a:bodyPr/>
-          <a:lstStyle/>
-          <a:p>
-            <a:r>
-              <a:rPr lang="en-US" smtClean="0"/>
-              <a:t>Click to edit Master title style</a:t>
-            </a:r>
-            <a:endParaRPr lang="en-US"/>
-          </a:p>
-        </p:txBody>
-      </p:sp>
-      <p:sp>
-        <p:nvSpPr>
-          <p:cNvPr id="3" name="Subtitle 2"/>
-          <p:cNvSpPr>
-            <a:spLocks noGrp="1"/>
-          </p:cNvSpPr>
-          <p:nvPr>
-            <p:ph type="subTitle" idx="1"/>
-          </p:nvPr>
-        </p:nvSpPr>
-        <p:spPr>
-          <a:xfrm>
-            <a:off x="1371600" y="3886200"/>
-            <a:ext cx="6400800" cy="1752600"/>
-          </a:xfrm>
-        </p:spPr>
-        <p:txBody>
-          <a:bodyPr/>
-          <a:lstStyle>
-            <a:lvl1pPr marL="0" indent="0" algn="ctr">
-              <a:buNone/>
-              <a:defRPr>
-                <a:solidFill>
-                  <a:schemeClr val="tx1">
-                    <a:tint val="75000"/>
-                  </a:schemeClr>
-                </a:solidFill>
-              </a:defRPr>
-            </a:lvl1pPr>
-            <a:lvl2pPr marL="457200" indent="0" algn="ctr">
-              <a:buNone/>
-              <a:defRPr>
-                <a:solidFill>
-                  <a:schemeClr val="tx1">
-                    <a:tint val="75000"/>
-                  </a:schemeClr>
-                </a:solidFill>
-              </a:defRPr>
-            </a:lvl2pPr>
-            <a:lvl3pPr marL="914400" indent="0" algn="ctr">
-              <a:buNone/>
-              <a:defRPr>
-                <a:solidFill>
-                  <a:schemeClr val="tx1">
-                    <a:tint val="75000"/>
-                  </a:schemeClr>
-                </a:solidFill>
-              </a:defRPr>
-            </a:lvl3pPr>
-            <a:lvl4pPr marL="1371600" indent="0" algn="ctr">
-              <a:buNone/>
-              <a:defRPr>
-                <a:solidFill>
-                  <a:schemeClr val="tx1">
-                    <a:tint val="75000"/>
-                  </a:schemeClr>
-                </a:solidFill>
-              </a:defRPr>
-            </a:lvl4pPr>
-            <a:lvl5pPr marL="1828800" indent="0" algn="ctr">
-              <a:buNone/>
-              <a:defRPr>
-                <a:solidFill>
-                  <a:schemeClr val="tx1">
-                    <a:tint val="75000"/>
-                  </a:schemeClr>
-                </a:solidFill>
-              </a:defRPr>
-            </a:lvl5pPr>
-            <a:lvl6pPr marL="2286000" indent="0" algn="ctr">
-              <a:buNone/>
-              <a:defRPr>
-                <a:solidFill>
-                  <a:schemeClr val="tx1">
-                    <a:tint val="75000"/>
-                  </a:schemeClr>
-                </a:solidFill>
-              </a:defRPr>
-            </a:lvl6pPr>
-            <a:lvl7pPr marL="2743200" indent="0" algn="ctr">
-              <a:buNone/>
-              <a:defRPr>
-                <a:solidFill>
-                  <a:schemeClr val="tx1">
-                    <a:tint val="75000"/>
-                  </a:schemeClr>
-                </a:solidFill>
-              </a:defRPr>
-            </a:lvl7pPr>
-            <a:lvl8pPr marL="3200400" indent="0" algn="ctr">
-              <a:buNone/>
-              <a:defRPr>
-                <a:solidFill>
-                  <a:schemeClr val="tx1">
-                    <a:tint val="75000"/>
-                  </a:schemeClr>
-                </a:solidFill>
-              </a:defRPr>
-            </a:lvl8pPr>
-            <a:lvl9pPr marL="3657600" indent="0" algn="ctr">
-              <a:buNone/>
-              <a:defRPr>
-                <a:solidFill>
-                  <a:schemeClr val="tx1">
-                    <a:tint val="75000"/>
-                  </a:schemeClr>
-                </a:solidFill>
-              </a:defRPr>
-            </a:lvl9pPr>
-          </a:lstStyle>
-          <a:p>
-            <a:r>
-              <a:rPr lang="en-US" smtClean="0"/>
-              <a:t>Click to edit Master subtitle style</a:t>
-            </a:r>
-            <a:endParaRPr lang="en-US"/>
-          </a:p>
-        </p:txBody>
-      </p:sp>
-      <p:sp>
-        <p:nvSpPr>
-          <p:cNvPr id="4" name="Date Placeholder 3"/>
-          <p:cNvSpPr>
-            <a:spLocks noGrp="1"/>
-          </p:cNvSpPr>
-          <p:nvPr>
-            <p:ph type="dt" sz="half" idx="10"/>
-          </p:nvPr>
-        </p:nvSpPr>
-        <p:spPr/>
-        <p:txBody>
-          <a:bodyPr/>
-          <a:lstStyle/>
-          <a:p>
-            <a:fld id="{5BCAD085-E8A6-8845-BD4E-CB4CCA059FC4}" type="datetimeFigureOut">
-              <a:rPr lang="en-US" smtClean="0"/>
-              <a:t>1/27/13</a:t>
-            </a:fld>
-            <a:endParaRPr lang="en-US"/>
-          </a:p>
-        </p:txBody>
-      </p:sp>
-      <p:sp>
-        <p:nvSpPr>
-          <p:cNvPr id="5" name="Footer Placeholder 4"/>
-          <p:cNvSpPr>
-            <a:spLocks noGrp="1"/>
-          </p:cNvSpPr>
-          <p:nvPr>
-            <p:ph type="ftr" sz="quarter" idx="11"/>
-          </p:nvPr>
-        </p:nvSpPr>
-        <p:spPr/>
-        <p:txBody>
-          <a:bodyPr/>
-          <a:lstStyle/>
-          <a:p>
-            <a:endParaRPr lang="en-US"/>
-          </a:p>
-        </p:txBody>
-      </p:sp>
-      <p:sp>
-        <p:nvSpPr>
-          <p:cNvPr id="6" name="Slide Number Placeholder 5"/>
-          <p:cNvSpPr>
-            <a:spLocks noGrp="1"/>
-          </p:cNvSpPr>
-          <p:nvPr>
-            <p:ph type="sldNum" sz="quarter" idx="12"/>
-          </p:nvPr>
-        </p:nvSpPr>
-        <p:spPr/>
-        <p:txBody>
-          <a:bodyPr/>
-          <a:lstStyle/>
-          <a:p>
-            <a:fld id="{C1FF6DA9-008F-8B48-92A6-B652298478BF}" type="slidenum">
-              <a:rPr lang="en-US" smtClean="0"/>
-              <a:t>‹#›</a:t>
-            </a:fld>
-            <a:endParaRPr lang="en-US"/>
-          </a:p>
-        </p:txBody>
-      </p:sp>
-    </p:spTree>
-    <p:extLst>
-      <p:ext uri="{BB962C8B-B14F-4D97-AF65-F5344CB8AC3E}">
-        <p14:creationId xmlns:p14="http://schemas.microsoft.com/office/powerpoint/2010/main" val="3168075583"/>
-      </p:ext>
-    </p:extLst>
-  </p:cSld>
-  <p:clrMapOvr>
-    <a:masterClrMapping/>
-  </p:clrMapOvr>
-</p:sldLayout>
-</file>
-
-<file path=ppt/slideLayouts/slideLayout10.xml><?xml version="1.0" encoding="utf-8"?>
-<p:sldLayout xmlns:a="http://schemas.openxmlformats.org/drawingml/2006/main" xmlns:r="http://schemas.openxmlformats.org/officeDocument/2006/relationships" xmlns:p="http://schemas.openxmlformats.org/presentationml/2006/main" type="vertTx" preserve="1">
-  <p:cSld name="Title and Vertical Text">
-    <p:spTree>
-      <p:nvGrpSpPr>
-        <p:cNvPr id="1" name=""/>
-        <p:cNvGrpSpPr/>
-        <p:nvPr/>
-      </p:nvGrpSpPr>
-      <p:grpSpPr>
-        <a:xfrm>
-          <a:off x="0" y="0"/>
-          <a:ext cx="0" cy="0"/>
-          <a:chOff x="0" y="0"/>
-          <a:chExt cx="0" cy="0"/>
-        </a:xfrm>
-      </p:grpSpPr>
-      <p:sp>
-        <p:nvSpPr>
-          <p:cNvPr id="2" name="Title 1"/>
-          <p:cNvSpPr>
-            <a:spLocks noGrp="1"/>
-          </p:cNvSpPr>
-          <p:nvPr>
-            <p:ph type="title"/>
-          </p:nvPr>
-        </p:nvSpPr>
-        <p:spPr/>
-        <p:txBody>
-          <a:bodyPr/>
-          <a:lstStyle/>
-          <a:p>
-            <a:r>
-              <a:rPr lang="en-US" smtClean="0"/>
-              <a:t>Click to edit Master title style</a:t>
-            </a:r>
-            <a:endParaRPr lang="en-US"/>
-          </a:p>
-        </p:txBody>
-      </p:sp>
-      <p:sp>
-        <p:nvSpPr>
-          <p:cNvPr id="3" name="Vertical Text Placeholder 2"/>
-          <p:cNvSpPr>
-            <a:spLocks noGrp="1"/>
-          </p:cNvSpPr>
-          <p:nvPr>
-            <p:ph type="body" orient="vert" idx="1"/>
-          </p:nvPr>
-        </p:nvSpPr>
-        <p:spPr/>
-        <p:txBody>
-          <a:bodyPr vert="eaVert"/>
-          <a:lstStyle/>
-          <a:p>
-            <a:pPr lvl="0"/>
-            <a:r>
-              <a:rPr lang="en-US" smtClean="0"/>
-              <a:t>Click to edit Master text styles</a:t>
-            </a:r>
-          </a:p>
-          <a:p>
-            <a:pPr lvl="1"/>
-            <a:r>
-              <a:rPr lang="en-US" smtClean="0"/>
-              <a:t>Second level</a:t>
-            </a:r>
-          </a:p>
-          <a:p>
-            <a:pPr lvl="2"/>
-            <a:r>
-              <a:rPr lang="en-US" smtClean="0"/>
-              <a:t>Third level</a:t>
-            </a:r>
-          </a:p>
-          <a:p>
-            <a:pPr lvl="3"/>
-            <a:r>
-              <a:rPr lang="en-US" smtClean="0"/>
-              <a:t>Fourth level</a:t>
-            </a:r>
-          </a:p>
-          <a:p>
-            <a:pPr lvl="4"/>
-            <a:r>
-              <a:rPr lang="en-US" smtClean="0"/>
-              <a:t>Fifth level</a:t>
-            </a:r>
-            <a:endParaRPr lang="en-US"/>
-          </a:p>
-        </p:txBody>
-      </p:sp>
-      <p:sp>
-        <p:nvSpPr>
-          <p:cNvPr id="4" name="Date Placeholder 3"/>
-          <p:cNvSpPr>
-            <a:spLocks noGrp="1"/>
-          </p:cNvSpPr>
-          <p:nvPr>
-            <p:ph type="dt" sz="half" idx="10"/>
-          </p:nvPr>
-        </p:nvSpPr>
-        <p:spPr/>
-        <p:txBody>
-          <a:bodyPr/>
-          <a:lstStyle/>
-          <a:p>
-            <a:fld id="{5BCAD085-E8A6-8845-BD4E-CB4CCA059FC4}" type="datetimeFigureOut">
-              <a:rPr lang="en-US" smtClean="0"/>
-              <a:t>1/27/13</a:t>
-            </a:fld>
-            <a:endParaRPr lang="en-US"/>
-          </a:p>
-        </p:txBody>
-      </p:sp>
-      <p:sp>
-        <p:nvSpPr>
-          <p:cNvPr id="5" name="Footer Placeholder 4"/>
-          <p:cNvSpPr>
-            <a:spLocks noGrp="1"/>
-          </p:cNvSpPr>
-          <p:nvPr>
-            <p:ph type="ftr" sz="quarter" idx="11"/>
-          </p:nvPr>
-        </p:nvSpPr>
-        <p:spPr/>
-        <p:txBody>
-          <a:bodyPr/>
-          <a:lstStyle/>
-          <a:p>
-            <a:endParaRPr lang="en-US"/>
-          </a:p>
-        </p:txBody>
-      </p:sp>
-      <p:sp>
-        <p:nvSpPr>
-          <p:cNvPr id="6" name="Slide Number Placeholder 5"/>
-          <p:cNvSpPr>
-            <a:spLocks noGrp="1"/>
-          </p:cNvSpPr>
-          <p:nvPr>
-            <p:ph type="sldNum" sz="quarter" idx="12"/>
-          </p:nvPr>
-        </p:nvSpPr>
-        <p:spPr/>
-        <p:txBody>
-          <a:bodyPr/>
-          <a:lstStyle/>
-          <a:p>
-            <a:fld id="{C1FF6DA9-008F-8B48-92A6-B652298478BF}" type="slidenum">
-              <a:rPr lang="en-US" smtClean="0"/>
-              <a:t>‹#›</a:t>
-            </a:fld>
-            <a:endParaRPr lang="en-US"/>
-          </a:p>
-        </p:txBody>
-      </p:sp>
-    </p:spTree>
-    <p:extLst>
-      <p:ext uri="{BB962C8B-B14F-4D97-AF65-F5344CB8AC3E}">
-        <p14:creationId xmlns:p14="http://schemas.microsoft.com/office/powerpoint/2010/main" val="2910927964"/>
-      </p:ext>
-    </p:extLst>
-  </p:cSld>
-  <p:clrMapOvr>
-    <a:masterClrMapping/>
-  </p:clrMapOvr>
-</p:sldLayout>
-</file>
-
-<file path=ppt/slideLayouts/slideLayout11.xml><?xml version="1.0" encoding="utf-8"?>
-<p:sldLayout xmlns:a="http://schemas.openxmlformats.org/drawingml/2006/main" xmlns:r="http://schemas.openxmlformats.org/officeDocument/2006/relationships" xmlns:p="http://schemas.openxmlformats.org/presentationml/2006/main" type="vertTitleAndTx" preserve="1">
-  <p:cSld name="Vertical Title and Text">
-    <p:spTree>
-      <p:nvGrpSpPr>
-        <p:cNvPr id="1" name=""/>
-        <p:cNvGrpSpPr/>
-        <p:nvPr/>
-      </p:nvGrpSpPr>
-      <p:grpSpPr>
-        <a:xfrm>
-          <a:off x="0" y="0"/>
-          <a:ext cx="0" cy="0"/>
-          <a:chOff x="0" y="0"/>
-          <a:chExt cx="0" cy="0"/>
-        </a:xfrm>
-      </p:grpSpPr>
-      <p:sp>
-        <p:nvSpPr>
-          <p:cNvPr id="2" name="Vertical Title 1"/>
-          <p:cNvSpPr>
-            <a:spLocks noGrp="1"/>
-          </p:cNvSpPr>
-          <p:nvPr>
-            <p:ph type="title" orient="vert"/>
-          </p:nvPr>
-        </p:nvSpPr>
-        <p:spPr>
-          <a:xfrm>
-            <a:off x="6629400" y="274638"/>
-            <a:ext cx="2057400" cy="5851525"/>
-          </a:xfrm>
-        </p:spPr>
-        <p:txBody>
-          <a:bodyPr vert="eaVert"/>
-          <a:lstStyle/>
-          <a:p>
-            <a:r>
-              <a:rPr lang="en-US" smtClean="0"/>
-              <a:t>Click to edit Master title style</a:t>
-            </a:r>
-            <a:endParaRPr lang="en-US"/>
-          </a:p>
-        </p:txBody>
-      </p:sp>
-      <p:sp>
-        <p:nvSpPr>
-          <p:cNvPr id="3" name="Vertical Text Placeholder 2"/>
-          <p:cNvSpPr>
-            <a:spLocks noGrp="1"/>
-          </p:cNvSpPr>
-          <p:nvPr>
-            <p:ph type="body" orient="vert" idx="1"/>
-          </p:nvPr>
-        </p:nvSpPr>
-        <p:spPr>
-          <a:xfrm>
-            <a:off x="457200" y="274638"/>
-            <a:ext cx="6019800" cy="5851525"/>
-          </a:xfrm>
-        </p:spPr>
-        <p:txBody>
-          <a:bodyPr vert="eaVert"/>
-          <a:lstStyle/>
-          <a:p>
-            <a:pPr lvl="0"/>
-            <a:r>
-              <a:rPr lang="en-US" smtClean="0"/>
-              <a:t>Click to edit Master text styles</a:t>
-            </a:r>
-          </a:p>
-          <a:p>
-            <a:pPr lvl="1"/>
-            <a:r>
-              <a:rPr lang="en-US" smtClean="0"/>
-              <a:t>Second level</a:t>
-            </a:r>
-          </a:p>
-          <a:p>
-            <a:pPr lvl="2"/>
-            <a:r>
-              <a:rPr lang="en-US" smtClean="0"/>
-              <a:t>Third level</a:t>
-            </a:r>
-          </a:p>
-          <a:p>
-            <a:pPr lvl="3"/>
-            <a:r>
-              <a:rPr lang="en-US" smtClean="0"/>
-              <a:t>Fourth level</a:t>
-            </a:r>
-          </a:p>
-          <a:p>
-            <a:pPr lvl="4"/>
-            <a:r>
-              <a:rPr lang="en-US" smtClean="0"/>
-              <a:t>Fifth level</a:t>
-            </a:r>
-            <a:endParaRPr lang="en-US"/>
-          </a:p>
-        </p:txBody>
-      </p:sp>
-      <p:sp>
-        <p:nvSpPr>
-          <p:cNvPr id="4" name="Date Placeholder 3"/>
-          <p:cNvSpPr>
-            <a:spLocks noGrp="1"/>
-          </p:cNvSpPr>
-          <p:nvPr>
-            <p:ph type="dt" sz="half" idx="10"/>
-          </p:nvPr>
-        </p:nvSpPr>
-        <p:spPr/>
-        <p:txBody>
-          <a:bodyPr/>
-          <a:lstStyle/>
-          <a:p>
-            <a:fld id="{5BCAD085-E8A6-8845-BD4E-CB4CCA059FC4}" type="datetimeFigureOut">
-              <a:rPr lang="en-US" smtClean="0"/>
-              <a:t>1/27/13</a:t>
-            </a:fld>
-            <a:endParaRPr lang="en-US"/>
-          </a:p>
-        </p:txBody>
-      </p:sp>
-      <p:sp>
-        <p:nvSpPr>
-          <p:cNvPr id="5" name="Footer Placeholder 4"/>
-          <p:cNvSpPr>
-            <a:spLocks noGrp="1"/>
-          </p:cNvSpPr>
-          <p:nvPr>
-            <p:ph type="ftr" sz="quarter" idx="11"/>
-          </p:nvPr>
-        </p:nvSpPr>
-        <p:spPr/>
-        <p:txBody>
-          <a:bodyPr/>
-          <a:lstStyle/>
-          <a:p>
-            <a:endParaRPr lang="en-US"/>
-          </a:p>
-        </p:txBody>
-      </p:sp>
-      <p:sp>
-        <p:nvSpPr>
-          <p:cNvPr id="6" name="Slide Number Placeholder 5"/>
-          <p:cNvSpPr>
-            <a:spLocks noGrp="1"/>
-          </p:cNvSpPr>
-          <p:nvPr>
-            <p:ph type="sldNum" sz="quarter" idx="12"/>
-          </p:nvPr>
-        </p:nvSpPr>
-        <p:spPr/>
-        <p:txBody>
-          <a:bodyPr/>
-          <a:lstStyle/>
-          <a:p>
-            <a:fld id="{C1FF6DA9-008F-8B48-92A6-B652298478BF}" type="slidenum">
-              <a:rPr lang="en-US" smtClean="0"/>
-              <a:t>‹#›</a:t>
-            </a:fld>
-            <a:endParaRPr lang="en-US"/>
-          </a:p>
-        </p:txBody>
-      </p:sp>
-    </p:spTree>
-    <p:extLst>
-      <p:ext uri="{BB962C8B-B14F-4D97-AF65-F5344CB8AC3E}">
-        <p14:creationId xmlns:p14="http://schemas.microsoft.com/office/powerpoint/2010/main" val="3612223792"/>
-      </p:ext>
-    </p:extLst>
-  </p:cSld>
-  <p:clrMapOvr>
-    <a:masterClrMapping/>
-  </p:clrMapOvr>
-</p:sldLayout>
-</file>
-
-<file path=ppt/slideLayouts/slideLayout2.xml><?xml version="1.0" encoding="utf-8"?>
-<p:sldLayout xmlns:a="http://schemas.openxmlformats.org/drawingml/2006/main" xmlns:r="http://schemas.openxmlformats.org/officeDocument/2006/relationships" xmlns:p="http://schemas.openxmlformats.org/presentationml/2006/main" type="obj" preserve="1">
-  <p:cSld name="Title and Content">
-    <p:spTree>
-      <p:nvGrpSpPr>
-        <p:cNvPr id="1" name=""/>
-        <p:cNvGrpSpPr/>
-        <p:nvPr/>
-      </p:nvGrpSpPr>
-      <p:grpSpPr>
-        <a:xfrm>
-          <a:off x="0" y="0"/>
-          <a:ext cx="0" cy="0"/>
-          <a:chOff x="0" y="0"/>
-          <a:chExt cx="0" cy="0"/>
-        </a:xfrm>
-      </p:grpSpPr>
-      <p:sp>
-        <p:nvSpPr>
-          <p:cNvPr id="2" name="Title 1"/>
-          <p:cNvSpPr>
-            <a:spLocks noGrp="1"/>
-          </p:cNvSpPr>
-          <p:nvPr>
-            <p:ph type="title"/>
-          </p:nvPr>
-        </p:nvSpPr>
-        <p:spPr/>
-        <p:txBody>
-          <a:bodyPr/>
-          <a:lstStyle/>
-          <a:p>
-            <a:r>
-              <a:rPr lang="en-US" smtClean="0"/>
-              <a:t>Click to edit Master title style</a:t>
-            </a:r>
-            <a:endParaRPr lang="en-US"/>
-          </a:p>
-        </p:txBody>
-      </p:sp>
-      <p:sp>
-        <p:nvSpPr>
-          <p:cNvPr id="3" name="Content Placeholder 2"/>
-          <p:cNvSpPr>
-            <a:spLocks noGrp="1"/>
-          </p:cNvSpPr>
-          <p:nvPr>
-            <p:ph idx="1"/>
-          </p:nvPr>
-        </p:nvSpPr>
-        <p:spPr/>
-        <p:txBody>
-          <a:bodyPr/>
-          <a:lstStyle/>
-          <a:p>
-            <a:pPr lvl="0"/>
-            <a:r>
-              <a:rPr lang="en-US" smtClean="0"/>
-              <a:t>Click to edit Master text styles</a:t>
-            </a:r>
-          </a:p>
-          <a:p>
-            <a:pPr lvl="1"/>
-            <a:r>
-              <a:rPr lang="en-US" smtClean="0"/>
-              <a:t>Second level</a:t>
-            </a:r>
-          </a:p>
-          <a:p>
-            <a:pPr lvl="2"/>
-            <a:r>
-              <a:rPr lang="en-US" smtClean="0"/>
-              <a:t>Third level</a:t>
-            </a:r>
-          </a:p>
-          <a:p>
-            <a:pPr lvl="3"/>
-            <a:r>
-              <a:rPr lang="en-US" smtClean="0"/>
-              <a:t>Fourth level</a:t>
-            </a:r>
-          </a:p>
-          <a:p>
-            <a:pPr lvl="4"/>
-            <a:r>
-              <a:rPr lang="en-US" smtClean="0"/>
-              <a:t>Fifth level</a:t>
-            </a:r>
-            <a:endParaRPr lang="en-US"/>
-          </a:p>
-        </p:txBody>
-      </p:sp>
-      <p:sp>
-        <p:nvSpPr>
-          <p:cNvPr id="4" name="Date Placeholder 3"/>
-          <p:cNvSpPr>
-            <a:spLocks noGrp="1"/>
-          </p:cNvSpPr>
-          <p:nvPr>
-            <p:ph type="dt" sz="half" idx="10"/>
-          </p:nvPr>
-        </p:nvSpPr>
-        <p:spPr/>
-        <p:txBody>
-          <a:bodyPr/>
-          <a:lstStyle/>
-          <a:p>
-            <a:fld id="{5BCAD085-E8A6-8845-BD4E-CB4CCA059FC4}" type="datetimeFigureOut">
-              <a:rPr lang="en-US" smtClean="0"/>
-              <a:t>1/27/13</a:t>
-            </a:fld>
-            <a:endParaRPr lang="en-US"/>
-          </a:p>
-        </p:txBody>
-      </p:sp>
-      <p:sp>
-        <p:nvSpPr>
-          <p:cNvPr id="5" name="Footer Placeholder 4"/>
-          <p:cNvSpPr>
-            <a:spLocks noGrp="1"/>
-          </p:cNvSpPr>
-          <p:nvPr>
-            <p:ph type="ftr" sz="quarter" idx="11"/>
-          </p:nvPr>
-        </p:nvSpPr>
-        <p:spPr/>
-        <p:txBody>
-          <a:bodyPr/>
-          <a:lstStyle/>
-          <a:p>
-            <a:endParaRPr lang="en-US"/>
-          </a:p>
-        </p:txBody>
-      </p:sp>
-      <p:sp>
-        <p:nvSpPr>
-          <p:cNvPr id="6" name="Slide Number Placeholder 5"/>
-          <p:cNvSpPr>
-            <a:spLocks noGrp="1"/>
-          </p:cNvSpPr>
-          <p:nvPr>
-            <p:ph type="sldNum" sz="quarter" idx="12"/>
-          </p:nvPr>
-        </p:nvSpPr>
-        <p:spPr/>
-        <p:txBody>
-          <a:bodyPr/>
-          <a:lstStyle/>
-          <a:p>
-            <a:fld id="{C1FF6DA9-008F-8B48-92A6-B652298478BF}" type="slidenum">
-              <a:rPr lang="en-US" smtClean="0"/>
-              <a:t>‹#›</a:t>
-            </a:fld>
-            <a:endParaRPr lang="en-US"/>
-          </a:p>
-        </p:txBody>
-      </p:sp>
-    </p:spTree>
-    <p:extLst>
-      <p:ext uri="{BB962C8B-B14F-4D97-AF65-F5344CB8AC3E}">
-        <p14:creationId xmlns:p14="http://schemas.microsoft.com/office/powerpoint/2010/main" val="2614314258"/>
-      </p:ext>
-    </p:extLst>
-  </p:cSld>
-  <p:clrMapOvr>
-    <a:masterClrMapping/>
-  </p:clrMapOvr>
-</p:sldLayout>
-</file>
-
-<file path=ppt/slideLayouts/slideLayout3.xml><?xml version="1.0" encoding="utf-8"?>
-<p:sldLayout xmlns:a="http://schemas.openxmlformats.org/drawingml/2006/main" xmlns:r="http://schemas.openxmlformats.org/officeDocument/2006/relationships" xmlns:p="http://schemas.openxmlformats.org/presentationml/2006/main" type="secHead" preserve="1">
-  <p:cSld name="Section Header">
-    <p:spTree>
-      <p:nvGrpSpPr>
-        <p:cNvPr id="1" name=""/>
-        <p:cNvGrpSpPr/>
-        <p:nvPr/>
-      </p:nvGrpSpPr>
-      <p:grpSpPr>
-        <a:xfrm>
-          <a:off x="0" y="0"/>
-          <a:ext cx="0" cy="0"/>
-          <a:chOff x="0" y="0"/>
-          <a:chExt cx="0" cy="0"/>
-        </a:xfrm>
-      </p:grpSpPr>
-      <p:sp>
-        <p:nvSpPr>
-          <p:cNvPr id="2" name="Title 1"/>
-          <p:cNvSpPr>
-            <a:spLocks noGrp="1"/>
-          </p:cNvSpPr>
-          <p:nvPr>
-            <p:ph type="title"/>
-          </p:nvPr>
-        </p:nvSpPr>
-        <p:spPr>
-          <a:xfrm>
-            <a:off x="722313" y="4406900"/>
-            <a:ext cx="7772400" cy="1362075"/>
-          </a:xfrm>
-        </p:spPr>
-        <p:txBody>
-          <a:bodyPr anchor="t"/>
-          <a:lstStyle>
-            <a:lvl1pPr algn="l">
-              <a:defRPr sz="4000" b="1" cap="all"/>
-            </a:lvl1pPr>
-          </a:lstStyle>
-          <a:p>
-            <a:r>
-              <a:rPr lang="en-US" smtClean="0"/>
-              <a:t>Click to edit Master title style</a:t>
-            </a:r>
-            <a:endParaRPr lang="en-US"/>
-          </a:p>
-        </p:txBody>
-      </p:sp>
-      <p:sp>
-        <p:nvSpPr>
-          <p:cNvPr id="3" name="Text Placeholder 2"/>
-          <p:cNvSpPr>
-            <a:spLocks noGrp="1"/>
-          </p:cNvSpPr>
-          <p:nvPr>
-            <p:ph type="body" idx="1"/>
-          </p:nvPr>
-        </p:nvSpPr>
-        <p:spPr>
-          <a:xfrm>
-            <a:off x="722313" y="2906713"/>
-            <a:ext cx="7772400" cy="1500187"/>
-          </a:xfrm>
-        </p:spPr>
-        <p:txBody>
-          <a:bodyPr anchor="b"/>
-          <a:lstStyle>
-            <a:lvl1pPr marL="0" indent="0">
-              <a:buNone/>
-              <a:defRPr sz="2000">
-                <a:solidFill>
-                  <a:schemeClr val="tx1">
-                    <a:tint val="75000"/>
-                  </a:schemeClr>
-                </a:solidFill>
-              </a:defRPr>
-            </a:lvl1pPr>
-            <a:lvl2pPr marL="457200" indent="0">
-              <a:buNone/>
-              <a:defRPr sz="1800">
-                <a:solidFill>
-                  <a:schemeClr val="tx1">
-                    <a:tint val="75000"/>
-                  </a:schemeClr>
-                </a:solidFill>
-              </a:defRPr>
-            </a:lvl2pPr>
-            <a:lvl3pPr marL="914400" indent="0">
-              <a:buNone/>
-              <a:defRPr sz="1600">
-                <a:solidFill>
-                  <a:schemeClr val="tx1">
-                    <a:tint val="75000"/>
-                  </a:schemeClr>
-                </a:solidFill>
-              </a:defRPr>
-            </a:lvl3pPr>
-            <a:lvl4pPr marL="1371600" indent="0">
-              <a:buNone/>
-              <a:defRPr sz="1400">
-                <a:solidFill>
-                  <a:schemeClr val="tx1">
-                    <a:tint val="75000"/>
-                  </a:schemeClr>
-                </a:solidFill>
-              </a:defRPr>
-            </a:lvl4pPr>
-            <a:lvl5pPr marL="1828800" indent="0">
-              <a:buNone/>
-              <a:defRPr sz="1400">
-                <a:solidFill>
-                  <a:schemeClr val="tx1">
-                    <a:tint val="75000"/>
-                  </a:schemeClr>
-                </a:solidFill>
-              </a:defRPr>
-            </a:lvl5pPr>
-            <a:lvl6pPr marL="2286000" indent="0">
-              <a:buNone/>
-              <a:defRPr sz="1400">
-                <a:solidFill>
-                  <a:schemeClr val="tx1">
-                    <a:tint val="75000"/>
-                  </a:schemeClr>
-                </a:solidFill>
-              </a:defRPr>
-            </a:lvl6pPr>
-            <a:lvl7pPr marL="2743200" indent="0">
-              <a:buNone/>
-              <a:defRPr sz="1400">
-                <a:solidFill>
-                  <a:schemeClr val="tx1">
-                    <a:tint val="75000"/>
-                  </a:schemeClr>
-                </a:solidFill>
-              </a:defRPr>
-            </a:lvl7pPr>
-            <a:lvl8pPr marL="3200400" indent="0">
-              <a:buNone/>
-              <a:defRPr sz="1400">
-                <a:solidFill>
-                  <a:schemeClr val="tx1">
-                    <a:tint val="75000"/>
-                  </a:schemeClr>
-                </a:solidFill>
-              </a:defRPr>
-            </a:lvl8pPr>
-            <a:lvl9pPr marL="3657600" indent="0">
-              <a:buNone/>
-              <a:defRPr sz="1400">
-                <a:solidFill>
-                  <a:schemeClr val="tx1">
-                    <a:tint val="75000"/>
-                  </a:schemeClr>
-                </a:solidFill>
-              </a:defRPr>
-            </a:lvl9pPr>
-          </a:lstStyle>
-          <a:p>
-            <a:pPr lvl="0"/>
-            <a:r>
-              <a:rPr lang="en-US" smtClean="0"/>
-              <a:t>Click to edit Master text styles</a:t>
-            </a:r>
-          </a:p>
-        </p:txBody>
-      </p:sp>
-      <p:sp>
-        <p:nvSpPr>
-          <p:cNvPr id="4" name="Date Placeholder 3"/>
-          <p:cNvSpPr>
-            <a:spLocks noGrp="1"/>
-          </p:cNvSpPr>
-          <p:nvPr>
-            <p:ph type="dt" sz="half" idx="10"/>
-          </p:nvPr>
-        </p:nvSpPr>
-        <p:spPr/>
-        <p:txBody>
-          <a:bodyPr/>
-          <a:lstStyle/>
-          <a:p>
-            <a:fld id="{5BCAD085-E8A6-8845-BD4E-CB4CCA059FC4}" type="datetimeFigureOut">
-              <a:rPr lang="en-US" smtClean="0"/>
-              <a:t>1/27/13</a:t>
-            </a:fld>
-            <a:endParaRPr lang="en-US"/>
-          </a:p>
-        </p:txBody>
-      </p:sp>
-      <p:sp>
-        <p:nvSpPr>
-          <p:cNvPr id="5" name="Footer Placeholder 4"/>
-          <p:cNvSpPr>
-            <a:spLocks noGrp="1"/>
-          </p:cNvSpPr>
-          <p:nvPr>
-            <p:ph type="ftr" sz="quarter" idx="11"/>
-          </p:nvPr>
-        </p:nvSpPr>
-        <p:spPr/>
-        <p:txBody>
-          <a:bodyPr/>
-          <a:lstStyle/>
-          <a:p>
-            <a:endParaRPr lang="en-US"/>
-          </a:p>
-        </p:txBody>
-      </p:sp>
-      <p:sp>
-        <p:nvSpPr>
-          <p:cNvPr id="6" name="Slide Number Placeholder 5"/>
-          <p:cNvSpPr>
-            <a:spLocks noGrp="1"/>
-          </p:cNvSpPr>
-          <p:nvPr>
-            <p:ph type="sldNum" sz="quarter" idx="12"/>
-          </p:nvPr>
-        </p:nvSpPr>
-        <p:spPr/>
-        <p:txBody>
-          <a:bodyPr/>
-          <a:lstStyle/>
-          <a:p>
-            <a:fld id="{C1FF6DA9-008F-8B48-92A6-B652298478BF}" type="slidenum">
-              <a:rPr lang="en-US" smtClean="0"/>
-              <a:t>‹#›</a:t>
-            </a:fld>
-            <a:endParaRPr lang="en-US"/>
-          </a:p>
-        </p:txBody>
-      </p:sp>
-    </p:spTree>
-    <p:extLst>
-      <p:ext uri="{BB962C8B-B14F-4D97-AF65-F5344CB8AC3E}">
-        <p14:creationId xmlns:p14="http://schemas.microsoft.com/office/powerpoint/2010/main" val="960648375"/>
-      </p:ext>
-    </p:extLst>
-  </p:cSld>
-  <p:clrMapOvr>
-    <a:masterClrMapping/>
-  </p:clrMapOvr>
-</p:sldLayout>
-</file>
-
-<file path=ppt/slideLayouts/slideLayout4.xml><?xml version="1.0" encoding="utf-8"?>
-<p:sldLayout xmlns:a="http://schemas.openxmlformats.org/drawingml/2006/main" xmlns:r="http://schemas.openxmlformats.org/officeDocument/2006/relationships" xmlns:p="http://schemas.openxmlformats.org/presentationml/2006/main" type="twoObj" preserve="1">
-  <p:cSld name="Two Content">
-    <p:spTree>
-      <p:nvGrpSpPr>
-        <p:cNvPr id="1" name=""/>
-        <p:cNvGrpSpPr/>
-        <p:nvPr/>
-      </p:nvGrpSpPr>
-      <p:grpSpPr>
-        <a:xfrm>
-          <a:off x="0" y="0"/>
-          <a:ext cx="0" cy="0"/>
-          <a:chOff x="0" y="0"/>
-          <a:chExt cx="0" cy="0"/>
-        </a:xfrm>
-      </p:grpSpPr>
-      <p:sp>
-        <p:nvSpPr>
-          <p:cNvPr id="2" name="Title 1"/>
-          <p:cNvSpPr>
-            <a:spLocks noGrp="1"/>
-          </p:cNvSpPr>
-          <p:nvPr>
-            <p:ph type="title"/>
-          </p:nvPr>
-        </p:nvSpPr>
-        <p:spPr/>
-        <p:txBody>
-          <a:bodyPr/>
-          <a:lstStyle/>
-          <a:p>
-            <a:r>
-              <a:rPr lang="en-US" smtClean="0"/>
-              <a:t>Click to edit Master title style</a:t>
-            </a:r>
-            <a:endParaRPr lang="en-US"/>
-          </a:p>
-        </p:txBody>
-      </p:sp>
-      <p:sp>
-        <p:nvSpPr>
-          <p:cNvPr id="3" name="Content Placeholder 2"/>
-          <p:cNvSpPr>
-            <a:spLocks noGrp="1"/>
-          </p:cNvSpPr>
-          <p:nvPr>
-            <p:ph sz="half" idx="1"/>
-          </p:nvPr>
-        </p:nvSpPr>
-        <p:spPr>
-          <a:xfrm>
-            <a:off x="457200" y="1600200"/>
-            <a:ext cx="4038600" cy="4525963"/>
-          </a:xfrm>
-        </p:spPr>
-        <p:txBody>
-          <a:bodyPr/>
-          <a:lstStyle>
-            <a:lvl1pPr>
-              <a:defRPr sz="2800"/>
-            </a:lvl1pPr>
-            <a:lvl2pPr>
-              <a:defRPr sz="2400"/>
-            </a:lvl2pPr>
-            <a:lvl3pPr>
-              <a:defRPr sz="2000"/>
-            </a:lvl3pPr>
-            <a:lvl4pPr>
-              <a:defRPr sz="1800"/>
-            </a:lvl4pPr>
-            <a:lvl5pPr>
-              <a:defRPr sz="1800"/>
-            </a:lvl5pPr>
-            <a:lvl6pPr>
-              <a:defRPr sz="1800"/>
-            </a:lvl6pPr>
-            <a:lvl7pPr>
-              <a:defRPr sz="1800"/>
-            </a:lvl7pPr>
-            <a:lvl8pPr>
-              <a:defRPr sz="1800"/>
-            </a:lvl8pPr>
-            <a:lvl9pPr>
-              <a:defRPr sz="1800"/>
-            </a:lvl9pPr>
-          </a:lstStyle>
-          <a:p>
-            <a:pPr lvl="0"/>
-            <a:r>
-              <a:rPr lang="en-US" smtClean="0"/>
-              <a:t>Click to edit Master text styles</a:t>
-            </a:r>
-          </a:p>
-          <a:p>
-            <a:pPr lvl="1"/>
-            <a:r>
-              <a:rPr lang="en-US" smtClean="0"/>
-              <a:t>Second level</a:t>
-            </a:r>
-          </a:p>
-          <a:p>
-            <a:pPr lvl="2"/>
-            <a:r>
-              <a:rPr lang="en-US" smtClean="0"/>
-              <a:t>Third level</a:t>
-            </a:r>
-          </a:p>
-          <a:p>
-            <a:pPr lvl="3"/>
-            <a:r>
-              <a:rPr lang="en-US" smtClean="0"/>
-              <a:t>Fourth level</a:t>
-            </a:r>
-          </a:p>
-          <a:p>
-            <a:pPr lvl="4"/>
-            <a:r>
-              <a:rPr lang="en-US" smtClean="0"/>
-              <a:t>Fifth level</a:t>
-            </a:r>
-            <a:endParaRPr lang="en-US"/>
-          </a:p>
-        </p:txBody>
-      </p:sp>
-      <p:sp>
-        <p:nvSpPr>
-          <p:cNvPr id="4" name="Content Placeholder 3"/>
-          <p:cNvSpPr>
-            <a:spLocks noGrp="1"/>
-          </p:cNvSpPr>
-          <p:nvPr>
-            <p:ph sz="half" idx="2"/>
-          </p:nvPr>
-        </p:nvSpPr>
-        <p:spPr>
-          <a:xfrm>
-            <a:off x="4648200" y="1600200"/>
-            <a:ext cx="4038600" cy="4525963"/>
-          </a:xfrm>
-        </p:spPr>
-        <p:txBody>
-          <a:bodyPr/>
-          <a:lstStyle>
-            <a:lvl1pPr>
-              <a:defRPr sz="2800"/>
-            </a:lvl1pPr>
-            <a:lvl2pPr>
-              <a:defRPr sz="2400"/>
-            </a:lvl2pPr>
-            <a:lvl3pPr>
-              <a:defRPr sz="2000"/>
-            </a:lvl3pPr>
-            <a:lvl4pPr>
-              <a:defRPr sz="1800"/>
-            </a:lvl4pPr>
-            <a:lvl5pPr>
-              <a:defRPr sz="1800"/>
-            </a:lvl5pPr>
-            <a:lvl6pPr>
-              <a:defRPr sz="1800"/>
-            </a:lvl6pPr>
-            <a:lvl7pPr>
-              <a:defRPr sz="1800"/>
-            </a:lvl7pPr>
-            <a:lvl8pPr>
-              <a:defRPr sz="1800"/>
-            </a:lvl8pPr>
-            <a:lvl9pPr>
-              <a:defRPr sz="1800"/>
-            </a:lvl9pPr>
-          </a:lstStyle>
-          <a:p>
-            <a:pPr lvl="0"/>
-            <a:r>
-              <a:rPr lang="en-US" smtClean="0"/>
-              <a:t>Click to edit Master text styles</a:t>
-            </a:r>
-          </a:p>
-          <a:p>
-            <a:pPr lvl="1"/>
-            <a:r>
-              <a:rPr lang="en-US" smtClean="0"/>
-              <a:t>Second level</a:t>
-            </a:r>
-          </a:p>
-          <a:p>
-            <a:pPr lvl="2"/>
-            <a:r>
-              <a:rPr lang="en-US" smtClean="0"/>
-              <a:t>Third level</a:t>
-            </a:r>
-          </a:p>
-          <a:p>
-            <a:pPr lvl="3"/>
-            <a:r>
-              <a:rPr lang="en-US" smtClean="0"/>
-              <a:t>Fourth level</a:t>
-            </a:r>
-          </a:p>
-          <a:p>
-            <a:pPr lvl="4"/>
-            <a:r>
-              <a:rPr lang="en-US" smtClean="0"/>
-              <a:t>Fifth level</a:t>
-            </a:r>
-            <a:endParaRPr lang="en-US"/>
-          </a:p>
-        </p:txBody>
-      </p:sp>
-      <p:sp>
-        <p:nvSpPr>
-          <p:cNvPr id="5" name="Date Placeholder 4"/>
-          <p:cNvSpPr>
-            <a:spLocks noGrp="1"/>
-          </p:cNvSpPr>
-          <p:nvPr>
-            <p:ph type="dt" sz="half" idx="10"/>
-          </p:nvPr>
-        </p:nvSpPr>
-        <p:spPr/>
-        <p:txBody>
-          <a:bodyPr/>
-          <a:lstStyle/>
-          <a:p>
-            <a:fld id="{5BCAD085-E8A6-8845-BD4E-CB4CCA059FC4}" type="datetimeFigureOut">
-              <a:rPr lang="en-US" smtClean="0"/>
-              <a:t>1/27/13</a:t>
-            </a:fld>
-            <a:endParaRPr lang="en-US"/>
-          </a:p>
-        </p:txBody>
-      </p:sp>
-      <p:sp>
-        <p:nvSpPr>
-          <p:cNvPr id="6" name="Footer Placeholder 5"/>
-          <p:cNvSpPr>
-            <a:spLocks noGrp="1"/>
-          </p:cNvSpPr>
-          <p:nvPr>
-            <p:ph type="ftr" sz="quarter" idx="11"/>
-          </p:nvPr>
-        </p:nvSpPr>
-        <p:spPr/>
-        <p:txBody>
-          <a:bodyPr/>
-          <a:lstStyle/>
-          <a:p>
-            <a:endParaRPr lang="en-US"/>
-          </a:p>
-        </p:txBody>
-      </p:sp>
-      <p:sp>
-        <p:nvSpPr>
-          <p:cNvPr id="7" name="Slide Number Placeholder 6"/>
-          <p:cNvSpPr>
-            <a:spLocks noGrp="1"/>
-          </p:cNvSpPr>
-          <p:nvPr>
-            <p:ph type="sldNum" sz="quarter" idx="12"/>
-          </p:nvPr>
-        </p:nvSpPr>
-        <p:spPr/>
-        <p:txBody>
-          <a:bodyPr/>
-          <a:lstStyle/>
-          <a:p>
-            <a:fld id="{C1FF6DA9-008F-8B48-92A6-B652298478BF}" type="slidenum">
-              <a:rPr lang="en-US" smtClean="0"/>
-              <a:t>‹#›</a:t>
-            </a:fld>
-            <a:endParaRPr lang="en-US"/>
-          </a:p>
-        </p:txBody>
-      </p:sp>
-    </p:spTree>
-    <p:extLst>
-      <p:ext uri="{BB962C8B-B14F-4D97-AF65-F5344CB8AC3E}">
-        <p14:creationId xmlns:p14="http://schemas.microsoft.com/office/powerpoint/2010/main" val="2782244947"/>
-      </p:ext>
-    </p:extLst>
-  </p:cSld>
-  <p:clrMapOvr>
-    <a:masterClrMapping/>
-  </p:clrMapOvr>
-</p:sldLayout>
-</file>
-
-<file path=ppt/slideLayouts/slideLayout5.xml><?xml version="1.0" encoding="utf-8"?>
-<p:sldLayout xmlns:a="http://schemas.openxmlformats.org/drawingml/2006/main" xmlns:r="http://schemas.openxmlformats.org/officeDocument/2006/relationships" xmlns:p="http://schemas.openxmlformats.org/presentationml/2006/main" type="twoTxTwoObj" preserve="1">
-  <p:cSld name="Comparison">
-    <p:spTree>
-      <p:nvGrpSpPr>
-        <p:cNvPr id="1" name=""/>
-        <p:cNvGrpSpPr/>
-        <p:nvPr/>
-      </p:nvGrpSpPr>
-      <p:grpSpPr>
-        <a:xfrm>
-          <a:off x="0" y="0"/>
-          <a:ext cx="0" cy="0"/>
-          <a:chOff x="0" y="0"/>
-          <a:chExt cx="0" cy="0"/>
-        </a:xfrm>
-      </p:grpSpPr>
-      <p:sp>
-        <p:nvSpPr>
-          <p:cNvPr id="2" name="Title 1"/>
-          <p:cNvSpPr>
-            <a:spLocks noGrp="1"/>
-          </p:cNvSpPr>
-          <p:nvPr>
-            <p:ph type="title"/>
-          </p:nvPr>
-        </p:nvSpPr>
-        <p:spPr/>
-        <p:txBody>
-          <a:bodyPr/>
-          <a:lstStyle>
-            <a:lvl1pPr>
-              <a:defRPr/>
-            </a:lvl1pPr>
-          </a:lstStyle>
-          <a:p>
-            <a:r>
-              <a:rPr lang="en-US" smtClean="0"/>
-              <a:t>Click to edit Master title style</a:t>
-            </a:r>
-            <a:endParaRPr lang="en-US"/>
-          </a:p>
-        </p:txBody>
-      </p:sp>
-      <p:sp>
-        <p:nvSpPr>
-          <p:cNvPr id="3" name="Text Placeholder 2"/>
-          <p:cNvSpPr>
-            <a:spLocks noGrp="1"/>
-          </p:cNvSpPr>
-          <p:nvPr>
-            <p:ph type="body" idx="1"/>
-          </p:nvPr>
-        </p:nvSpPr>
-        <p:spPr>
-          <a:xfrm>
-            <a:off x="457200" y="1535113"/>
-            <a:ext cx="4040188" cy="639762"/>
-          </a:xfrm>
-        </p:spPr>
-        <p:txBody>
-          <a:bodyPr anchor="b"/>
-          <a:lstStyle>
-            <a:lvl1pPr marL="0" indent="0">
-              <a:buNone/>
-              <a:defRPr sz="2400" b="1"/>
-            </a:lvl1pPr>
-            <a:lvl2pPr marL="457200" indent="0">
-              <a:buNone/>
-              <a:defRPr sz="2000" b="1"/>
-            </a:lvl2pPr>
-            <a:lvl3pPr marL="914400" indent="0">
-              <a:buNone/>
-              <a:defRPr sz="1800" b="1"/>
-            </a:lvl3pPr>
-            <a:lvl4pPr marL="1371600" indent="0">
-              <a:buNone/>
-              <a:defRPr sz="1600" b="1"/>
-            </a:lvl4pPr>
-            <a:lvl5pPr marL="1828800" indent="0">
-              <a:buNone/>
-              <a:defRPr sz="1600" b="1"/>
-            </a:lvl5pPr>
-            <a:lvl6pPr marL="2286000" indent="0">
-              <a:buNone/>
-              <a:defRPr sz="1600" b="1"/>
-            </a:lvl6pPr>
-            <a:lvl7pPr marL="2743200" indent="0">
-              <a:buNone/>
-              <a:defRPr sz="1600" b="1"/>
-            </a:lvl7pPr>
-            <a:lvl8pPr marL="3200400" indent="0">
-              <a:buNone/>
-              <a:defRPr sz="1600" b="1"/>
-            </a:lvl8pPr>
-            <a:lvl9pPr marL="3657600" indent="0">
-              <a:buNone/>
-              <a:defRPr sz="1600" b="1"/>
-            </a:lvl9pPr>
-          </a:lstStyle>
-          <a:p>
-            <a:pPr lvl="0"/>
-            <a:r>
-              <a:rPr lang="en-US" smtClean="0"/>
-              <a:t>Click to edit Master text styles</a:t>
-            </a:r>
-          </a:p>
-        </p:txBody>
-      </p:sp>
-      <p:sp>
-        <p:nvSpPr>
-          <p:cNvPr id="4" name="Content Placeholder 3"/>
-          <p:cNvSpPr>
-            <a:spLocks noGrp="1"/>
-          </p:cNvSpPr>
-          <p:nvPr>
-            <p:ph sz="half" idx="2"/>
-          </p:nvPr>
-        </p:nvSpPr>
-        <p:spPr>
-          <a:xfrm>
-            <a:off x="457200" y="2174875"/>
-            <a:ext cx="4040188" cy="3951288"/>
-          </a:xfrm>
-        </p:spPr>
-        <p:txBody>
-          <a:bodyPr/>
-          <a:lstStyle>
-            <a:lvl1pPr>
-              <a:defRPr sz="2400"/>
-            </a:lvl1pPr>
-            <a:lvl2pPr>
-              <a:defRPr sz="2000"/>
-            </a:lvl2pPr>
-            <a:lvl3pPr>
-              <a:defRPr sz="1800"/>
-            </a:lvl3pPr>
-            <a:lvl4pPr>
-              <a:defRPr sz="1600"/>
-            </a:lvl4pPr>
-            <a:lvl5pPr>
-              <a:defRPr sz="1600"/>
-            </a:lvl5pPr>
-            <a:lvl6pPr>
-              <a:defRPr sz="1600"/>
-            </a:lvl6pPr>
-            <a:lvl7pPr>
-              <a:defRPr sz="1600"/>
-            </a:lvl7pPr>
-            <a:lvl8pPr>
-              <a:defRPr sz="1600"/>
-            </a:lvl8pPr>
-            <a:lvl9pPr>
-              <a:defRPr sz="1600"/>
-            </a:lvl9pPr>
-          </a:lstStyle>
-          <a:p>
-            <a:pPr lvl="0"/>
-            <a:r>
-              <a:rPr lang="en-US" smtClean="0"/>
-              <a:t>Click to edit Master text styles</a:t>
-            </a:r>
-          </a:p>
-          <a:p>
-            <a:pPr lvl="1"/>
-            <a:r>
-              <a:rPr lang="en-US" smtClean="0"/>
-              <a:t>Second level</a:t>
-            </a:r>
-          </a:p>
-          <a:p>
-            <a:pPr lvl="2"/>
-            <a:r>
-              <a:rPr lang="en-US" smtClean="0"/>
-              <a:t>Third level</a:t>
-            </a:r>
-          </a:p>
-          <a:p>
-            <a:pPr lvl="3"/>
-            <a:r>
-              <a:rPr lang="en-US" smtClean="0"/>
-              <a:t>Fourth level</a:t>
-            </a:r>
-          </a:p>
-          <a:p>
-            <a:pPr lvl="4"/>
-            <a:r>
-              <a:rPr lang="en-US" smtClean="0"/>
-              <a:t>Fifth level</a:t>
-            </a:r>
-            <a:endParaRPr lang="en-US"/>
-          </a:p>
-        </p:txBody>
-      </p:sp>
-      <p:sp>
-        <p:nvSpPr>
-          <p:cNvPr id="5" name="Text Placeholder 4"/>
-          <p:cNvSpPr>
-            <a:spLocks noGrp="1"/>
-          </p:cNvSpPr>
-          <p:nvPr>
-            <p:ph type="body" sz="quarter" idx="3"/>
-          </p:nvPr>
-        </p:nvSpPr>
-        <p:spPr>
-          <a:xfrm>
-            <a:off x="4645025" y="1535113"/>
-            <a:ext cx="4041775" cy="639762"/>
-          </a:xfrm>
-        </p:spPr>
-        <p:txBody>
-          <a:bodyPr anchor="b"/>
-          <a:lstStyle>
-            <a:lvl1pPr marL="0" indent="0">
-              <a:buNone/>
-              <a:defRPr sz="2400" b="1"/>
-            </a:lvl1pPr>
-            <a:lvl2pPr marL="457200" indent="0">
-              <a:buNone/>
-              <a:defRPr sz="2000" b="1"/>
-            </a:lvl2pPr>
-            <a:lvl3pPr marL="914400" indent="0">
-              <a:buNone/>
-              <a:defRPr sz="1800" b="1"/>
-            </a:lvl3pPr>
-            <a:lvl4pPr marL="1371600" indent="0">
-              <a:buNone/>
-              <a:defRPr sz="1600" b="1"/>
-            </a:lvl4pPr>
-            <a:lvl5pPr marL="1828800" indent="0">
-              <a:buNone/>
-              <a:defRPr sz="1600" b="1"/>
-            </a:lvl5pPr>
-            <a:lvl6pPr marL="2286000" indent="0">
-              <a:buNone/>
-              <a:defRPr sz="1600" b="1"/>
-            </a:lvl6pPr>
-            <a:lvl7pPr marL="2743200" indent="0">
-              <a:buNone/>
-              <a:defRPr sz="1600" b="1"/>
-            </a:lvl7pPr>
-            <a:lvl8pPr marL="3200400" indent="0">
-              <a:buNone/>
-              <a:defRPr sz="1600" b="1"/>
-            </a:lvl8pPr>
-            <a:lvl9pPr marL="3657600" indent="0">
-              <a:buNone/>
-              <a:defRPr sz="1600" b="1"/>
-            </a:lvl9pPr>
-          </a:lstStyle>
-          <a:p>
-            <a:pPr lvl="0"/>
-            <a:r>
-              <a:rPr lang="en-US" smtClean="0"/>
-              <a:t>Click to edit Master text styles</a:t>
-            </a:r>
-          </a:p>
-        </p:txBody>
-      </p:sp>
-      <p:sp>
-        <p:nvSpPr>
-          <p:cNvPr id="6" name="Content Placeholder 5"/>
-          <p:cNvSpPr>
-            <a:spLocks noGrp="1"/>
-          </p:cNvSpPr>
-          <p:nvPr>
-            <p:ph sz="quarter" idx="4"/>
-          </p:nvPr>
-        </p:nvSpPr>
-        <p:spPr>
-          <a:xfrm>
-            <a:off x="4645025" y="2174875"/>
-            <a:ext cx="4041775" cy="3951288"/>
-          </a:xfrm>
-        </p:spPr>
-        <p:txBody>
-          <a:bodyPr/>
-          <a:lstStyle>
-            <a:lvl1pPr>
-              <a:defRPr sz="2400"/>
-            </a:lvl1pPr>
-            <a:lvl2pPr>
-              <a:defRPr sz="2000"/>
-            </a:lvl2pPr>
-            <a:lvl3pPr>
-              <a:defRPr sz="1800"/>
-            </a:lvl3pPr>
-            <a:lvl4pPr>
-              <a:defRPr sz="1600"/>
-            </a:lvl4pPr>
-            <a:lvl5pPr>
-              <a:defRPr sz="1600"/>
-            </a:lvl5pPr>
-            <a:lvl6pPr>
-              <a:defRPr sz="1600"/>
-            </a:lvl6pPr>
-            <a:lvl7pPr>
-              <a:defRPr sz="1600"/>
-            </a:lvl7pPr>
-            <a:lvl8pPr>
-              <a:defRPr sz="1600"/>
-            </a:lvl8pPr>
-            <a:lvl9pPr>
-              <a:defRPr sz="1600"/>
-            </a:lvl9pPr>
-          </a:lstStyle>
-          <a:p>
-            <a:pPr lvl="0"/>
-            <a:r>
-              <a:rPr lang="en-US" smtClean="0"/>
-              <a:t>Click to edit Master text styles</a:t>
-            </a:r>
-          </a:p>
-          <a:p>
-            <a:pPr lvl="1"/>
-            <a:r>
-              <a:rPr lang="en-US" smtClean="0"/>
-              <a:t>Second level</a:t>
-            </a:r>
-          </a:p>
-          <a:p>
-            <a:pPr lvl="2"/>
-            <a:r>
-              <a:rPr lang="en-US" smtClean="0"/>
-              <a:t>Third level</a:t>
-            </a:r>
-          </a:p>
-          <a:p>
-            <a:pPr lvl="3"/>
-            <a:r>
-              <a:rPr lang="en-US" smtClean="0"/>
-              <a:t>Fourth level</a:t>
-            </a:r>
-          </a:p>
-          <a:p>
-            <a:pPr lvl="4"/>
-            <a:r>
-              <a:rPr lang="en-US" smtClean="0"/>
-              <a:t>Fifth level</a:t>
-            </a:r>
-            <a:endParaRPr lang="en-US"/>
-          </a:p>
-        </p:txBody>
-      </p:sp>
-      <p:sp>
-        <p:nvSpPr>
-          <p:cNvPr id="7" name="Date Placeholder 6"/>
-          <p:cNvSpPr>
-            <a:spLocks noGrp="1"/>
-          </p:cNvSpPr>
-          <p:nvPr>
-            <p:ph type="dt" sz="half" idx="10"/>
-          </p:nvPr>
-        </p:nvSpPr>
-        <p:spPr/>
-        <p:txBody>
-          <a:bodyPr/>
-          <a:lstStyle/>
-          <a:p>
-            <a:fld id="{5BCAD085-E8A6-8845-BD4E-CB4CCA059FC4}" type="datetimeFigureOut">
-              <a:rPr lang="en-US" smtClean="0"/>
-              <a:t>1/27/13</a:t>
-            </a:fld>
-            <a:endParaRPr lang="en-US"/>
-          </a:p>
-        </p:txBody>
-      </p:sp>
-      <p:sp>
-        <p:nvSpPr>
-          <p:cNvPr id="8" name="Footer Placeholder 7"/>
-          <p:cNvSpPr>
-            <a:spLocks noGrp="1"/>
-          </p:cNvSpPr>
-          <p:nvPr>
-            <p:ph type="ftr" sz="quarter" idx="11"/>
-          </p:nvPr>
-        </p:nvSpPr>
-        <p:spPr/>
-        <p:txBody>
-          <a:bodyPr/>
-          <a:lstStyle/>
-          <a:p>
-            <a:endParaRPr lang="en-US"/>
-          </a:p>
-        </p:txBody>
-      </p:sp>
-      <p:sp>
-        <p:nvSpPr>
-          <p:cNvPr id="9" name="Slide Number Placeholder 8"/>
-          <p:cNvSpPr>
-            <a:spLocks noGrp="1"/>
-          </p:cNvSpPr>
-          <p:nvPr>
-            <p:ph type="sldNum" sz="quarter" idx="12"/>
-          </p:nvPr>
-        </p:nvSpPr>
-        <p:spPr/>
-        <p:txBody>
-          <a:bodyPr/>
-          <a:lstStyle/>
-          <a:p>
-            <a:fld id="{C1FF6DA9-008F-8B48-92A6-B652298478BF}" type="slidenum">
-              <a:rPr lang="en-US" smtClean="0"/>
-              <a:t>‹#›</a:t>
-            </a:fld>
-            <a:endParaRPr lang="en-US"/>
-          </a:p>
-        </p:txBody>
-      </p:sp>
-    </p:spTree>
-    <p:extLst>
-      <p:ext uri="{BB962C8B-B14F-4D97-AF65-F5344CB8AC3E}">
-        <p14:creationId xmlns:p14="http://schemas.microsoft.com/office/powerpoint/2010/main" val="990158736"/>
-      </p:ext>
-    </p:extLst>
-  </p:cSld>
-  <p:clrMapOvr>
-    <a:masterClrMapping/>
-  </p:clrMapOvr>
-</p:sldLayout>
-</file>
-
-<file path=ppt/slideLayouts/slideLayout6.xml><?xml version="1.0" encoding="utf-8"?>
-<p:sldLayout xmlns:a="http://schemas.openxmlformats.org/drawingml/2006/main" xmlns:r="http://schemas.openxmlformats.org/officeDocument/2006/relationships" xmlns:p="http://schemas.openxmlformats.org/presentationml/2006/main" type="titleOnly" preserve="1">
-  <p:cSld name="Title Only">
-    <p:spTree>
-      <p:nvGrpSpPr>
-        <p:cNvPr id="1" name=""/>
-        <p:cNvGrpSpPr/>
-        <p:nvPr/>
-      </p:nvGrpSpPr>
-      <p:grpSpPr>
-        <a:xfrm>
-          <a:off x="0" y="0"/>
-          <a:ext cx="0" cy="0"/>
-          <a:chOff x="0" y="0"/>
-          <a:chExt cx="0" cy="0"/>
-        </a:xfrm>
-      </p:grpSpPr>
-      <p:sp>
-        <p:nvSpPr>
-          <p:cNvPr id="2" name="Title 1"/>
-          <p:cNvSpPr>
-            <a:spLocks noGrp="1"/>
-          </p:cNvSpPr>
-          <p:nvPr>
-            <p:ph type="title"/>
-          </p:nvPr>
-        </p:nvSpPr>
-        <p:spPr/>
-        <p:txBody>
-          <a:bodyPr/>
-          <a:lstStyle/>
-          <a:p>
-            <a:r>
-              <a:rPr lang="en-US" smtClean="0"/>
-              <a:t>Click to edit Master title style</a:t>
-            </a:r>
-            <a:endParaRPr lang="en-US"/>
-          </a:p>
-        </p:txBody>
-      </p:sp>
-      <p:sp>
-        <p:nvSpPr>
-          <p:cNvPr id="3" name="Date Placeholder 2"/>
-          <p:cNvSpPr>
-            <a:spLocks noGrp="1"/>
-          </p:cNvSpPr>
-          <p:nvPr>
-            <p:ph type="dt" sz="half" idx="10"/>
-          </p:nvPr>
-        </p:nvSpPr>
-        <p:spPr/>
-        <p:txBody>
-          <a:bodyPr/>
-          <a:lstStyle/>
-          <a:p>
-            <a:fld id="{5BCAD085-E8A6-8845-BD4E-CB4CCA059FC4}" type="datetimeFigureOut">
-              <a:rPr lang="en-US" smtClean="0"/>
-              <a:t>1/27/13</a:t>
-            </a:fld>
-            <a:endParaRPr lang="en-US"/>
-          </a:p>
-        </p:txBody>
-      </p:sp>
-      <p:sp>
-        <p:nvSpPr>
-          <p:cNvPr id="4" name="Footer Placeholder 3"/>
-          <p:cNvSpPr>
-            <a:spLocks noGrp="1"/>
-          </p:cNvSpPr>
-          <p:nvPr>
-            <p:ph type="ftr" sz="quarter" idx="11"/>
-          </p:nvPr>
-        </p:nvSpPr>
-        <p:spPr/>
-        <p:txBody>
-          <a:bodyPr/>
-          <a:lstStyle/>
-          <a:p>
-            <a:endParaRPr lang="en-US"/>
-          </a:p>
-        </p:txBody>
-      </p:sp>
-      <p:sp>
-        <p:nvSpPr>
-          <p:cNvPr id="5" name="Slide Number Placeholder 4"/>
-          <p:cNvSpPr>
-            <a:spLocks noGrp="1"/>
-          </p:cNvSpPr>
-          <p:nvPr>
-            <p:ph type="sldNum" sz="quarter" idx="12"/>
-          </p:nvPr>
-        </p:nvSpPr>
-        <p:spPr/>
-        <p:txBody>
-          <a:bodyPr/>
-          <a:lstStyle/>
-          <a:p>
-            <a:fld id="{C1FF6DA9-008F-8B48-92A6-B652298478BF}" type="slidenum">
-              <a:rPr lang="en-US" smtClean="0"/>
-              <a:t>‹#›</a:t>
-            </a:fld>
-            <a:endParaRPr lang="en-US"/>
-          </a:p>
-        </p:txBody>
-      </p:sp>
-    </p:spTree>
-    <p:extLst>
-      <p:ext uri="{BB962C8B-B14F-4D97-AF65-F5344CB8AC3E}">
-        <p14:creationId xmlns:p14="http://schemas.microsoft.com/office/powerpoint/2010/main" val="727027711"/>
-      </p:ext>
-    </p:extLst>
-  </p:cSld>
-  <p:clrMapOvr>
-    <a:masterClrMapping/>
-  </p:clrMapOvr>
-</p:sldLayout>
-</file>
-
 <file path=ppt/slideLayouts/slideLayout7.xml><?xml version="1.0" encoding="utf-8"?>
 <p:sldLayout xmlns:a="http://schemas.openxmlformats.org/drawingml/2006/main" xmlns:r="http://schemas.openxmlformats.org/officeDocument/2006/relationships" xmlns:p="http://schemas.openxmlformats.org/presentationml/2006/main" type="blank" preserve="1">
   <p:cSld name="Blank">
@@ -1985,71 +149,6 @@
       </p:grpSpPr>
       <p:sp>
         <p:nvSpPr>
-          <p:cNvPr id="2" name="Date Placeholder 1"/>
-          <p:cNvSpPr>
-            <a:spLocks noGrp="1"/>
-          </p:cNvSpPr>
-          <p:nvPr>
-            <p:ph type="dt" sz="half" idx="10"/>
-          </p:nvPr>
-        </p:nvSpPr>
-        <p:spPr/>
-        <p:txBody>
-          <a:bodyPr/>
-          <a:lstStyle/>
-          <a:p>
-            <a:fld id="{5BCAD085-E8A6-8845-BD4E-CB4CCA059FC4}" type="datetimeFigureOut">
-              <a:rPr lang="en-US" smtClean="0"/>
-              <a:t>1/27/13</a:t>
-            </a:fld>
-            <a:endParaRPr lang="en-US"/>
-          </a:p>
-        </p:txBody>
-      </p:sp>
-      <p:sp>
-        <p:nvSpPr>
-          <p:cNvPr id="3" name="Footer Placeholder 2"/>
-          <p:cNvSpPr>
-            <a:spLocks noGrp="1"/>
-          </p:cNvSpPr>
-          <p:nvPr>
-            <p:ph type="ftr" sz="quarter" idx="11"/>
-          </p:nvPr>
-        </p:nvSpPr>
-        <p:spPr/>
-        <p:txBody>
-          <a:bodyPr/>
-          <a:lstStyle/>
-          <a:p>
-            <a:endParaRPr lang="en-US"/>
-          </a:p>
-        </p:txBody>
-      </p:sp>
-      <p:sp>
-        <p:nvSpPr>
-          <p:cNvPr id="4" name="Slide Number Placeholder 3"/>
-          <p:cNvSpPr>
-            <a:spLocks noGrp="1"/>
-          </p:cNvSpPr>
-          <p:nvPr>
-            <p:ph type="sldNum" sz="quarter" idx="12"/>
-          </p:nvPr>
-        </p:nvSpPr>
-        <p:spPr/>
-        <p:txBody>
-          <a:bodyPr/>
-          <a:lstStyle/>
-          <a:p>
-            <a:fld id="{C1FF6DA9-008F-8B48-92A6-B652298478BF}" type="slidenum">
-              <a:rPr lang="en-US" smtClean="0"/>
-              <a:t>‹#›</a:t>
-            </a:fld>
-            <a:endParaRPr lang="en-US"/>
-          </a:p>
-        </p:txBody>
-      </p:sp>
-      <p:sp>
-        <p:nvSpPr>
           <p:cNvPr id="2" name="Rectangle 1"/>
           <p:cNvSpPr/>
           <p:nvPr/>
@@ -2181,536 +280,6 @@
     <p:extLst>
       <p:ext uri="{BB962C8B-B14F-4D97-AF65-F5344CB8AC3E}">
         <p14:creationId xmlns:p14="http://schemas.microsoft.com/office/powerpoint/2010/main" val="1212999818"/>
-      </p:ext>
-    </p:extLst>
-  </p:cSld>
-  <p:clrMapOvr>
-    <a:masterClrMapping/>
-  </p:clrMapOvr>
-</p:sldLayout>
-</file>
-
-<file path=ppt/slideLayouts/slideLayout8.xml><?xml version="1.0" encoding="utf-8"?>
-<p:sldLayout xmlns:a="http://schemas.openxmlformats.org/drawingml/2006/main" xmlns:r="http://schemas.openxmlformats.org/officeDocument/2006/relationships" xmlns:p="http://schemas.openxmlformats.org/presentationml/2006/main" type="objTx" preserve="1">
-  <p:cSld name="Content with Caption">
-    <p:spTree>
-      <p:nvGrpSpPr>
-        <p:cNvPr id="1" name=""/>
-        <p:cNvGrpSpPr/>
-        <p:nvPr/>
-      </p:nvGrpSpPr>
-      <p:grpSpPr>
-        <a:xfrm>
-          <a:off x="0" y="0"/>
-          <a:ext cx="0" cy="0"/>
-          <a:chOff x="0" y="0"/>
-          <a:chExt cx="0" cy="0"/>
-        </a:xfrm>
-      </p:grpSpPr>
-      <p:sp>
-        <p:nvSpPr>
-          <p:cNvPr id="2" name="Title 1"/>
-          <p:cNvSpPr>
-            <a:spLocks noGrp="1"/>
-          </p:cNvSpPr>
-          <p:nvPr>
-            <p:ph type="title"/>
-          </p:nvPr>
-        </p:nvSpPr>
-        <p:spPr>
-          <a:xfrm>
-            <a:off x="457200" y="273050"/>
-            <a:ext cx="3008313" cy="1162050"/>
-          </a:xfrm>
-        </p:spPr>
-        <p:txBody>
-          <a:bodyPr anchor="b"/>
-          <a:lstStyle>
-            <a:lvl1pPr algn="l">
-              <a:defRPr sz="2000" b="1"/>
-            </a:lvl1pPr>
-          </a:lstStyle>
-          <a:p>
-            <a:r>
-              <a:rPr lang="en-US" smtClean="0"/>
-              <a:t>Click to edit Master title style</a:t>
-            </a:r>
-            <a:endParaRPr lang="en-US"/>
-          </a:p>
-        </p:txBody>
-      </p:sp>
-      <p:sp>
-        <p:nvSpPr>
-          <p:cNvPr id="3" name="Content Placeholder 2"/>
-          <p:cNvSpPr>
-            <a:spLocks noGrp="1"/>
-          </p:cNvSpPr>
-          <p:nvPr>
-            <p:ph idx="1"/>
-          </p:nvPr>
-        </p:nvSpPr>
-        <p:spPr>
-          <a:xfrm>
-            <a:off x="3575050" y="273050"/>
-            <a:ext cx="5111750" cy="5853113"/>
-          </a:xfrm>
-        </p:spPr>
-        <p:txBody>
-          <a:bodyPr/>
-          <a:lstStyle>
-            <a:lvl1pPr>
-              <a:defRPr sz="3200"/>
-            </a:lvl1pPr>
-            <a:lvl2pPr>
-              <a:defRPr sz="2800"/>
-            </a:lvl2pPr>
-            <a:lvl3pPr>
-              <a:defRPr sz="2400"/>
-            </a:lvl3pPr>
-            <a:lvl4pPr>
-              <a:defRPr sz="2000"/>
-            </a:lvl4pPr>
-            <a:lvl5pPr>
-              <a:defRPr sz="2000"/>
-            </a:lvl5pPr>
-            <a:lvl6pPr>
-              <a:defRPr sz="2000"/>
-            </a:lvl6pPr>
-            <a:lvl7pPr>
-              <a:defRPr sz="2000"/>
-            </a:lvl7pPr>
-            <a:lvl8pPr>
-              <a:defRPr sz="2000"/>
-            </a:lvl8pPr>
-            <a:lvl9pPr>
-              <a:defRPr sz="2000"/>
-            </a:lvl9pPr>
-          </a:lstStyle>
-          <a:p>
-            <a:pPr lvl="0"/>
-            <a:r>
-              <a:rPr lang="en-US" smtClean="0"/>
-              <a:t>Click to edit Master text styles</a:t>
-            </a:r>
-          </a:p>
-          <a:p>
-            <a:pPr lvl="1"/>
-            <a:r>
-              <a:rPr lang="en-US" smtClean="0"/>
-              <a:t>Second level</a:t>
-            </a:r>
-          </a:p>
-          <a:p>
-            <a:pPr lvl="2"/>
-            <a:r>
-              <a:rPr lang="en-US" smtClean="0"/>
-              <a:t>Third level</a:t>
-            </a:r>
-          </a:p>
-          <a:p>
-            <a:pPr lvl="3"/>
-            <a:r>
-              <a:rPr lang="en-US" smtClean="0"/>
-              <a:t>Fourth level</a:t>
-            </a:r>
-          </a:p>
-          <a:p>
-            <a:pPr lvl="4"/>
-            <a:r>
-              <a:rPr lang="en-US" smtClean="0"/>
-              <a:t>Fifth level</a:t>
-            </a:r>
-            <a:endParaRPr lang="en-US"/>
-          </a:p>
-        </p:txBody>
-      </p:sp>
-      <p:sp>
-        <p:nvSpPr>
-          <p:cNvPr id="4" name="Text Placeholder 3"/>
-          <p:cNvSpPr>
-            <a:spLocks noGrp="1"/>
-          </p:cNvSpPr>
-          <p:nvPr>
-            <p:ph type="body" sz="half" idx="2"/>
-          </p:nvPr>
-        </p:nvSpPr>
-        <p:spPr>
-          <a:xfrm>
-            <a:off x="457200" y="1435100"/>
-            <a:ext cx="3008313" cy="4691063"/>
-          </a:xfrm>
-        </p:spPr>
-        <p:txBody>
-          <a:bodyPr/>
-          <a:lstStyle>
-            <a:lvl1pPr marL="0" indent="0">
-              <a:buNone/>
-              <a:defRPr sz="1400"/>
-            </a:lvl1pPr>
-            <a:lvl2pPr marL="457200" indent="0">
-              <a:buNone/>
-              <a:defRPr sz="1200"/>
-            </a:lvl2pPr>
-            <a:lvl3pPr marL="914400" indent="0">
-              <a:buNone/>
-              <a:defRPr sz="1000"/>
-            </a:lvl3pPr>
-            <a:lvl4pPr marL="1371600" indent="0">
-              <a:buNone/>
-              <a:defRPr sz="900"/>
-            </a:lvl4pPr>
-            <a:lvl5pPr marL="1828800" indent="0">
-              <a:buNone/>
-              <a:defRPr sz="900"/>
-            </a:lvl5pPr>
-            <a:lvl6pPr marL="2286000" indent="0">
-              <a:buNone/>
-              <a:defRPr sz="900"/>
-            </a:lvl6pPr>
-            <a:lvl7pPr marL="2743200" indent="0">
-              <a:buNone/>
-              <a:defRPr sz="900"/>
-            </a:lvl7pPr>
-            <a:lvl8pPr marL="3200400" indent="0">
-              <a:buNone/>
-              <a:defRPr sz="900"/>
-            </a:lvl8pPr>
-            <a:lvl9pPr marL="3657600" indent="0">
-              <a:buNone/>
-              <a:defRPr sz="900"/>
-            </a:lvl9pPr>
-          </a:lstStyle>
-          <a:p>
-            <a:pPr lvl="0"/>
-            <a:r>
-              <a:rPr lang="en-US" smtClean="0"/>
-              <a:t>Click to edit Master text styles</a:t>
-            </a:r>
-          </a:p>
-        </p:txBody>
-      </p:sp>
-      <p:sp>
-        <p:nvSpPr>
-          <p:cNvPr id="5" name="Date Placeholder 4"/>
-          <p:cNvSpPr>
-            <a:spLocks noGrp="1"/>
-          </p:cNvSpPr>
-          <p:nvPr>
-            <p:ph type="dt" sz="half" idx="10"/>
-          </p:nvPr>
-        </p:nvSpPr>
-        <p:spPr/>
-        <p:txBody>
-          <a:bodyPr/>
-          <a:lstStyle/>
-          <a:p>
-            <a:fld id="{5BCAD085-E8A6-8845-BD4E-CB4CCA059FC4}" type="datetimeFigureOut">
-              <a:rPr lang="en-US" smtClean="0"/>
-              <a:t>1/27/13</a:t>
-            </a:fld>
-            <a:endParaRPr lang="en-US"/>
-          </a:p>
-        </p:txBody>
-      </p:sp>
-      <p:sp>
-        <p:nvSpPr>
-          <p:cNvPr id="6" name="Footer Placeholder 5"/>
-          <p:cNvSpPr>
-            <a:spLocks noGrp="1"/>
-          </p:cNvSpPr>
-          <p:nvPr>
-            <p:ph type="ftr" sz="quarter" idx="11"/>
-          </p:nvPr>
-        </p:nvSpPr>
-        <p:spPr/>
-        <p:txBody>
-          <a:bodyPr/>
-          <a:lstStyle/>
-          <a:p>
-            <a:endParaRPr lang="en-US"/>
-          </a:p>
-        </p:txBody>
-      </p:sp>
-      <p:sp>
-        <p:nvSpPr>
-          <p:cNvPr id="7" name="Slide Number Placeholder 6"/>
-          <p:cNvSpPr>
-            <a:spLocks noGrp="1"/>
-          </p:cNvSpPr>
-          <p:nvPr>
-            <p:ph type="sldNum" sz="quarter" idx="12"/>
-          </p:nvPr>
-        </p:nvSpPr>
-        <p:spPr/>
-        <p:txBody>
-          <a:bodyPr/>
-          <a:lstStyle/>
-          <a:p>
-            <a:fld id="{C1FF6DA9-008F-8B48-92A6-B652298478BF}" type="slidenum">
-              <a:rPr lang="en-US" smtClean="0"/>
-              <a:t>‹#›</a:t>
-            </a:fld>
-            <a:endParaRPr lang="en-US"/>
-          </a:p>
-        </p:txBody>
-      </p:sp>
-    </p:spTree>
-    <p:extLst>
-      <p:ext uri="{BB962C8B-B14F-4D97-AF65-F5344CB8AC3E}">
-        <p14:creationId xmlns:p14="http://schemas.microsoft.com/office/powerpoint/2010/main" val="1840726560"/>
-      </p:ext>
-    </p:extLst>
-  </p:cSld>
-  <p:clrMapOvr>
-    <a:masterClrMapping/>
-  </p:clrMapOvr>
-</p:sldLayout>
-</file>
-
-<file path=ppt/slideLayouts/slideLayout9.xml><?xml version="1.0" encoding="utf-8"?>
-<p:sldLayout xmlns:a="http://schemas.openxmlformats.org/drawingml/2006/main" xmlns:r="http://schemas.openxmlformats.org/officeDocument/2006/relationships" xmlns:p="http://schemas.openxmlformats.org/presentationml/2006/main" type="picTx" preserve="1">
-  <p:cSld name="Picture with Caption">
-    <p:spTree>
-      <p:nvGrpSpPr>
-        <p:cNvPr id="1" name=""/>
-        <p:cNvGrpSpPr/>
-        <p:nvPr/>
-      </p:nvGrpSpPr>
-      <p:grpSpPr>
-        <a:xfrm>
-          <a:off x="0" y="0"/>
-          <a:ext cx="0" cy="0"/>
-          <a:chOff x="0" y="0"/>
-          <a:chExt cx="0" cy="0"/>
-        </a:xfrm>
-      </p:grpSpPr>
-      <p:sp>
-        <p:nvSpPr>
-          <p:cNvPr id="2" name="Title 1"/>
-          <p:cNvSpPr>
-            <a:spLocks noGrp="1"/>
-          </p:cNvSpPr>
-          <p:nvPr>
-            <p:ph type="title"/>
-          </p:nvPr>
-        </p:nvSpPr>
-        <p:spPr>
-          <a:xfrm>
-            <a:off x="1792288" y="4800600"/>
-            <a:ext cx="5486400" cy="566738"/>
-          </a:xfrm>
-        </p:spPr>
-        <p:txBody>
-          <a:bodyPr anchor="b"/>
-          <a:lstStyle>
-            <a:lvl1pPr algn="l">
-              <a:defRPr sz="2000" b="1"/>
-            </a:lvl1pPr>
-          </a:lstStyle>
-          <a:p>
-            <a:r>
-              <a:rPr lang="en-US" smtClean="0"/>
-              <a:t>Click to edit Master title style</a:t>
-            </a:r>
-            <a:endParaRPr lang="en-US"/>
-          </a:p>
-        </p:txBody>
-      </p:sp>
-      <p:sp>
-        <p:nvSpPr>
-          <p:cNvPr id="3" name="Picture Placeholder 2"/>
-          <p:cNvSpPr>
-            <a:spLocks noGrp="1"/>
-          </p:cNvSpPr>
-          <p:nvPr>
-            <p:ph type="pic" idx="1"/>
-          </p:nvPr>
-        </p:nvSpPr>
-        <p:spPr>
-          <a:xfrm>
-            <a:off x="1792288" y="612775"/>
-            <a:ext cx="5486400" cy="4114800"/>
-          </a:xfrm>
-        </p:spPr>
-        <p:txBody>
-          <a:bodyPr/>
-          <a:lstStyle>
-            <a:lvl1pPr marL="0" indent="0">
-              <a:buNone/>
-              <a:defRPr sz="3200"/>
-            </a:lvl1pPr>
-            <a:lvl2pPr marL="457200" indent="0">
-              <a:buNone/>
-              <a:defRPr sz="2800"/>
-            </a:lvl2pPr>
-            <a:lvl3pPr marL="914400" indent="0">
-              <a:buNone/>
-              <a:defRPr sz="2400"/>
-            </a:lvl3pPr>
-            <a:lvl4pPr marL="1371600" indent="0">
-              <a:buNone/>
-              <a:defRPr sz="2000"/>
-            </a:lvl4pPr>
-            <a:lvl5pPr marL="1828800" indent="0">
-              <a:buNone/>
-              <a:defRPr sz="2000"/>
-            </a:lvl5pPr>
-            <a:lvl6pPr marL="2286000" indent="0">
-              <a:buNone/>
-              <a:defRPr sz="2000"/>
-            </a:lvl6pPr>
-            <a:lvl7pPr marL="2743200" indent="0">
-              <a:buNone/>
-              <a:defRPr sz="2000"/>
-            </a:lvl7pPr>
-            <a:lvl8pPr marL="3200400" indent="0">
-              <a:buNone/>
-              <a:defRPr sz="2000"/>
-            </a:lvl8pPr>
-            <a:lvl9pPr marL="3657600" indent="0">
-              <a:buNone/>
-              <a:defRPr sz="2000"/>
-            </a:lvl9pPr>
-          </a:lstStyle>
-          <a:p>
-            <a:endParaRPr lang="en-US"/>
-          </a:p>
-        </p:txBody>
-      </p:sp>
-      <p:sp>
-        <p:nvSpPr>
-          <p:cNvPr id="4" name="Text Placeholder 3"/>
-          <p:cNvSpPr>
-            <a:spLocks noGrp="1"/>
-          </p:cNvSpPr>
-          <p:nvPr>
-            <p:ph type="body" sz="half" idx="2"/>
-          </p:nvPr>
-        </p:nvSpPr>
-        <p:spPr>
-          <a:xfrm>
-            <a:off x="1792288" y="5367338"/>
-            <a:ext cx="5486400" cy="804862"/>
-          </a:xfrm>
-        </p:spPr>
-        <p:txBody>
-          <a:bodyPr/>
-          <a:lstStyle>
-            <a:lvl1pPr marL="0" indent="0">
-              <a:buNone/>
-              <a:defRPr sz="1400"/>
-            </a:lvl1pPr>
-            <a:lvl2pPr marL="457200" indent="0">
-              <a:buNone/>
-              <a:defRPr sz="1200"/>
-            </a:lvl2pPr>
-            <a:lvl3pPr marL="914400" indent="0">
-              <a:buNone/>
-              <a:defRPr sz="1000"/>
-            </a:lvl3pPr>
-            <a:lvl4pPr marL="1371600" indent="0">
-              <a:buNone/>
-              <a:defRPr sz="900"/>
-            </a:lvl4pPr>
-            <a:lvl5pPr marL="1828800" indent="0">
-              <a:buNone/>
-              <a:defRPr sz="900"/>
-            </a:lvl5pPr>
-            <a:lvl6pPr marL="2286000" indent="0">
-              <a:buNone/>
-              <a:defRPr sz="900"/>
-            </a:lvl6pPr>
-            <a:lvl7pPr marL="2743200" indent="0">
-              <a:buNone/>
-              <a:defRPr sz="900"/>
-            </a:lvl7pPr>
-            <a:lvl8pPr marL="3200400" indent="0">
-              <a:buNone/>
-              <a:defRPr sz="900"/>
-            </a:lvl8pPr>
-            <a:lvl9pPr marL="3657600" indent="0">
-              <a:buNone/>
-              <a:defRPr sz="900"/>
-            </a:lvl9pPr>
-          </a:lstStyle>
-          <a:p>
-            <a:pPr lvl="0"/>
-            <a:r>
-              <a:rPr lang="en-US" smtClean="0"/>
-              <a:t>Click to edit Master text styles</a:t>
-            </a:r>
-          </a:p>
-        </p:txBody>
-      </p:sp>
-      <p:sp>
-        <p:nvSpPr>
-          <p:cNvPr id="5" name="Date Placeholder 4"/>
-          <p:cNvSpPr>
-            <a:spLocks noGrp="1"/>
-          </p:cNvSpPr>
-          <p:nvPr>
-            <p:ph type="dt" sz="half" idx="10"/>
-          </p:nvPr>
-        </p:nvSpPr>
-        <p:spPr/>
-        <p:txBody>
-          <a:bodyPr/>
-          <a:lstStyle/>
-          <a:p>
-            <a:fld id="{5BCAD085-E8A6-8845-BD4E-CB4CCA059FC4}" type="datetimeFigureOut">
-              <a:rPr lang="en-US" smtClean="0"/>
-              <a:t>1/27/13</a:t>
-            </a:fld>
-            <a:endParaRPr lang="en-US"/>
-          </a:p>
-        </p:txBody>
-      </p:sp>
-      <p:sp>
-        <p:nvSpPr>
-          <p:cNvPr id="6" name="Footer Placeholder 5"/>
-          <p:cNvSpPr>
-            <a:spLocks noGrp="1"/>
-          </p:cNvSpPr>
-          <p:nvPr>
-            <p:ph type="ftr" sz="quarter" idx="11"/>
-          </p:nvPr>
-        </p:nvSpPr>
-        <p:spPr/>
-        <p:txBody>
-          <a:bodyPr/>
-          <a:lstStyle/>
-          <a:p>
-            <a:endParaRPr lang="en-US"/>
-          </a:p>
-        </p:txBody>
-      </p:sp>
-      <p:sp>
-        <p:nvSpPr>
-          <p:cNvPr id="7" name="Slide Number Placeholder 6"/>
-          <p:cNvSpPr>
-            <a:spLocks noGrp="1"/>
-          </p:cNvSpPr>
-          <p:nvPr>
-            <p:ph type="sldNum" sz="quarter" idx="12"/>
-          </p:nvPr>
-        </p:nvSpPr>
-        <p:spPr/>
-        <p:txBody>
-          <a:bodyPr/>
-          <a:lstStyle/>
-          <a:p>
-            <a:fld id="{C1FF6DA9-008F-8B48-92A6-B652298478BF}" type="slidenum">
-              <a:rPr lang="en-US" smtClean="0"/>
-              <a:t>‹#›</a:t>
-            </a:fld>
-            <a:endParaRPr lang="en-US"/>
-          </a:p>
-        </p:txBody>
-      </p:sp>
-    </p:spTree>
-    <p:extLst>
-      <p:ext uri="{BB962C8B-B14F-4D97-AF65-F5344CB8AC3E}">
-        <p14:creationId xmlns:p14="http://schemas.microsoft.com/office/powerpoint/2010/main" val="3889236939"/>
       </p:ext>
     </p:extLst>
   </p:cSld>
@@ -2742,220 +311,6 @@
           <a:chExt cx="0" cy="0"/>
         </a:xfrm>
       </p:grpSpPr>
-      <p:sp>
-        <p:nvSpPr>
-          <p:cNvPr id="2" name="Title Placeholder 1"/>
-          <p:cNvSpPr>
-            <a:spLocks noGrp="1"/>
-          </p:cNvSpPr>
-          <p:nvPr>
-            <p:ph type="title"/>
-          </p:nvPr>
-        </p:nvSpPr>
-        <p:spPr>
-          <a:xfrm>
-            <a:off x="457200" y="274638"/>
-            <a:ext cx="8229600" cy="1143000"/>
-          </a:xfrm>
-          <a:prstGeom prst="rect">
-            <a:avLst/>
-          </a:prstGeom>
-        </p:spPr>
-        <p:txBody>
-          <a:bodyPr vert="horz" lIns="91440" tIns="45720" rIns="91440" bIns="45720" rtlCol="0" anchor="ctr">
-            <a:normAutofit/>
-          </a:bodyPr>
-          <a:lstStyle/>
-          <a:p>
-            <a:r>
-              <a:rPr lang="en-US" smtClean="0"/>
-              <a:t>Click to edit Master title style</a:t>
-            </a:r>
-            <a:endParaRPr lang="en-US"/>
-          </a:p>
-        </p:txBody>
-      </p:sp>
-      <p:sp>
-        <p:nvSpPr>
-          <p:cNvPr id="3" name="Text Placeholder 2"/>
-          <p:cNvSpPr>
-            <a:spLocks noGrp="1"/>
-          </p:cNvSpPr>
-          <p:nvPr>
-            <p:ph type="body" idx="1"/>
-          </p:nvPr>
-        </p:nvSpPr>
-        <p:spPr>
-          <a:xfrm>
-            <a:off x="457200" y="1600200"/>
-            <a:ext cx="8229600" cy="4525963"/>
-          </a:xfrm>
-          <a:prstGeom prst="rect">
-            <a:avLst/>
-          </a:prstGeom>
-        </p:spPr>
-        <p:txBody>
-          <a:bodyPr vert="horz" lIns="91440" tIns="45720" rIns="91440" bIns="45720" rtlCol="0">
-            <a:normAutofit/>
-          </a:bodyPr>
-          <a:lstStyle/>
-          <a:p>
-            <a:pPr lvl="0"/>
-            <a:r>
-              <a:rPr lang="en-US" smtClean="0"/>
-              <a:t>Click to edit Master text styles</a:t>
-            </a:r>
-          </a:p>
-          <a:p>
-            <a:pPr lvl="1"/>
-            <a:r>
-              <a:rPr lang="en-US" smtClean="0"/>
-              <a:t>Second level</a:t>
-            </a:r>
-          </a:p>
-          <a:p>
-            <a:pPr lvl="2"/>
-            <a:r>
-              <a:rPr lang="en-US" smtClean="0"/>
-              <a:t>Third level</a:t>
-            </a:r>
-          </a:p>
-          <a:p>
-            <a:pPr lvl="3"/>
-            <a:r>
-              <a:rPr lang="en-US" smtClean="0"/>
-              <a:t>Fourth level</a:t>
-            </a:r>
-          </a:p>
-          <a:p>
-            <a:pPr lvl="4"/>
-            <a:r>
-              <a:rPr lang="en-US" smtClean="0"/>
-              <a:t>Fifth level</a:t>
-            </a:r>
-            <a:endParaRPr lang="en-US"/>
-          </a:p>
-        </p:txBody>
-      </p:sp>
-      <p:sp>
-        <p:nvSpPr>
-          <p:cNvPr id="4" name="Date Placeholder 3"/>
-          <p:cNvSpPr>
-            <a:spLocks noGrp="1"/>
-          </p:cNvSpPr>
-          <p:nvPr>
-            <p:ph type="dt" sz="half" idx="2"/>
-          </p:nvPr>
-        </p:nvSpPr>
-        <p:spPr>
-          <a:xfrm>
-            <a:off x="457200" y="6356350"/>
-            <a:ext cx="2133600" cy="365125"/>
-          </a:xfrm>
-          <a:prstGeom prst="rect">
-            <a:avLst/>
-          </a:prstGeom>
-        </p:spPr>
-        <p:txBody>
-          <a:bodyPr vert="horz" lIns="91440" tIns="45720" rIns="91440" bIns="45720" rtlCol="0" anchor="ctr"/>
-          <a:lstStyle>
-            <a:lvl1pPr algn="l">
-              <a:defRPr sz="1200">
-                <a:solidFill>
-                  <a:schemeClr val="tx1">
-                    <a:tint val="75000"/>
-                  </a:schemeClr>
-                </a:solidFill>
-              </a:defRPr>
-            </a:lvl1pPr>
-          </a:lstStyle>
-          <a:p>
-            <a:fld id="{5BCAD085-E8A6-8845-BD4E-CB4CCA059FC4}" type="datetimeFigureOut">
-              <a:rPr lang="en-US" smtClean="0"/>
-              <a:t>1/27/13</a:t>
-            </a:fld>
-            <a:endParaRPr lang="en-US"/>
-          </a:p>
-        </p:txBody>
-      </p:sp>
-      <p:sp>
-        <p:nvSpPr>
-          <p:cNvPr id="5" name="Footer Placeholder 4"/>
-          <p:cNvSpPr>
-            <a:spLocks noGrp="1"/>
-          </p:cNvSpPr>
-          <p:nvPr>
-            <p:ph type="ftr" sz="quarter" idx="3"/>
-          </p:nvPr>
-        </p:nvSpPr>
-        <p:spPr>
-          <a:xfrm>
-            <a:off x="3124200" y="6356350"/>
-            <a:ext cx="2895600" cy="365125"/>
-          </a:xfrm>
-          <a:prstGeom prst="rect">
-            <a:avLst/>
-          </a:prstGeom>
-        </p:spPr>
-        <p:txBody>
-          <a:bodyPr vert="horz" lIns="91440" tIns="45720" rIns="91440" bIns="45720" rtlCol="0" anchor="ctr"/>
-          <a:lstStyle>
-            <a:lvl1pPr algn="ctr">
-              <a:defRPr sz="1200">
-                <a:solidFill>
-                  <a:schemeClr val="tx1">
-                    <a:tint val="75000"/>
-                  </a:schemeClr>
-                </a:solidFill>
-              </a:defRPr>
-            </a:lvl1pPr>
-          </a:lstStyle>
-          <a:p>
-            <a:endParaRPr lang="en-US"/>
-          </a:p>
-        </p:txBody>
-      </p:sp>
-      <p:sp>
-        <p:nvSpPr>
-          <p:cNvPr id="6" name="Slide Number Placeholder 5"/>
-          <p:cNvSpPr>
-            <a:spLocks noGrp="1"/>
-          </p:cNvSpPr>
-          <p:nvPr>
-            <p:ph type="sldNum" sz="quarter" idx="4"/>
-          </p:nvPr>
-        </p:nvSpPr>
-        <p:spPr>
-          <a:xfrm>
-            <a:off x="6553200" y="6356350"/>
-            <a:ext cx="2133600" cy="365125"/>
-          </a:xfrm>
-          <a:prstGeom prst="rect">
-            <a:avLst/>
-          </a:prstGeom>
-        </p:spPr>
-        <p:txBody>
-          <a:bodyPr vert="horz" lIns="91440" tIns="45720" rIns="91440" bIns="45720" rtlCol="0" anchor="ctr"/>
-          <a:lstStyle>
-            <a:lvl1pPr algn="r">
-              <a:defRPr sz="1200">
-                <a:solidFill>
-                  <a:schemeClr val="tx1">
-                    <a:tint val="75000"/>
-                  </a:schemeClr>
-                </a:solidFill>
-              </a:defRPr>
-            </a:lvl1pPr>
-          </a:lstStyle>
-          <a:p>
-            <a:fld id="{C1FF6DA9-008F-8B48-92A6-B652298478BF}" type="slidenum">
-              <a:rPr lang="en-US" smtClean="0"/>
-              <a:t>‹#›</a:t>
-            </a:fld>
-            <a:endParaRPr lang="en-US"/>
-          </a:p>
-        </p:txBody>
-      </p:sp>
     </p:spTree>
     <p:extLst>
       <p:ext uri="{BB962C8B-B14F-4D97-AF65-F5344CB8AC3E}">
@@ -2965,17 +320,7 @@
   </p:cSld>
   <p:clrMap bg1="lt1" tx1="dk1" bg2="lt2" tx2="dk2" accent1="accent1" accent2="accent2" accent3="accent3" accent4="accent4" accent5="accent5" accent6="accent6" hlink="hlink" folHlink="folHlink"/>
   <p:sldLayoutIdLst>
-    <p:sldLayoutId id="2147483649" r:id="rId1"/>
-    <p:sldLayoutId id="2147483650" r:id="rId2"/>
-    <p:sldLayoutId id="2147483651" r:id="rId3"/>
-    <p:sldLayoutId id="2147483652" r:id="rId4"/>
-    <p:sldLayoutId id="2147483653" r:id="rId5"/>
-    <p:sldLayoutId id="2147483654" r:id="rId6"/>
     <p:sldLayoutId id="2147483655" r:id="rId7"/>
-    <p:sldLayoutId id="2147483656" r:id="rId8"/>
-    <p:sldLayoutId id="2147483657" r:id="rId9"/>
-    <p:sldLayoutId id="2147483658" r:id="rId10"/>
-    <p:sldLayoutId id="2147483659" r:id="rId11"/>
   </p:sldLayoutIdLst>
   <p:txStyles>
     <p:titleStyle>

</xml_diff>

<commit_message>
fix(figures+ppt): infocard wraps title/detail to card width + real line spacing (no 0-gap overlap) + vertical auto-fit (no overflow); bump PPT line spacing 1.1/1.08→1.16; word-aware wrap (no mid-word splits)
Co-Authored-By: Claude Opus 4.8 <noreply@anthropic.com>
</commit_message>
<xml_diff>
--- a/IC_Backend_Notes/slides/05_Floorplan.pptx
+++ b/IC_Backend_Notes/slides/05_Floorplan.pptx
@@ -1338,7 +1338,7 @@
           <a:p>
             <a:pPr algn="l">
               <a:lnSpc>
-                <a:spcPct val="110000"/>
+                <a:spcPct val="116000"/>
               </a:lnSpc>
               <a:spcAft>
                 <a:spcPts val="800"/>
@@ -1359,7 +1359,7 @@
           <a:p>
             <a:pPr algn="l">
               <a:lnSpc>
-                <a:spcPct val="110000"/>
+                <a:spcPct val="116000"/>
               </a:lnSpc>
               <a:spcAft>
                 <a:spcPts val="800"/>
@@ -1380,7 +1380,7 @@
           <a:p>
             <a:pPr algn="l">
               <a:lnSpc>
-                <a:spcPct val="110000"/>
+                <a:spcPct val="116000"/>
               </a:lnSpc>
               <a:spcAft>
                 <a:spcPts val="800"/>
@@ -1401,7 +1401,7 @@
           <a:p>
             <a:pPr algn="l">
               <a:lnSpc>
-                <a:spcPct val="110000"/>
+                <a:spcPct val="116000"/>
               </a:lnSpc>
               <a:spcAft>
                 <a:spcPts val="800"/>
@@ -1422,7 +1422,7 @@
           <a:p>
             <a:pPr algn="l">
               <a:lnSpc>
-                <a:spcPct val="110000"/>
+                <a:spcPct val="116000"/>
               </a:lnSpc>
               <a:spcAft>
                 <a:spcPts val="800"/>
@@ -1909,7 +1909,7 @@
           <a:p>
             <a:pPr algn="l">
               <a:lnSpc>
-                <a:spcPct val="110000"/>
+                <a:spcPct val="116000"/>
               </a:lnSpc>
               <a:spcAft>
                 <a:spcPts val="800"/>
@@ -1930,7 +1930,7 @@
           <a:p>
             <a:pPr algn="l">
               <a:lnSpc>
-                <a:spcPct val="110000"/>
+                <a:spcPct val="116000"/>
               </a:lnSpc>
               <a:spcAft>
                 <a:spcPts val="800"/>
@@ -1951,7 +1951,7 @@
           <a:p>
             <a:pPr algn="l">
               <a:lnSpc>
-                <a:spcPct val="110000"/>
+                <a:spcPct val="116000"/>
               </a:lnSpc>
               <a:spcAft>
                 <a:spcPts val="800"/>
@@ -1972,7 +1972,7 @@
           <a:p>
             <a:pPr algn="l">
               <a:lnSpc>
-                <a:spcPct val="110000"/>
+                <a:spcPct val="116000"/>
               </a:lnSpc>
               <a:spcAft>
                 <a:spcPts val="800"/>
@@ -1993,7 +1993,7 @@
           <a:p>
             <a:pPr algn="l">
               <a:lnSpc>
-                <a:spcPct val="110000"/>
+                <a:spcPct val="116000"/>
               </a:lnSpc>
               <a:spcAft>
                 <a:spcPts val="800"/>
@@ -2196,7 +2196,7 @@
           <a:p>
             <a:pPr algn="l">
               <a:lnSpc>
-                <a:spcPct val="110000"/>
+                <a:spcPct val="116000"/>
               </a:lnSpc>
               <a:spcAft>
                 <a:spcPts val="800"/>
@@ -2217,7 +2217,7 @@
           <a:p>
             <a:pPr algn="l">
               <a:lnSpc>
-                <a:spcPct val="110000"/>
+                <a:spcPct val="116000"/>
               </a:lnSpc>
               <a:spcAft>
                 <a:spcPts val="800"/>
@@ -2238,7 +2238,7 @@
           <a:p>
             <a:pPr algn="l">
               <a:lnSpc>
-                <a:spcPct val="110000"/>
+                <a:spcPct val="116000"/>
               </a:lnSpc>
               <a:spcAft>
                 <a:spcPts val="800"/>
@@ -2259,7 +2259,7 @@
           <a:p>
             <a:pPr algn="l">
               <a:lnSpc>
-                <a:spcPct val="110000"/>
+                <a:spcPct val="116000"/>
               </a:lnSpc>
               <a:spcAft>
                 <a:spcPts val="800"/>
@@ -2280,7 +2280,7 @@
           <a:p>
             <a:pPr algn="l">
               <a:lnSpc>
-                <a:spcPct val="110000"/>
+                <a:spcPct val="116000"/>
               </a:lnSpc>
               <a:spcAft>
                 <a:spcPts val="800"/>
@@ -2301,7 +2301,7 @@
           <a:p>
             <a:pPr algn="l">
               <a:lnSpc>
-                <a:spcPct val="110000"/>
+                <a:spcPct val="116000"/>
               </a:lnSpc>
               <a:spcAft>
                 <a:spcPts val="800"/>
@@ -2337,8 +2337,8 @@
         </p:blipFill>
         <p:spPr>
           <a:xfrm>
-            <a:off x="5486400" y="1766552"/>
-            <a:ext cx="6263640" cy="4376455"/>
+            <a:off x="5486400" y="1740229"/>
+            <a:ext cx="6263640" cy="4429101"/>
           </a:xfrm>
           <a:prstGeom prst="rect">
             <a:avLst/>
@@ -2504,7 +2504,7 @@
           <a:p>
             <a:pPr algn="l">
               <a:lnSpc>
-                <a:spcPct val="110000"/>
+                <a:spcPct val="116000"/>
               </a:lnSpc>
               <a:spcAft>
                 <a:spcPts val="800"/>
@@ -2525,7 +2525,7 @@
           <a:p>
             <a:pPr algn="l">
               <a:lnSpc>
-                <a:spcPct val="110000"/>
+                <a:spcPct val="116000"/>
               </a:lnSpc>
               <a:spcAft>
                 <a:spcPts val="800"/>
@@ -2546,7 +2546,7 @@
           <a:p>
             <a:pPr algn="l">
               <a:lnSpc>
-                <a:spcPct val="110000"/>
+                <a:spcPct val="116000"/>
               </a:lnSpc>
               <a:spcAft>
                 <a:spcPts val="800"/>
@@ -2567,7 +2567,7 @@
           <a:p>
             <a:pPr algn="l">
               <a:lnSpc>
-                <a:spcPct val="110000"/>
+                <a:spcPct val="116000"/>
               </a:lnSpc>
               <a:spcAft>
                 <a:spcPts val="800"/>
@@ -2588,7 +2588,7 @@
           <a:p>
             <a:pPr algn="l">
               <a:lnSpc>
-                <a:spcPct val="110000"/>
+                <a:spcPct val="116000"/>
               </a:lnSpc>
               <a:spcAft>
                 <a:spcPts val="800"/>
@@ -2609,7 +2609,7 @@
           <a:p>
             <a:pPr algn="l">
               <a:lnSpc>
-                <a:spcPct val="110000"/>
+                <a:spcPct val="116000"/>
               </a:lnSpc>
               <a:spcAft>
                 <a:spcPts val="800"/>
@@ -2812,7 +2812,7 @@
           <a:p>
             <a:pPr algn="l">
               <a:lnSpc>
-                <a:spcPct val="110000"/>
+                <a:spcPct val="116000"/>
               </a:lnSpc>
               <a:spcAft>
                 <a:spcPts val="800"/>
@@ -2833,7 +2833,7 @@
           <a:p>
             <a:pPr algn="l">
               <a:lnSpc>
-                <a:spcPct val="110000"/>
+                <a:spcPct val="116000"/>
               </a:lnSpc>
               <a:spcAft>
                 <a:spcPts val="800"/>
@@ -2854,7 +2854,7 @@
           <a:p>
             <a:pPr algn="l">
               <a:lnSpc>
-                <a:spcPct val="110000"/>
+                <a:spcPct val="116000"/>
               </a:lnSpc>
               <a:spcAft>
                 <a:spcPts val="800"/>
@@ -2875,7 +2875,7 @@
           <a:p>
             <a:pPr algn="l">
               <a:lnSpc>
-                <a:spcPct val="110000"/>
+                <a:spcPct val="116000"/>
               </a:lnSpc>
               <a:spcAft>
                 <a:spcPts val="800"/>
@@ -2896,7 +2896,7 @@
           <a:p>
             <a:pPr algn="l">
               <a:lnSpc>
-                <a:spcPct val="110000"/>
+                <a:spcPct val="116000"/>
               </a:lnSpc>
               <a:spcAft>
                 <a:spcPts val="800"/>
@@ -3099,7 +3099,7 @@
           <a:p>
             <a:pPr algn="l">
               <a:lnSpc>
-                <a:spcPct val="110000"/>
+                <a:spcPct val="116000"/>
               </a:lnSpc>
               <a:spcAft>
                 <a:spcPts val="800"/>
@@ -3120,7 +3120,7 @@
           <a:p>
             <a:pPr algn="l">
               <a:lnSpc>
-                <a:spcPct val="110000"/>
+                <a:spcPct val="116000"/>
               </a:lnSpc>
               <a:spcAft>
                 <a:spcPts val="800"/>
@@ -3141,7 +3141,7 @@
           <a:p>
             <a:pPr algn="l">
               <a:lnSpc>
-                <a:spcPct val="110000"/>
+                <a:spcPct val="116000"/>
               </a:lnSpc>
               <a:spcAft>
                 <a:spcPts val="800"/>
@@ -3162,7 +3162,7 @@
           <a:p>
             <a:pPr algn="l">
               <a:lnSpc>
-                <a:spcPct val="110000"/>
+                <a:spcPct val="116000"/>
               </a:lnSpc>
               <a:spcAft>
                 <a:spcPts val="800"/>
@@ -3183,7 +3183,7 @@
           <a:p>
             <a:pPr algn="l">
               <a:lnSpc>
-                <a:spcPct val="110000"/>
+                <a:spcPct val="116000"/>
               </a:lnSpc>
               <a:spcAft>
                 <a:spcPts val="800"/>
@@ -3204,7 +3204,7 @@
           <a:p>
             <a:pPr algn="l">
               <a:lnSpc>
-                <a:spcPct val="110000"/>
+                <a:spcPct val="116000"/>
               </a:lnSpc>
               <a:spcAft>
                 <a:spcPts val="800"/>
@@ -3407,7 +3407,7 @@
           <a:p>
             <a:pPr algn="l">
               <a:lnSpc>
-                <a:spcPct val="110000"/>
+                <a:spcPct val="116000"/>
               </a:lnSpc>
               <a:spcAft>
                 <a:spcPts val="800"/>
@@ -3428,7 +3428,7 @@
           <a:p>
             <a:pPr algn="l">
               <a:lnSpc>
-                <a:spcPct val="110000"/>
+                <a:spcPct val="116000"/>
               </a:lnSpc>
               <a:spcAft>
                 <a:spcPts val="800"/>
@@ -3449,7 +3449,7 @@
           <a:p>
             <a:pPr algn="l">
               <a:lnSpc>
-                <a:spcPct val="110000"/>
+                <a:spcPct val="116000"/>
               </a:lnSpc>
               <a:spcAft>
                 <a:spcPts val="800"/>
@@ -3470,7 +3470,7 @@
           <a:p>
             <a:pPr algn="l">
               <a:lnSpc>
-                <a:spcPct val="110000"/>
+                <a:spcPct val="116000"/>
               </a:lnSpc>
               <a:spcAft>
                 <a:spcPts val="800"/>
@@ -3491,7 +3491,7 @@
           <a:p>
             <a:pPr algn="l">
               <a:lnSpc>
-                <a:spcPct val="110000"/>
+                <a:spcPct val="116000"/>
               </a:lnSpc>
               <a:spcAft>
                 <a:spcPts val="800"/>
@@ -3512,7 +3512,7 @@
           <a:p>
             <a:pPr algn="l">
               <a:lnSpc>
-                <a:spcPct val="110000"/>
+                <a:spcPct val="116000"/>
               </a:lnSpc>
               <a:spcAft>
                 <a:spcPts val="800"/>
@@ -3715,7 +3715,7 @@
           <a:p>
             <a:pPr algn="l">
               <a:lnSpc>
-                <a:spcPct val="110000"/>
+                <a:spcPct val="116000"/>
               </a:lnSpc>
               <a:spcAft>
                 <a:spcPts val="800"/>
@@ -3736,7 +3736,7 @@
           <a:p>
             <a:pPr algn="l">
               <a:lnSpc>
-                <a:spcPct val="110000"/>
+                <a:spcPct val="116000"/>
               </a:lnSpc>
               <a:spcAft>
                 <a:spcPts val="800"/>
@@ -3757,7 +3757,7 @@
           <a:p>
             <a:pPr algn="l">
               <a:lnSpc>
-                <a:spcPct val="110000"/>
+                <a:spcPct val="116000"/>
               </a:lnSpc>
               <a:spcAft>
                 <a:spcPts val="800"/>
@@ -3778,7 +3778,7 @@
           <a:p>
             <a:pPr algn="l">
               <a:lnSpc>
-                <a:spcPct val="110000"/>
+                <a:spcPct val="116000"/>
               </a:lnSpc>
               <a:spcAft>
                 <a:spcPts val="800"/>
@@ -3799,7 +3799,7 @@
           <a:p>
             <a:pPr algn="l">
               <a:lnSpc>
-                <a:spcPct val="110000"/>
+                <a:spcPct val="116000"/>
               </a:lnSpc>
               <a:spcAft>
                 <a:spcPts val="800"/>
@@ -3820,7 +3820,7 @@
           <a:p>
             <a:pPr algn="l">
               <a:lnSpc>
-                <a:spcPct val="110000"/>
+                <a:spcPct val="116000"/>
               </a:lnSpc>
               <a:spcAft>
                 <a:spcPts val="800"/>
@@ -5343,7 +5343,7 @@
           <a:p>
             <a:pPr algn="l">
               <a:lnSpc>
-                <a:spcPct val="108000"/>
+                <a:spcPct val="116000"/>
               </a:lnSpc>
               <a:spcAft>
                 <a:spcPts val="600"/>
@@ -5364,7 +5364,7 @@
           <a:p>
             <a:pPr algn="l">
               <a:lnSpc>
-                <a:spcPct val="108000"/>
+                <a:spcPct val="116000"/>
               </a:lnSpc>
               <a:spcAft>
                 <a:spcPts val="600"/>
@@ -5385,7 +5385,7 @@
           <a:p>
             <a:pPr algn="l">
               <a:lnSpc>
-                <a:spcPct val="108000"/>
+                <a:spcPct val="116000"/>
               </a:lnSpc>
               <a:spcAft>
                 <a:spcPts val="600"/>
@@ -5406,7 +5406,7 @@
           <a:p>
             <a:pPr algn="l">
               <a:lnSpc>
-                <a:spcPct val="108000"/>
+                <a:spcPct val="116000"/>
               </a:lnSpc>
               <a:spcAft>
                 <a:spcPts val="600"/>
@@ -5427,7 +5427,7 @@
           <a:p>
             <a:pPr algn="l">
               <a:lnSpc>
-                <a:spcPct val="108000"/>
+                <a:spcPct val="116000"/>
               </a:lnSpc>
               <a:spcAft>
                 <a:spcPts val="600"/>
@@ -5448,7 +5448,7 @@
           <a:p>
             <a:pPr algn="l">
               <a:lnSpc>
-                <a:spcPct val="108000"/>
+                <a:spcPct val="116000"/>
               </a:lnSpc>
               <a:spcAft>
                 <a:spcPts val="600"/>
@@ -5623,7 +5623,7 @@
           <a:p>
             <a:pPr algn="l">
               <a:lnSpc>
-                <a:spcPct val="108000"/>
+                <a:spcPct val="116000"/>
               </a:lnSpc>
               <a:spcAft>
                 <a:spcPts val="600"/>
@@ -5644,7 +5644,7 @@
           <a:p>
             <a:pPr algn="l">
               <a:lnSpc>
-                <a:spcPct val="108000"/>
+                <a:spcPct val="116000"/>
               </a:lnSpc>
               <a:spcAft>
                 <a:spcPts val="600"/>
@@ -5665,7 +5665,7 @@
           <a:p>
             <a:pPr algn="l">
               <a:lnSpc>
-                <a:spcPct val="108000"/>
+                <a:spcPct val="116000"/>
               </a:lnSpc>
               <a:spcAft>
                 <a:spcPts val="600"/>
@@ -5686,7 +5686,7 @@
           <a:p>
             <a:pPr algn="l">
               <a:lnSpc>
-                <a:spcPct val="108000"/>
+                <a:spcPct val="116000"/>
               </a:lnSpc>
               <a:spcAft>
                 <a:spcPts val="600"/>
@@ -5707,7 +5707,7 @@
           <a:p>
             <a:pPr algn="l">
               <a:lnSpc>
-                <a:spcPct val="108000"/>
+                <a:spcPct val="116000"/>
               </a:lnSpc>
               <a:spcAft>
                 <a:spcPts val="600"/>
@@ -5728,7 +5728,7 @@
           <a:p>
             <a:pPr algn="l">
               <a:lnSpc>
-                <a:spcPct val="108000"/>
+                <a:spcPct val="116000"/>
               </a:lnSpc>
               <a:spcAft>
                 <a:spcPts val="600"/>
@@ -6037,6 +6037,9 @@
           <a:lstStyle/>
           <a:p>
             <a:pPr algn="l">
+              <a:lnSpc>
+                <a:spcPct val="112000"/>
+              </a:lnSpc>
               <a:spcAft>
                 <a:spcPts val="700"/>
               </a:spcAft>
@@ -6055,6 +6058,9 @@
           </a:p>
           <a:p>
             <a:pPr algn="l">
+              <a:lnSpc>
+                <a:spcPct val="112000"/>
+              </a:lnSpc>
               <a:spcAft>
                 <a:spcPts val="700"/>
               </a:spcAft>
@@ -6073,6 +6079,9 @@
           </a:p>
           <a:p>
             <a:pPr algn="l">
+              <a:lnSpc>
+                <a:spcPct val="112000"/>
+              </a:lnSpc>
               <a:spcAft>
                 <a:spcPts val="700"/>
               </a:spcAft>
@@ -6091,6 +6100,9 @@
           </a:p>
           <a:p>
             <a:pPr algn="l">
+              <a:lnSpc>
+                <a:spcPct val="112000"/>
+              </a:lnSpc>
               <a:spcAft>
                 <a:spcPts val="700"/>
               </a:spcAft>
@@ -6109,6 +6121,9 @@
           </a:p>
           <a:p>
             <a:pPr algn="l">
+              <a:lnSpc>
+                <a:spcPct val="112000"/>
+              </a:lnSpc>
               <a:spcAft>
                 <a:spcPts val="700"/>
               </a:spcAft>
@@ -6127,6 +6142,9 @@
           </a:p>
           <a:p>
             <a:pPr algn="l">
+              <a:lnSpc>
+                <a:spcPct val="112000"/>
+              </a:lnSpc>
               <a:spcAft>
                 <a:spcPts val="700"/>
               </a:spcAft>
@@ -6145,6 +6163,9 @@
           </a:p>
           <a:p>
             <a:pPr algn="l">
+              <a:lnSpc>
+                <a:spcPct val="112000"/>
+              </a:lnSpc>
               <a:spcAft>
                 <a:spcPts val="700"/>
               </a:spcAft>
@@ -6317,6 +6338,9 @@
           <a:lstStyle/>
           <a:p>
             <a:pPr algn="l">
+              <a:lnSpc>
+                <a:spcPct val="112000"/>
+              </a:lnSpc>
               <a:spcAft>
                 <a:spcPts val="700"/>
               </a:spcAft>
@@ -6335,6 +6359,9 @@
           </a:p>
           <a:p>
             <a:pPr algn="l">
+              <a:lnSpc>
+                <a:spcPct val="112000"/>
+              </a:lnSpc>
               <a:spcAft>
                 <a:spcPts val="700"/>
               </a:spcAft>
@@ -6353,6 +6380,9 @@
           </a:p>
           <a:p>
             <a:pPr algn="l">
+              <a:lnSpc>
+                <a:spcPct val="112000"/>
+              </a:lnSpc>
               <a:spcAft>
                 <a:spcPts val="700"/>
               </a:spcAft>
@@ -6371,6 +6401,9 @@
           </a:p>
           <a:p>
             <a:pPr algn="l">
+              <a:lnSpc>
+                <a:spcPct val="112000"/>
+              </a:lnSpc>
               <a:spcAft>
                 <a:spcPts val="700"/>
               </a:spcAft>
@@ -6389,6 +6422,9 @@
           </a:p>
           <a:p>
             <a:pPr algn="l">
+              <a:lnSpc>
+                <a:spcPct val="112000"/>
+              </a:lnSpc>
               <a:spcAft>
                 <a:spcPts val="700"/>
               </a:spcAft>
@@ -6407,6 +6443,9 @@
           </a:p>
           <a:p>
             <a:pPr algn="l">
+              <a:lnSpc>
+                <a:spcPct val="112000"/>
+              </a:lnSpc>
               <a:spcAft>
                 <a:spcPts val="700"/>
               </a:spcAft>
@@ -6425,6 +6464,9 @@
           </a:p>
           <a:p>
             <a:pPr algn="l">
+              <a:lnSpc>
+                <a:spcPct val="112000"/>
+              </a:lnSpc>
               <a:spcAft>
                 <a:spcPts val="700"/>
               </a:spcAft>
@@ -7082,7 +7124,7 @@
           <a:p>
             <a:pPr algn="l">
               <a:lnSpc>
-                <a:spcPct val="108000"/>
+                <a:spcPct val="116000"/>
               </a:lnSpc>
               <a:spcAft>
                 <a:spcPts val="600"/>
@@ -7103,7 +7145,7 @@
           <a:p>
             <a:pPr algn="l">
               <a:lnSpc>
-                <a:spcPct val="108000"/>
+                <a:spcPct val="116000"/>
               </a:lnSpc>
               <a:spcAft>
                 <a:spcPts val="600"/>
@@ -7124,7 +7166,7 @@
           <a:p>
             <a:pPr algn="l">
               <a:lnSpc>
-                <a:spcPct val="108000"/>
+                <a:spcPct val="116000"/>
               </a:lnSpc>
               <a:spcAft>
                 <a:spcPts val="600"/>
@@ -7145,7 +7187,7 @@
           <a:p>
             <a:pPr algn="l">
               <a:lnSpc>
-                <a:spcPct val="108000"/>
+                <a:spcPct val="116000"/>
               </a:lnSpc>
               <a:spcAft>
                 <a:spcPts val="600"/>
@@ -7166,7 +7208,7 @@
           <a:p>
             <a:pPr algn="l">
               <a:lnSpc>
-                <a:spcPct val="108000"/>
+                <a:spcPct val="116000"/>
               </a:lnSpc>
               <a:spcAft>
                 <a:spcPts val="600"/>
@@ -7187,7 +7229,7 @@
           <a:p>
             <a:pPr algn="l">
               <a:lnSpc>
-                <a:spcPct val="108000"/>
+                <a:spcPct val="116000"/>
               </a:lnSpc>
               <a:spcAft>
                 <a:spcPts val="600"/>
@@ -7208,7 +7250,7 @@
           <a:p>
             <a:pPr algn="l">
               <a:lnSpc>
-                <a:spcPct val="108000"/>
+                <a:spcPct val="116000"/>
               </a:lnSpc>
               <a:spcAft>
                 <a:spcPts val="600"/>
@@ -7229,7 +7271,7 @@
           <a:p>
             <a:pPr algn="l">
               <a:lnSpc>
-                <a:spcPct val="108000"/>
+                <a:spcPct val="116000"/>
               </a:lnSpc>
               <a:spcAft>
                 <a:spcPts val="600"/>
@@ -7404,7 +7446,7 @@
           <a:p>
             <a:pPr algn="l">
               <a:lnSpc>
-                <a:spcPct val="108000"/>
+                <a:spcPct val="116000"/>
               </a:lnSpc>
               <a:spcAft>
                 <a:spcPts val="600"/>
@@ -7425,7 +7467,7 @@
           <a:p>
             <a:pPr algn="l">
               <a:lnSpc>
-                <a:spcPct val="108000"/>
+                <a:spcPct val="116000"/>
               </a:lnSpc>
               <a:spcAft>
                 <a:spcPts val="600"/>
@@ -7446,7 +7488,7 @@
           <a:p>
             <a:pPr algn="l">
               <a:lnSpc>
-                <a:spcPct val="108000"/>
+                <a:spcPct val="116000"/>
               </a:lnSpc>
               <a:spcAft>
                 <a:spcPts val="600"/>
@@ -7467,7 +7509,7 @@
           <a:p>
             <a:pPr algn="l">
               <a:lnSpc>
-                <a:spcPct val="108000"/>
+                <a:spcPct val="116000"/>
               </a:lnSpc>
               <a:spcAft>
                 <a:spcPts val="600"/>
@@ -7488,7 +7530,7 @@
           <a:p>
             <a:pPr algn="l">
               <a:lnSpc>
-                <a:spcPct val="108000"/>
+                <a:spcPct val="116000"/>
               </a:lnSpc>
               <a:spcAft>
                 <a:spcPts val="600"/>
@@ -7509,7 +7551,7 @@
           <a:p>
             <a:pPr algn="l">
               <a:lnSpc>
-                <a:spcPct val="108000"/>
+                <a:spcPct val="116000"/>
               </a:lnSpc>
               <a:spcAft>
                 <a:spcPts val="600"/>
@@ -7530,7 +7572,7 @@
           <a:p>
             <a:pPr algn="l">
               <a:lnSpc>
-                <a:spcPct val="108000"/>
+                <a:spcPct val="116000"/>
               </a:lnSpc>
               <a:spcAft>
                 <a:spcPts val="600"/>
@@ -7551,7 +7593,7 @@
           <a:p>
             <a:pPr algn="l">
               <a:lnSpc>
-                <a:spcPct val="108000"/>
+                <a:spcPct val="116000"/>
               </a:lnSpc>
               <a:spcAft>
                 <a:spcPts val="600"/>
@@ -8052,7 +8094,7 @@
           <a:p>
             <a:pPr algn="l">
               <a:lnSpc>
-                <a:spcPct val="110000"/>
+                <a:spcPct val="116000"/>
               </a:lnSpc>
               <a:spcAft>
                 <a:spcPts val="800"/>
@@ -8073,7 +8115,7 @@
           <a:p>
             <a:pPr algn="l">
               <a:lnSpc>
-                <a:spcPct val="110000"/>
+                <a:spcPct val="116000"/>
               </a:lnSpc>
               <a:spcAft>
                 <a:spcPts val="800"/>
@@ -8094,7 +8136,7 @@
           <a:p>
             <a:pPr algn="l">
               <a:lnSpc>
-                <a:spcPct val="110000"/>
+                <a:spcPct val="116000"/>
               </a:lnSpc>
               <a:spcAft>
                 <a:spcPts val="800"/>
@@ -8115,7 +8157,7 @@
           <a:p>
             <a:pPr algn="l">
               <a:lnSpc>
-                <a:spcPct val="110000"/>
+                <a:spcPct val="116000"/>
               </a:lnSpc>
               <a:spcAft>
                 <a:spcPts val="800"/>
@@ -8136,7 +8178,7 @@
           <a:p>
             <a:pPr algn="l">
               <a:lnSpc>
-                <a:spcPct val="110000"/>
+                <a:spcPct val="116000"/>
               </a:lnSpc>
               <a:spcAft>
                 <a:spcPts val="800"/>
@@ -8157,7 +8199,7 @@
           <a:p>
             <a:pPr algn="l">
               <a:lnSpc>
-                <a:spcPct val="110000"/>
+                <a:spcPct val="116000"/>
               </a:lnSpc>
               <a:spcAft>
                 <a:spcPts val="800"/>
@@ -8360,7 +8402,7 @@
           <a:p>
             <a:pPr algn="l">
               <a:lnSpc>
-                <a:spcPct val="110000"/>
+                <a:spcPct val="116000"/>
               </a:lnSpc>
               <a:spcAft>
                 <a:spcPts val="800"/>
@@ -8381,7 +8423,7 @@
           <a:p>
             <a:pPr algn="l">
               <a:lnSpc>
-                <a:spcPct val="110000"/>
+                <a:spcPct val="116000"/>
               </a:lnSpc>
               <a:spcAft>
                 <a:spcPts val="800"/>
@@ -8402,7 +8444,7 @@
           <a:p>
             <a:pPr algn="l">
               <a:lnSpc>
-                <a:spcPct val="110000"/>
+                <a:spcPct val="116000"/>
               </a:lnSpc>
               <a:spcAft>
                 <a:spcPts val="800"/>
@@ -8423,7 +8465,7 @@
           <a:p>
             <a:pPr algn="l">
               <a:lnSpc>
-                <a:spcPct val="110000"/>
+                <a:spcPct val="116000"/>
               </a:lnSpc>
               <a:spcAft>
                 <a:spcPts val="800"/>
@@ -8444,7 +8486,7 @@
           <a:p>
             <a:pPr algn="l">
               <a:lnSpc>
-                <a:spcPct val="110000"/>
+                <a:spcPct val="116000"/>
               </a:lnSpc>
               <a:spcAft>
                 <a:spcPts val="800"/>
@@ -8465,7 +8507,7 @@
           <a:p>
             <a:pPr algn="l">
               <a:lnSpc>
-                <a:spcPct val="110000"/>
+                <a:spcPct val="116000"/>
               </a:lnSpc>
               <a:spcAft>
                 <a:spcPts val="800"/>
@@ -8668,7 +8710,7 @@
           <a:p>
             <a:pPr algn="l">
               <a:lnSpc>
-                <a:spcPct val="110000"/>
+                <a:spcPct val="116000"/>
               </a:lnSpc>
               <a:spcAft>
                 <a:spcPts val="800"/>
@@ -8689,7 +8731,7 @@
           <a:p>
             <a:pPr algn="l">
               <a:lnSpc>
-                <a:spcPct val="110000"/>
+                <a:spcPct val="116000"/>
               </a:lnSpc>
               <a:spcAft>
                 <a:spcPts val="800"/>
@@ -8710,7 +8752,7 @@
           <a:p>
             <a:pPr algn="l">
               <a:lnSpc>
-                <a:spcPct val="110000"/>
+                <a:spcPct val="116000"/>
               </a:lnSpc>
               <a:spcAft>
                 <a:spcPts val="800"/>
@@ -8731,7 +8773,7 @@
           <a:p>
             <a:pPr algn="l">
               <a:lnSpc>
-                <a:spcPct val="110000"/>
+                <a:spcPct val="116000"/>
               </a:lnSpc>
               <a:spcAft>
                 <a:spcPts val="800"/>
@@ -8752,7 +8794,7 @@
           <a:p>
             <a:pPr algn="l">
               <a:lnSpc>
-                <a:spcPct val="110000"/>
+                <a:spcPct val="116000"/>
               </a:lnSpc>
               <a:spcAft>
                 <a:spcPts val="800"/>
@@ -8773,7 +8815,7 @@
           <a:p>
             <a:pPr algn="l">
               <a:lnSpc>
-                <a:spcPct val="110000"/>
+                <a:spcPct val="116000"/>
               </a:lnSpc>
               <a:spcAft>
                 <a:spcPts val="800"/>
@@ -8976,7 +9018,7 @@
           <a:p>
             <a:pPr algn="l">
               <a:lnSpc>
-                <a:spcPct val="110000"/>
+                <a:spcPct val="116000"/>
               </a:lnSpc>
               <a:spcAft>
                 <a:spcPts val="800"/>
@@ -8997,7 +9039,7 @@
           <a:p>
             <a:pPr algn="l">
               <a:lnSpc>
-                <a:spcPct val="110000"/>
+                <a:spcPct val="116000"/>
               </a:lnSpc>
               <a:spcAft>
                 <a:spcPts val="800"/>
@@ -9018,7 +9060,7 @@
           <a:p>
             <a:pPr algn="l">
               <a:lnSpc>
-                <a:spcPct val="110000"/>
+                <a:spcPct val="116000"/>
               </a:lnSpc>
               <a:spcAft>
                 <a:spcPts val="800"/>
@@ -9039,7 +9081,7 @@
           <a:p>
             <a:pPr algn="l">
               <a:lnSpc>
-                <a:spcPct val="110000"/>
+                <a:spcPct val="116000"/>
               </a:lnSpc>
               <a:spcAft>
                 <a:spcPts val="800"/>
@@ -9060,7 +9102,7 @@
           <a:p>
             <a:pPr algn="l">
               <a:lnSpc>
-                <a:spcPct val="110000"/>
+                <a:spcPct val="116000"/>
               </a:lnSpc>
               <a:spcAft>
                 <a:spcPts val="800"/>
@@ -9081,7 +9123,7 @@
           <a:p>
             <a:pPr algn="l">
               <a:lnSpc>
-                <a:spcPct val="110000"/>
+                <a:spcPct val="116000"/>
               </a:lnSpc>
               <a:spcAft>
                 <a:spcPts val="800"/>
@@ -9284,7 +9326,7 @@
           <a:p>
             <a:pPr algn="l">
               <a:lnSpc>
-                <a:spcPct val="110000"/>
+                <a:spcPct val="116000"/>
               </a:lnSpc>
               <a:spcAft>
                 <a:spcPts val="800"/>
@@ -9305,7 +9347,7 @@
           <a:p>
             <a:pPr algn="l">
               <a:lnSpc>
-                <a:spcPct val="110000"/>
+                <a:spcPct val="116000"/>
               </a:lnSpc>
               <a:spcAft>
                 <a:spcPts val="800"/>
@@ -9326,7 +9368,7 @@
           <a:p>
             <a:pPr algn="l">
               <a:lnSpc>
-                <a:spcPct val="110000"/>
+                <a:spcPct val="116000"/>
               </a:lnSpc>
               <a:spcAft>
                 <a:spcPts val="800"/>
@@ -9347,7 +9389,7 @@
           <a:p>
             <a:pPr algn="l">
               <a:lnSpc>
-                <a:spcPct val="110000"/>
+                <a:spcPct val="116000"/>
               </a:lnSpc>
               <a:spcAft>
                 <a:spcPts val="800"/>
@@ -9368,7 +9410,7 @@
           <a:p>
             <a:pPr algn="l">
               <a:lnSpc>
-                <a:spcPct val="110000"/>
+                <a:spcPct val="116000"/>
               </a:lnSpc>
               <a:spcAft>
                 <a:spcPts val="800"/>
@@ -9389,7 +9431,7 @@
           <a:p>
             <a:pPr algn="l">
               <a:lnSpc>
-                <a:spcPct val="110000"/>
+                <a:spcPct val="116000"/>
               </a:lnSpc>
               <a:spcAft>
                 <a:spcPts val="800"/>
@@ -9592,7 +9634,7 @@
           <a:p>
             <a:pPr algn="l">
               <a:lnSpc>
-                <a:spcPct val="110000"/>
+                <a:spcPct val="116000"/>
               </a:lnSpc>
               <a:spcAft>
                 <a:spcPts val="800"/>
@@ -9613,7 +9655,7 @@
           <a:p>
             <a:pPr algn="l">
               <a:lnSpc>
-                <a:spcPct val="110000"/>
+                <a:spcPct val="116000"/>
               </a:lnSpc>
               <a:spcAft>
                 <a:spcPts val="800"/>
@@ -9634,7 +9676,7 @@
           <a:p>
             <a:pPr algn="l">
               <a:lnSpc>
-                <a:spcPct val="110000"/>
+                <a:spcPct val="116000"/>
               </a:lnSpc>
               <a:spcAft>
                 <a:spcPts val="800"/>
@@ -9655,7 +9697,7 @@
           <a:p>
             <a:pPr algn="l">
               <a:lnSpc>
-                <a:spcPct val="110000"/>
+                <a:spcPct val="116000"/>
               </a:lnSpc>
               <a:spcAft>
                 <a:spcPts val="800"/>
@@ -9676,7 +9718,7 @@
           <a:p>
             <a:pPr algn="l">
               <a:lnSpc>
-                <a:spcPct val="110000"/>
+                <a:spcPct val="116000"/>
               </a:lnSpc>
               <a:spcAft>
                 <a:spcPts val="800"/>
@@ -9879,7 +9921,7 @@
           <a:p>
             <a:pPr algn="l">
               <a:lnSpc>
-                <a:spcPct val="110000"/>
+                <a:spcPct val="116000"/>
               </a:lnSpc>
               <a:spcAft>
                 <a:spcPts val="800"/>
@@ -9900,7 +9942,7 @@
           <a:p>
             <a:pPr algn="l">
               <a:lnSpc>
-                <a:spcPct val="110000"/>
+                <a:spcPct val="116000"/>
               </a:lnSpc>
               <a:spcAft>
                 <a:spcPts val="800"/>
@@ -9921,7 +9963,7 @@
           <a:p>
             <a:pPr algn="l">
               <a:lnSpc>
-                <a:spcPct val="110000"/>
+                <a:spcPct val="116000"/>
               </a:lnSpc>
               <a:spcAft>
                 <a:spcPts val="800"/>
@@ -9942,7 +9984,7 @@
           <a:p>
             <a:pPr algn="l">
               <a:lnSpc>
-                <a:spcPct val="110000"/>
+                <a:spcPct val="116000"/>
               </a:lnSpc>
               <a:spcAft>
                 <a:spcPts val="800"/>
@@ -9963,7 +10005,7 @@
           <a:p>
             <a:pPr algn="l">
               <a:lnSpc>
-                <a:spcPct val="110000"/>
+                <a:spcPct val="116000"/>
               </a:lnSpc>
               <a:spcAft>
                 <a:spcPts val="800"/>
@@ -9984,7 +10026,7 @@
           <a:p>
             <a:pPr algn="l">
               <a:lnSpc>
-                <a:spcPct val="110000"/>
+                <a:spcPct val="116000"/>
               </a:lnSpc>
               <a:spcAft>
                 <a:spcPts val="800"/>

</xml_diff>

<commit_message>
② drop meaningless ① on single-heading figures (f01/f16); ① add prose style (paragraphs, no ▪) + convert narrative slides 2.3/3.3/4.2 to note-faithful prose
Co-Authored-By: Claude Opus 4.8 <noreply@anthropic.com>
</commit_message>
<xml_diff>
--- a/IC_Backend_Notes/slides/05_Floorplan.pptx
+++ b/IC_Backend_Notes/slides/05_Floorplan.pptx
@@ -1255,7 +1255,7 @@
           <a:lstStyle/>
           <a:p>
             <a:pPr algn="r"/>
-            <a:fld id="{9683FF6D-9B6B-4D48-996C-2EF508BF5E53}" type="slidenum">
+            <a:fld id="{01521D2C-28F4-44B6-8EA4-8D65AAF07430}" type="slidenum">
               <a:rPr lang="en-US" sz="1000">
                 <a:solidFill>
                   <a:srgbClr val="9AA3B0"/>
@@ -1604,7 +1604,7 @@
           <a:lstStyle/>
           <a:p>
             <a:pPr algn="r"/>
-            <a:fld id="{F57ECA73-B494-406C-AE40-C18821B148AB}" type="slidenum">
+            <a:fld id="{75094B48-A983-46E6-A8D4-6D3A88E5367E}" type="slidenum">
               <a:rPr lang="en-US" sz="1000">
                 <a:solidFill>
                   <a:srgbClr val="9AA3B0"/>
@@ -1796,7 +1796,7 @@
                 <a:ea typeface="Microsoft YaHei"/>
                 <a:cs typeface="Microsoft YaHei"/>
               </a:rPr>
-              <a:t>▪  进入物理域前网表必须唯一化：每个子模块只被引用一次</a:t>
+              <a:t>进入物理域前，网表必须唯一化——每个子模块只被引用一次。这是因为物理优化要按实例独立移动、插缓冲器、做优化。</a:t>
             </a:r>
           </a:p>
           <a:p>
@@ -1817,7 +1817,7 @@
                 <a:ea typeface="Microsoft YaHei"/>
                 <a:cs typeface="Microsoft YaHei"/>
               </a:rPr>
-              <a:t>▪  物理优化要按实例独立移动、插缓冲、优化</a:t>
+              <a:t>如果两个实例共享同一个模块定义，工具想优化 m1/u1 时就可能同时改变 m2/u1，物理优化边界不清晰。</a:t>
             </a:r>
           </a:p>
           <a:p>
@@ -1838,49 +1838,7 @@
                 <a:ea typeface="Microsoft YaHei"/>
                 <a:cs typeface="Microsoft YaHei"/>
               </a:rPr>
-              <a:t>▪  若两实例共享模块定义，优化 m1/u1 会牵连 m2/u1</a:t>
-            </a:r>
-          </a:p>
-          <a:p>
-            <a:pPr algn="l">
-              <a:lnSpc>
-                <a:spcPct val="116000"/>
-              </a:lnSpc>
-              <a:spcAft>
-                <a:spcPts val="800"/>
-              </a:spcAft>
-            </a:pPr>
-            <a:r>
-              <a:rPr sz="1400" b="0">
-                <a:solidFill>
-                  <a:srgbClr val="1A1F2B"/>
-                </a:solidFill>
-                <a:latin typeface="Microsoft YaHei"/>
-                <a:ea typeface="Microsoft YaHei"/>
-                <a:cs typeface="Microsoft YaHei"/>
-              </a:rPr>
-              <a:t>▪  唯一化后各实例有清晰的物理优化边界</a:t>
-            </a:r>
-          </a:p>
-          <a:p>
-            <a:pPr algn="l">
-              <a:lnSpc>
-                <a:spcPct val="116000"/>
-              </a:lnSpc>
-              <a:spcAft>
-                <a:spcPts val="800"/>
-              </a:spcAft>
-            </a:pPr>
-            <a:r>
-              <a:rPr sz="1400" b="0">
-                <a:solidFill>
-                  <a:srgbClr val="1A1F2B"/>
-                </a:solidFill>
-                <a:latin typeface="Microsoft YaHei"/>
-                <a:ea typeface="Microsoft YaHei"/>
-                <a:cs typeface="Microsoft YaHei"/>
-              </a:rPr>
-              <a:t>▪  由综合工具或设计导入阶段完成，必须在布局之前</a:t>
+              <a:t>综合后的网表必须在布局之前完成唯一化：可以由综合工具完成，也可以在设计导入阶段完成。</a:t>
             </a:r>
           </a:p>
         </p:txBody>
@@ -1932,7 +1890,7 @@
           <a:lstStyle/>
           <a:p>
             <a:pPr algn="r"/>
-            <a:fld id="{60815C65-45B5-4361-835E-3C8DEDBC6B96}" type="slidenum">
+            <a:fld id="{6DA7BCB9-CED7-4EEE-A4D9-B17C9CCC9789}" type="slidenum">
               <a:rPr lang="en-US" sz="1000">
                 <a:solidFill>
                   <a:srgbClr val="9AA3B0"/>
@@ -2281,7 +2239,7 @@
           <a:lstStyle/>
           <a:p>
             <a:pPr algn="r"/>
-            <a:fld id="{D70F0EAC-8327-4E40-90F0-0393DE9E2D3D}" type="slidenum">
+            <a:fld id="{CF9285E1-452B-4A62-B164-241FC198C23D}" type="slidenum">
               <a:rPr lang="en-US" sz="1000">
                 <a:solidFill>
                   <a:srgbClr val="9AA3B0"/>
@@ -3169,7 +3127,7 @@
           <a:lstStyle/>
           <a:p>
             <a:pPr algn="r"/>
-            <a:fld id="{4B112CB8-93A7-49FA-A452-84FCA69F36A7}" type="slidenum">
+            <a:fld id="{39092A75-A224-4E8F-80C6-A1EE8E265FED}" type="slidenum">
               <a:rPr lang="en-US" sz="1000">
                 <a:solidFill>
                   <a:srgbClr val="9AA3B0"/>
@@ -3497,7 +3455,7 @@
           <a:lstStyle/>
           <a:p>
             <a:pPr algn="r"/>
-            <a:fld id="{313D518F-B1DF-4EAC-9870-E77001AFE226}" type="slidenum">
+            <a:fld id="{6CE7E581-49B7-4B42-8F52-20EE8FF92F1C}" type="slidenum">
               <a:rPr lang="en-US" sz="1000">
                 <a:solidFill>
                   <a:srgbClr val="9AA3B0"/>
@@ -3866,7 +3824,7 @@
           <a:lstStyle/>
           <a:p>
             <a:pPr algn="r"/>
-            <a:fld id="{31BBB3E0-6F04-4363-8C5D-715AD39EBC00}" type="slidenum">
+            <a:fld id="{8888F1B3-29B5-4345-B032-B696C849B58C}" type="slidenum">
               <a:rPr lang="en-US" sz="1000">
                 <a:solidFill>
                   <a:srgbClr val="9AA3B0"/>
@@ -4792,7 +4750,7 @@
           <a:lstStyle/>
           <a:p>
             <a:pPr algn="r"/>
-            <a:fld id="{E4E5DD25-805D-477B-B964-70CA802718BA}" type="slidenum">
+            <a:fld id="{6BEC6096-64AB-49E0-B91C-9C34ED120102}" type="slidenum">
               <a:rPr lang="en-US" sz="1000">
                 <a:solidFill>
                   <a:srgbClr val="9AA3B0"/>
@@ -5141,7 +5099,7 @@
           <a:lstStyle/>
           <a:p>
             <a:pPr algn="r"/>
-            <a:fld id="{B3CE1E3B-5704-4061-8825-4A2F82CCFE4A}" type="slidenum">
+            <a:fld id="{118B3996-1CDC-4D30-8741-BF77A36F17DD}" type="slidenum">
               <a:rPr lang="en-US" sz="1000">
                 <a:solidFill>
                   <a:srgbClr val="9AA3B0"/>
@@ -6056,7 +6014,7 @@
           <a:lstStyle/>
           <a:p>
             <a:pPr algn="r"/>
-            <a:fld id="{1DECF7D0-4D85-4591-AD21-990E225BC076}" type="slidenum">
+            <a:fld id="{F6933381-1F99-46CF-97C4-55D95394D7DE}" type="slidenum">
               <a:rPr lang="en-US" sz="1000">
                 <a:solidFill>
                   <a:srgbClr val="9AA3B0"/>
@@ -6248,7 +6206,7 @@
                 <a:ea typeface="Microsoft YaHei"/>
                 <a:cs typeface="Microsoft YaHei"/>
               </a:rPr>
-              <a:t>▪  顶层 IO 摆放决定对外接口，影响封装 / ESD / 电源焊盘 / 边界</a:t>
+              <a:t>顶层 IO 摆放决定芯片对外接口位置，影响封装、ESD、电源焊盘与芯片边界；模块级引脚分配则决定层次化模块之间如何连接，影响模块间布线、时序预算、feedthrough 与全芯片收敛。</a:t>
             </a:r>
           </a:p>
           <a:p>
@@ -6269,7 +6227,7 @@
                 <a:ea typeface="Microsoft YaHei"/>
                 <a:cs typeface="Microsoft YaHei"/>
               </a:rPr>
-              <a:t>▪  模块级引脚决定层次化模块间连接、布线、时序预算与收敛</a:t>
+              <a:t>模块级引脚的约束常包括布线层、引脚间距与尺寸、重叠规则、网络分组、引脚引导区域、数据流方向，以及试布线的边界穿越情况。</a:t>
             </a:r>
           </a:p>
           <a:p>
@@ -6290,70 +6248,7 @@
                 <a:ea typeface="Microsoft YaHei"/>
                 <a:cs typeface="Microsoft YaHei"/>
               </a:rPr>
-              <a:t>▪  模块 pin 约束：布线层、间距、尺寸、重叠、网络分组、引导区、数据流方向</a:t>
-            </a:r>
-          </a:p>
-          <a:p>
-            <a:pPr algn="l">
-              <a:lnSpc>
-                <a:spcPct val="116000"/>
-              </a:lnSpc>
-              <a:spcAft>
-                <a:spcPts val="800"/>
-              </a:spcAft>
-            </a:pPr>
-            <a:r>
-              <a:rPr sz="1400" b="0">
-                <a:solidFill>
-                  <a:srgbClr val="1A1F2B"/>
-                </a:solidFill>
-                <a:latin typeface="Microsoft YaHei"/>
-                <a:ea typeface="Microsoft YaHei"/>
-                <a:cs typeface="Microsoft YaHei"/>
-              </a:rPr>
-              <a:t>▪  无通道 / 通道紧张的设计中 feedthrough 很关键</a:t>
-            </a:r>
-          </a:p>
-          <a:p>
-            <a:pPr algn="l">
-              <a:lnSpc>
-                <a:spcPct val="116000"/>
-              </a:lnSpc>
-              <a:spcAft>
-                <a:spcPts val="800"/>
-              </a:spcAft>
-            </a:pPr>
-            <a:r>
-              <a:rPr sz="1400" b="0">
-                <a:solidFill>
-                  <a:srgbClr val="1A1F2B"/>
-                </a:solidFill>
-                <a:latin typeface="Microsoft YaHei"/>
-                <a:ea typeface="Microsoft YaHei"/>
-                <a:cs typeface="Microsoft YaHei"/>
-              </a:rPr>
-              <a:t>▪  信号穿过无 feedthrough 的中间分区，会被迫绕过整块</a:t>
-            </a:r>
-          </a:p>
-          <a:p>
-            <a:pPr algn="l">
-              <a:lnSpc>
-                <a:spcPct val="116000"/>
-              </a:lnSpc>
-              <a:spcAft>
-                <a:spcPts val="800"/>
-              </a:spcAft>
-            </a:pPr>
-            <a:r>
-              <a:rPr sz="1400" b="0">
-                <a:solidFill>
-                  <a:srgbClr val="1A1F2B"/>
-                </a:solidFill>
-                <a:latin typeface="Microsoft YaHei"/>
-                <a:ea typeface="Microsoft YaHei"/>
-                <a:cs typeface="Microsoft YaHei"/>
-              </a:rPr>
-              <a:t>▪  解法：在中间分区生成 feedthrough 引脚 / 网络，把跨越拆成几段</a:t>
+              <a:t>在无通道或通道资源紧张的设计中 feedthrough 很关键：若信号从分区 A 经分区 B 到分区 C，而 B 没有 feedthrough，信号可能被迫绕过整个模块。解法是在 B 上生成 feedthrough 引脚 / 网络，把跨越 B 的连接拆成几段。</a:t>
             </a:r>
           </a:p>
         </p:txBody>
@@ -6405,7 +6300,7 @@
           <a:lstStyle/>
           <a:p>
             <a:pPr algn="r"/>
-            <a:fld id="{7D745C7B-6DE9-4A41-87CD-CB5B5226A4A9}" type="slidenum">
+            <a:fld id="{6BD8C240-218D-44A4-BE58-363A5F26341E}" type="slidenum">
               <a:rPr lang="en-US" sz="1000">
                 <a:solidFill>
                   <a:srgbClr val="9AA3B0"/>
@@ -7671,7 +7566,7 @@
           <a:lstStyle/>
           <a:p>
             <a:pPr algn="r"/>
-            <a:fld id="{A55E6260-E706-48CD-8B65-8C354C417E59}" type="slidenum">
+            <a:fld id="{5861ABF0-F969-4EBA-AE06-62D996492164}" type="slidenum">
               <a:rPr lang="en-US" sz="1000">
                 <a:solidFill>
                   <a:srgbClr val="9AA3B0"/>
@@ -7863,7 +7758,7 @@
                 <a:ea typeface="Microsoft YaHei"/>
                 <a:cs typeface="Microsoft YaHei"/>
               </a:rPr>
-              <a:t>▪  IR 压降是供电线上的电压下降：ΔV = I · R</a:t>
+              <a:t>IR 压降是供电线上的电压下降，ΔV = I·R。芯片电源网格是个巨大网络，工具建立电阻矩阵、结合每个门的平均电流，求解每个节点的电压。</a:t>
             </a:r>
           </a:p>
           <a:p>
@@ -7884,7 +7779,7 @@
                 <a:ea typeface="Microsoft YaHei"/>
                 <a:cs typeface="Microsoft YaHei"/>
               </a:rPr>
-              <a:t>▪  工具建电阻矩阵 + 各门平均电流，求解每个节点电压</a:t>
+              <a:t>若实际电压低于容差下限，单元延迟会增加、时序可能失败，严重时功能错误。</a:t>
             </a:r>
           </a:p>
           <a:p>
@@ -7905,70 +7800,7 @@
                 <a:ea typeface="Microsoft YaHei"/>
                 <a:cs typeface="Microsoft YaHei"/>
               </a:rPr>
-              <a:t>▪  实际电压低于容差 → 延迟增大、时序失败，严重时功能错误</a:t>
-            </a:r>
-          </a:p>
-          <a:p>
-            <a:pPr algn="l">
-              <a:lnSpc>
-                <a:spcPct val="116000"/>
-              </a:lnSpc>
-              <a:spcAft>
-                <a:spcPts val="800"/>
-              </a:spcAft>
-            </a:pPr>
-            <a:r>
-              <a:rPr sz="1400" b="0">
-                <a:solidFill>
-                  <a:srgbClr val="1A1F2B"/>
-                </a:solidFill>
-                <a:latin typeface="Microsoft YaHei"/>
-                <a:ea typeface="Microsoft YaHei"/>
-                <a:cs typeface="Microsoft YaHei"/>
-              </a:rPr>
-              <a:t>▪  估算：1mm×100nm 的 M1 轨（0.1Ω/□）线阻约 1000Ω</a:t>
-            </a:r>
-          </a:p>
-          <a:p>
-            <a:pPr algn="l">
-              <a:lnSpc>
-                <a:spcPct val="116000"/>
-              </a:lnSpc>
-              <a:spcAft>
-                <a:spcPts val="800"/>
-              </a:spcAft>
-            </a:pPr>
-            <a:r>
-              <a:rPr sz="1400" b="0">
-                <a:solidFill>
-                  <a:srgbClr val="1A1F2B"/>
-                </a:solidFill>
-                <a:latin typeface="Microsoft YaHei"/>
-                <a:ea typeface="Microsoft YaHei"/>
-                <a:cs typeface="Microsoft YaHei"/>
-              </a:rPr>
-              <a:t>▪  承载约 0.1mA 时 IR 压降可达约 100mV</a:t>
-            </a:r>
-          </a:p>
-          <a:p>
-            <a:pPr algn="l">
-              <a:lnSpc>
-                <a:spcPct val="116000"/>
-              </a:lnSpc>
-              <a:spcAft>
-                <a:spcPts val="800"/>
-              </a:spcAft>
-            </a:pPr>
-            <a:r>
-              <a:rPr sz="1400" b="0">
-                <a:solidFill>
-                  <a:srgbClr val="1A1F2B"/>
-                </a:solidFill>
-                <a:latin typeface="Microsoft YaHei"/>
-                <a:ea typeface="Microsoft YaHei"/>
-                <a:cs typeface="Microsoft YaHei"/>
-              </a:rPr>
-              <a:t>▪  结论：必须用更宽 / 更厚 / 更高层 / 多路径 / 多过孔的结构</a:t>
+              <a:t>一个典型估算：1 mm 长、100 nm 宽的 M1 电源轨，方块电阻 0.1 Ω/□ 时线阻约 1000 Ω，承载约 0.1 mA 时 IR 压降可达约 100 mV——细而长的低层电源线无法单独供电，必须用更宽、更厚、更高层、多路径、多过孔的结构。</a:t>
             </a:r>
           </a:p>
         </p:txBody>
@@ -8020,7 +7852,7 @@
           <a:lstStyle/>
           <a:p>
             <a:pPr algn="r"/>
-            <a:fld id="{E92252FF-687D-48CB-9166-DCD192C26F6B}" type="slidenum">
+            <a:fld id="{E3F978EA-E96F-4563-9CD8-D14A8212D9F6}" type="slidenum">
               <a:rPr lang="en-US" sz="1000">
                 <a:solidFill>
                   <a:srgbClr val="9AA3B0"/>
@@ -8368,7 +8200,7 @@
           <a:lstStyle/>
           <a:p>
             <a:pPr algn="r"/>
-            <a:fld id="{EFB3E82C-5779-4297-8F37-8507690A4331}" type="slidenum">
+            <a:fld id="{C90631B8-8431-44A9-9821-9E76F7FDF897}" type="slidenum">
               <a:rPr lang="en-US" sz="1000">
                 <a:solidFill>
                   <a:srgbClr val="9AA3B0"/>
@@ -9256,7 +9088,7 @@
           <a:lstStyle/>
           <a:p>
             <a:pPr algn="r"/>
-            <a:fld id="{629184CE-E705-4E88-A4E1-ECC38DF00283}" type="slidenum">
+            <a:fld id="{1F71D001-7C9C-45B2-AE32-318A334A5FDD}" type="slidenum">
               <a:rPr lang="en-US" sz="1000">
                 <a:solidFill>
                   <a:srgbClr val="9AA3B0"/>
@@ -10102,7 +9934,7 @@
           <a:lstStyle/>
           <a:p>
             <a:pPr algn="r"/>
-            <a:fld id="{2BF084A5-469A-44EA-9AE7-3AC16017E3B8}" type="slidenum">
+            <a:fld id="{C59AC980-431D-40A2-A573-C5B1457C64B3}" type="slidenum">
               <a:rPr lang="en-US" sz="1000">
                 <a:solidFill>
                   <a:srgbClr val="9AA3B0"/>
@@ -10427,7 +10259,7 @@
           <a:lstStyle/>
           <a:p>
             <a:pPr algn="r"/>
-            <a:fld id="{5F573DB3-E687-4DEA-814A-62A34C1C03F0}" type="slidenum">
+            <a:fld id="{5534D947-1BF1-4ED0-921C-8BBF55A5D711}" type="slidenum">
               <a:rPr lang="en-US" sz="1000">
                 <a:solidFill>
                   <a:srgbClr val="9AA3B0"/>
@@ -10776,7 +10608,7 @@
           <a:lstStyle/>
           <a:p>
             <a:pPr algn="r"/>
-            <a:fld id="{1ED25D2C-7CFD-4DA6-AB56-A6CA7CE987B4}" type="slidenum">
+            <a:fld id="{F613B7A0-6152-4BAF-B182-C7BDE70B0DEF}" type="slidenum">
               <a:rPr lang="en-US" sz="1000">
                 <a:solidFill>
                   <a:srgbClr val="9AA3B0"/>
@@ -12364,7 +12196,7 @@
           <a:lstStyle/>
           <a:p>
             <a:pPr algn="r"/>
-            <a:fld id="{31987454-DF0E-40CA-A506-3D43B902597E}" type="slidenum">
+            <a:fld id="{B6BAAB42-28A5-4A75-BE00-453DDE40F0FC}" type="slidenum">
               <a:rPr lang="en-US" sz="1000">
                 <a:solidFill>
                   <a:srgbClr val="9AA3B0"/>
@@ -13389,7 +13221,7 @@
           <a:lstStyle/>
           <a:p>
             <a:pPr algn="r"/>
-            <a:fld id="{A8E2CD2D-C947-41E0-8AC7-9F508F55C554}" type="slidenum">
+            <a:fld id="{5B2F85FF-1A85-43A3-A5B4-E297466DA69E}" type="slidenum">
               <a:rPr lang="en-US" sz="1000">
                 <a:solidFill>
                   <a:srgbClr val="9AA3B0"/>
@@ -14167,7 +13999,7 @@
           <a:lstStyle/>
           <a:p>
             <a:pPr algn="r"/>
-            <a:fld id="{4FAD4592-72C5-4476-A552-C1E002F843B1}" type="slidenum">
+            <a:fld id="{64894240-A8C1-4841-9B6B-682DD28EA610}" type="slidenum">
               <a:rPr lang="en-US" sz="1000">
                 <a:solidFill>
                   <a:srgbClr val="9AA3B0"/>
@@ -14814,7 +14646,7 @@
           <a:lstStyle/>
           <a:p>
             <a:pPr algn="r"/>
-            <a:fld id="{FBFFCFD3-7817-4390-8B5B-71ACEA8CFA6A}" type="slidenum">
+            <a:fld id="{FE4D8DCF-CB7B-4CCC-A6FE-82C7229E6420}" type="slidenum">
               <a:rPr lang="en-US" sz="1000">
                 <a:solidFill>
                   <a:srgbClr val="9AA3B0"/>
@@ -15476,7 +15308,7 @@
           <a:lstStyle/>
           <a:p>
             <a:pPr algn="r"/>
-            <a:fld id="{E3401C14-77B9-4DB3-8418-E6F6696C18C1}" type="slidenum">
+            <a:fld id="{BA7DA80D-D7C4-4313-B442-F7D0BBC86FB9}" type="slidenum">
               <a:rPr lang="en-US" sz="1000">
                 <a:solidFill>
                   <a:srgbClr val="9AA3B0"/>
@@ -15825,7 +15657,7 @@
           <a:lstStyle/>
           <a:p>
             <a:pPr algn="r"/>
-            <a:fld id="{FD433C96-A62B-4296-9618-103A6526D11E}" type="slidenum">
+            <a:fld id="{E933E586-EEF3-4D87-A365-D7393CFD3289}" type="slidenum">
               <a:rPr lang="en-US" sz="1000">
                 <a:solidFill>
                   <a:srgbClr val="9AA3B0"/>
@@ -16855,7 +16687,7 @@
           <a:lstStyle/>
           <a:p>
             <a:pPr algn="r"/>
-            <a:fld id="{5F55933E-A569-4AC5-A634-1A5DB32ED61D}" type="slidenum">
+            <a:fld id="{0D1B071B-C112-4097-9558-3DE0EC89F884}" type="slidenum">
               <a:rPr lang="en-US" sz="1000">
                 <a:solidFill>
                   <a:srgbClr val="9AA3B0"/>
@@ -17204,7 +17036,7 @@
           <a:lstStyle/>
           <a:p>
             <a:pPr algn="r"/>
-            <a:fld id="{F963078C-C2B8-4141-AEEC-C6EBD3F68C6B}" type="slidenum">
+            <a:fld id="{F7EE3B4F-A495-40E9-9E03-D216F8F8135E}" type="slidenum">
               <a:rPr lang="en-US" sz="1000">
                 <a:solidFill>
                   <a:srgbClr val="9AA3B0"/>

</xml_diff>

<commit_message>
① extend prose to 2.2 / 4.1 (note-faithful paragraphs; folded genuine lists into sentences)
Co-Authored-By: Claude Opus 4.8 <noreply@anthropic.com>
</commit_message>
<xml_diff>
--- a/IC_Backend_Notes/slides/05_Floorplan.pptx
+++ b/IC_Backend_Notes/slides/05_Floorplan.pptx
@@ -1255,7 +1255,7 @@
           <a:lstStyle/>
           <a:p>
             <a:pPr algn="r"/>
-            <a:fld id="{01521D2C-28F4-44B6-8EA4-8D65AAF07430}" type="slidenum">
+            <a:fld id="{6F8B6C25-106C-43FC-A911-4E07F88D7D90}" type="slidenum">
               <a:rPr lang="en-US" sz="1000">
                 <a:solidFill>
                   <a:srgbClr val="9AA3B0"/>
@@ -1447,7 +1447,7 @@
                 <a:ea typeface="Microsoft YaHei"/>
                 <a:cs typeface="Microsoft YaHei"/>
               </a:rPr>
-              <a:t>▪  Floorplan 利用率 = 标准单元占核心区比例，常见初值约 70%</a:t>
+              <a:t>Floorplan 阶段的利用率通常指标准单元占核心区面积的比例，常见初值约 70%。</a:t>
             </a:r>
           </a:p>
           <a:p>
@@ -1468,7 +1468,7 @@
                 <a:ea typeface="Microsoft YaHei"/>
                 <a:cs typeface="Microsoft YaHei"/>
               </a:rPr>
-              <a:t>▪  太高 → 拥塞上升、合法化 / 优化自由度不足、局部拥塞、抢 PG 资源</a:t>
+              <a:t>利用率太高会带来布线拥塞、合法化与优化自由度不足、引脚密集处局部拥塞，以及电源网格与信号抢资源；太低则浪费面积、拉长平均互连。</a:t>
             </a:r>
           </a:p>
           <a:p>
@@ -1489,70 +1489,7 @@
                 <a:ea typeface="Microsoft YaHei"/>
                 <a:cs typeface="Microsoft YaHei"/>
               </a:rPr>
-              <a:t>▪  太低 → 浪费晶粒面积、平均互连变长</a:t>
-            </a:r>
-          </a:p>
-          <a:p>
-            <a:pPr algn="l">
-              <a:lnSpc>
-                <a:spcPct val="116000"/>
-              </a:lnSpc>
-              <a:spcAft>
-                <a:spcPts val="800"/>
-              </a:spcAft>
-            </a:pPr>
-            <a:r>
-              <a:rPr sz="1400" b="0">
-                <a:solidFill>
-                  <a:srgbClr val="1A1F2B"/>
-                </a:solidFill>
-                <a:latin typeface="Microsoft YaHei"/>
-                <a:ea typeface="Microsoft YaHei"/>
-                <a:cs typeface="Microsoft YaHei"/>
-              </a:rPr>
-              <a:t>▪  总利用率 =（Σ单元 + Σ宏）/ 核心区面积</a:t>
-            </a:r>
-          </a:p>
-          <a:p>
-            <a:pPr algn="l">
-              <a:lnSpc>
-                <a:spcPct val="116000"/>
-              </a:lnSpc>
-              <a:spcAft>
-                <a:spcPts val="800"/>
-              </a:spcAft>
-            </a:pPr>
-            <a:r>
-              <a:rPr sz="1400" b="0">
-                <a:solidFill>
-                  <a:srgbClr val="1A1F2B"/>
-                </a:solidFill>
-                <a:latin typeface="Microsoft YaHei"/>
-                <a:ea typeface="Microsoft YaHei"/>
-                <a:cs typeface="Microsoft YaHei"/>
-              </a:rPr>
-              <a:t>▪  有效利用率 = Σ单元 /（核心区 − 阻挡 − 宏留边 − 禁布区）</a:t>
-            </a:r>
-          </a:p>
-          <a:p>
-            <a:pPr algn="l">
-              <a:lnSpc>
-                <a:spcPct val="116000"/>
-              </a:lnSpc>
-              <a:spcAft>
-                <a:spcPts val="800"/>
-              </a:spcAft>
-            </a:pPr>
-            <a:r>
-              <a:rPr sz="1400" b="0">
-                <a:solidFill>
-                  <a:srgbClr val="1A1F2B"/>
-                </a:solidFill>
-                <a:latin typeface="Microsoft YaHei"/>
-                <a:ea typeface="Microsoft YaHei"/>
-                <a:cs typeface="Microsoft YaHei"/>
-              </a:rPr>
-              <a:t>▪  不能只凭利用率定尺寸：先跑试布线 / 全局布线估拥塞再决定</a:t>
+              <a:t>工程上要区分总利用率（含宏）与有效利用率（扣除阻挡、宏留边、禁布区）；但不能只凭利用率定尺寸——完成初始估算后还要跑试布线或全局布线估拥塞，再决定是否放大核心、调综合、移宏或改引脚。</a:t>
             </a:r>
           </a:p>
         </p:txBody>
@@ -1604,7 +1541,7 @@
           <a:lstStyle/>
           <a:p>
             <a:pPr algn="r"/>
-            <a:fld id="{75094B48-A983-46E6-A8D4-6D3A88E5367E}" type="slidenum">
+            <a:fld id="{82EB5A1E-E2EC-4D73-8852-D38556845169}" type="slidenum">
               <a:rPr lang="en-US" sz="1000">
                 <a:solidFill>
                   <a:srgbClr val="9AA3B0"/>
@@ -1890,7 +1827,7 @@
           <a:lstStyle/>
           <a:p>
             <a:pPr algn="r"/>
-            <a:fld id="{6DA7BCB9-CED7-4EEE-A4D9-B17C9CCC9789}" type="slidenum">
+            <a:fld id="{AF1FD4E7-E9A8-4D52-9ABA-516CF8EA0397}" type="slidenum">
               <a:rPr lang="en-US" sz="1000">
                 <a:solidFill>
                   <a:srgbClr val="9AA3B0"/>
@@ -2239,7 +2176,7 @@
           <a:lstStyle/>
           <a:p>
             <a:pPr algn="r"/>
-            <a:fld id="{CF9285E1-452B-4A62-B164-241FC198C23D}" type="slidenum">
+            <a:fld id="{9601574E-85F2-4D55-98F2-EF0E6EABA4B9}" type="slidenum">
               <a:rPr lang="en-US" sz="1000">
                 <a:solidFill>
                   <a:srgbClr val="9AA3B0"/>
@@ -3127,7 +3064,7 @@
           <a:lstStyle/>
           <a:p>
             <a:pPr algn="r"/>
-            <a:fld id="{39092A75-A224-4E8F-80C6-A1EE8E265FED}" type="slidenum">
+            <a:fld id="{B24DEE3C-2B59-4303-B1F6-4BC6755E0501}" type="slidenum">
               <a:rPr lang="en-US" sz="1000">
                 <a:solidFill>
                   <a:srgbClr val="9AA3B0"/>
@@ -3455,7 +3392,7 @@
           <a:lstStyle/>
           <a:p>
             <a:pPr algn="r"/>
-            <a:fld id="{6CE7E581-49B7-4B42-8F52-20EE8FF92F1C}" type="slidenum">
+            <a:fld id="{6A125483-3AC9-4703-815D-4C30054963E6}" type="slidenum">
               <a:rPr lang="en-US" sz="1000">
                 <a:solidFill>
                   <a:srgbClr val="9AA3B0"/>
@@ -3824,7 +3761,7 @@
           <a:lstStyle/>
           <a:p>
             <a:pPr algn="r"/>
-            <a:fld id="{8888F1B3-29B5-4345-B032-B696C849B58C}" type="slidenum">
+            <a:fld id="{67DF5C0C-A714-4210-942C-F1EB68B5E505}" type="slidenum">
               <a:rPr lang="en-US" sz="1000">
                 <a:solidFill>
                   <a:srgbClr val="9AA3B0"/>
@@ -4750,7 +4687,7 @@
           <a:lstStyle/>
           <a:p>
             <a:pPr algn="r"/>
-            <a:fld id="{6BEC6096-64AB-49E0-B91C-9C34ED120102}" type="slidenum">
+            <a:fld id="{61F4E830-3146-4214-A7CF-35E94431DB77}" type="slidenum">
               <a:rPr lang="en-US" sz="1000">
                 <a:solidFill>
                   <a:srgbClr val="9AA3B0"/>
@@ -5099,7 +5036,7 @@
           <a:lstStyle/>
           <a:p>
             <a:pPr algn="r"/>
-            <a:fld id="{118B3996-1CDC-4D30-8741-BF77A36F17DD}" type="slidenum">
+            <a:fld id="{48BABD96-86E4-4A18-9E31-345EA57EA1E1}" type="slidenum">
               <a:rPr lang="en-US" sz="1000">
                 <a:solidFill>
                   <a:srgbClr val="9AA3B0"/>
@@ -6014,7 +5951,7 @@
           <a:lstStyle/>
           <a:p>
             <a:pPr algn="r"/>
-            <a:fld id="{F6933381-1F99-46CF-97C4-55D95394D7DE}" type="slidenum">
+            <a:fld id="{5BFEE65C-DDA6-4291-8414-337855263930}" type="slidenum">
               <a:rPr lang="en-US" sz="1000">
                 <a:solidFill>
                   <a:srgbClr val="9AA3B0"/>
@@ -6300,7 +6237,7 @@
           <a:lstStyle/>
           <a:p>
             <a:pPr algn="r"/>
-            <a:fld id="{6BD8C240-218D-44A4-BE58-363A5F26341E}" type="slidenum">
+            <a:fld id="{7C900152-436C-4559-8365-556BC94554D1}" type="slidenum">
               <a:rPr lang="en-US" sz="1000">
                 <a:solidFill>
                   <a:srgbClr val="9AA3B0"/>
@@ -7409,7 +7346,7 @@
                 <a:ea typeface="Microsoft YaHei"/>
                 <a:cs typeface="Microsoft YaHei"/>
               </a:rPr>
-              <a:t>▪  电源规划关系动态功耗、静态漏电、IR、电压跌落、EM、自热磨损</a:t>
+              <a:t>电源规划要解决的不只是“连上 VDD/GND”，它同时关系到动态功耗、静态漏电、IR 压降、电压跌落、电迁移和自热磨损。</a:t>
             </a:r>
           </a:p>
           <a:p>
@@ -7430,7 +7367,7 @@
                 <a:ea typeface="Microsoft YaHei"/>
                 <a:cs typeface="Microsoft YaHei"/>
               </a:rPr>
-              <a:t>▪  PDN 要把电流从焊盘 / 凸点送到晶体管</a:t>
+              <a:t>电源分布网络（PDN）需要把电流从焊盘 / 凸点送到晶体管，保持稳定低噪声的电压，提供平均与峰值功耗，为信号提供返回路径，避免电迁移与自热，并合理占用面积与布线资源。</a:t>
             </a:r>
           </a:p>
           <a:p>
@@ -7451,70 +7388,7 @@
                 <a:ea typeface="Microsoft YaHei"/>
                 <a:cs typeface="Microsoft YaHei"/>
               </a:rPr>
-              <a:t>▪  保持稳定低噪声电压，提供平均与峰值功耗需求</a:t>
-            </a:r>
-          </a:p>
-          <a:p>
-            <a:pPr algn="l">
-              <a:lnSpc>
-                <a:spcPct val="116000"/>
-              </a:lnSpc>
-              <a:spcAft>
-                <a:spcPts val="800"/>
-              </a:spcAft>
-            </a:pPr>
-            <a:r>
-              <a:rPr sz="1400" b="0">
-                <a:solidFill>
-                  <a:srgbClr val="1A1F2B"/>
-                </a:solidFill>
-                <a:latin typeface="Microsoft YaHei"/>
-                <a:ea typeface="Microsoft YaHei"/>
-                <a:cs typeface="Microsoft YaHei"/>
-              </a:rPr>
-              <a:t>▪  为信号提供返回路径，避免 EM 与自热磨损</a:t>
-            </a:r>
-          </a:p>
-          <a:p>
-            <a:pPr algn="l">
-              <a:lnSpc>
-                <a:spcPct val="116000"/>
-              </a:lnSpc>
-              <a:spcAft>
-                <a:spcPts val="800"/>
-              </a:spcAft>
-            </a:pPr>
-            <a:r>
-              <a:rPr sz="1400" b="0">
-                <a:solidFill>
-                  <a:srgbClr val="1A1F2B"/>
-                </a:solidFill>
-                <a:latin typeface="Microsoft YaHei"/>
-                <a:ea typeface="Microsoft YaHei"/>
-                <a:cs typeface="Microsoft YaHei"/>
-              </a:rPr>
-              <a:t>▪  合理占用芯片面积与布线资源</a:t>
-            </a:r>
-          </a:p>
-          <a:p>
-            <a:pPr algn="l">
-              <a:lnSpc>
-                <a:spcPct val="116000"/>
-              </a:lnSpc>
-              <a:spcAft>
-                <a:spcPts val="800"/>
-              </a:spcAft>
-            </a:pPr>
-            <a:r>
-              <a:rPr sz="1400" b="0">
-                <a:solidFill>
-                  <a:srgbClr val="1A1F2B"/>
-                </a:solidFill>
-                <a:latin typeface="Microsoft YaHei"/>
-                <a:ea typeface="Microsoft YaHei"/>
-                <a:cs typeface="Microsoft YaHei"/>
-              </a:rPr>
-              <a:t>▪  从 floorplan 阶段就开始，而非布线后补救</a:t>
+              <a:t>因此电源规划从 floorplan 阶段就开始，而不是等布线之后再补救。</a:t>
             </a:r>
           </a:p>
         </p:txBody>
@@ -7566,7 +7440,7 @@
           <a:lstStyle/>
           <a:p>
             <a:pPr algn="r"/>
-            <a:fld id="{5861ABF0-F969-4EBA-AE06-62D996492164}" type="slidenum">
+            <a:fld id="{AA664313-3ADD-4C63-B8B6-1F482250C2B8}" type="slidenum">
               <a:rPr lang="en-US" sz="1000">
                 <a:solidFill>
                   <a:srgbClr val="9AA3B0"/>
@@ -7852,7 +7726,7 @@
           <a:lstStyle/>
           <a:p>
             <a:pPr algn="r"/>
-            <a:fld id="{E3F978EA-E96F-4563-9CD8-D14A8212D9F6}" type="slidenum">
+            <a:fld id="{2E09271A-51CA-4307-AC04-71E1058643E7}" type="slidenum">
               <a:rPr lang="en-US" sz="1000">
                 <a:solidFill>
                   <a:srgbClr val="9AA3B0"/>
@@ -8200,7 +8074,7 @@
           <a:lstStyle/>
           <a:p>
             <a:pPr algn="r"/>
-            <a:fld id="{C90631B8-8431-44A9-9821-9E76F7FDF897}" type="slidenum">
+            <a:fld id="{3488F4D0-9DF2-4325-B0D0-B4A8DF2A8706}" type="slidenum">
               <a:rPr lang="en-US" sz="1000">
                 <a:solidFill>
                   <a:srgbClr val="9AA3B0"/>
@@ -9088,7 +8962,7 @@
           <a:lstStyle/>
           <a:p>
             <a:pPr algn="r"/>
-            <a:fld id="{1F71D001-7C9C-45B2-AE32-318A334A5FDD}" type="slidenum">
+            <a:fld id="{2ED3AD23-CAD1-417B-85BA-262BFDA45079}" type="slidenum">
               <a:rPr lang="en-US" sz="1000">
                 <a:solidFill>
                   <a:srgbClr val="9AA3B0"/>
@@ -9934,7 +9808,7 @@
           <a:lstStyle/>
           <a:p>
             <a:pPr algn="r"/>
-            <a:fld id="{C59AC980-431D-40A2-A573-C5B1457C64B3}" type="slidenum">
+            <a:fld id="{94E93B7D-5A9C-4E5B-AD36-91B1015A9AA1}" type="slidenum">
               <a:rPr lang="en-US" sz="1000">
                 <a:solidFill>
                   <a:srgbClr val="9AA3B0"/>
@@ -10259,7 +10133,7 @@
           <a:lstStyle/>
           <a:p>
             <a:pPr algn="r"/>
-            <a:fld id="{5534D947-1BF1-4ED0-921C-8BBF55A5D711}" type="slidenum">
+            <a:fld id="{016D836E-E2FE-497D-94EC-96212BDCD090}" type="slidenum">
               <a:rPr lang="en-US" sz="1000">
                 <a:solidFill>
                   <a:srgbClr val="9AA3B0"/>
@@ -10608,7 +10482,7 @@
           <a:lstStyle/>
           <a:p>
             <a:pPr algn="r"/>
-            <a:fld id="{F613B7A0-6152-4BAF-B182-C7BDE70B0DEF}" type="slidenum">
+            <a:fld id="{1334EADD-3153-4C8F-B231-25283D5941B6}" type="slidenum">
               <a:rPr lang="en-US" sz="1000">
                 <a:solidFill>
                   <a:srgbClr val="9AA3B0"/>
@@ -12196,7 +12070,7 @@
           <a:lstStyle/>
           <a:p>
             <a:pPr algn="r"/>
-            <a:fld id="{B6BAAB42-28A5-4A75-BE00-453DDE40F0FC}" type="slidenum">
+            <a:fld id="{14735D9A-BDB8-46FD-ACB3-0CDABC9F8297}" type="slidenum">
               <a:rPr lang="en-US" sz="1000">
                 <a:solidFill>
                   <a:srgbClr val="9AA3B0"/>
@@ -13221,7 +13095,7 @@
           <a:lstStyle/>
           <a:p>
             <a:pPr algn="r"/>
-            <a:fld id="{5B2F85FF-1A85-43A3-A5B4-E297466DA69E}" type="slidenum">
+            <a:fld id="{68B93EA3-E0D1-49C9-8925-3848D94CF6F9}" type="slidenum">
               <a:rPr lang="en-US" sz="1000">
                 <a:solidFill>
                   <a:srgbClr val="9AA3B0"/>
@@ -13999,7 +13873,7 @@
           <a:lstStyle/>
           <a:p>
             <a:pPr algn="r"/>
-            <a:fld id="{64894240-A8C1-4841-9B6B-682DD28EA610}" type="slidenum">
+            <a:fld id="{2E728453-5078-4FE0-9740-6440E1ABB5F6}" type="slidenum">
               <a:rPr lang="en-US" sz="1000">
                 <a:solidFill>
                   <a:srgbClr val="9AA3B0"/>
@@ -14646,7 +14520,7 @@
           <a:lstStyle/>
           <a:p>
             <a:pPr algn="r"/>
-            <a:fld id="{FE4D8DCF-CB7B-4CCC-A6FE-82C7229E6420}" type="slidenum">
+            <a:fld id="{05C11166-C3F1-4A1F-9227-623723F64677}" type="slidenum">
               <a:rPr lang="en-US" sz="1000">
                 <a:solidFill>
                   <a:srgbClr val="9AA3B0"/>
@@ -15308,7 +15182,7 @@
           <a:lstStyle/>
           <a:p>
             <a:pPr algn="r"/>
-            <a:fld id="{BA7DA80D-D7C4-4313-B442-F7D0BBC86FB9}" type="slidenum">
+            <a:fld id="{CD3EACBC-746A-4ACB-8196-E00FED1F086E}" type="slidenum">
               <a:rPr lang="en-US" sz="1000">
                 <a:solidFill>
                   <a:srgbClr val="9AA3B0"/>
@@ -15657,7 +15531,7 @@
           <a:lstStyle/>
           <a:p>
             <a:pPr algn="r"/>
-            <a:fld id="{E933E586-EEF3-4D87-A365-D7393CFD3289}" type="slidenum">
+            <a:fld id="{F2CD6174-8429-459B-BFA1-7DFEE5F201F5}" type="slidenum">
               <a:rPr lang="en-US" sz="1000">
                 <a:solidFill>
                   <a:srgbClr val="9AA3B0"/>
@@ -16687,7 +16561,7 @@
           <a:lstStyle/>
           <a:p>
             <a:pPr algn="r"/>
-            <a:fld id="{0D1B071B-C112-4097-9558-3DE0EC89F884}" type="slidenum">
+            <a:fld id="{97700F37-5D52-4581-94C3-4EC638486A7E}" type="slidenum">
               <a:rPr lang="en-US" sz="1000">
                 <a:solidFill>
                   <a:srgbClr val="9AA3B0"/>
@@ -17036,7 +16910,7 @@
           <a:lstStyle/>
           <a:p>
             <a:pPr algn="r"/>
-            <a:fld id="{F7EE3B4F-A495-40E9-9E03-D216F8F8135E}" type="slidenum">
+            <a:fld id="{B48E2F2A-C2D1-4F1C-9BF3-161CC0F6B043}" type="slidenum">
               <a:rPr lang="en-US" sz="1000">
                 <a:solidFill>
                   <a:srgbClr val="9AA3B0"/>

</xml_diff>

<commit_message>
③ native-shape diagram engine: one layout drives editable pptx shapes + matplotlib preview; convert 5 box-diagrams (uniquify/hier/pnr/io/loop) to native via split(diagram=...) — editable in PowerPoint, not inserted images
Co-Authored-By: Claude Opus 4.8 <noreply@anthropic.com>
</commit_message>
<xml_diff>
--- a/IC_Backend_Notes/slides/05_Floorplan.pptx
+++ b/IC_Backend_Notes/slides/05_Floorplan.pptx
@@ -1255,7 +1255,7 @@
           <a:lstStyle/>
           <a:p>
             <a:pPr algn="r"/>
-            <a:fld id="{6F8B6C25-106C-43FC-A911-4E07F88D7D90}" type="slidenum">
+            <a:fld id="{53C74F42-B7B0-4985-B475-6F2C860A82DA}" type="slidenum">
               <a:rPr lang="en-US" sz="1000">
                 <a:solidFill>
                   <a:srgbClr val="9AA3B0"/>
@@ -1541,7 +1541,7 @@
           <a:lstStyle/>
           <a:p>
             <a:pPr algn="r"/>
-            <a:fld id="{82EB5A1E-E2EC-4D73-8852-D38556845169}" type="slidenum">
+            <a:fld id="{DF4D5A3E-B567-42AC-A1AB-DA62ACE1DC73}" type="slidenum">
               <a:rPr lang="en-US" sz="1000">
                 <a:solidFill>
                   <a:srgbClr val="9AA3B0"/>
@@ -1780,40 +1780,1131 @@
           </a:p>
         </p:txBody>
       </p:sp>
-      <p:pic>
-        <p:nvPicPr>
-          <p:cNvPr id="6" name="Picture 5" descr="f16_uniquify.png"/>
-          <p:cNvPicPr>
-            <a:picLocks noChangeAspect="1"/>
-          </p:cNvPicPr>
-          <p:nvPr/>
-        </p:nvPicPr>
-        <p:blipFill>
-          <a:blip r:embed="rId2"/>
-          <a:stretch>
-            <a:fillRect/>
-          </a:stretch>
-        </p:blipFill>
-        <p:spPr>
-          <a:xfrm>
-            <a:off x="5486400" y="1861440"/>
-            <a:ext cx="6263640" cy="4186679"/>
-          </a:xfrm>
-          <a:prstGeom prst="rect">
-            <a:avLst/>
-          </a:prstGeom>
-        </p:spPr>
-      </p:pic>
-      <p:sp>
-        <p:nvSpPr>
-          <p:cNvPr id="7" name="TextBox 6"/>
+      <p:sp>
+        <p:nvSpPr>
+          <p:cNvPr id="6" name="Rounded Rectangle 5"/>
+          <p:cNvSpPr/>
+          <p:nvPr/>
+        </p:nvSpPr>
+        <p:spPr>
+          <a:xfrm>
+            <a:off x="6400800" y="2194560"/>
+            <a:ext cx="1280160" cy="502920"/>
+          </a:xfrm>
+          <a:prstGeom prst="roundRect">
+            <a:avLst>
+              <a:gd name="adj" fmla="val 12000"/>
+            </a:avLst>
+          </a:prstGeom>
+          <a:solidFill>
+            <a:srgbClr val="EDF0F4"/>
+          </a:solidFill>
+          <a:ln w="19050">
+            <a:solidFill>
+              <a:srgbClr val="94A3B8"/>
+            </a:solidFill>
+          </a:ln>
+          <a:effectLst/>
+        </p:spPr>
+        <p:style>
+          <a:lnRef idx="1">
+            <a:schemeClr val="accent1"/>
+          </a:lnRef>
+          <a:fillRef idx="3">
+            <a:schemeClr val="accent1"/>
+          </a:fillRef>
+          <a:effectRef idx="2">
+            <a:schemeClr val="accent1"/>
+          </a:effectRef>
+          <a:fontRef idx="minor">
+            <a:schemeClr val="lt1"/>
+          </a:fontRef>
+        </p:style>
+        <p:txBody>
+          <a:bodyPr rtlCol="0" anchor="ctr" wrap="square" lIns="38100" rIns="38100" tIns="25400" bIns="25400"/>
+          <a:lstStyle/>
+          <a:p>
+            <a:pPr algn="ctr"/>
+            <a:r>
+              <a:rPr sz="1300" b="1">
+                <a:solidFill>
+                  <a:srgbClr val="1A1F2B"/>
+                </a:solidFill>
+                <a:latin typeface="Microsoft YaHei"/>
+                <a:ea typeface="Microsoft YaHei"/>
+                <a:cs typeface="Microsoft YaHei"/>
+              </a:rPr>
+              <a:t>top</a:t>
+            </a:r>
+          </a:p>
+        </p:txBody>
+      </p:sp>
+      <p:sp>
+        <p:nvSpPr>
+          <p:cNvPr id="7" name="Rounded Rectangle 6"/>
+          <p:cNvSpPr/>
+          <p:nvPr/>
+        </p:nvSpPr>
+        <p:spPr>
+          <a:xfrm>
+            <a:off x="5623560" y="3200400"/>
+            <a:ext cx="1188720" cy="502920"/>
+          </a:xfrm>
+          <a:prstGeom prst="roundRect">
+            <a:avLst>
+              <a:gd name="adj" fmla="val 12000"/>
+            </a:avLst>
+          </a:prstGeom>
+          <a:solidFill>
+            <a:srgbClr val="DBEAFE"/>
+          </a:solidFill>
+          <a:ln w="19050">
+            <a:solidFill>
+              <a:srgbClr val="1D4ED8"/>
+            </a:solidFill>
+          </a:ln>
+          <a:effectLst/>
+        </p:spPr>
+        <p:style>
+          <a:lnRef idx="1">
+            <a:schemeClr val="accent1"/>
+          </a:lnRef>
+          <a:fillRef idx="3">
+            <a:schemeClr val="accent1"/>
+          </a:fillRef>
+          <a:effectRef idx="2">
+            <a:schemeClr val="accent1"/>
+          </a:effectRef>
+          <a:fontRef idx="minor">
+            <a:schemeClr val="lt1"/>
+          </a:fontRef>
+        </p:style>
+        <p:txBody>
+          <a:bodyPr rtlCol="0" anchor="ctr" wrap="square" lIns="38100" rIns="38100" tIns="25400" bIns="25400"/>
+          <a:lstStyle/>
+          <a:p>
+            <a:pPr algn="ctr"/>
+            <a:r>
+              <a:rPr sz="1300" b="1">
+                <a:solidFill>
+                  <a:srgbClr val="1E3A8A"/>
+                </a:solidFill>
+                <a:latin typeface="Microsoft YaHei"/>
+                <a:ea typeface="Microsoft YaHei"/>
+                <a:cs typeface="Microsoft YaHei"/>
+              </a:rPr>
+              <a:t>m1</a:t>
+            </a:r>
+          </a:p>
+        </p:txBody>
+      </p:sp>
+      <p:sp>
+        <p:nvSpPr>
+          <p:cNvPr id="8" name="Rounded Rectangle 7"/>
+          <p:cNvSpPr/>
+          <p:nvPr/>
+        </p:nvSpPr>
+        <p:spPr>
+          <a:xfrm>
+            <a:off x="7269480" y="3200400"/>
+            <a:ext cx="1188720" cy="502920"/>
+          </a:xfrm>
+          <a:prstGeom prst="roundRect">
+            <a:avLst>
+              <a:gd name="adj" fmla="val 12000"/>
+            </a:avLst>
+          </a:prstGeom>
+          <a:solidFill>
+            <a:srgbClr val="DBEAFE"/>
+          </a:solidFill>
+          <a:ln w="19050">
+            <a:solidFill>
+              <a:srgbClr val="1D4ED8"/>
+            </a:solidFill>
+          </a:ln>
+          <a:effectLst/>
+        </p:spPr>
+        <p:style>
+          <a:lnRef idx="1">
+            <a:schemeClr val="accent1"/>
+          </a:lnRef>
+          <a:fillRef idx="3">
+            <a:schemeClr val="accent1"/>
+          </a:fillRef>
+          <a:effectRef idx="2">
+            <a:schemeClr val="accent1"/>
+          </a:effectRef>
+          <a:fontRef idx="minor">
+            <a:schemeClr val="lt1"/>
+          </a:fontRef>
+        </p:style>
+        <p:txBody>
+          <a:bodyPr rtlCol="0" anchor="ctr" wrap="square" lIns="38100" rIns="38100" tIns="25400" bIns="25400"/>
+          <a:lstStyle/>
+          <a:p>
+            <a:pPr algn="ctr"/>
+            <a:r>
+              <a:rPr sz="1300" b="1">
+                <a:solidFill>
+                  <a:srgbClr val="1E3A8A"/>
+                </a:solidFill>
+                <a:latin typeface="Microsoft YaHei"/>
+                <a:ea typeface="Microsoft YaHei"/>
+                <a:cs typeface="Microsoft YaHei"/>
+              </a:rPr>
+              <a:t>m2</a:t>
+            </a:r>
+          </a:p>
+        </p:txBody>
+      </p:sp>
+      <p:sp>
+        <p:nvSpPr>
+          <p:cNvPr id="9" name="Rounded Rectangle 8"/>
+          <p:cNvSpPr/>
+          <p:nvPr/>
+        </p:nvSpPr>
+        <p:spPr>
+          <a:xfrm>
+            <a:off x="6400800" y="4206240"/>
+            <a:ext cx="1280160" cy="502920"/>
+          </a:xfrm>
+          <a:prstGeom prst="roundRect">
+            <a:avLst>
+              <a:gd name="adj" fmla="val 12000"/>
+            </a:avLst>
+          </a:prstGeom>
+          <a:solidFill>
+            <a:srgbClr val="CCFBF1"/>
+          </a:solidFill>
+          <a:ln w="19050">
+            <a:solidFill>
+              <a:srgbClr val="0D9488"/>
+            </a:solidFill>
+          </a:ln>
+          <a:effectLst/>
+        </p:spPr>
+        <p:style>
+          <a:lnRef idx="1">
+            <a:schemeClr val="accent1"/>
+          </a:lnRef>
+          <a:fillRef idx="3">
+            <a:schemeClr val="accent1"/>
+          </a:fillRef>
+          <a:effectRef idx="2">
+            <a:schemeClr val="accent1"/>
+          </a:effectRef>
+          <a:fontRef idx="minor">
+            <a:schemeClr val="lt1"/>
+          </a:fontRef>
+        </p:style>
+        <p:txBody>
+          <a:bodyPr rtlCol="0" anchor="ctr" wrap="square" lIns="38100" rIns="38100" tIns="25400" bIns="25400"/>
+          <a:lstStyle/>
+          <a:p>
+            <a:pPr algn="ctr"/>
+            <a:r>
+              <a:rPr sz="1300" b="1">
+                <a:solidFill>
+                  <a:srgbClr val="115E59"/>
+                </a:solidFill>
+                <a:latin typeface="Microsoft YaHei"/>
+                <a:ea typeface="Microsoft YaHei"/>
+                <a:cs typeface="Microsoft YaHei"/>
+              </a:rPr>
+              <a:t>amod</a:t>
+            </a:r>
+          </a:p>
+        </p:txBody>
+      </p:sp>
+      <p:sp>
+        <p:nvSpPr>
+          <p:cNvPr id="10" name="Rounded Rectangle 9"/>
+          <p:cNvSpPr/>
+          <p:nvPr/>
+        </p:nvSpPr>
+        <p:spPr>
+          <a:xfrm>
+            <a:off x="6400800" y="5212080"/>
+            <a:ext cx="1280160" cy="502920"/>
+          </a:xfrm>
+          <a:prstGeom prst="roundRect">
+            <a:avLst>
+              <a:gd name="adj" fmla="val 12000"/>
+            </a:avLst>
+          </a:prstGeom>
+          <a:solidFill>
+            <a:srgbClr val="FEE2E2"/>
+          </a:solidFill>
+          <a:ln w="19050">
+            <a:solidFill>
+              <a:srgbClr val="DC2626"/>
+            </a:solidFill>
+          </a:ln>
+          <a:effectLst/>
+        </p:spPr>
+        <p:style>
+          <a:lnRef idx="1">
+            <a:schemeClr val="accent1"/>
+          </a:lnRef>
+          <a:fillRef idx="3">
+            <a:schemeClr val="accent1"/>
+          </a:fillRef>
+          <a:effectRef idx="2">
+            <a:schemeClr val="accent1"/>
+          </a:effectRef>
+          <a:fontRef idx="minor">
+            <a:schemeClr val="lt1"/>
+          </a:fontRef>
+        </p:style>
+        <p:txBody>
+          <a:bodyPr rtlCol="0" anchor="ctr" wrap="square" lIns="38100" rIns="38100" tIns="25400" bIns="25400"/>
+          <a:lstStyle/>
+          <a:p>
+            <a:pPr algn="ctr"/>
+            <a:r>
+              <a:rPr sz="1300" b="1">
+                <a:solidFill>
+                  <a:srgbClr val="991B1B"/>
+                </a:solidFill>
+                <a:latin typeface="Microsoft YaHei"/>
+                <a:ea typeface="Microsoft YaHei"/>
+                <a:cs typeface="Microsoft YaHei"/>
+              </a:rPr>
+              <a:t>u1</a:t>
+            </a:r>
+          </a:p>
+        </p:txBody>
+      </p:sp>
+      <p:sp>
+        <p:nvSpPr>
+          <p:cNvPr id="11" name="Rounded Rectangle 10"/>
+          <p:cNvSpPr/>
+          <p:nvPr/>
+        </p:nvSpPr>
+        <p:spPr>
+          <a:xfrm>
+            <a:off x="9601200" y="2194560"/>
+            <a:ext cx="1280160" cy="502920"/>
+          </a:xfrm>
+          <a:prstGeom prst="roundRect">
+            <a:avLst>
+              <a:gd name="adj" fmla="val 12000"/>
+            </a:avLst>
+          </a:prstGeom>
+          <a:solidFill>
+            <a:srgbClr val="EDF0F4"/>
+          </a:solidFill>
+          <a:ln w="19050">
+            <a:solidFill>
+              <a:srgbClr val="94A3B8"/>
+            </a:solidFill>
+          </a:ln>
+          <a:effectLst/>
+        </p:spPr>
+        <p:style>
+          <a:lnRef idx="1">
+            <a:schemeClr val="accent1"/>
+          </a:lnRef>
+          <a:fillRef idx="3">
+            <a:schemeClr val="accent1"/>
+          </a:fillRef>
+          <a:effectRef idx="2">
+            <a:schemeClr val="accent1"/>
+          </a:effectRef>
+          <a:fontRef idx="minor">
+            <a:schemeClr val="lt1"/>
+          </a:fontRef>
+        </p:style>
+        <p:txBody>
+          <a:bodyPr rtlCol="0" anchor="ctr" wrap="square" lIns="38100" rIns="38100" tIns="25400" bIns="25400"/>
+          <a:lstStyle/>
+          <a:p>
+            <a:pPr algn="ctr"/>
+            <a:r>
+              <a:rPr sz="1300" b="1">
+                <a:solidFill>
+                  <a:srgbClr val="1A1F2B"/>
+                </a:solidFill>
+                <a:latin typeface="Microsoft YaHei"/>
+                <a:ea typeface="Microsoft YaHei"/>
+                <a:cs typeface="Microsoft YaHei"/>
+              </a:rPr>
+              <a:t>top</a:t>
+            </a:r>
+          </a:p>
+        </p:txBody>
+      </p:sp>
+      <p:sp>
+        <p:nvSpPr>
+          <p:cNvPr id="12" name="Rounded Rectangle 11"/>
+          <p:cNvSpPr/>
+          <p:nvPr/>
+        </p:nvSpPr>
+        <p:spPr>
+          <a:xfrm>
+            <a:off x="8823960" y="3200400"/>
+            <a:ext cx="1188720" cy="502920"/>
+          </a:xfrm>
+          <a:prstGeom prst="roundRect">
+            <a:avLst>
+              <a:gd name="adj" fmla="val 12000"/>
+            </a:avLst>
+          </a:prstGeom>
+          <a:solidFill>
+            <a:srgbClr val="DBEAFE"/>
+          </a:solidFill>
+          <a:ln w="19050">
+            <a:solidFill>
+              <a:srgbClr val="1D4ED8"/>
+            </a:solidFill>
+          </a:ln>
+          <a:effectLst/>
+        </p:spPr>
+        <p:style>
+          <a:lnRef idx="1">
+            <a:schemeClr val="accent1"/>
+          </a:lnRef>
+          <a:fillRef idx="3">
+            <a:schemeClr val="accent1"/>
+          </a:fillRef>
+          <a:effectRef idx="2">
+            <a:schemeClr val="accent1"/>
+          </a:effectRef>
+          <a:fontRef idx="minor">
+            <a:schemeClr val="lt1"/>
+          </a:fontRef>
+        </p:style>
+        <p:txBody>
+          <a:bodyPr rtlCol="0" anchor="ctr" wrap="square" lIns="38100" rIns="38100" tIns="25400" bIns="25400"/>
+          <a:lstStyle/>
+          <a:p>
+            <a:pPr algn="ctr"/>
+            <a:r>
+              <a:rPr sz="1300" b="1">
+                <a:solidFill>
+                  <a:srgbClr val="1E3A8A"/>
+                </a:solidFill>
+                <a:latin typeface="Microsoft YaHei"/>
+                <a:ea typeface="Microsoft YaHei"/>
+                <a:cs typeface="Microsoft YaHei"/>
+              </a:rPr>
+              <a:t>m1</a:t>
+            </a:r>
+          </a:p>
+        </p:txBody>
+      </p:sp>
+      <p:sp>
+        <p:nvSpPr>
+          <p:cNvPr id="13" name="Rounded Rectangle 12"/>
+          <p:cNvSpPr/>
+          <p:nvPr/>
+        </p:nvSpPr>
+        <p:spPr>
+          <a:xfrm>
+            <a:off x="10469880" y="3200400"/>
+            <a:ext cx="1188720" cy="502920"/>
+          </a:xfrm>
+          <a:prstGeom prst="roundRect">
+            <a:avLst>
+              <a:gd name="adj" fmla="val 12000"/>
+            </a:avLst>
+          </a:prstGeom>
+          <a:solidFill>
+            <a:srgbClr val="DBEAFE"/>
+          </a:solidFill>
+          <a:ln w="19050">
+            <a:solidFill>
+              <a:srgbClr val="1D4ED8"/>
+            </a:solidFill>
+          </a:ln>
+          <a:effectLst/>
+        </p:spPr>
+        <p:style>
+          <a:lnRef idx="1">
+            <a:schemeClr val="accent1"/>
+          </a:lnRef>
+          <a:fillRef idx="3">
+            <a:schemeClr val="accent1"/>
+          </a:fillRef>
+          <a:effectRef idx="2">
+            <a:schemeClr val="accent1"/>
+          </a:effectRef>
+          <a:fontRef idx="minor">
+            <a:schemeClr val="lt1"/>
+          </a:fontRef>
+        </p:style>
+        <p:txBody>
+          <a:bodyPr rtlCol="0" anchor="ctr" wrap="square" lIns="38100" rIns="38100" tIns="25400" bIns="25400"/>
+          <a:lstStyle/>
+          <a:p>
+            <a:pPr algn="ctr"/>
+            <a:r>
+              <a:rPr sz="1300" b="1">
+                <a:solidFill>
+                  <a:srgbClr val="1E3A8A"/>
+                </a:solidFill>
+                <a:latin typeface="Microsoft YaHei"/>
+                <a:ea typeface="Microsoft YaHei"/>
+                <a:cs typeface="Microsoft YaHei"/>
+              </a:rPr>
+              <a:t>m2</a:t>
+            </a:r>
+          </a:p>
+        </p:txBody>
+      </p:sp>
+      <p:sp>
+        <p:nvSpPr>
+          <p:cNvPr id="14" name="Rounded Rectangle 13"/>
+          <p:cNvSpPr/>
+          <p:nvPr/>
+        </p:nvSpPr>
+        <p:spPr>
+          <a:xfrm>
+            <a:off x="8823960" y="4206240"/>
+            <a:ext cx="1188720" cy="502920"/>
+          </a:xfrm>
+          <a:prstGeom prst="roundRect">
+            <a:avLst>
+              <a:gd name="adj" fmla="val 12000"/>
+            </a:avLst>
+          </a:prstGeom>
+          <a:solidFill>
+            <a:srgbClr val="CCFBF1"/>
+          </a:solidFill>
+          <a:ln w="19050">
+            <a:solidFill>
+              <a:srgbClr val="0D9488"/>
+            </a:solidFill>
+          </a:ln>
+          <a:effectLst/>
+        </p:spPr>
+        <p:style>
+          <a:lnRef idx="1">
+            <a:schemeClr val="accent1"/>
+          </a:lnRef>
+          <a:fillRef idx="3">
+            <a:schemeClr val="accent1"/>
+          </a:fillRef>
+          <a:effectRef idx="2">
+            <a:schemeClr val="accent1"/>
+          </a:effectRef>
+          <a:fontRef idx="minor">
+            <a:schemeClr val="lt1"/>
+          </a:fontRef>
+        </p:style>
+        <p:txBody>
+          <a:bodyPr rtlCol="0" anchor="ctr" wrap="square" lIns="38100" rIns="38100" tIns="25400" bIns="25400"/>
+          <a:lstStyle/>
+          <a:p>
+            <a:pPr algn="ctr"/>
+            <a:r>
+              <a:rPr sz="1300" b="1">
+                <a:solidFill>
+                  <a:srgbClr val="115E59"/>
+                </a:solidFill>
+                <a:latin typeface="Microsoft YaHei"/>
+                <a:ea typeface="Microsoft YaHei"/>
+                <a:cs typeface="Microsoft YaHei"/>
+              </a:rPr>
+              <a:t>amod1</a:t>
+            </a:r>
+          </a:p>
+        </p:txBody>
+      </p:sp>
+      <p:sp>
+        <p:nvSpPr>
+          <p:cNvPr id="15" name="Rounded Rectangle 14"/>
+          <p:cNvSpPr/>
+          <p:nvPr/>
+        </p:nvSpPr>
+        <p:spPr>
+          <a:xfrm>
+            <a:off x="10469880" y="4206240"/>
+            <a:ext cx="1188720" cy="502920"/>
+          </a:xfrm>
+          <a:prstGeom prst="roundRect">
+            <a:avLst>
+              <a:gd name="adj" fmla="val 12000"/>
+            </a:avLst>
+          </a:prstGeom>
+          <a:solidFill>
+            <a:srgbClr val="CCFBF1"/>
+          </a:solidFill>
+          <a:ln w="19050">
+            <a:solidFill>
+              <a:srgbClr val="0D9488"/>
+            </a:solidFill>
+          </a:ln>
+          <a:effectLst/>
+        </p:spPr>
+        <p:style>
+          <a:lnRef idx="1">
+            <a:schemeClr val="accent1"/>
+          </a:lnRef>
+          <a:fillRef idx="3">
+            <a:schemeClr val="accent1"/>
+          </a:fillRef>
+          <a:effectRef idx="2">
+            <a:schemeClr val="accent1"/>
+          </a:effectRef>
+          <a:fontRef idx="minor">
+            <a:schemeClr val="lt1"/>
+          </a:fontRef>
+        </p:style>
+        <p:txBody>
+          <a:bodyPr rtlCol="0" anchor="ctr" wrap="square" lIns="38100" rIns="38100" tIns="25400" bIns="25400"/>
+          <a:lstStyle/>
+          <a:p>
+            <a:pPr algn="ctr"/>
+            <a:r>
+              <a:rPr sz="1300" b="1">
+                <a:solidFill>
+                  <a:srgbClr val="115E59"/>
+                </a:solidFill>
+                <a:latin typeface="Microsoft YaHei"/>
+                <a:ea typeface="Microsoft YaHei"/>
+                <a:cs typeface="Microsoft YaHei"/>
+              </a:rPr>
+              <a:t>amod2</a:t>
+            </a:r>
+          </a:p>
+        </p:txBody>
+      </p:sp>
+      <p:sp>
+        <p:nvSpPr>
+          <p:cNvPr id="16" name="Rounded Rectangle 15"/>
+          <p:cNvSpPr/>
+          <p:nvPr/>
+        </p:nvSpPr>
+        <p:spPr>
+          <a:xfrm>
+            <a:off x="8823960" y="5212080"/>
+            <a:ext cx="1188720" cy="502920"/>
+          </a:xfrm>
+          <a:prstGeom prst="roundRect">
+            <a:avLst>
+              <a:gd name="adj" fmla="val 12000"/>
+            </a:avLst>
+          </a:prstGeom>
+          <a:solidFill>
+            <a:srgbClr val="FEE2E2"/>
+          </a:solidFill>
+          <a:ln w="19050">
+            <a:solidFill>
+              <a:srgbClr val="DC2626"/>
+            </a:solidFill>
+          </a:ln>
+          <a:effectLst/>
+        </p:spPr>
+        <p:style>
+          <a:lnRef idx="1">
+            <a:schemeClr val="accent1"/>
+          </a:lnRef>
+          <a:fillRef idx="3">
+            <a:schemeClr val="accent1"/>
+          </a:fillRef>
+          <a:effectRef idx="2">
+            <a:schemeClr val="accent1"/>
+          </a:effectRef>
+          <a:fontRef idx="minor">
+            <a:schemeClr val="lt1"/>
+          </a:fontRef>
+        </p:style>
+        <p:txBody>
+          <a:bodyPr rtlCol="0" anchor="ctr" wrap="square" lIns="38100" rIns="38100" tIns="25400" bIns="25400"/>
+          <a:lstStyle/>
+          <a:p>
+            <a:pPr algn="ctr"/>
+            <a:r>
+              <a:rPr sz="1300" b="1">
+                <a:solidFill>
+                  <a:srgbClr val="991B1B"/>
+                </a:solidFill>
+                <a:latin typeface="Microsoft YaHei"/>
+                <a:ea typeface="Microsoft YaHei"/>
+                <a:cs typeface="Microsoft YaHei"/>
+              </a:rPr>
+              <a:t>u1</a:t>
+            </a:r>
+          </a:p>
+        </p:txBody>
+      </p:sp>
+      <p:sp>
+        <p:nvSpPr>
+          <p:cNvPr id="17" name="Rounded Rectangle 16"/>
+          <p:cNvSpPr/>
+          <p:nvPr/>
+        </p:nvSpPr>
+        <p:spPr>
+          <a:xfrm>
+            <a:off x="10469880" y="5212080"/>
+            <a:ext cx="1188720" cy="502920"/>
+          </a:xfrm>
+          <a:prstGeom prst="roundRect">
+            <a:avLst>
+              <a:gd name="adj" fmla="val 12000"/>
+            </a:avLst>
+          </a:prstGeom>
+          <a:solidFill>
+            <a:srgbClr val="FEE2E2"/>
+          </a:solidFill>
+          <a:ln w="19050">
+            <a:solidFill>
+              <a:srgbClr val="DC2626"/>
+            </a:solidFill>
+          </a:ln>
+          <a:effectLst/>
+        </p:spPr>
+        <p:style>
+          <a:lnRef idx="1">
+            <a:schemeClr val="accent1"/>
+          </a:lnRef>
+          <a:fillRef idx="3">
+            <a:schemeClr val="accent1"/>
+          </a:fillRef>
+          <a:effectRef idx="2">
+            <a:schemeClr val="accent1"/>
+          </a:effectRef>
+          <a:fontRef idx="minor">
+            <a:schemeClr val="lt1"/>
+          </a:fontRef>
+        </p:style>
+        <p:txBody>
+          <a:bodyPr rtlCol="0" anchor="ctr" wrap="square" lIns="38100" rIns="38100" tIns="25400" bIns="25400"/>
+          <a:lstStyle/>
+          <a:p>
+            <a:pPr algn="ctr"/>
+            <a:r>
+              <a:rPr sz="1300" b="1">
+                <a:solidFill>
+                  <a:srgbClr val="991B1B"/>
+                </a:solidFill>
+                <a:latin typeface="Microsoft YaHei"/>
+                <a:ea typeface="Microsoft YaHei"/>
+                <a:cs typeface="Microsoft YaHei"/>
+              </a:rPr>
+              <a:t>u1</a:t>
+            </a:r>
+          </a:p>
+        </p:txBody>
+      </p:sp>
+      <p:cxnSp>
+        <p:nvCxnSpPr>
+          <p:cNvPr id="18" name="Connector 17"/>
+          <p:cNvCxnSpPr/>
+          <p:nvPr/>
+        </p:nvCxnSpPr>
+        <p:spPr>
+          <a:xfrm flipH="1">
+            <a:off x="6355080" y="2697480"/>
+            <a:ext cx="502920" cy="484631"/>
+          </a:xfrm>
+          <a:prstGeom prst="line">
+            <a:avLst/>
+          </a:prstGeom>
+          <a:ln w="19050">
+            <a:solidFill>
+              <a:srgbClr val="3A4252"/>
+            </a:solidFill>
+            <a:tailEnd type="triangle" w="med" len="med"/>
+          </a:ln>
+          <a:effectLst/>
+        </p:spPr>
+        <p:style>
+          <a:lnRef idx="2">
+            <a:schemeClr val="accent1"/>
+          </a:lnRef>
+          <a:fillRef idx="0">
+            <a:schemeClr val="accent1"/>
+          </a:fillRef>
+          <a:effectRef idx="1">
+            <a:schemeClr val="accent1"/>
+          </a:effectRef>
+          <a:fontRef idx="minor">
+            <a:schemeClr val="tx1"/>
+          </a:fontRef>
+        </p:style>
+      </p:cxnSp>
+      <p:cxnSp>
+        <p:nvCxnSpPr>
+          <p:cNvPr id="19" name="Connector 18"/>
+          <p:cNvCxnSpPr/>
+          <p:nvPr/>
+        </p:nvCxnSpPr>
+        <p:spPr>
+          <a:xfrm>
+            <a:off x="7223760" y="2697480"/>
+            <a:ext cx="502919" cy="484631"/>
+          </a:xfrm>
+          <a:prstGeom prst="line">
+            <a:avLst/>
+          </a:prstGeom>
+          <a:ln w="19050">
+            <a:solidFill>
+              <a:srgbClr val="3A4252"/>
+            </a:solidFill>
+            <a:tailEnd type="triangle" w="med" len="med"/>
+          </a:ln>
+          <a:effectLst/>
+        </p:spPr>
+        <p:style>
+          <a:lnRef idx="2">
+            <a:schemeClr val="accent1"/>
+          </a:lnRef>
+          <a:fillRef idx="0">
+            <a:schemeClr val="accent1"/>
+          </a:fillRef>
+          <a:effectRef idx="1">
+            <a:schemeClr val="accent1"/>
+          </a:effectRef>
+          <a:fontRef idx="minor">
+            <a:schemeClr val="tx1"/>
+          </a:fontRef>
+        </p:style>
+      </p:cxnSp>
+      <p:cxnSp>
+        <p:nvCxnSpPr>
+          <p:cNvPr id="20" name="Connector 19"/>
+          <p:cNvCxnSpPr/>
+          <p:nvPr/>
+        </p:nvCxnSpPr>
+        <p:spPr>
+          <a:xfrm>
+            <a:off x="6355080" y="3703320"/>
+            <a:ext cx="457200" cy="484632"/>
+          </a:xfrm>
+          <a:prstGeom prst="line">
+            <a:avLst/>
+          </a:prstGeom>
+          <a:ln w="19050">
+            <a:solidFill>
+              <a:srgbClr val="DC2626"/>
+            </a:solidFill>
+            <a:tailEnd type="triangle" w="med" len="med"/>
+          </a:ln>
+          <a:effectLst/>
+        </p:spPr>
+        <p:style>
+          <a:lnRef idx="2">
+            <a:schemeClr val="accent1"/>
+          </a:lnRef>
+          <a:fillRef idx="0">
+            <a:schemeClr val="accent1"/>
+          </a:fillRef>
+          <a:effectRef idx="1">
+            <a:schemeClr val="accent1"/>
+          </a:effectRef>
+          <a:fontRef idx="minor">
+            <a:schemeClr val="tx1"/>
+          </a:fontRef>
+        </p:style>
+      </p:cxnSp>
+      <p:cxnSp>
+        <p:nvCxnSpPr>
+          <p:cNvPr id="21" name="Connector 20"/>
+          <p:cNvCxnSpPr/>
+          <p:nvPr/>
+        </p:nvCxnSpPr>
+        <p:spPr>
+          <a:xfrm flipH="1">
+            <a:off x="7269480" y="3703320"/>
+            <a:ext cx="457199" cy="484632"/>
+          </a:xfrm>
+          <a:prstGeom prst="line">
+            <a:avLst/>
+          </a:prstGeom>
+          <a:ln w="19050">
+            <a:solidFill>
+              <a:srgbClr val="DC2626"/>
+            </a:solidFill>
+            <a:tailEnd type="triangle" w="med" len="med"/>
+          </a:ln>
+          <a:effectLst/>
+        </p:spPr>
+        <p:style>
+          <a:lnRef idx="2">
+            <a:schemeClr val="accent1"/>
+          </a:lnRef>
+          <a:fillRef idx="0">
+            <a:schemeClr val="accent1"/>
+          </a:fillRef>
+          <a:effectRef idx="1">
+            <a:schemeClr val="accent1"/>
+          </a:effectRef>
+          <a:fontRef idx="minor">
+            <a:schemeClr val="tx1"/>
+          </a:fontRef>
+        </p:style>
+      </p:cxnSp>
+      <p:cxnSp>
+        <p:nvCxnSpPr>
+          <p:cNvPr id="22" name="Connector 21"/>
+          <p:cNvCxnSpPr/>
+          <p:nvPr/>
+        </p:nvCxnSpPr>
+        <p:spPr>
+          <a:xfrm>
+            <a:off x="7040880" y="4709160"/>
+            <a:ext cx="0" cy="484632"/>
+          </a:xfrm>
+          <a:prstGeom prst="line">
+            <a:avLst/>
+          </a:prstGeom>
+          <a:ln w="19050">
+            <a:solidFill>
+              <a:srgbClr val="3A4252"/>
+            </a:solidFill>
+            <a:tailEnd type="triangle" w="med" len="med"/>
+          </a:ln>
+          <a:effectLst/>
+        </p:spPr>
+        <p:style>
+          <a:lnRef idx="2">
+            <a:schemeClr val="accent1"/>
+          </a:lnRef>
+          <a:fillRef idx="0">
+            <a:schemeClr val="accent1"/>
+          </a:fillRef>
+          <a:effectRef idx="1">
+            <a:schemeClr val="accent1"/>
+          </a:effectRef>
+          <a:fontRef idx="minor">
+            <a:schemeClr val="tx1"/>
+          </a:fontRef>
+        </p:style>
+      </p:cxnSp>
+      <p:cxnSp>
+        <p:nvCxnSpPr>
+          <p:cNvPr id="23" name="Connector 22"/>
+          <p:cNvCxnSpPr/>
+          <p:nvPr/>
+        </p:nvCxnSpPr>
+        <p:spPr>
+          <a:xfrm flipH="1">
+            <a:off x="9555480" y="2697480"/>
+            <a:ext cx="502920" cy="484631"/>
+          </a:xfrm>
+          <a:prstGeom prst="line">
+            <a:avLst/>
+          </a:prstGeom>
+          <a:ln w="19050">
+            <a:solidFill>
+              <a:srgbClr val="3A4252"/>
+            </a:solidFill>
+            <a:tailEnd type="triangle" w="med" len="med"/>
+          </a:ln>
+          <a:effectLst/>
+        </p:spPr>
+        <p:style>
+          <a:lnRef idx="2">
+            <a:schemeClr val="accent1"/>
+          </a:lnRef>
+          <a:fillRef idx="0">
+            <a:schemeClr val="accent1"/>
+          </a:fillRef>
+          <a:effectRef idx="1">
+            <a:schemeClr val="accent1"/>
+          </a:effectRef>
+          <a:fontRef idx="minor">
+            <a:schemeClr val="tx1"/>
+          </a:fontRef>
+        </p:style>
+      </p:cxnSp>
+      <p:cxnSp>
+        <p:nvCxnSpPr>
+          <p:cNvPr id="24" name="Connector 23"/>
+          <p:cNvCxnSpPr/>
+          <p:nvPr/>
+        </p:nvCxnSpPr>
+        <p:spPr>
+          <a:xfrm>
+            <a:off x="10424160" y="2697480"/>
+            <a:ext cx="502920" cy="484631"/>
+          </a:xfrm>
+          <a:prstGeom prst="line">
+            <a:avLst/>
+          </a:prstGeom>
+          <a:ln w="19050">
+            <a:solidFill>
+              <a:srgbClr val="3A4252"/>
+            </a:solidFill>
+            <a:tailEnd type="triangle" w="med" len="med"/>
+          </a:ln>
+          <a:effectLst/>
+        </p:spPr>
+        <p:style>
+          <a:lnRef idx="2">
+            <a:schemeClr val="accent1"/>
+          </a:lnRef>
+          <a:fillRef idx="0">
+            <a:schemeClr val="accent1"/>
+          </a:fillRef>
+          <a:effectRef idx="1">
+            <a:schemeClr val="accent1"/>
+          </a:effectRef>
+          <a:fontRef idx="minor">
+            <a:schemeClr val="tx1"/>
+          </a:fontRef>
+        </p:style>
+      </p:cxnSp>
+      <p:cxnSp>
+        <p:nvCxnSpPr>
+          <p:cNvPr id="25" name="Connector 24"/>
+          <p:cNvCxnSpPr/>
+          <p:nvPr/>
+        </p:nvCxnSpPr>
+        <p:spPr>
+          <a:xfrm>
+            <a:off x="9418320" y="3703320"/>
+            <a:ext cx="0" cy="484632"/>
+          </a:xfrm>
+          <a:prstGeom prst="line">
+            <a:avLst/>
+          </a:prstGeom>
+          <a:ln w="19050">
+            <a:solidFill>
+              <a:srgbClr val="3A4252"/>
+            </a:solidFill>
+            <a:tailEnd type="triangle" w="med" len="med"/>
+          </a:ln>
+          <a:effectLst/>
+        </p:spPr>
+        <p:style>
+          <a:lnRef idx="2">
+            <a:schemeClr val="accent1"/>
+          </a:lnRef>
+          <a:fillRef idx="0">
+            <a:schemeClr val="accent1"/>
+          </a:fillRef>
+          <a:effectRef idx="1">
+            <a:schemeClr val="accent1"/>
+          </a:effectRef>
+          <a:fontRef idx="minor">
+            <a:schemeClr val="tx1"/>
+          </a:fontRef>
+        </p:style>
+      </p:cxnSp>
+      <p:cxnSp>
+        <p:nvCxnSpPr>
+          <p:cNvPr id="26" name="Connector 25"/>
+          <p:cNvCxnSpPr/>
+          <p:nvPr/>
+        </p:nvCxnSpPr>
+        <p:spPr>
+          <a:xfrm>
+            <a:off x="11064240" y="3703320"/>
+            <a:ext cx="0" cy="484632"/>
+          </a:xfrm>
+          <a:prstGeom prst="line">
+            <a:avLst/>
+          </a:prstGeom>
+          <a:ln w="19050">
+            <a:solidFill>
+              <a:srgbClr val="3A4252"/>
+            </a:solidFill>
+            <a:tailEnd type="triangle" w="med" len="med"/>
+          </a:ln>
+          <a:effectLst/>
+        </p:spPr>
+        <p:style>
+          <a:lnRef idx="2">
+            <a:schemeClr val="accent1"/>
+          </a:lnRef>
+          <a:fillRef idx="0">
+            <a:schemeClr val="accent1"/>
+          </a:fillRef>
+          <a:effectRef idx="1">
+            <a:schemeClr val="accent1"/>
+          </a:effectRef>
+          <a:fontRef idx="minor">
+            <a:schemeClr val="tx1"/>
+          </a:fontRef>
+        </p:style>
+      </p:cxnSp>
+      <p:cxnSp>
+        <p:nvCxnSpPr>
+          <p:cNvPr id="27" name="Connector 26"/>
+          <p:cNvCxnSpPr/>
+          <p:nvPr/>
+        </p:nvCxnSpPr>
+        <p:spPr>
+          <a:xfrm>
+            <a:off x="9418320" y="4709160"/>
+            <a:ext cx="0" cy="484632"/>
+          </a:xfrm>
+          <a:prstGeom prst="line">
+            <a:avLst/>
+          </a:prstGeom>
+          <a:ln w="19050">
+            <a:solidFill>
+              <a:srgbClr val="3A4252"/>
+            </a:solidFill>
+            <a:tailEnd type="triangle" w="med" len="med"/>
+          </a:ln>
+          <a:effectLst/>
+        </p:spPr>
+        <p:style>
+          <a:lnRef idx="2">
+            <a:schemeClr val="accent1"/>
+          </a:lnRef>
+          <a:fillRef idx="0">
+            <a:schemeClr val="accent1"/>
+          </a:fillRef>
+          <a:effectRef idx="1">
+            <a:schemeClr val="accent1"/>
+          </a:effectRef>
+          <a:fontRef idx="minor">
+            <a:schemeClr val="tx1"/>
+          </a:fontRef>
+        </p:style>
+      </p:cxnSp>
+      <p:cxnSp>
+        <p:nvCxnSpPr>
+          <p:cNvPr id="28" name="Connector 27"/>
+          <p:cNvCxnSpPr/>
+          <p:nvPr/>
+        </p:nvCxnSpPr>
+        <p:spPr>
+          <a:xfrm>
+            <a:off x="11064240" y="4709160"/>
+            <a:ext cx="0" cy="484632"/>
+          </a:xfrm>
+          <a:prstGeom prst="line">
+            <a:avLst/>
+          </a:prstGeom>
+          <a:ln w="19050">
+            <a:solidFill>
+              <a:srgbClr val="3A4252"/>
+            </a:solidFill>
+            <a:tailEnd type="triangle" w="med" len="med"/>
+          </a:ln>
+          <a:effectLst/>
+        </p:spPr>
+        <p:style>
+          <a:lnRef idx="2">
+            <a:schemeClr val="accent1"/>
+          </a:lnRef>
+          <a:fillRef idx="0">
+            <a:schemeClr val="accent1"/>
+          </a:fillRef>
+          <a:effectRef idx="1">
+            <a:schemeClr val="accent1"/>
+          </a:effectRef>
+          <a:fontRef idx="minor">
+            <a:schemeClr val="tx1"/>
+          </a:fontRef>
+        </p:style>
+      </p:cxnSp>
+      <p:sp>
+        <p:nvSpPr>
+          <p:cNvPr id="29" name="TextBox 28"/>
           <p:cNvSpPr txBox="1"/>
           <p:nvPr/>
         </p:nvSpPr>
         <p:spPr>
           <a:xfrm>
-            <a:off x="9875520" y="6446520"/>
-            <a:ext cx="2011680" cy="365760"/>
+            <a:off x="5394960" y="1645919"/>
+            <a:ext cx="3291840" cy="365760"/>
           </a:xfrm>
           <a:prstGeom prst="rect">
             <a:avLst/>
@@ -1826,8 +2917,156 @@
           </a:bodyPr>
           <a:lstStyle/>
           <a:p>
+            <a:pPr algn="ctr"/>
+            <a:r>
+              <a:rPr sz="1150" b="1">
+                <a:solidFill>
+                  <a:srgbClr val="991B1B"/>
+                </a:solidFill>
+                <a:latin typeface="Microsoft YaHei"/>
+                <a:ea typeface="Microsoft YaHei"/>
+                <a:cs typeface="Microsoft YaHei"/>
+              </a:rPr>
+              <a:t>非唯一：m1/m2 共享 amod</a:t>
+            </a:r>
+          </a:p>
+        </p:txBody>
+      </p:sp>
+      <p:sp>
+        <p:nvSpPr>
+          <p:cNvPr id="30" name="TextBox 29"/>
+          <p:cNvSpPr txBox="1"/>
+          <p:nvPr/>
+        </p:nvSpPr>
+        <p:spPr>
+          <a:xfrm>
+            <a:off x="8595359" y="1645919"/>
+            <a:ext cx="3291840" cy="365760"/>
+          </a:xfrm>
+          <a:prstGeom prst="rect">
+            <a:avLst/>
+          </a:prstGeom>
+          <a:noFill/>
+        </p:spPr>
+        <p:txBody>
+          <a:bodyPr wrap="none" lIns="0" rIns="0" tIns="0" bIns="0">
+            <a:spAutoFit/>
+          </a:bodyPr>
+          <a:lstStyle/>
+          <a:p>
+            <a:pPr algn="ctr"/>
+            <a:r>
+              <a:rPr sz="1150" b="1">
+                <a:solidFill>
+                  <a:srgbClr val="115E59"/>
+                </a:solidFill>
+                <a:latin typeface="Microsoft YaHei"/>
+                <a:ea typeface="Microsoft YaHei"/>
+                <a:cs typeface="Microsoft YaHei"/>
+              </a:rPr>
+              <a:t>唯一化：各自独立副本</a:t>
+            </a:r>
+          </a:p>
+        </p:txBody>
+      </p:sp>
+      <p:sp>
+        <p:nvSpPr>
+          <p:cNvPr id="31" name="TextBox 30"/>
+          <p:cNvSpPr txBox="1"/>
+          <p:nvPr/>
+        </p:nvSpPr>
+        <p:spPr>
+          <a:xfrm>
+            <a:off x="5394960" y="5916168"/>
+            <a:ext cx="3291840" cy="365760"/>
+          </a:xfrm>
+          <a:prstGeom prst="rect">
+            <a:avLst/>
+          </a:prstGeom>
+          <a:noFill/>
+        </p:spPr>
+        <p:txBody>
+          <a:bodyPr wrap="none" lIns="0" rIns="0" tIns="0" bIns="0">
+            <a:spAutoFit/>
+          </a:bodyPr>
+          <a:lstStyle/>
+          <a:p>
+            <a:pPr algn="ctr"/>
+            <a:r>
+              <a:rPr sz="950" b="0">
+                <a:solidFill>
+                  <a:srgbClr val="991B1B"/>
+                </a:solidFill>
+                <a:latin typeface="Microsoft YaHei"/>
+                <a:ea typeface="Microsoft YaHei"/>
+                <a:cs typeface="Microsoft YaHei"/>
+              </a:rPr>
+              <a:t>改 m1/u1 牵连 m2/u1</a:t>
+            </a:r>
+          </a:p>
+        </p:txBody>
+      </p:sp>
+      <p:sp>
+        <p:nvSpPr>
+          <p:cNvPr id="32" name="TextBox 31"/>
+          <p:cNvSpPr txBox="1"/>
+          <p:nvPr/>
+        </p:nvSpPr>
+        <p:spPr>
+          <a:xfrm>
+            <a:off x="8595359" y="5916168"/>
+            <a:ext cx="3291840" cy="365760"/>
+          </a:xfrm>
+          <a:prstGeom prst="rect">
+            <a:avLst/>
+          </a:prstGeom>
+          <a:noFill/>
+        </p:spPr>
+        <p:txBody>
+          <a:bodyPr wrap="none" lIns="0" rIns="0" tIns="0" bIns="0">
+            <a:spAutoFit/>
+          </a:bodyPr>
+          <a:lstStyle/>
+          <a:p>
+            <a:pPr algn="ctr"/>
+            <a:r>
+              <a:rPr sz="950" b="0">
+                <a:solidFill>
+                  <a:srgbClr val="115E59"/>
+                </a:solidFill>
+                <a:latin typeface="Microsoft YaHei"/>
+                <a:ea typeface="Microsoft YaHei"/>
+                <a:cs typeface="Microsoft YaHei"/>
+              </a:rPr>
+              <a:t>各实例可独立优化、移动</a:t>
+            </a:r>
+          </a:p>
+        </p:txBody>
+      </p:sp>
+      <p:sp>
+        <p:nvSpPr>
+          <p:cNvPr id="33" name="TextBox 32"/>
+          <p:cNvSpPr txBox="1"/>
+          <p:nvPr/>
+        </p:nvSpPr>
+        <p:spPr>
+          <a:xfrm>
+            <a:off x="9875520" y="6446520"/>
+            <a:ext cx="2011680" cy="365760"/>
+          </a:xfrm>
+          <a:prstGeom prst="rect">
+            <a:avLst/>
+          </a:prstGeom>
+          <a:noFill/>
+        </p:spPr>
+        <p:txBody>
+          <a:bodyPr wrap="none" lIns="0" rIns="0" tIns="0" bIns="0">
+            <a:spAutoFit/>
+          </a:bodyPr>
+          <a:lstStyle/>
+          <a:p>
             <a:pPr algn="r"/>
-            <a:fld id="{AF1FD4E7-E9A8-4D52-9ABA-516CF8EA0397}" type="slidenum">
+            <a:fld id="{BD822B1F-EF48-4D65-9049-7C7FBA70B969}" type="slidenum">
               <a:rPr lang="en-US" sz="1000">
                 <a:solidFill>
                   <a:srgbClr val="9AA3B0"/>
@@ -2176,7 +3415,7 @@
           <a:lstStyle/>
           <a:p>
             <a:pPr algn="r"/>
-            <a:fld id="{9601574E-85F2-4D55-98F2-EF0E6EABA4B9}" type="slidenum">
+            <a:fld id="{67541B69-78B2-40D5-825F-742B1E0DF2F2}" type="slidenum">
               <a:rPr lang="en-US" sz="1000">
                 <a:solidFill>
                   <a:srgbClr val="9AA3B0"/>
@@ -3064,7 +4303,7 @@
           <a:lstStyle/>
           <a:p>
             <a:pPr algn="r"/>
-            <a:fld id="{B24DEE3C-2B59-4303-B1F6-4BC6755E0501}" type="slidenum">
+            <a:fld id="{0F1FF2F7-0690-46D7-A380-6D4BF8DC4B85}" type="slidenum">
               <a:rPr lang="en-US" sz="1000">
                 <a:solidFill>
                   <a:srgbClr val="9AA3B0"/>
@@ -3392,7 +4631,7 @@
           <a:lstStyle/>
           <a:p>
             <a:pPr algn="r"/>
-            <a:fld id="{6A125483-3AC9-4703-815D-4C30054963E6}" type="slidenum">
+            <a:fld id="{3565EDBB-850B-46E4-964E-0F51F58FF39A}" type="slidenum">
               <a:rPr lang="en-US" sz="1000">
                 <a:solidFill>
                   <a:srgbClr val="9AA3B0"/>
@@ -3761,7 +5000,7 @@
           <a:lstStyle/>
           <a:p>
             <a:pPr algn="r"/>
-            <a:fld id="{67DF5C0C-A714-4210-942C-F1EB68B5E505}" type="slidenum">
+            <a:fld id="{148FBE15-6AC0-4F62-AF01-8DE4D8B16245}" type="slidenum">
               <a:rPr lang="en-US" sz="1000">
                 <a:solidFill>
                   <a:srgbClr val="9AA3B0"/>
@@ -4640,40 +5879,613 @@
           </a:p>
         </p:txBody>
       </p:sp>
-      <p:pic>
-        <p:nvPicPr>
-          <p:cNvPr id="6" name="Picture 5" descr="f17_hier.png"/>
-          <p:cNvPicPr>
-            <a:picLocks noChangeAspect="1"/>
-          </p:cNvPicPr>
-          <p:nvPr/>
-        </p:nvPicPr>
-        <p:blipFill>
-          <a:blip r:embed="rId2"/>
-          <a:stretch>
-            <a:fillRect/>
-          </a:stretch>
-        </p:blipFill>
-        <p:spPr>
-          <a:xfrm>
-            <a:off x="5486400" y="1938425"/>
-            <a:ext cx="6263640" cy="4032709"/>
-          </a:xfrm>
-          <a:prstGeom prst="rect">
-            <a:avLst/>
-          </a:prstGeom>
-        </p:spPr>
-      </p:pic>
-      <p:sp>
-        <p:nvSpPr>
-          <p:cNvPr id="7" name="TextBox 6"/>
+      <p:sp>
+        <p:nvSpPr>
+          <p:cNvPr id="6" name="Rounded Rectangle 5"/>
+          <p:cNvSpPr/>
+          <p:nvPr/>
+        </p:nvSpPr>
+        <p:spPr>
+          <a:xfrm>
+            <a:off x="5623560" y="2286000"/>
+            <a:ext cx="2606040" cy="2834640"/>
+          </a:xfrm>
+          <a:prstGeom prst="roundRect">
+            <a:avLst>
+              <a:gd name="adj" fmla="val 12000"/>
+            </a:avLst>
+          </a:prstGeom>
+          <a:solidFill>
+            <a:srgbClr val="FFFFFF"/>
+          </a:solidFill>
+          <a:ln w="19050">
+            <a:solidFill>
+              <a:srgbClr val="94A3B8"/>
+            </a:solidFill>
+          </a:ln>
+          <a:effectLst/>
+        </p:spPr>
+        <p:style>
+          <a:lnRef idx="1">
+            <a:schemeClr val="accent1"/>
+          </a:lnRef>
+          <a:fillRef idx="3">
+            <a:schemeClr val="accent1"/>
+          </a:fillRef>
+          <a:effectRef idx="2">
+            <a:schemeClr val="accent1"/>
+          </a:effectRef>
+          <a:fontRef idx="minor">
+            <a:schemeClr val="lt1"/>
+          </a:fontRef>
+        </p:style>
+        <p:txBody>
+          <a:bodyPr rtlCol="0" anchor="ctr" wrap="square" lIns="38100" rIns="38100" tIns="25400" bIns="25400"/>
+          <a:lstStyle/>
+          <a:p>
+            <a:pPr algn="ctr"/>
+            <a:r>
+              <a:rPr sz="1200" b="1">
+                <a:solidFill>
+                  <a:srgbClr val="1A1F2B"/>
+                </a:solidFill>
+                <a:latin typeface="Microsoft YaHei"/>
+                <a:ea typeface="Microsoft YaHei"/>
+                <a:cs typeface="Microsoft YaHei"/>
+              </a:rPr>
+              <a:t/>
+            </a:r>
+          </a:p>
+        </p:txBody>
+      </p:sp>
+      <p:sp>
+        <p:nvSpPr>
+          <p:cNvPr id="7" name="Rounded Rectangle 6"/>
+          <p:cNvSpPr/>
+          <p:nvPr/>
+        </p:nvSpPr>
+        <p:spPr>
+          <a:xfrm>
+            <a:off x="5943600" y="2834639"/>
+            <a:ext cx="1965960" cy="1234440"/>
+          </a:xfrm>
+          <a:prstGeom prst="roundRect">
+            <a:avLst>
+              <a:gd name="adj" fmla="val 12000"/>
+            </a:avLst>
+          </a:prstGeom>
+          <a:solidFill>
+            <a:srgbClr val="DBEAFE"/>
+          </a:solidFill>
+          <a:ln w="19050">
+            <a:solidFill>
+              <a:srgbClr val="1D4ED8"/>
+            </a:solidFill>
+          </a:ln>
+          <a:effectLst/>
+        </p:spPr>
+        <p:style>
+          <a:lnRef idx="1">
+            <a:schemeClr val="accent1"/>
+          </a:lnRef>
+          <a:fillRef idx="3">
+            <a:schemeClr val="accent1"/>
+          </a:fillRef>
+          <a:effectRef idx="2">
+            <a:schemeClr val="accent1"/>
+          </a:effectRef>
+          <a:fontRef idx="minor">
+            <a:schemeClr val="lt1"/>
+          </a:fontRef>
+        </p:style>
+        <p:txBody>
+          <a:bodyPr rtlCol="0" anchor="ctr" wrap="square" lIns="38100" rIns="38100" tIns="25400" bIns="25400"/>
+          <a:lstStyle/>
+          <a:p>
+            <a:pPr algn="ctr"/>
+            <a:r>
+              <a:rPr sz="1200" b="1">
+                <a:solidFill>
+                  <a:srgbClr val="1E3A8A"/>
+                </a:solidFill>
+                <a:latin typeface="Microsoft YaHei"/>
+                <a:ea typeface="Microsoft YaHei"/>
+                <a:cs typeface="Microsoft YaHei"/>
+              </a:rPr>
+              <a:t>整颗芯片</a:t>
+            </a:r>
+          </a:p>
+          <a:p>
+            <a:pPr algn="ctr"/>
+            <a:r>
+              <a:rPr sz="1200" b="1">
+                <a:solidFill>
+                  <a:srgbClr val="1E3A8A"/>
+                </a:solidFill>
+                <a:latin typeface="Microsoft YaHei"/>
+                <a:ea typeface="Microsoft YaHei"/>
+                <a:cs typeface="Microsoft YaHei"/>
+              </a:rPr>
+              <a:t>一次 P&amp;R</a:t>
+            </a:r>
+          </a:p>
+        </p:txBody>
+      </p:sp>
+      <p:sp>
+        <p:nvSpPr>
+          <p:cNvPr id="8" name="Rounded Rectangle 7"/>
+          <p:cNvSpPr/>
+          <p:nvPr/>
+        </p:nvSpPr>
+        <p:spPr>
+          <a:xfrm>
+            <a:off x="8732520" y="2286000"/>
+            <a:ext cx="2880360" cy="2834640"/>
+          </a:xfrm>
+          <a:prstGeom prst="roundRect">
+            <a:avLst>
+              <a:gd name="adj" fmla="val 12000"/>
+            </a:avLst>
+          </a:prstGeom>
+          <a:solidFill>
+            <a:srgbClr val="FFFFFF"/>
+          </a:solidFill>
+          <a:ln w="19050">
+            <a:solidFill>
+              <a:srgbClr val="94A3B8"/>
+            </a:solidFill>
+          </a:ln>
+          <a:effectLst/>
+        </p:spPr>
+        <p:style>
+          <a:lnRef idx="1">
+            <a:schemeClr val="accent1"/>
+          </a:lnRef>
+          <a:fillRef idx="3">
+            <a:schemeClr val="accent1"/>
+          </a:fillRef>
+          <a:effectRef idx="2">
+            <a:schemeClr val="accent1"/>
+          </a:effectRef>
+          <a:fontRef idx="minor">
+            <a:schemeClr val="lt1"/>
+          </a:fontRef>
+        </p:style>
+        <p:txBody>
+          <a:bodyPr rtlCol="0" anchor="ctr" wrap="square" lIns="38100" rIns="38100" tIns="25400" bIns="25400"/>
+          <a:lstStyle/>
+          <a:p>
+            <a:pPr algn="ctr"/>
+            <a:r>
+              <a:rPr sz="1200" b="1">
+                <a:solidFill>
+                  <a:srgbClr val="1A1F2B"/>
+                </a:solidFill>
+                <a:latin typeface="Microsoft YaHei"/>
+                <a:ea typeface="Microsoft YaHei"/>
+                <a:cs typeface="Microsoft YaHei"/>
+              </a:rPr>
+              <a:t/>
+            </a:r>
+          </a:p>
+        </p:txBody>
+      </p:sp>
+      <p:sp>
+        <p:nvSpPr>
+          <p:cNvPr id="9" name="Rounded Rectangle 8"/>
+          <p:cNvSpPr/>
+          <p:nvPr/>
+        </p:nvSpPr>
+        <p:spPr>
+          <a:xfrm>
+            <a:off x="9646920" y="2560320"/>
+            <a:ext cx="1417320" cy="594360"/>
+          </a:xfrm>
+          <a:prstGeom prst="roundRect">
+            <a:avLst>
+              <a:gd name="adj" fmla="val 12000"/>
+            </a:avLst>
+          </a:prstGeom>
+          <a:solidFill>
+            <a:srgbClr val="EDF0F4"/>
+          </a:solidFill>
+          <a:ln w="19050">
+            <a:solidFill>
+              <a:srgbClr val="94A3B8"/>
+            </a:solidFill>
+          </a:ln>
+          <a:effectLst/>
+        </p:spPr>
+        <p:style>
+          <a:lnRef idx="1">
+            <a:schemeClr val="accent1"/>
+          </a:lnRef>
+          <a:fillRef idx="3">
+            <a:schemeClr val="accent1"/>
+          </a:fillRef>
+          <a:effectRef idx="2">
+            <a:schemeClr val="accent1"/>
+          </a:effectRef>
+          <a:fontRef idx="minor">
+            <a:schemeClr val="lt1"/>
+          </a:fontRef>
+        </p:style>
+        <p:txBody>
+          <a:bodyPr rtlCol="0" anchor="ctr" wrap="square" lIns="38100" rIns="38100" tIns="25400" bIns="25400"/>
+          <a:lstStyle/>
+          <a:p>
+            <a:pPr algn="ctr"/>
+            <a:r>
+              <a:rPr sz="1200" b="1">
+                <a:solidFill>
+                  <a:srgbClr val="1A1F2B"/>
+                </a:solidFill>
+                <a:latin typeface="Microsoft YaHei"/>
+                <a:ea typeface="Microsoft YaHei"/>
+                <a:cs typeface="Microsoft YaHei"/>
+              </a:rPr>
+              <a:t>Top 集成</a:t>
+            </a:r>
+          </a:p>
+        </p:txBody>
+      </p:sp>
+      <p:sp>
+        <p:nvSpPr>
+          <p:cNvPr id="10" name="Rounded Rectangle 9"/>
+          <p:cNvSpPr/>
+          <p:nvPr/>
+        </p:nvSpPr>
+        <p:spPr>
+          <a:xfrm>
+            <a:off x="8915400" y="3474720"/>
+            <a:ext cx="777240" cy="731520"/>
+          </a:xfrm>
+          <a:prstGeom prst="roundRect">
+            <a:avLst>
+              <a:gd name="adj" fmla="val 12000"/>
+            </a:avLst>
+          </a:prstGeom>
+          <a:solidFill>
+            <a:srgbClr val="CCFBF1"/>
+          </a:solidFill>
+          <a:ln w="19050">
+            <a:solidFill>
+              <a:srgbClr val="0D9488"/>
+            </a:solidFill>
+          </a:ln>
+          <a:effectLst/>
+        </p:spPr>
+        <p:style>
+          <a:lnRef idx="1">
+            <a:schemeClr val="accent1"/>
+          </a:lnRef>
+          <a:fillRef idx="3">
+            <a:schemeClr val="accent1"/>
+          </a:fillRef>
+          <a:effectRef idx="2">
+            <a:schemeClr val="accent1"/>
+          </a:effectRef>
+          <a:fontRef idx="minor">
+            <a:schemeClr val="lt1"/>
+          </a:fontRef>
+        </p:style>
+        <p:txBody>
+          <a:bodyPr rtlCol="0" anchor="ctr" wrap="square" lIns="38100" rIns="38100" tIns="25400" bIns="25400"/>
+          <a:lstStyle/>
+          <a:p>
+            <a:pPr algn="ctr"/>
+            <a:r>
+              <a:rPr sz="1200" b="1">
+                <a:solidFill>
+                  <a:srgbClr val="115E59"/>
+                </a:solidFill>
+                <a:latin typeface="Microsoft YaHei"/>
+                <a:ea typeface="Microsoft YaHei"/>
+                <a:cs typeface="Microsoft YaHei"/>
+              </a:rPr>
+              <a:t>Blk1</a:t>
+            </a:r>
+          </a:p>
+        </p:txBody>
+      </p:sp>
+      <p:sp>
+        <p:nvSpPr>
+          <p:cNvPr id="11" name="Rounded Rectangle 10"/>
+          <p:cNvSpPr/>
+          <p:nvPr/>
+        </p:nvSpPr>
+        <p:spPr>
+          <a:xfrm>
+            <a:off x="9784080" y="3474720"/>
+            <a:ext cx="777240" cy="731520"/>
+          </a:xfrm>
+          <a:prstGeom prst="roundRect">
+            <a:avLst>
+              <a:gd name="adj" fmla="val 12000"/>
+            </a:avLst>
+          </a:prstGeom>
+          <a:solidFill>
+            <a:srgbClr val="CCFBF1"/>
+          </a:solidFill>
+          <a:ln w="19050">
+            <a:solidFill>
+              <a:srgbClr val="0D9488"/>
+            </a:solidFill>
+          </a:ln>
+          <a:effectLst/>
+        </p:spPr>
+        <p:style>
+          <a:lnRef idx="1">
+            <a:schemeClr val="accent1"/>
+          </a:lnRef>
+          <a:fillRef idx="3">
+            <a:schemeClr val="accent1"/>
+          </a:fillRef>
+          <a:effectRef idx="2">
+            <a:schemeClr val="accent1"/>
+          </a:effectRef>
+          <a:fontRef idx="minor">
+            <a:schemeClr val="lt1"/>
+          </a:fontRef>
+        </p:style>
+        <p:txBody>
+          <a:bodyPr rtlCol="0" anchor="ctr" wrap="square" lIns="38100" rIns="38100" tIns="25400" bIns="25400"/>
+          <a:lstStyle/>
+          <a:p>
+            <a:pPr algn="ctr"/>
+            <a:r>
+              <a:rPr sz="1200" b="1">
+                <a:solidFill>
+                  <a:srgbClr val="115E59"/>
+                </a:solidFill>
+                <a:latin typeface="Microsoft YaHei"/>
+                <a:ea typeface="Microsoft YaHei"/>
+                <a:cs typeface="Microsoft YaHei"/>
+              </a:rPr>
+              <a:t>Blk2</a:t>
+            </a:r>
+          </a:p>
+        </p:txBody>
+      </p:sp>
+      <p:sp>
+        <p:nvSpPr>
+          <p:cNvPr id="12" name="Rounded Rectangle 11"/>
+          <p:cNvSpPr/>
+          <p:nvPr/>
+        </p:nvSpPr>
+        <p:spPr>
+          <a:xfrm>
+            <a:off x="10652760" y="3474720"/>
+            <a:ext cx="777240" cy="731520"/>
+          </a:xfrm>
+          <a:prstGeom prst="roundRect">
+            <a:avLst>
+              <a:gd name="adj" fmla="val 12000"/>
+            </a:avLst>
+          </a:prstGeom>
+          <a:solidFill>
+            <a:srgbClr val="CCFBF1"/>
+          </a:solidFill>
+          <a:ln w="19050">
+            <a:solidFill>
+              <a:srgbClr val="0D9488"/>
+            </a:solidFill>
+          </a:ln>
+          <a:effectLst/>
+        </p:spPr>
+        <p:style>
+          <a:lnRef idx="1">
+            <a:schemeClr val="accent1"/>
+          </a:lnRef>
+          <a:fillRef idx="3">
+            <a:schemeClr val="accent1"/>
+          </a:fillRef>
+          <a:effectRef idx="2">
+            <a:schemeClr val="accent1"/>
+          </a:effectRef>
+          <a:fontRef idx="minor">
+            <a:schemeClr val="lt1"/>
+          </a:fontRef>
+        </p:style>
+        <p:txBody>
+          <a:bodyPr rtlCol="0" anchor="ctr" wrap="square" lIns="38100" rIns="38100" tIns="25400" bIns="25400"/>
+          <a:lstStyle/>
+          <a:p>
+            <a:pPr algn="ctr"/>
+            <a:r>
+              <a:rPr sz="1200" b="1">
+                <a:solidFill>
+                  <a:srgbClr val="115E59"/>
+                </a:solidFill>
+                <a:latin typeface="Microsoft YaHei"/>
+                <a:ea typeface="Microsoft YaHei"/>
+                <a:cs typeface="Microsoft YaHei"/>
+              </a:rPr>
+              <a:t>Blk3</a:t>
+            </a:r>
+          </a:p>
+        </p:txBody>
+      </p:sp>
+      <p:sp>
+        <p:nvSpPr>
+          <p:cNvPr id="13" name="Rounded Rectangle 12"/>
+          <p:cNvSpPr/>
+          <p:nvPr/>
+        </p:nvSpPr>
+        <p:spPr>
+          <a:xfrm>
+            <a:off x="5623560" y="5330952"/>
+            <a:ext cx="5989320" cy="841248"/>
+          </a:xfrm>
+          <a:prstGeom prst="roundRect">
+            <a:avLst>
+              <a:gd name="adj" fmla="val 12000"/>
+            </a:avLst>
+          </a:prstGeom>
+          <a:solidFill>
+            <a:srgbClr val="EDF0F4"/>
+          </a:solidFill>
+          <a:ln w="19050">
+            <a:solidFill>
+              <a:srgbClr val="94A3B8"/>
+            </a:solidFill>
+          </a:ln>
+          <a:effectLst/>
+        </p:spPr>
+        <p:style>
+          <a:lnRef idx="1">
+            <a:schemeClr val="accent1"/>
+          </a:lnRef>
+          <a:fillRef idx="3">
+            <a:schemeClr val="accent1"/>
+          </a:fillRef>
+          <a:effectRef idx="2">
+            <a:schemeClr val="accent1"/>
+          </a:effectRef>
+          <a:fontRef idx="minor">
+            <a:schemeClr val="lt1"/>
+          </a:fontRef>
+        </p:style>
+        <p:txBody>
+          <a:bodyPr rtlCol="0" anchor="ctr" wrap="square" lIns="38100" rIns="38100" tIns="25400" bIns="25400"/>
+          <a:lstStyle/>
+          <a:p>
+            <a:pPr algn="ctr"/>
+            <a:r>
+              <a:rPr sz="1200" b="1">
+                <a:solidFill>
+                  <a:srgbClr val="1A1F2B"/>
+                </a:solidFill>
+                <a:latin typeface="Microsoft YaHei"/>
+                <a:ea typeface="Microsoft YaHei"/>
+                <a:cs typeface="Microsoft YaHei"/>
+              </a:rPr>
+              <a:t>层次化省运行时间 / 内存、利于复用；但全芯片时序收敛更难，依赖引脚 / feedthrough / 时序预算 / ILM</a:t>
+            </a:r>
+          </a:p>
+        </p:txBody>
+      </p:sp>
+      <p:cxnSp>
+        <p:nvCxnSpPr>
+          <p:cNvPr id="14" name="Connector 13"/>
+          <p:cNvCxnSpPr/>
+          <p:nvPr/>
+        </p:nvCxnSpPr>
+        <p:spPr>
+          <a:xfrm flipV="1">
+            <a:off x="9304020" y="3154680"/>
+            <a:ext cx="662940" cy="320040"/>
+          </a:xfrm>
+          <a:prstGeom prst="line">
+            <a:avLst/>
+          </a:prstGeom>
+          <a:ln w="19050">
+            <a:solidFill>
+              <a:srgbClr val="3A4252"/>
+            </a:solidFill>
+            <a:tailEnd type="triangle" w="med" len="med"/>
+          </a:ln>
+          <a:effectLst/>
+        </p:spPr>
+        <p:style>
+          <a:lnRef idx="2">
+            <a:schemeClr val="accent1"/>
+          </a:lnRef>
+          <a:fillRef idx="0">
+            <a:schemeClr val="accent1"/>
+          </a:fillRef>
+          <a:effectRef idx="1">
+            <a:schemeClr val="accent1"/>
+          </a:effectRef>
+          <a:fontRef idx="minor">
+            <a:schemeClr val="tx1"/>
+          </a:fontRef>
+        </p:style>
+      </p:cxnSp>
+      <p:cxnSp>
+        <p:nvCxnSpPr>
+          <p:cNvPr id="15" name="Connector 14"/>
+          <p:cNvCxnSpPr/>
+          <p:nvPr/>
+        </p:nvCxnSpPr>
+        <p:spPr>
+          <a:xfrm flipV="1">
+            <a:off x="10172700" y="3154680"/>
+            <a:ext cx="68580" cy="320040"/>
+          </a:xfrm>
+          <a:prstGeom prst="line">
+            <a:avLst/>
+          </a:prstGeom>
+          <a:ln w="19050">
+            <a:solidFill>
+              <a:srgbClr val="3A4252"/>
+            </a:solidFill>
+            <a:tailEnd type="triangle" w="med" len="med"/>
+          </a:ln>
+          <a:effectLst/>
+        </p:spPr>
+        <p:style>
+          <a:lnRef idx="2">
+            <a:schemeClr val="accent1"/>
+          </a:lnRef>
+          <a:fillRef idx="0">
+            <a:schemeClr val="accent1"/>
+          </a:fillRef>
+          <a:effectRef idx="1">
+            <a:schemeClr val="accent1"/>
+          </a:effectRef>
+          <a:fontRef idx="minor">
+            <a:schemeClr val="tx1"/>
+          </a:fontRef>
+        </p:style>
+      </p:cxnSp>
+      <p:cxnSp>
+        <p:nvCxnSpPr>
+          <p:cNvPr id="16" name="Connector 15"/>
+          <p:cNvCxnSpPr/>
+          <p:nvPr/>
+        </p:nvCxnSpPr>
+        <p:spPr>
+          <a:xfrm flipH="1" flipV="1">
+            <a:off x="10515600" y="3154680"/>
+            <a:ext cx="525780" cy="320040"/>
+          </a:xfrm>
+          <a:prstGeom prst="line">
+            <a:avLst/>
+          </a:prstGeom>
+          <a:ln w="19050">
+            <a:solidFill>
+              <a:srgbClr val="3A4252"/>
+            </a:solidFill>
+            <a:tailEnd type="triangle" w="med" len="med"/>
+          </a:ln>
+          <a:effectLst/>
+        </p:spPr>
+        <p:style>
+          <a:lnRef idx="2">
+            <a:schemeClr val="accent1"/>
+          </a:lnRef>
+          <a:fillRef idx="0">
+            <a:schemeClr val="accent1"/>
+          </a:fillRef>
+          <a:effectRef idx="1">
+            <a:schemeClr val="accent1"/>
+          </a:effectRef>
+          <a:fontRef idx="minor">
+            <a:schemeClr val="tx1"/>
+          </a:fontRef>
+        </p:style>
+      </p:cxnSp>
+      <p:sp>
+        <p:nvSpPr>
+          <p:cNvPr id="17" name="TextBox 16"/>
           <p:cNvSpPr txBox="1"/>
           <p:nvPr/>
         </p:nvSpPr>
         <p:spPr>
           <a:xfrm>
-            <a:off x="9875520" y="6446520"/>
-            <a:ext cx="2011680" cy="365760"/>
+            <a:off x="5280660" y="1801368"/>
+            <a:ext cx="3291840" cy="365760"/>
           </a:xfrm>
           <a:prstGeom prst="rect">
             <a:avLst/>
@@ -4686,8 +6498,230 @@
           </a:bodyPr>
           <a:lstStyle/>
           <a:p>
+            <a:pPr algn="ctr"/>
+            <a:r>
+              <a:rPr sz="1400" b="1">
+                <a:solidFill>
+                  <a:srgbClr val="1E3A8A"/>
+                </a:solidFill>
+                <a:latin typeface="Microsoft YaHei"/>
+                <a:ea typeface="Microsoft YaHei"/>
+                <a:cs typeface="Microsoft YaHei"/>
+              </a:rPr>
+              <a:t>扁平 Flat</a:t>
+            </a:r>
+          </a:p>
+        </p:txBody>
+      </p:sp>
+      <p:sp>
+        <p:nvSpPr>
+          <p:cNvPr id="18" name="TextBox 17"/>
+          <p:cNvSpPr txBox="1"/>
+          <p:nvPr/>
+        </p:nvSpPr>
+        <p:spPr>
+          <a:xfrm>
+            <a:off x="8526780" y="1801368"/>
+            <a:ext cx="3291840" cy="365760"/>
+          </a:xfrm>
+          <a:prstGeom prst="rect">
+            <a:avLst/>
+          </a:prstGeom>
+          <a:noFill/>
+        </p:spPr>
+        <p:txBody>
+          <a:bodyPr wrap="none" lIns="0" rIns="0" tIns="0" bIns="0">
+            <a:spAutoFit/>
+          </a:bodyPr>
+          <a:lstStyle/>
+          <a:p>
+            <a:pPr algn="ctr"/>
+            <a:r>
+              <a:rPr sz="1400" b="1">
+                <a:solidFill>
+                  <a:srgbClr val="115E59"/>
+                </a:solidFill>
+                <a:latin typeface="Microsoft YaHei"/>
+                <a:ea typeface="Microsoft YaHei"/>
+                <a:cs typeface="Microsoft YaHei"/>
+              </a:rPr>
+              <a:t>层次化 Hierarchical</a:t>
+            </a:r>
+          </a:p>
+        </p:txBody>
+      </p:sp>
+      <p:sp>
+        <p:nvSpPr>
+          <p:cNvPr id="19" name="TextBox 18"/>
+          <p:cNvSpPr txBox="1"/>
+          <p:nvPr/>
+        </p:nvSpPr>
+        <p:spPr>
+          <a:xfrm>
+            <a:off x="5280660" y="4690872"/>
+            <a:ext cx="3291840" cy="365760"/>
+          </a:xfrm>
+          <a:prstGeom prst="rect">
+            <a:avLst/>
+          </a:prstGeom>
+          <a:noFill/>
+        </p:spPr>
+        <p:txBody>
+          <a:bodyPr wrap="none" lIns="0" rIns="0" tIns="0" bIns="0">
+            <a:spAutoFit/>
+          </a:bodyPr>
+          <a:lstStyle/>
+          <a:p>
+            <a:pPr algn="ctr"/>
+            <a:r>
+              <a:rPr sz="1000" b="0">
+                <a:solidFill>
+                  <a:srgbClr val="6B7280"/>
+                </a:solidFill>
+                <a:latin typeface="Microsoft YaHei"/>
+                <a:ea typeface="Microsoft YaHei"/>
+                <a:cs typeface="Microsoft YaHei"/>
+              </a:rPr>
+              <a:t>运行慢 / 内存大</a:t>
+            </a:r>
+          </a:p>
+        </p:txBody>
+      </p:sp>
+      <p:sp>
+        <p:nvSpPr>
+          <p:cNvPr id="20" name="TextBox 19"/>
+          <p:cNvSpPr txBox="1"/>
+          <p:nvPr/>
+        </p:nvSpPr>
+        <p:spPr>
+          <a:xfrm>
+            <a:off x="7658100" y="4233672"/>
+            <a:ext cx="3291840" cy="365760"/>
+          </a:xfrm>
+          <a:prstGeom prst="rect">
+            <a:avLst/>
+          </a:prstGeom>
+          <a:noFill/>
+        </p:spPr>
+        <p:txBody>
+          <a:bodyPr wrap="none" lIns="0" rIns="0" tIns="0" bIns="0">
+            <a:spAutoFit/>
+          </a:bodyPr>
+          <a:lstStyle/>
+          <a:p>
+            <a:pPr algn="ctr"/>
+            <a:r>
+              <a:rPr sz="850" b="0">
+                <a:solidFill>
+                  <a:srgbClr val="6B7280"/>
+                </a:solidFill>
+                <a:latin typeface="Microsoft YaHei"/>
+                <a:ea typeface="Microsoft YaHei"/>
+                <a:cs typeface="Microsoft YaHei"/>
+              </a:rPr>
+              <a:t>P&amp;R</a:t>
+            </a:r>
+          </a:p>
+        </p:txBody>
+      </p:sp>
+      <p:sp>
+        <p:nvSpPr>
+          <p:cNvPr id="21" name="TextBox 20"/>
+          <p:cNvSpPr txBox="1"/>
+          <p:nvPr/>
+        </p:nvSpPr>
+        <p:spPr>
+          <a:xfrm>
+            <a:off x="8526780" y="4233672"/>
+            <a:ext cx="3291840" cy="365760"/>
+          </a:xfrm>
+          <a:prstGeom prst="rect">
+            <a:avLst/>
+          </a:prstGeom>
+          <a:noFill/>
+        </p:spPr>
+        <p:txBody>
+          <a:bodyPr wrap="none" lIns="0" rIns="0" tIns="0" bIns="0">
+            <a:spAutoFit/>
+          </a:bodyPr>
+          <a:lstStyle/>
+          <a:p>
+            <a:pPr algn="ctr"/>
+            <a:r>
+              <a:rPr sz="850" b="0">
+                <a:solidFill>
+                  <a:srgbClr val="6B7280"/>
+                </a:solidFill>
+                <a:latin typeface="Microsoft YaHei"/>
+                <a:ea typeface="Microsoft YaHei"/>
+                <a:cs typeface="Microsoft YaHei"/>
+              </a:rPr>
+              <a:t>P&amp;R</a:t>
+            </a:r>
+          </a:p>
+        </p:txBody>
+      </p:sp>
+      <p:sp>
+        <p:nvSpPr>
+          <p:cNvPr id="22" name="TextBox 21"/>
+          <p:cNvSpPr txBox="1"/>
+          <p:nvPr/>
+        </p:nvSpPr>
+        <p:spPr>
+          <a:xfrm>
+            <a:off x="9395459" y="4233672"/>
+            <a:ext cx="3291840" cy="365760"/>
+          </a:xfrm>
+          <a:prstGeom prst="rect">
+            <a:avLst/>
+          </a:prstGeom>
+          <a:noFill/>
+        </p:spPr>
+        <p:txBody>
+          <a:bodyPr wrap="none" lIns="0" rIns="0" tIns="0" bIns="0">
+            <a:spAutoFit/>
+          </a:bodyPr>
+          <a:lstStyle/>
+          <a:p>
+            <a:pPr algn="ctr"/>
+            <a:r>
+              <a:rPr sz="850" b="0">
+                <a:solidFill>
+                  <a:srgbClr val="6B7280"/>
+                </a:solidFill>
+                <a:latin typeface="Microsoft YaHei"/>
+                <a:ea typeface="Microsoft YaHei"/>
+                <a:cs typeface="Microsoft YaHei"/>
+              </a:rPr>
+              <a:t>P&amp;R</a:t>
+            </a:r>
+          </a:p>
+        </p:txBody>
+      </p:sp>
+      <p:sp>
+        <p:nvSpPr>
+          <p:cNvPr id="23" name="TextBox 22"/>
+          <p:cNvSpPr txBox="1"/>
+          <p:nvPr/>
+        </p:nvSpPr>
+        <p:spPr>
+          <a:xfrm>
+            <a:off x="9875520" y="6446520"/>
+            <a:ext cx="2011680" cy="365760"/>
+          </a:xfrm>
+          <a:prstGeom prst="rect">
+            <a:avLst/>
+          </a:prstGeom>
+          <a:noFill/>
+        </p:spPr>
+        <p:txBody>
+          <a:bodyPr wrap="none" lIns="0" rIns="0" tIns="0" bIns="0">
+            <a:spAutoFit/>
+          </a:bodyPr>
+          <a:lstStyle/>
+          <a:p>
             <a:pPr algn="r"/>
-            <a:fld id="{61F4E830-3146-4214-A7CF-35E94431DB77}" type="slidenum">
+            <a:fld id="{111319D4-A014-4B16-A5D4-89B2D27E35EF}" type="slidenum">
               <a:rPr lang="en-US" sz="1000">
                 <a:solidFill>
                   <a:srgbClr val="9AA3B0"/>
@@ -5036,7 +7070,7 @@
           <a:lstStyle/>
           <a:p>
             <a:pPr algn="r"/>
-            <a:fld id="{48BABD96-86E4-4A18-9E31-345EA57EA1E1}" type="slidenum">
+            <a:fld id="{F05F5638-7A76-4F8D-9513-CAF4681F7ACF}" type="slidenum">
               <a:rPr lang="en-US" sz="1000">
                 <a:solidFill>
                   <a:srgbClr val="9AA3B0"/>
@@ -5951,7 +7985,7 @@
           <a:lstStyle/>
           <a:p>
             <a:pPr algn="r"/>
-            <a:fld id="{5BFEE65C-DDA6-4291-8414-337855263930}" type="slidenum">
+            <a:fld id="{6ACA0FB2-2845-4399-BABE-DB1C926ED1B3}" type="slidenum">
               <a:rPr lang="en-US" sz="1000">
                 <a:solidFill>
                   <a:srgbClr val="9AA3B0"/>
@@ -6237,7 +8271,7 @@
           <a:lstStyle/>
           <a:p>
             <a:pPr algn="r"/>
-            <a:fld id="{7C900152-436C-4559-8365-556BC94554D1}" type="slidenum">
+            <a:fld id="{EBB46898-A383-45D0-A462-D94FC6974E7A}" type="slidenum">
               <a:rPr lang="en-US" sz="1000">
                 <a:solidFill>
                   <a:srgbClr val="9AA3B0"/>
@@ -7440,7 +9474,7 @@
           <a:lstStyle/>
           <a:p>
             <a:pPr algn="r"/>
-            <a:fld id="{AA664313-3ADD-4C63-B8B6-1F482250C2B8}" type="slidenum">
+            <a:fld id="{8E00E50A-D1FA-4270-A379-E752B4FDBAEA}" type="slidenum">
               <a:rPr lang="en-US" sz="1000">
                 <a:solidFill>
                   <a:srgbClr val="9AA3B0"/>
@@ -7726,7 +9760,7 @@
           <a:lstStyle/>
           <a:p>
             <a:pPr algn="r"/>
-            <a:fld id="{2E09271A-51CA-4307-AC04-71E1058643E7}" type="slidenum">
+            <a:fld id="{F0A5BEF0-698C-48E8-83B3-8DFE9E5B7595}" type="slidenum">
               <a:rPr lang="en-US" sz="1000">
                 <a:solidFill>
                   <a:srgbClr val="9AA3B0"/>
@@ -8074,7 +10108,7 @@
           <a:lstStyle/>
           <a:p>
             <a:pPr algn="r"/>
-            <a:fld id="{3488F4D0-9DF2-4325-B0D0-B4A8DF2A8706}" type="slidenum">
+            <a:fld id="{04F41E0A-25D7-49C6-AA9E-5711A05BE535}" type="slidenum">
               <a:rPr lang="en-US" sz="1000">
                 <a:solidFill>
                   <a:srgbClr val="9AA3B0"/>
@@ -8962,7 +10996,7 @@
           <a:lstStyle/>
           <a:p>
             <a:pPr algn="r"/>
-            <a:fld id="{2ED3AD23-CAD1-417B-85BA-262BFDA45079}" type="slidenum">
+            <a:fld id="{B6B3AC91-5145-4ABB-87E2-AF8247D5101D}" type="slidenum">
               <a:rPr lang="en-US" sz="1000">
                 <a:solidFill>
                   <a:srgbClr val="9AA3B0"/>
@@ -9808,7 +11842,7 @@
           <a:lstStyle/>
           <a:p>
             <a:pPr algn="r"/>
-            <a:fld id="{94E93B7D-5A9C-4E5B-AD36-91B1015A9AA1}" type="slidenum">
+            <a:fld id="{B14515C1-5FBD-476F-919B-B911DD859E43}" type="slidenum">
               <a:rPr lang="en-US" sz="1000">
                 <a:solidFill>
                   <a:srgbClr val="9AA3B0"/>
@@ -10133,7 +12167,7 @@
           <a:lstStyle/>
           <a:p>
             <a:pPr algn="r"/>
-            <a:fld id="{016D836E-E2FE-497D-94EC-96212BDCD090}" type="slidenum">
+            <a:fld id="{0EA850DC-56B2-4AF1-8F51-DAC93BF57DFB}" type="slidenum">
               <a:rPr lang="en-US" sz="1000">
                 <a:solidFill>
                   <a:srgbClr val="9AA3B0"/>
@@ -10482,7 +12516,7 @@
           <a:lstStyle/>
           <a:p>
             <a:pPr algn="r"/>
-            <a:fld id="{1334EADD-3153-4C8F-B231-25283D5941B6}" type="slidenum">
+            <a:fld id="{33D45A6D-6F2A-4824-AFC3-170715536317}" type="slidenum">
               <a:rPr lang="en-US" sz="1000">
                 <a:solidFill>
                   <a:srgbClr val="9AA3B0"/>
@@ -12023,40 +14057,428 @@
           </a:p>
         </p:txBody>
       </p:sp>
-      <p:pic>
-        <p:nvPicPr>
-          <p:cNvPr id="6" name="Picture 5" descr="f15_loop.png"/>
-          <p:cNvPicPr>
-            <a:picLocks noChangeAspect="1"/>
-          </p:cNvPicPr>
-          <p:nvPr/>
-        </p:nvPicPr>
-        <p:blipFill>
-          <a:blip r:embed="rId2"/>
-          <a:stretch>
-            <a:fillRect/>
-          </a:stretch>
-        </p:blipFill>
-        <p:spPr>
-          <a:xfrm>
-            <a:off x="5933860" y="1554480"/>
-            <a:ext cx="5368718" cy="4800600"/>
-          </a:xfrm>
-          <a:prstGeom prst="rect">
-            <a:avLst/>
-          </a:prstGeom>
-        </p:spPr>
-      </p:pic>
-      <p:sp>
-        <p:nvSpPr>
-          <p:cNvPr id="7" name="TextBox 6"/>
+      <p:sp>
+        <p:nvSpPr>
+          <p:cNvPr id="6" name="Rounded Rectangle 5"/>
+          <p:cNvSpPr/>
+          <p:nvPr/>
+        </p:nvSpPr>
+        <p:spPr>
+          <a:xfrm>
+            <a:off x="7589520" y="1874519"/>
+            <a:ext cx="2011680" cy="822960"/>
+          </a:xfrm>
+          <a:prstGeom prst="roundRect">
+            <a:avLst>
+              <a:gd name="adj" fmla="val 12000"/>
+            </a:avLst>
+          </a:prstGeom>
+          <a:solidFill>
+            <a:srgbClr val="DBEAFE"/>
+          </a:solidFill>
+          <a:ln w="19050">
+            <a:solidFill>
+              <a:srgbClr val="1D4ED8"/>
+            </a:solidFill>
+          </a:ln>
+          <a:effectLst/>
+        </p:spPr>
+        <p:style>
+          <a:lnRef idx="1">
+            <a:schemeClr val="accent1"/>
+          </a:lnRef>
+          <a:fillRef idx="3">
+            <a:schemeClr val="accent1"/>
+          </a:fillRef>
+          <a:effectRef idx="2">
+            <a:schemeClr val="accent1"/>
+          </a:effectRef>
+          <a:fontRef idx="minor">
+            <a:schemeClr val="lt1"/>
+          </a:fontRef>
+        </p:style>
+        <p:txBody>
+          <a:bodyPr rtlCol="0" anchor="ctr" wrap="square" lIns="38100" rIns="38100" tIns="25400" bIns="25400"/>
+          <a:lstStyle/>
+          <a:p>
+            <a:pPr algn="ctr"/>
+            <a:r>
+              <a:rPr sz="1200" b="1">
+                <a:solidFill>
+                  <a:srgbClr val="1E3A8A"/>
+                </a:solidFill>
+                <a:latin typeface="Microsoft YaHei"/>
+                <a:ea typeface="Microsoft YaHei"/>
+                <a:cs typeface="Microsoft YaHei"/>
+              </a:rPr>
+              <a:t>Floorplan</a:t>
+            </a:r>
+          </a:p>
+          <a:p>
+            <a:pPr algn="ctr"/>
+            <a:r>
+              <a:rPr sz="1200" b="1">
+                <a:solidFill>
+                  <a:srgbClr val="1E3A8A"/>
+                </a:solidFill>
+                <a:latin typeface="Microsoft YaHei"/>
+                <a:ea typeface="Microsoft YaHei"/>
+                <a:cs typeface="Microsoft YaHei"/>
+              </a:rPr>
+              <a:t>定 die/macro/PG</a:t>
+            </a:r>
+          </a:p>
+        </p:txBody>
+      </p:sp>
+      <p:sp>
+        <p:nvSpPr>
+          <p:cNvPr id="7" name="Rounded Rectangle 6"/>
+          <p:cNvSpPr/>
+          <p:nvPr/>
+        </p:nvSpPr>
+        <p:spPr>
+          <a:xfrm>
+            <a:off x="9784080" y="3611880"/>
+            <a:ext cx="1828800" cy="822960"/>
+          </a:xfrm>
+          <a:prstGeom prst="roundRect">
+            <a:avLst>
+              <a:gd name="adj" fmla="val 12000"/>
+            </a:avLst>
+          </a:prstGeom>
+          <a:solidFill>
+            <a:srgbClr val="CCFBF1"/>
+          </a:solidFill>
+          <a:ln w="19050">
+            <a:solidFill>
+              <a:srgbClr val="0D9488"/>
+            </a:solidFill>
+          </a:ln>
+          <a:effectLst/>
+        </p:spPr>
+        <p:style>
+          <a:lnRef idx="1">
+            <a:schemeClr val="accent1"/>
+          </a:lnRef>
+          <a:fillRef idx="3">
+            <a:schemeClr val="accent1"/>
+          </a:fillRef>
+          <a:effectRef idx="2">
+            <a:schemeClr val="accent1"/>
+          </a:effectRef>
+          <a:fontRef idx="minor">
+            <a:schemeClr val="lt1"/>
+          </a:fontRef>
+        </p:style>
+        <p:txBody>
+          <a:bodyPr rtlCol="0" anchor="ctr" wrap="square" lIns="38100" rIns="38100" tIns="25400" bIns="25400"/>
+          <a:lstStyle/>
+          <a:p>
+            <a:pPr algn="ctr"/>
+            <a:r>
+              <a:rPr sz="1200" b="1">
+                <a:solidFill>
+                  <a:srgbClr val="115E59"/>
+                </a:solidFill>
+                <a:latin typeface="Microsoft YaHei"/>
+                <a:ea typeface="Microsoft YaHei"/>
+                <a:cs typeface="Microsoft YaHei"/>
+              </a:rPr>
+              <a:t>试布局 + GR</a:t>
+            </a:r>
+          </a:p>
+        </p:txBody>
+      </p:sp>
+      <p:sp>
+        <p:nvSpPr>
+          <p:cNvPr id="8" name="Rounded Rectangle 7"/>
+          <p:cNvSpPr/>
+          <p:nvPr/>
+        </p:nvSpPr>
+        <p:spPr>
+          <a:xfrm>
+            <a:off x="7589520" y="5257800"/>
+            <a:ext cx="2011680" cy="822960"/>
+          </a:xfrm>
+          <a:prstGeom prst="roundRect">
+            <a:avLst>
+              <a:gd name="adj" fmla="val 12000"/>
+            </a:avLst>
+          </a:prstGeom>
+          <a:solidFill>
+            <a:srgbClr val="FEE2E2"/>
+          </a:solidFill>
+          <a:ln w="19050">
+            <a:solidFill>
+              <a:srgbClr val="DC2626"/>
+            </a:solidFill>
+          </a:ln>
+          <a:effectLst/>
+        </p:spPr>
+        <p:style>
+          <a:lnRef idx="1">
+            <a:schemeClr val="accent1"/>
+          </a:lnRef>
+          <a:fillRef idx="3">
+            <a:schemeClr val="accent1"/>
+          </a:fillRef>
+          <a:effectRef idx="2">
+            <a:schemeClr val="accent1"/>
+          </a:effectRef>
+          <a:fontRef idx="minor">
+            <a:schemeClr val="lt1"/>
+          </a:fontRef>
+        </p:style>
+        <p:txBody>
+          <a:bodyPr rtlCol="0" anchor="ctr" wrap="square" lIns="38100" rIns="38100" tIns="25400" bIns="25400"/>
+          <a:lstStyle/>
+          <a:p>
+            <a:pPr algn="ctr"/>
+            <a:r>
+              <a:rPr sz="1200" b="1">
+                <a:solidFill>
+                  <a:srgbClr val="991B1B"/>
+                </a:solidFill>
+                <a:latin typeface="Microsoft YaHei"/>
+                <a:ea typeface="Microsoft YaHei"/>
+                <a:cs typeface="Microsoft YaHei"/>
+              </a:rPr>
+              <a:t>评估</a:t>
+            </a:r>
+          </a:p>
+          <a:p>
+            <a:pPr algn="ctr"/>
+            <a:r>
+              <a:rPr sz="1200" b="1">
+                <a:solidFill>
+                  <a:srgbClr val="991B1B"/>
+                </a:solidFill>
+                <a:latin typeface="Microsoft YaHei"/>
+                <a:ea typeface="Microsoft YaHei"/>
+                <a:cs typeface="Microsoft YaHei"/>
+              </a:rPr>
+              <a:t>拥塞 / 时序 / IR</a:t>
+            </a:r>
+          </a:p>
+        </p:txBody>
+      </p:sp>
+      <p:sp>
+        <p:nvSpPr>
+          <p:cNvPr id="9" name="Rounded Rectangle 8"/>
+          <p:cNvSpPr/>
+          <p:nvPr/>
+        </p:nvSpPr>
+        <p:spPr>
+          <a:xfrm>
+            <a:off x="5577840" y="3611880"/>
+            <a:ext cx="1828800" cy="822960"/>
+          </a:xfrm>
+          <a:prstGeom prst="roundRect">
+            <a:avLst>
+              <a:gd name="adj" fmla="val 12000"/>
+            </a:avLst>
+          </a:prstGeom>
+          <a:solidFill>
+            <a:srgbClr val="FFEDD5"/>
+          </a:solidFill>
+          <a:ln w="19050">
+            <a:solidFill>
+              <a:srgbClr val="EA580C"/>
+            </a:solidFill>
+          </a:ln>
+          <a:effectLst/>
+        </p:spPr>
+        <p:style>
+          <a:lnRef idx="1">
+            <a:schemeClr val="accent1"/>
+          </a:lnRef>
+          <a:fillRef idx="3">
+            <a:schemeClr val="accent1"/>
+          </a:fillRef>
+          <a:effectRef idx="2">
+            <a:schemeClr val="accent1"/>
+          </a:effectRef>
+          <a:fontRef idx="minor">
+            <a:schemeClr val="lt1"/>
+          </a:fontRef>
+        </p:style>
+        <p:txBody>
+          <a:bodyPr rtlCol="0" anchor="ctr" wrap="square" lIns="38100" rIns="38100" tIns="25400" bIns="25400"/>
+          <a:lstStyle/>
+          <a:p>
+            <a:pPr algn="ctr"/>
+            <a:r>
+              <a:rPr sz="1200" b="1">
+                <a:solidFill>
+                  <a:srgbClr val="9A3412"/>
+                </a:solidFill>
+                <a:latin typeface="Microsoft YaHei"/>
+                <a:ea typeface="Microsoft YaHei"/>
+                <a:cs typeface="Microsoft YaHei"/>
+              </a:rPr>
+              <a:t>回退调整</a:t>
+            </a:r>
+          </a:p>
+        </p:txBody>
+      </p:sp>
+      <p:cxnSp>
+        <p:nvCxnSpPr>
+          <p:cNvPr id="10" name="Connector 9"/>
+          <p:cNvCxnSpPr/>
+          <p:nvPr/>
+        </p:nvCxnSpPr>
+        <p:spPr>
+          <a:xfrm>
+            <a:off x="9601200" y="2651760"/>
+            <a:ext cx="868680" cy="914400"/>
+          </a:xfrm>
+          <a:prstGeom prst="line">
+            <a:avLst/>
+          </a:prstGeom>
+          <a:ln w="19050">
+            <a:solidFill>
+              <a:srgbClr val="3A4252"/>
+            </a:solidFill>
+            <a:tailEnd type="triangle" w="med" len="med"/>
+          </a:ln>
+          <a:effectLst/>
+        </p:spPr>
+        <p:style>
+          <a:lnRef idx="2">
+            <a:schemeClr val="accent1"/>
+          </a:lnRef>
+          <a:fillRef idx="0">
+            <a:schemeClr val="accent1"/>
+          </a:fillRef>
+          <a:effectRef idx="1">
+            <a:schemeClr val="accent1"/>
+          </a:effectRef>
+          <a:fontRef idx="minor">
+            <a:schemeClr val="tx1"/>
+          </a:fontRef>
+        </p:style>
+      </p:cxnSp>
+      <p:cxnSp>
+        <p:nvCxnSpPr>
+          <p:cNvPr id="11" name="Connector 10"/>
+          <p:cNvCxnSpPr/>
+          <p:nvPr/>
+        </p:nvCxnSpPr>
+        <p:spPr>
+          <a:xfrm flipH="1">
+            <a:off x="9601200" y="4434840"/>
+            <a:ext cx="960120" cy="960120"/>
+          </a:xfrm>
+          <a:prstGeom prst="line">
+            <a:avLst/>
+          </a:prstGeom>
+          <a:ln w="19050">
+            <a:solidFill>
+              <a:srgbClr val="3A4252"/>
+            </a:solidFill>
+            <a:tailEnd type="triangle" w="med" len="med"/>
+          </a:ln>
+          <a:effectLst/>
+        </p:spPr>
+        <p:style>
+          <a:lnRef idx="2">
+            <a:schemeClr val="accent1"/>
+          </a:lnRef>
+          <a:fillRef idx="0">
+            <a:schemeClr val="accent1"/>
+          </a:fillRef>
+          <a:effectRef idx="1">
+            <a:schemeClr val="accent1"/>
+          </a:effectRef>
+          <a:fontRef idx="minor">
+            <a:schemeClr val="tx1"/>
+          </a:fontRef>
+        </p:style>
+      </p:cxnSp>
+      <p:cxnSp>
+        <p:nvCxnSpPr>
+          <p:cNvPr id="12" name="Connector 11"/>
+          <p:cNvCxnSpPr/>
+          <p:nvPr/>
+        </p:nvCxnSpPr>
+        <p:spPr>
+          <a:xfrm flipH="1" flipV="1">
+            <a:off x="6720840" y="4480560"/>
+            <a:ext cx="868680" cy="914400"/>
+          </a:xfrm>
+          <a:prstGeom prst="line">
+            <a:avLst/>
+          </a:prstGeom>
+          <a:ln w="19050">
+            <a:solidFill>
+              <a:srgbClr val="3A4252"/>
+            </a:solidFill>
+            <a:tailEnd type="triangle" w="med" len="med"/>
+          </a:ln>
+          <a:effectLst/>
+        </p:spPr>
+        <p:style>
+          <a:lnRef idx="2">
+            <a:schemeClr val="accent1"/>
+          </a:lnRef>
+          <a:fillRef idx="0">
+            <a:schemeClr val="accent1"/>
+          </a:fillRef>
+          <a:effectRef idx="1">
+            <a:schemeClr val="accent1"/>
+          </a:effectRef>
+          <a:fontRef idx="minor">
+            <a:schemeClr val="tx1"/>
+          </a:fontRef>
+        </p:style>
+      </p:cxnSp>
+      <p:cxnSp>
+        <p:nvCxnSpPr>
+          <p:cNvPr id="13" name="Connector 12"/>
+          <p:cNvCxnSpPr/>
+          <p:nvPr/>
+        </p:nvCxnSpPr>
+        <p:spPr>
+          <a:xfrm flipV="1">
+            <a:off x="6720840" y="2651760"/>
+            <a:ext cx="868680" cy="960120"/>
+          </a:xfrm>
+          <a:prstGeom prst="line">
+            <a:avLst/>
+          </a:prstGeom>
+          <a:ln w="19050">
+            <a:solidFill>
+              <a:srgbClr val="3A4252"/>
+            </a:solidFill>
+            <a:tailEnd type="triangle" w="med" len="med"/>
+          </a:ln>
+          <a:effectLst/>
+        </p:spPr>
+        <p:style>
+          <a:lnRef idx="2">
+            <a:schemeClr val="accent1"/>
+          </a:lnRef>
+          <a:fillRef idx="0">
+            <a:schemeClr val="accent1"/>
+          </a:fillRef>
+          <a:effectRef idx="1">
+            <a:schemeClr val="accent1"/>
+          </a:effectRef>
+          <a:fontRef idx="minor">
+            <a:schemeClr val="tx1"/>
+          </a:fontRef>
+        </p:style>
+      </p:cxnSp>
+      <p:sp>
+        <p:nvSpPr>
+          <p:cNvPr id="14" name="TextBox 13"/>
           <p:cNvSpPr txBox="1"/>
           <p:nvPr/>
         </p:nvSpPr>
         <p:spPr>
           <a:xfrm>
-            <a:off x="9875520" y="6446520"/>
-            <a:ext cx="2011680" cy="365760"/>
+            <a:off x="6949440" y="3840480"/>
+            <a:ext cx="3291840" cy="365760"/>
           </a:xfrm>
           <a:prstGeom prst="rect">
             <a:avLst/>
@@ -12069,8 +14491,82 @@
           </a:bodyPr>
           <a:lstStyle/>
           <a:p>
+            <a:pPr algn="ctr"/>
+            <a:r>
+              <a:rPr sz="1300" b="1">
+                <a:solidFill>
+                  <a:srgbClr val="6B7280"/>
+                </a:solidFill>
+                <a:latin typeface="Microsoft YaHei"/>
+                <a:ea typeface="Microsoft YaHei"/>
+                <a:cs typeface="Microsoft YaHei"/>
+              </a:rPr>
+              <a:t>迭代闭环</a:t>
+            </a:r>
+          </a:p>
+        </p:txBody>
+      </p:sp>
+      <p:sp>
+        <p:nvSpPr>
+          <p:cNvPr id="15" name="TextBox 14"/>
+          <p:cNvSpPr txBox="1"/>
+          <p:nvPr/>
+        </p:nvSpPr>
+        <p:spPr>
+          <a:xfrm>
+            <a:off x="6949440" y="1554480"/>
+            <a:ext cx="3291840" cy="365760"/>
+          </a:xfrm>
+          <a:prstGeom prst="rect">
+            <a:avLst/>
+          </a:prstGeom>
+          <a:noFill/>
+        </p:spPr>
+        <p:txBody>
+          <a:bodyPr wrap="none" lIns="0" rIns="0" tIns="0" bIns="0">
+            <a:spAutoFit/>
+          </a:bodyPr>
+          <a:lstStyle/>
+          <a:p>
+            <a:pPr algn="ctr"/>
+            <a:r>
+              <a:rPr sz="1250" b="1">
+                <a:solidFill>
+                  <a:srgbClr val="1A1F2B"/>
+                </a:solidFill>
+                <a:latin typeface="Microsoft YaHei"/>
+                <a:ea typeface="Microsoft YaHei"/>
+                <a:cs typeface="Microsoft YaHei"/>
+              </a:rPr>
+              <a:t>收敛后才进详细 Placement</a:t>
+            </a:r>
+          </a:p>
+        </p:txBody>
+      </p:sp>
+      <p:sp>
+        <p:nvSpPr>
+          <p:cNvPr id="16" name="TextBox 15"/>
+          <p:cNvSpPr txBox="1"/>
+          <p:nvPr/>
+        </p:nvSpPr>
+        <p:spPr>
+          <a:xfrm>
+            <a:off x="9875520" y="6446520"/>
+            <a:ext cx="2011680" cy="365760"/>
+          </a:xfrm>
+          <a:prstGeom prst="rect">
+            <a:avLst/>
+          </a:prstGeom>
+          <a:noFill/>
+        </p:spPr>
+        <p:txBody>
+          <a:bodyPr wrap="none" lIns="0" rIns="0" tIns="0" bIns="0">
+            <a:spAutoFit/>
+          </a:bodyPr>
+          <a:lstStyle/>
+          <a:p>
             <a:pPr algn="r"/>
-            <a:fld id="{14735D9A-BDB8-46FD-ACB3-0CDABC9F8297}" type="slidenum">
+            <a:fld id="{B66ADE2F-85CA-4958-9D74-89FFC6F6A5B7}" type="slidenum">
               <a:rPr lang="en-US" sz="1000">
                 <a:solidFill>
                   <a:srgbClr val="9AA3B0"/>
@@ -13095,7 +15591,7 @@
           <a:lstStyle/>
           <a:p>
             <a:pPr algn="r"/>
-            <a:fld id="{68B93EA3-E0D1-49C9-8925-3848D94CF6F9}" type="slidenum">
+            <a:fld id="{E7FC3159-9582-4614-A066-46C9A1D67AA4}" type="slidenum">
               <a:rPr lang="en-US" sz="1000">
                 <a:solidFill>
                   <a:srgbClr val="9AA3B0"/>
@@ -13873,7 +16369,7 @@
           <a:lstStyle/>
           <a:p>
             <a:pPr algn="r"/>
-            <a:fld id="{2E728453-5078-4FE0-9740-6440E1ABB5F6}" type="slidenum">
+            <a:fld id="{6EBA6E46-ED12-46D4-B6A8-77153A5D5B2F}" type="slidenum">
               <a:rPr lang="en-US" sz="1000">
                 <a:solidFill>
                   <a:srgbClr val="9AA3B0"/>
@@ -14520,7 +17016,7 @@
           <a:lstStyle/>
           <a:p>
             <a:pPr algn="r"/>
-            <a:fld id="{05C11166-C3F1-4A1F-9227-623723F64677}" type="slidenum">
+            <a:fld id="{BF0BA4ED-7E09-450E-A607-78D533EDB2A3}" type="slidenum">
               <a:rPr lang="en-US" sz="1000">
                 <a:solidFill>
                   <a:srgbClr val="9AA3B0"/>
@@ -15182,7 +17678,7 @@
           <a:lstStyle/>
           <a:p>
             <a:pPr algn="r"/>
-            <a:fld id="{CD3EACBC-746A-4ACB-8196-E00FED1F086E}" type="slidenum">
+            <a:fld id="{89A49474-FA67-469A-B126-D09C114F6D73}" type="slidenum">
               <a:rPr lang="en-US" sz="1000">
                 <a:solidFill>
                   <a:srgbClr val="9AA3B0"/>
@@ -15484,40 +17980,765 @@
           </a:p>
         </p:txBody>
       </p:sp>
-      <p:pic>
-        <p:nvPicPr>
-          <p:cNvPr id="6" name="Picture 5" descr="f01_position.png"/>
-          <p:cNvPicPr>
-            <a:picLocks noChangeAspect="1"/>
-          </p:cNvPicPr>
-          <p:nvPr/>
-        </p:nvPicPr>
-        <p:blipFill>
-          <a:blip r:embed="rId2"/>
-          <a:stretch>
-            <a:fillRect/>
-          </a:stretch>
-        </p:blipFill>
-        <p:spPr>
-          <a:xfrm>
-            <a:off x="5486400" y="1575143"/>
-            <a:ext cx="6263640" cy="4759272"/>
-          </a:xfrm>
-          <a:prstGeom prst="rect">
-            <a:avLst/>
-          </a:prstGeom>
-        </p:spPr>
-      </p:pic>
-      <p:sp>
-        <p:nvSpPr>
-          <p:cNvPr id="7" name="TextBox 6"/>
+      <p:sp>
+        <p:nvSpPr>
+          <p:cNvPr id="6" name="Rounded Rectangle 5"/>
+          <p:cNvSpPr/>
+          <p:nvPr/>
+        </p:nvSpPr>
+        <p:spPr>
+          <a:xfrm>
+            <a:off x="5532120" y="1719072"/>
+            <a:ext cx="1051560" cy="658368"/>
+          </a:xfrm>
+          <a:prstGeom prst="roundRect">
+            <a:avLst>
+              <a:gd name="adj" fmla="val 12000"/>
+            </a:avLst>
+          </a:prstGeom>
+          <a:solidFill>
+            <a:srgbClr val="FFFFFF"/>
+          </a:solidFill>
+          <a:ln w="19050">
+            <a:solidFill>
+              <a:srgbClr val="94A3B8"/>
+            </a:solidFill>
+          </a:ln>
+          <a:effectLst/>
+        </p:spPr>
+        <p:style>
+          <a:lnRef idx="1">
+            <a:schemeClr val="accent1"/>
+          </a:lnRef>
+          <a:fillRef idx="3">
+            <a:schemeClr val="accent1"/>
+          </a:fillRef>
+          <a:effectRef idx="2">
+            <a:schemeClr val="accent1"/>
+          </a:effectRef>
+          <a:fontRef idx="minor">
+            <a:schemeClr val="lt1"/>
+          </a:fontRef>
+        </p:style>
+        <p:txBody>
+          <a:bodyPr rtlCol="0" anchor="ctr" wrap="square" lIns="38100" rIns="38100" tIns="25400" bIns="25400"/>
+          <a:lstStyle/>
+          <a:p>
+            <a:pPr algn="ctr"/>
+            <a:r>
+              <a:rPr sz="1200" b="1">
+                <a:solidFill>
+                  <a:srgbClr val="1A1F2B"/>
+                </a:solidFill>
+                <a:latin typeface="Microsoft YaHei"/>
+                <a:ea typeface="Microsoft YaHei"/>
+                <a:cs typeface="Microsoft YaHei"/>
+              </a:rPr>
+              <a:t>逻辑综合</a:t>
+            </a:r>
+          </a:p>
+          <a:p>
+            <a:pPr algn="ctr"/>
+            <a:r>
+              <a:rPr sz="1200" b="1">
+                <a:solidFill>
+                  <a:srgbClr val="1A1F2B"/>
+                </a:solidFill>
+                <a:latin typeface="Microsoft YaHei"/>
+                <a:ea typeface="Microsoft YaHei"/>
+                <a:cs typeface="Microsoft YaHei"/>
+              </a:rPr>
+              <a:t>Synth</a:t>
+            </a:r>
+          </a:p>
+        </p:txBody>
+      </p:sp>
+      <p:sp>
+        <p:nvSpPr>
+          <p:cNvPr id="7" name="Rounded Rectangle 6"/>
+          <p:cNvSpPr/>
+          <p:nvPr/>
+        </p:nvSpPr>
+        <p:spPr>
+          <a:xfrm>
+            <a:off x="6830568" y="1719072"/>
+            <a:ext cx="1051560" cy="658368"/>
+          </a:xfrm>
+          <a:prstGeom prst="roundRect">
+            <a:avLst>
+              <a:gd name="adj" fmla="val 12000"/>
+            </a:avLst>
+          </a:prstGeom>
+          <a:solidFill>
+            <a:srgbClr val="EDE9FE"/>
+          </a:solidFill>
+          <a:ln w="19050">
+            <a:solidFill>
+              <a:srgbClr val="6D28D9"/>
+            </a:solidFill>
+          </a:ln>
+          <a:effectLst/>
+        </p:spPr>
+        <p:style>
+          <a:lnRef idx="1">
+            <a:schemeClr val="accent1"/>
+          </a:lnRef>
+          <a:fillRef idx="3">
+            <a:schemeClr val="accent1"/>
+          </a:fillRef>
+          <a:effectRef idx="2">
+            <a:schemeClr val="accent1"/>
+          </a:effectRef>
+          <a:fontRef idx="minor">
+            <a:schemeClr val="lt1"/>
+          </a:fontRef>
+        </p:style>
+        <p:txBody>
+          <a:bodyPr rtlCol="0" anchor="ctr" wrap="square" lIns="38100" rIns="38100" tIns="25400" bIns="25400"/>
+          <a:lstStyle/>
+          <a:p>
+            <a:pPr algn="ctr"/>
+            <a:r>
+              <a:rPr sz="1200" b="1">
+                <a:solidFill>
+                  <a:srgbClr val="5B21B6"/>
+                </a:solidFill>
+                <a:latin typeface="Microsoft YaHei"/>
+                <a:ea typeface="Microsoft YaHei"/>
+                <a:cs typeface="Microsoft YaHei"/>
+              </a:rPr>
+              <a:t>布图规划</a:t>
+            </a:r>
+          </a:p>
+          <a:p>
+            <a:pPr algn="ctr"/>
+            <a:r>
+              <a:rPr sz="1200" b="1">
+                <a:solidFill>
+                  <a:srgbClr val="5B21B6"/>
+                </a:solidFill>
+                <a:latin typeface="Microsoft YaHei"/>
+                <a:ea typeface="Microsoft YaHei"/>
+                <a:cs typeface="Microsoft YaHei"/>
+              </a:rPr>
+              <a:t>Floorplan</a:t>
+            </a:r>
+          </a:p>
+        </p:txBody>
+      </p:sp>
+      <p:sp>
+        <p:nvSpPr>
+          <p:cNvPr id="8" name="Rounded Rectangle 7"/>
+          <p:cNvSpPr/>
+          <p:nvPr/>
+        </p:nvSpPr>
+        <p:spPr>
+          <a:xfrm>
+            <a:off x="8129016" y="1719072"/>
+            <a:ext cx="1051560" cy="658368"/>
+          </a:xfrm>
+          <a:prstGeom prst="roundRect">
+            <a:avLst>
+              <a:gd name="adj" fmla="val 12000"/>
+            </a:avLst>
+          </a:prstGeom>
+          <a:solidFill>
+            <a:srgbClr val="FFFFFF"/>
+          </a:solidFill>
+          <a:ln w="19050">
+            <a:solidFill>
+              <a:srgbClr val="94A3B8"/>
+            </a:solidFill>
+          </a:ln>
+          <a:effectLst/>
+        </p:spPr>
+        <p:style>
+          <a:lnRef idx="1">
+            <a:schemeClr val="accent1"/>
+          </a:lnRef>
+          <a:fillRef idx="3">
+            <a:schemeClr val="accent1"/>
+          </a:fillRef>
+          <a:effectRef idx="2">
+            <a:schemeClr val="accent1"/>
+          </a:effectRef>
+          <a:fontRef idx="minor">
+            <a:schemeClr val="lt1"/>
+          </a:fontRef>
+        </p:style>
+        <p:txBody>
+          <a:bodyPr rtlCol="0" anchor="ctr" wrap="square" lIns="38100" rIns="38100" tIns="25400" bIns="25400"/>
+          <a:lstStyle/>
+          <a:p>
+            <a:pPr algn="ctr"/>
+            <a:r>
+              <a:rPr sz="1200" b="1">
+                <a:solidFill>
+                  <a:srgbClr val="1A1F2B"/>
+                </a:solidFill>
+                <a:latin typeface="Microsoft YaHei"/>
+                <a:ea typeface="Microsoft YaHei"/>
+                <a:cs typeface="Microsoft YaHei"/>
+              </a:rPr>
+              <a:t>布局</a:t>
+            </a:r>
+          </a:p>
+          <a:p>
+            <a:pPr algn="ctr"/>
+            <a:r>
+              <a:rPr sz="1200" b="1">
+                <a:solidFill>
+                  <a:srgbClr val="1A1F2B"/>
+                </a:solidFill>
+                <a:latin typeface="Microsoft YaHei"/>
+                <a:ea typeface="Microsoft YaHei"/>
+                <a:cs typeface="Microsoft YaHei"/>
+              </a:rPr>
+              <a:t>Place</a:t>
+            </a:r>
+          </a:p>
+        </p:txBody>
+      </p:sp>
+      <p:sp>
+        <p:nvSpPr>
+          <p:cNvPr id="9" name="Rounded Rectangle 8"/>
+          <p:cNvSpPr/>
+          <p:nvPr/>
+        </p:nvSpPr>
+        <p:spPr>
+          <a:xfrm>
+            <a:off x="9427463" y="1719072"/>
+            <a:ext cx="1051560" cy="658368"/>
+          </a:xfrm>
+          <a:prstGeom prst="roundRect">
+            <a:avLst>
+              <a:gd name="adj" fmla="val 12000"/>
+            </a:avLst>
+          </a:prstGeom>
+          <a:solidFill>
+            <a:srgbClr val="FFFFFF"/>
+          </a:solidFill>
+          <a:ln w="19050">
+            <a:solidFill>
+              <a:srgbClr val="94A3B8"/>
+            </a:solidFill>
+          </a:ln>
+          <a:effectLst/>
+        </p:spPr>
+        <p:style>
+          <a:lnRef idx="1">
+            <a:schemeClr val="accent1"/>
+          </a:lnRef>
+          <a:fillRef idx="3">
+            <a:schemeClr val="accent1"/>
+          </a:fillRef>
+          <a:effectRef idx="2">
+            <a:schemeClr val="accent1"/>
+          </a:effectRef>
+          <a:fontRef idx="minor">
+            <a:schemeClr val="lt1"/>
+          </a:fontRef>
+        </p:style>
+        <p:txBody>
+          <a:bodyPr rtlCol="0" anchor="ctr" wrap="square" lIns="38100" rIns="38100" tIns="25400" bIns="25400"/>
+          <a:lstStyle/>
+          <a:p>
+            <a:pPr algn="ctr"/>
+            <a:r>
+              <a:rPr sz="1200" b="1">
+                <a:solidFill>
+                  <a:srgbClr val="1A1F2B"/>
+                </a:solidFill>
+                <a:latin typeface="Microsoft YaHei"/>
+                <a:ea typeface="Microsoft YaHei"/>
+                <a:cs typeface="Microsoft YaHei"/>
+              </a:rPr>
+              <a:t>时钟树</a:t>
+            </a:r>
+          </a:p>
+          <a:p>
+            <a:pPr algn="ctr"/>
+            <a:r>
+              <a:rPr sz="1200" b="1">
+                <a:solidFill>
+                  <a:srgbClr val="1A1F2B"/>
+                </a:solidFill>
+                <a:latin typeface="Microsoft YaHei"/>
+                <a:ea typeface="Microsoft YaHei"/>
+                <a:cs typeface="Microsoft YaHei"/>
+              </a:rPr>
+              <a:t>CTS</a:t>
+            </a:r>
+          </a:p>
+        </p:txBody>
+      </p:sp>
+      <p:sp>
+        <p:nvSpPr>
+          <p:cNvPr id="10" name="Rounded Rectangle 9"/>
+          <p:cNvSpPr/>
+          <p:nvPr/>
+        </p:nvSpPr>
+        <p:spPr>
+          <a:xfrm>
+            <a:off x="10725912" y="1719072"/>
+            <a:ext cx="1051560" cy="658368"/>
+          </a:xfrm>
+          <a:prstGeom prst="roundRect">
+            <a:avLst>
+              <a:gd name="adj" fmla="val 12000"/>
+            </a:avLst>
+          </a:prstGeom>
+          <a:solidFill>
+            <a:srgbClr val="FFFFFF"/>
+          </a:solidFill>
+          <a:ln w="19050">
+            <a:solidFill>
+              <a:srgbClr val="94A3B8"/>
+            </a:solidFill>
+          </a:ln>
+          <a:effectLst/>
+        </p:spPr>
+        <p:style>
+          <a:lnRef idx="1">
+            <a:schemeClr val="accent1"/>
+          </a:lnRef>
+          <a:fillRef idx="3">
+            <a:schemeClr val="accent1"/>
+          </a:fillRef>
+          <a:effectRef idx="2">
+            <a:schemeClr val="accent1"/>
+          </a:effectRef>
+          <a:fontRef idx="minor">
+            <a:schemeClr val="lt1"/>
+          </a:fontRef>
+        </p:style>
+        <p:txBody>
+          <a:bodyPr rtlCol="0" anchor="ctr" wrap="square" lIns="38100" rIns="38100" tIns="25400" bIns="25400"/>
+          <a:lstStyle/>
+          <a:p>
+            <a:pPr algn="ctr"/>
+            <a:r>
+              <a:rPr sz="1200" b="1">
+                <a:solidFill>
+                  <a:srgbClr val="1A1F2B"/>
+                </a:solidFill>
+                <a:latin typeface="Microsoft YaHei"/>
+                <a:ea typeface="Microsoft YaHei"/>
+                <a:cs typeface="Microsoft YaHei"/>
+              </a:rPr>
+              <a:t>布线</a:t>
+            </a:r>
+          </a:p>
+          <a:p>
+            <a:pPr algn="ctr"/>
+            <a:r>
+              <a:rPr sz="1200" b="1">
+                <a:solidFill>
+                  <a:srgbClr val="1A1F2B"/>
+                </a:solidFill>
+                <a:latin typeface="Microsoft YaHei"/>
+                <a:ea typeface="Microsoft YaHei"/>
+                <a:cs typeface="Microsoft YaHei"/>
+              </a:rPr>
+              <a:t>Route</a:t>
+            </a:r>
+          </a:p>
+        </p:txBody>
+      </p:sp>
+      <p:sp>
+        <p:nvSpPr>
+          <p:cNvPr id="11" name="Rounded Rectangle 10"/>
+          <p:cNvSpPr/>
+          <p:nvPr/>
+        </p:nvSpPr>
+        <p:spPr>
+          <a:xfrm>
+            <a:off x="5577840" y="3246120"/>
+            <a:ext cx="2926080" cy="868680"/>
+          </a:xfrm>
+          <a:prstGeom prst="roundRect">
+            <a:avLst>
+              <a:gd name="adj" fmla="val 12000"/>
+            </a:avLst>
+          </a:prstGeom>
+          <a:solidFill>
+            <a:srgbClr val="DBEAFE"/>
+          </a:solidFill>
+          <a:ln w="19050">
+            <a:solidFill>
+              <a:srgbClr val="1D4ED8"/>
+            </a:solidFill>
+          </a:ln>
+          <a:effectLst/>
+        </p:spPr>
+        <p:style>
+          <a:lnRef idx="1">
+            <a:schemeClr val="accent1"/>
+          </a:lnRef>
+          <a:fillRef idx="3">
+            <a:schemeClr val="accent1"/>
+          </a:fillRef>
+          <a:effectRef idx="2">
+            <a:schemeClr val="accent1"/>
+          </a:effectRef>
+          <a:fontRef idx="minor">
+            <a:schemeClr val="lt1"/>
+          </a:fontRef>
+        </p:style>
+        <p:txBody>
+          <a:bodyPr rtlCol="0" anchor="ctr" wrap="square" lIns="38100" rIns="38100" tIns="25400" bIns="25400"/>
+          <a:lstStyle/>
+          <a:p>
+            <a:pPr algn="ctr"/>
+            <a:r>
+              <a:rPr sz="1200" b="1">
+                <a:solidFill>
+                  <a:srgbClr val="1E3A8A"/>
+                </a:solidFill>
+                <a:latin typeface="Microsoft YaHei"/>
+                <a:ea typeface="Microsoft YaHei"/>
+                <a:cs typeface="Microsoft YaHei"/>
+              </a:rPr>
+              <a:t>① die / core 几何</a:t>
+            </a:r>
+          </a:p>
+        </p:txBody>
+      </p:sp>
+      <p:sp>
+        <p:nvSpPr>
+          <p:cNvPr id="12" name="Rounded Rectangle 11"/>
+          <p:cNvSpPr/>
+          <p:nvPr/>
+        </p:nvSpPr>
+        <p:spPr>
+          <a:xfrm>
+            <a:off x="8732520" y="3246120"/>
+            <a:ext cx="2926080" cy="868680"/>
+          </a:xfrm>
+          <a:prstGeom prst="roundRect">
+            <a:avLst>
+              <a:gd name="adj" fmla="val 12000"/>
+            </a:avLst>
+          </a:prstGeom>
+          <a:solidFill>
+            <a:srgbClr val="CCFBF1"/>
+          </a:solidFill>
+          <a:ln w="19050">
+            <a:solidFill>
+              <a:srgbClr val="0D9488"/>
+            </a:solidFill>
+          </a:ln>
+          <a:effectLst/>
+        </p:spPr>
+        <p:style>
+          <a:lnRef idx="1">
+            <a:schemeClr val="accent1"/>
+          </a:lnRef>
+          <a:fillRef idx="3">
+            <a:schemeClr val="accent1"/>
+          </a:fillRef>
+          <a:effectRef idx="2">
+            <a:schemeClr val="accent1"/>
+          </a:effectRef>
+          <a:fontRef idx="minor">
+            <a:schemeClr val="lt1"/>
+          </a:fontRef>
+        </p:style>
+        <p:txBody>
+          <a:bodyPr rtlCol="0" anchor="ctr" wrap="square" lIns="38100" rIns="38100" tIns="25400" bIns="25400"/>
+          <a:lstStyle/>
+          <a:p>
+            <a:pPr algn="ctr"/>
+            <a:r>
+              <a:rPr sz="1200" b="1">
+                <a:solidFill>
+                  <a:srgbClr val="115E59"/>
+                </a:solidFill>
+                <a:latin typeface="Microsoft YaHei"/>
+                <a:ea typeface="Microsoft YaHei"/>
+                <a:cs typeface="Microsoft YaHei"/>
+              </a:rPr>
+              <a:t>② 宏摆放 &amp; 朝向</a:t>
+            </a:r>
+          </a:p>
+        </p:txBody>
+      </p:sp>
+      <p:sp>
+        <p:nvSpPr>
+          <p:cNvPr id="13" name="Rounded Rectangle 12"/>
+          <p:cNvSpPr/>
+          <p:nvPr/>
+        </p:nvSpPr>
+        <p:spPr>
+          <a:xfrm>
+            <a:off x="5577840" y="4297680"/>
+            <a:ext cx="2926080" cy="868680"/>
+          </a:xfrm>
+          <a:prstGeom prst="roundRect">
+            <a:avLst>
+              <a:gd name="adj" fmla="val 12000"/>
+            </a:avLst>
+          </a:prstGeom>
+          <a:solidFill>
+            <a:srgbClr val="FFEDD5"/>
+          </a:solidFill>
+          <a:ln w="19050">
+            <a:solidFill>
+              <a:srgbClr val="EA580C"/>
+            </a:solidFill>
+          </a:ln>
+          <a:effectLst/>
+        </p:spPr>
+        <p:style>
+          <a:lnRef idx="1">
+            <a:schemeClr val="accent1"/>
+          </a:lnRef>
+          <a:fillRef idx="3">
+            <a:schemeClr val="accent1"/>
+          </a:fillRef>
+          <a:effectRef idx="2">
+            <a:schemeClr val="accent1"/>
+          </a:effectRef>
+          <a:fontRef idx="minor">
+            <a:schemeClr val="lt1"/>
+          </a:fontRef>
+        </p:style>
+        <p:txBody>
+          <a:bodyPr rtlCol="0" anchor="ctr" wrap="square" lIns="38100" rIns="38100" tIns="25400" bIns="25400"/>
+          <a:lstStyle/>
+          <a:p>
+            <a:pPr algn="ctr"/>
+            <a:r>
+              <a:rPr sz="1200" b="1">
+                <a:solidFill>
+                  <a:srgbClr val="9A3412"/>
+                </a:solidFill>
+                <a:latin typeface="Microsoft YaHei"/>
+                <a:ea typeface="Microsoft YaHei"/>
+                <a:cs typeface="Microsoft YaHei"/>
+              </a:rPr>
+              <a:t>③ 电源规划 PG</a:t>
+            </a:r>
+          </a:p>
+        </p:txBody>
+      </p:sp>
+      <p:sp>
+        <p:nvSpPr>
+          <p:cNvPr id="14" name="Rounded Rectangle 13"/>
+          <p:cNvSpPr/>
+          <p:nvPr/>
+        </p:nvSpPr>
+        <p:spPr>
+          <a:xfrm>
+            <a:off x="8732520" y="4297680"/>
+            <a:ext cx="2926080" cy="868680"/>
+          </a:xfrm>
+          <a:prstGeom prst="roundRect">
+            <a:avLst>
+              <a:gd name="adj" fmla="val 12000"/>
+            </a:avLst>
+          </a:prstGeom>
+          <a:solidFill>
+            <a:srgbClr val="FEE2E2"/>
+          </a:solidFill>
+          <a:ln w="19050">
+            <a:solidFill>
+              <a:srgbClr val="DC2626"/>
+            </a:solidFill>
+          </a:ln>
+          <a:effectLst/>
+        </p:spPr>
+        <p:style>
+          <a:lnRef idx="1">
+            <a:schemeClr val="accent1"/>
+          </a:lnRef>
+          <a:fillRef idx="3">
+            <a:schemeClr val="accent1"/>
+          </a:fillRef>
+          <a:effectRef idx="2">
+            <a:schemeClr val="accent1"/>
+          </a:effectRef>
+          <a:fontRef idx="minor">
+            <a:schemeClr val="lt1"/>
+          </a:fontRef>
+        </p:style>
+        <p:txBody>
+          <a:bodyPr rtlCol="0" anchor="ctr" wrap="square" lIns="38100" rIns="38100" tIns="25400" bIns="25400"/>
+          <a:lstStyle/>
+          <a:p>
+            <a:pPr algn="ctr"/>
+            <a:r>
+              <a:rPr sz="1200" b="1">
+                <a:solidFill>
+                  <a:srgbClr val="991B1B"/>
+                </a:solidFill>
+                <a:latin typeface="Microsoft YaHei"/>
+                <a:ea typeface="Microsoft YaHei"/>
+                <a:cs typeface="Microsoft YaHei"/>
+              </a:rPr>
+              <a:t>④ 多电压 / blockage</a:t>
+            </a:r>
+          </a:p>
+        </p:txBody>
+      </p:sp>
+      <p:cxnSp>
+        <p:nvCxnSpPr>
+          <p:cNvPr id="15" name="Connector 14"/>
+          <p:cNvCxnSpPr/>
+          <p:nvPr/>
+        </p:nvCxnSpPr>
+        <p:spPr>
+          <a:xfrm>
+            <a:off x="6583680" y="2048256"/>
+            <a:ext cx="246888" cy="0"/>
+          </a:xfrm>
+          <a:prstGeom prst="line">
+            <a:avLst/>
+          </a:prstGeom>
+          <a:ln w="19050">
+            <a:solidFill>
+              <a:srgbClr val="3A4252"/>
+            </a:solidFill>
+            <a:tailEnd type="triangle" w="med" len="med"/>
+          </a:ln>
+          <a:effectLst/>
+        </p:spPr>
+        <p:style>
+          <a:lnRef idx="2">
+            <a:schemeClr val="accent1"/>
+          </a:lnRef>
+          <a:fillRef idx="0">
+            <a:schemeClr val="accent1"/>
+          </a:fillRef>
+          <a:effectRef idx="1">
+            <a:schemeClr val="accent1"/>
+          </a:effectRef>
+          <a:fontRef idx="minor">
+            <a:schemeClr val="tx1"/>
+          </a:fontRef>
+        </p:style>
+      </p:cxnSp>
+      <p:cxnSp>
+        <p:nvCxnSpPr>
+          <p:cNvPr id="16" name="Connector 15"/>
+          <p:cNvCxnSpPr/>
+          <p:nvPr/>
+        </p:nvCxnSpPr>
+        <p:spPr>
+          <a:xfrm>
+            <a:off x="7882127" y="2048256"/>
+            <a:ext cx="246889" cy="0"/>
+          </a:xfrm>
+          <a:prstGeom prst="line">
+            <a:avLst/>
+          </a:prstGeom>
+          <a:ln w="19050">
+            <a:solidFill>
+              <a:srgbClr val="3A4252"/>
+            </a:solidFill>
+            <a:tailEnd type="triangle" w="med" len="med"/>
+          </a:ln>
+          <a:effectLst/>
+        </p:spPr>
+        <p:style>
+          <a:lnRef idx="2">
+            <a:schemeClr val="accent1"/>
+          </a:lnRef>
+          <a:fillRef idx="0">
+            <a:schemeClr val="accent1"/>
+          </a:fillRef>
+          <a:effectRef idx="1">
+            <a:schemeClr val="accent1"/>
+          </a:effectRef>
+          <a:fontRef idx="minor">
+            <a:schemeClr val="tx1"/>
+          </a:fontRef>
+        </p:style>
+      </p:cxnSp>
+      <p:cxnSp>
+        <p:nvCxnSpPr>
+          <p:cNvPr id="17" name="Connector 16"/>
+          <p:cNvCxnSpPr/>
+          <p:nvPr/>
+        </p:nvCxnSpPr>
+        <p:spPr>
+          <a:xfrm>
+            <a:off x="9180576" y="2048256"/>
+            <a:ext cx="246887" cy="0"/>
+          </a:xfrm>
+          <a:prstGeom prst="line">
+            <a:avLst/>
+          </a:prstGeom>
+          <a:ln w="19050">
+            <a:solidFill>
+              <a:srgbClr val="3A4252"/>
+            </a:solidFill>
+            <a:tailEnd type="triangle" w="med" len="med"/>
+          </a:ln>
+          <a:effectLst/>
+        </p:spPr>
+        <p:style>
+          <a:lnRef idx="2">
+            <a:schemeClr val="accent1"/>
+          </a:lnRef>
+          <a:fillRef idx="0">
+            <a:schemeClr val="accent1"/>
+          </a:fillRef>
+          <a:effectRef idx="1">
+            <a:schemeClr val="accent1"/>
+          </a:effectRef>
+          <a:fontRef idx="minor">
+            <a:schemeClr val="tx1"/>
+          </a:fontRef>
+        </p:style>
+      </p:cxnSp>
+      <p:cxnSp>
+        <p:nvCxnSpPr>
+          <p:cNvPr id="18" name="Connector 17"/>
+          <p:cNvCxnSpPr/>
+          <p:nvPr/>
+        </p:nvCxnSpPr>
+        <p:spPr>
+          <a:xfrm>
+            <a:off x="10479024" y="2048256"/>
+            <a:ext cx="246888" cy="0"/>
+          </a:xfrm>
+          <a:prstGeom prst="line">
+            <a:avLst/>
+          </a:prstGeom>
+          <a:ln w="19050">
+            <a:solidFill>
+              <a:srgbClr val="3A4252"/>
+            </a:solidFill>
+            <a:tailEnd type="triangle" w="med" len="med"/>
+          </a:ln>
+          <a:effectLst/>
+        </p:spPr>
+        <p:style>
+          <a:lnRef idx="2">
+            <a:schemeClr val="accent1"/>
+          </a:lnRef>
+          <a:fillRef idx="0">
+            <a:schemeClr val="accent1"/>
+          </a:fillRef>
+          <a:effectRef idx="1">
+            <a:schemeClr val="accent1"/>
+          </a:effectRef>
+          <a:fontRef idx="minor">
+            <a:schemeClr val="tx1"/>
+          </a:fontRef>
+        </p:style>
+      </p:cxnSp>
+      <p:sp>
+        <p:nvSpPr>
+          <p:cNvPr id="19" name="TextBox 18"/>
           <p:cNvSpPr txBox="1"/>
           <p:nvPr/>
         </p:nvSpPr>
         <p:spPr>
           <a:xfrm>
-            <a:off x="9875520" y="6446520"/>
-            <a:ext cx="2011680" cy="365760"/>
+            <a:off x="5577840" y="1435608"/>
+            <a:ext cx="3291840" cy="365760"/>
           </a:xfrm>
           <a:prstGeom prst="rect">
             <a:avLst/>
@@ -15530,8 +18751,82 @@
           </a:bodyPr>
           <a:lstStyle/>
           <a:p>
+            <a:pPr algn="l"/>
+            <a:r>
+              <a:rPr sz="1250" b="1">
+                <a:solidFill>
+                  <a:srgbClr val="1A1F2B"/>
+                </a:solidFill>
+                <a:latin typeface="Microsoft YaHei"/>
+                <a:ea typeface="Microsoft YaHei"/>
+                <a:cs typeface="Microsoft YaHei"/>
+              </a:rPr>
+              <a:t>Floorplan 在 PnR 流程中的位置</a:t>
+            </a:r>
+          </a:p>
+        </p:txBody>
+      </p:sp>
+      <p:sp>
+        <p:nvSpPr>
+          <p:cNvPr id="20" name="TextBox 19"/>
+          <p:cNvSpPr txBox="1"/>
+          <p:nvPr/>
+        </p:nvSpPr>
+        <p:spPr>
+          <a:xfrm>
+            <a:off x="5577840" y="2697480"/>
+            <a:ext cx="3291840" cy="365760"/>
+          </a:xfrm>
+          <a:prstGeom prst="rect">
+            <a:avLst/>
+          </a:prstGeom>
+          <a:noFill/>
+        </p:spPr>
+        <p:txBody>
+          <a:bodyPr wrap="none" lIns="0" rIns="0" tIns="0" bIns="0">
+            <a:spAutoFit/>
+          </a:bodyPr>
+          <a:lstStyle/>
+          <a:p>
+            <a:pPr algn="l"/>
+            <a:r>
+              <a:rPr sz="1250" b="1">
+                <a:solidFill>
+                  <a:srgbClr val="1A1F2B"/>
+                </a:solidFill>
+                <a:latin typeface="Microsoft YaHei"/>
+                <a:ea typeface="Microsoft YaHei"/>
+                <a:cs typeface="Microsoft YaHei"/>
+              </a:rPr>
+              <a:t>Floorplan 主要任务</a:t>
+            </a:r>
+          </a:p>
+        </p:txBody>
+      </p:sp>
+      <p:sp>
+        <p:nvSpPr>
+          <p:cNvPr id="21" name="TextBox 20"/>
+          <p:cNvSpPr txBox="1"/>
+          <p:nvPr/>
+        </p:nvSpPr>
+        <p:spPr>
+          <a:xfrm>
+            <a:off x="9875520" y="6446520"/>
+            <a:ext cx="2011680" cy="365760"/>
+          </a:xfrm>
+          <a:prstGeom prst="rect">
+            <a:avLst/>
+          </a:prstGeom>
+          <a:noFill/>
+        </p:spPr>
+        <p:txBody>
+          <a:bodyPr wrap="none" lIns="0" rIns="0" tIns="0" bIns="0">
+            <a:spAutoFit/>
+          </a:bodyPr>
+          <a:lstStyle/>
+          <a:p>
             <a:pPr algn="r"/>
-            <a:fld id="{F2CD6174-8429-459B-BFA1-7DFEE5F201F5}" type="slidenum">
+            <a:fld id="{8EFAB514-9CA8-4D98-AC96-2B31006639CA}" type="slidenum">
               <a:rPr lang="en-US" sz="1000">
                 <a:solidFill>
                   <a:srgbClr val="9AA3B0"/>
@@ -16561,7 +19856,7 @@
           <a:lstStyle/>
           <a:p>
             <a:pPr algn="r"/>
-            <a:fld id="{97700F37-5D52-4581-94C3-4EC638486A7E}" type="slidenum">
+            <a:fld id="{35BB1B18-C49D-42A8-9D90-08A772F588D3}" type="slidenum">
               <a:rPr lang="en-US" sz="1000">
                 <a:solidFill>
                   <a:srgbClr val="9AA3B0"/>
@@ -16863,40 +20158,694 @@
           </a:p>
         </p:txBody>
       </p:sp>
-      <p:pic>
-        <p:nvPicPr>
-          <p:cNvPr id="6" name="Picture 5" descr="f12_io.png"/>
-          <p:cNvPicPr>
-            <a:picLocks noChangeAspect="1"/>
-          </p:cNvPicPr>
-          <p:nvPr/>
-        </p:nvPicPr>
-        <p:blipFill>
-          <a:blip r:embed="rId2"/>
-          <a:stretch>
-            <a:fillRect/>
-          </a:stretch>
-        </p:blipFill>
-        <p:spPr>
-          <a:xfrm>
-            <a:off x="6016777" y="1554480"/>
-            <a:ext cx="5202884" cy="4800600"/>
-          </a:xfrm>
-          <a:prstGeom prst="rect">
-            <a:avLst/>
-          </a:prstGeom>
-        </p:spPr>
-      </p:pic>
-      <p:sp>
-        <p:nvSpPr>
-          <p:cNvPr id="7" name="TextBox 6"/>
+      <p:sp>
+        <p:nvSpPr>
+          <p:cNvPr id="6" name="Rounded Rectangle 5"/>
+          <p:cNvSpPr/>
+          <p:nvPr/>
+        </p:nvSpPr>
+        <p:spPr>
+          <a:xfrm>
+            <a:off x="5577840" y="1856232"/>
+            <a:ext cx="1417320" cy="566928"/>
+          </a:xfrm>
+          <a:prstGeom prst="roundRect">
+            <a:avLst>
+              <a:gd name="adj" fmla="val 12000"/>
+            </a:avLst>
+          </a:prstGeom>
+          <a:solidFill>
+            <a:srgbClr val="EDF0F4"/>
+          </a:solidFill>
+          <a:ln w="19050">
+            <a:solidFill>
+              <a:srgbClr val="94A3B8"/>
+            </a:solidFill>
+          </a:ln>
+          <a:effectLst/>
+        </p:spPr>
+        <p:style>
+          <a:lnRef idx="1">
+            <a:schemeClr val="accent1"/>
+          </a:lnRef>
+          <a:fillRef idx="3">
+            <a:schemeClr val="accent1"/>
+          </a:fillRef>
+          <a:effectRef idx="2">
+            <a:schemeClr val="accent1"/>
+          </a:effectRef>
+          <a:fontRef idx="minor">
+            <a:schemeClr val="lt1"/>
+          </a:fontRef>
+        </p:style>
+        <p:txBody>
+          <a:bodyPr rtlCol="0" anchor="ctr" wrap="square" lIns="38100" rIns="38100" tIns="25400" bIns="25400"/>
+          <a:lstStyle/>
+          <a:p>
+            <a:pPr algn="ctr"/>
+            <a:r>
+              <a:rPr sz="1150" b="1">
+                <a:solidFill>
+                  <a:srgbClr val="1A1F2B"/>
+                </a:solidFill>
+                <a:latin typeface="Microsoft YaHei"/>
+                <a:ea typeface="Microsoft YaHei"/>
+                <a:cs typeface="Microsoft YaHei"/>
+              </a:rPr>
+              <a:t>Netlist (.v)</a:t>
+            </a:r>
+          </a:p>
+        </p:txBody>
+      </p:sp>
+      <p:sp>
+        <p:nvSpPr>
+          <p:cNvPr id="7" name="Rounded Rectangle 6"/>
+          <p:cNvSpPr/>
+          <p:nvPr/>
+        </p:nvSpPr>
+        <p:spPr>
+          <a:xfrm>
+            <a:off x="7086600" y="1856232"/>
+            <a:ext cx="1417320" cy="566928"/>
+          </a:xfrm>
+          <a:prstGeom prst="roundRect">
+            <a:avLst>
+              <a:gd name="adj" fmla="val 12000"/>
+            </a:avLst>
+          </a:prstGeom>
+          <a:solidFill>
+            <a:srgbClr val="EDF0F4"/>
+          </a:solidFill>
+          <a:ln w="19050">
+            <a:solidFill>
+              <a:srgbClr val="94A3B8"/>
+            </a:solidFill>
+          </a:ln>
+          <a:effectLst/>
+        </p:spPr>
+        <p:style>
+          <a:lnRef idx="1">
+            <a:schemeClr val="accent1"/>
+          </a:lnRef>
+          <a:fillRef idx="3">
+            <a:schemeClr val="accent1"/>
+          </a:fillRef>
+          <a:effectRef idx="2">
+            <a:schemeClr val="accent1"/>
+          </a:effectRef>
+          <a:fontRef idx="minor">
+            <a:schemeClr val="lt1"/>
+          </a:fontRef>
+        </p:style>
+        <p:txBody>
+          <a:bodyPr rtlCol="0" anchor="ctr" wrap="square" lIns="38100" rIns="38100" tIns="25400" bIns="25400"/>
+          <a:lstStyle/>
+          <a:p>
+            <a:pPr algn="ctr"/>
+            <a:r>
+              <a:rPr sz="1150" b="1">
+                <a:solidFill>
+                  <a:srgbClr val="1A1F2B"/>
+                </a:solidFill>
+                <a:latin typeface="Microsoft YaHei"/>
+                <a:ea typeface="Microsoft YaHei"/>
+                <a:cs typeface="Microsoft YaHei"/>
+              </a:rPr>
+              <a:t>LEF</a:t>
+            </a:r>
+          </a:p>
+        </p:txBody>
+      </p:sp>
+      <p:sp>
+        <p:nvSpPr>
+          <p:cNvPr id="8" name="Rounded Rectangle 7"/>
+          <p:cNvSpPr/>
+          <p:nvPr/>
+        </p:nvSpPr>
+        <p:spPr>
+          <a:xfrm>
+            <a:off x="5577840" y="2569464"/>
+            <a:ext cx="1417320" cy="566928"/>
+          </a:xfrm>
+          <a:prstGeom prst="roundRect">
+            <a:avLst>
+              <a:gd name="adj" fmla="val 12000"/>
+            </a:avLst>
+          </a:prstGeom>
+          <a:solidFill>
+            <a:srgbClr val="EDF0F4"/>
+          </a:solidFill>
+          <a:ln w="19050">
+            <a:solidFill>
+              <a:srgbClr val="94A3B8"/>
+            </a:solidFill>
+          </a:ln>
+          <a:effectLst/>
+        </p:spPr>
+        <p:style>
+          <a:lnRef idx="1">
+            <a:schemeClr val="accent1"/>
+          </a:lnRef>
+          <a:fillRef idx="3">
+            <a:schemeClr val="accent1"/>
+          </a:fillRef>
+          <a:effectRef idx="2">
+            <a:schemeClr val="accent1"/>
+          </a:effectRef>
+          <a:fontRef idx="minor">
+            <a:schemeClr val="lt1"/>
+          </a:fontRef>
+        </p:style>
+        <p:txBody>
+          <a:bodyPr rtlCol="0" anchor="ctr" wrap="square" lIns="38100" rIns="38100" tIns="25400" bIns="25400"/>
+          <a:lstStyle/>
+          <a:p>
+            <a:pPr algn="ctr"/>
+            <a:r>
+              <a:rPr sz="1150" b="1">
+                <a:solidFill>
+                  <a:srgbClr val="1A1F2B"/>
+                </a:solidFill>
+                <a:latin typeface="Microsoft YaHei"/>
+                <a:ea typeface="Microsoft YaHei"/>
+                <a:cs typeface="Microsoft YaHei"/>
+              </a:rPr>
+              <a:t>Liberty (.lib)</a:t>
+            </a:r>
+          </a:p>
+        </p:txBody>
+      </p:sp>
+      <p:sp>
+        <p:nvSpPr>
+          <p:cNvPr id="9" name="Rounded Rectangle 8"/>
+          <p:cNvSpPr/>
+          <p:nvPr/>
+        </p:nvSpPr>
+        <p:spPr>
+          <a:xfrm>
+            <a:off x="7086600" y="2569464"/>
+            <a:ext cx="1417320" cy="566928"/>
+          </a:xfrm>
+          <a:prstGeom prst="roundRect">
+            <a:avLst>
+              <a:gd name="adj" fmla="val 12000"/>
+            </a:avLst>
+          </a:prstGeom>
+          <a:solidFill>
+            <a:srgbClr val="EDF0F4"/>
+          </a:solidFill>
+          <a:ln w="19050">
+            <a:solidFill>
+              <a:srgbClr val="94A3B8"/>
+            </a:solidFill>
+          </a:ln>
+          <a:effectLst/>
+        </p:spPr>
+        <p:style>
+          <a:lnRef idx="1">
+            <a:schemeClr val="accent1"/>
+          </a:lnRef>
+          <a:fillRef idx="3">
+            <a:schemeClr val="accent1"/>
+          </a:fillRef>
+          <a:effectRef idx="2">
+            <a:schemeClr val="accent1"/>
+          </a:effectRef>
+          <a:fontRef idx="minor">
+            <a:schemeClr val="lt1"/>
+          </a:fontRef>
+        </p:style>
+        <p:txBody>
+          <a:bodyPr rtlCol="0" anchor="ctr" wrap="square" lIns="38100" rIns="38100" tIns="25400" bIns="25400"/>
+          <a:lstStyle/>
+          <a:p>
+            <a:pPr algn="ctr"/>
+            <a:r>
+              <a:rPr sz="1150" b="1">
+                <a:solidFill>
+                  <a:srgbClr val="1A1F2B"/>
+                </a:solidFill>
+                <a:latin typeface="Microsoft YaHei"/>
+                <a:ea typeface="Microsoft YaHei"/>
+                <a:cs typeface="Microsoft YaHei"/>
+              </a:rPr>
+              <a:t>SDC</a:t>
+            </a:r>
+          </a:p>
+        </p:txBody>
+      </p:sp>
+      <p:sp>
+        <p:nvSpPr>
+          <p:cNvPr id="10" name="Rounded Rectangle 9"/>
+          <p:cNvSpPr/>
+          <p:nvPr/>
+        </p:nvSpPr>
+        <p:spPr>
+          <a:xfrm>
+            <a:off x="5577840" y="3282696"/>
+            <a:ext cx="1417320" cy="566928"/>
+          </a:xfrm>
+          <a:prstGeom prst="roundRect">
+            <a:avLst>
+              <a:gd name="adj" fmla="val 12000"/>
+            </a:avLst>
+          </a:prstGeom>
+          <a:solidFill>
+            <a:srgbClr val="EDF0F4"/>
+          </a:solidFill>
+          <a:ln w="19050">
+            <a:solidFill>
+              <a:srgbClr val="94A3B8"/>
+            </a:solidFill>
+          </a:ln>
+          <a:effectLst/>
+        </p:spPr>
+        <p:style>
+          <a:lnRef idx="1">
+            <a:schemeClr val="accent1"/>
+          </a:lnRef>
+          <a:fillRef idx="3">
+            <a:schemeClr val="accent1"/>
+          </a:fillRef>
+          <a:effectRef idx="2">
+            <a:schemeClr val="accent1"/>
+          </a:effectRef>
+          <a:fontRef idx="minor">
+            <a:schemeClr val="lt1"/>
+          </a:fontRef>
+        </p:style>
+        <p:txBody>
+          <a:bodyPr rtlCol="0" anchor="ctr" wrap="square" lIns="38100" rIns="38100" tIns="25400" bIns="25400"/>
+          <a:lstStyle/>
+          <a:p>
+            <a:pPr algn="ctr"/>
+            <a:r>
+              <a:rPr sz="1150" b="1">
+                <a:solidFill>
+                  <a:srgbClr val="1A1F2B"/>
+                </a:solidFill>
+                <a:latin typeface="Microsoft YaHei"/>
+                <a:ea typeface="Microsoft YaHei"/>
+                <a:cs typeface="Microsoft YaHei"/>
+              </a:rPr>
+              <a:t>UPF</a:t>
+            </a:r>
+          </a:p>
+        </p:txBody>
+      </p:sp>
+      <p:sp>
+        <p:nvSpPr>
+          <p:cNvPr id="11" name="Rounded Rectangle 10"/>
+          <p:cNvSpPr/>
+          <p:nvPr/>
+        </p:nvSpPr>
+        <p:spPr>
+          <a:xfrm>
+            <a:off x="7086600" y="3282696"/>
+            <a:ext cx="1417320" cy="566928"/>
+          </a:xfrm>
+          <a:prstGeom prst="roundRect">
+            <a:avLst>
+              <a:gd name="adj" fmla="val 12000"/>
+            </a:avLst>
+          </a:prstGeom>
+          <a:solidFill>
+            <a:srgbClr val="EDF0F4"/>
+          </a:solidFill>
+          <a:ln w="19050">
+            <a:solidFill>
+              <a:srgbClr val="94A3B8"/>
+            </a:solidFill>
+          </a:ln>
+          <a:effectLst/>
+        </p:spPr>
+        <p:style>
+          <a:lnRef idx="1">
+            <a:schemeClr val="accent1"/>
+          </a:lnRef>
+          <a:fillRef idx="3">
+            <a:schemeClr val="accent1"/>
+          </a:fillRef>
+          <a:effectRef idx="2">
+            <a:schemeClr val="accent1"/>
+          </a:effectRef>
+          <a:fontRef idx="minor">
+            <a:schemeClr val="lt1"/>
+          </a:fontRef>
+        </p:style>
+        <p:txBody>
+          <a:bodyPr rtlCol="0" anchor="ctr" wrap="square" lIns="38100" rIns="38100" tIns="25400" bIns="25400"/>
+          <a:lstStyle/>
+          <a:p>
+            <a:pPr algn="ctr"/>
+            <a:r>
+              <a:rPr sz="1150" b="1">
+                <a:solidFill>
+                  <a:srgbClr val="1A1F2B"/>
+                </a:solidFill>
+                <a:latin typeface="Microsoft YaHei"/>
+                <a:ea typeface="Microsoft YaHei"/>
+                <a:cs typeface="Microsoft YaHei"/>
+              </a:rPr>
+              <a:t>Partition / 预算</a:t>
+            </a:r>
+          </a:p>
+        </p:txBody>
+      </p:sp>
+      <p:sp>
+        <p:nvSpPr>
+          <p:cNvPr id="12" name="Rounded Rectangle 11"/>
+          <p:cNvSpPr/>
+          <p:nvPr/>
+        </p:nvSpPr>
+        <p:spPr>
+          <a:xfrm>
+            <a:off x="9372600" y="2194560"/>
+            <a:ext cx="2240280" cy="1188720"/>
+          </a:xfrm>
+          <a:prstGeom prst="roundRect">
+            <a:avLst>
+              <a:gd name="adj" fmla="val 12000"/>
+            </a:avLst>
+          </a:prstGeom>
+          <a:solidFill>
+            <a:srgbClr val="1D4ED8"/>
+          </a:solidFill>
+          <a:ln w="19050">
+            <a:solidFill>
+              <a:srgbClr val="1D4ED8"/>
+            </a:solidFill>
+          </a:ln>
+          <a:effectLst/>
+        </p:spPr>
+        <p:style>
+          <a:lnRef idx="1">
+            <a:schemeClr val="accent1"/>
+          </a:lnRef>
+          <a:fillRef idx="3">
+            <a:schemeClr val="accent1"/>
+          </a:fillRef>
+          <a:effectRef idx="2">
+            <a:schemeClr val="accent1"/>
+          </a:effectRef>
+          <a:fontRef idx="minor">
+            <a:schemeClr val="lt1"/>
+          </a:fontRef>
+        </p:style>
+        <p:txBody>
+          <a:bodyPr rtlCol="0" anchor="ctr" wrap="square" lIns="38100" rIns="38100" tIns="25400" bIns="25400"/>
+          <a:lstStyle/>
+          <a:p>
+            <a:pPr algn="ctr"/>
+            <a:r>
+              <a:rPr sz="1150" b="1">
+                <a:solidFill>
+                  <a:srgbClr val="FFFFFF"/>
+                </a:solidFill>
+                <a:latin typeface="Microsoft YaHei"/>
+                <a:ea typeface="Microsoft YaHei"/>
+                <a:cs typeface="Microsoft YaHei"/>
+              </a:rPr>
+              <a:t>Floorplan</a:t>
+            </a:r>
+          </a:p>
+          <a:p>
+            <a:pPr algn="ctr"/>
+            <a:r>
+              <a:rPr sz="1150" b="1">
+                <a:solidFill>
+                  <a:srgbClr val="FFFFFF"/>
+                </a:solidFill>
+                <a:latin typeface="Microsoft YaHei"/>
+                <a:ea typeface="Microsoft YaHei"/>
+                <a:cs typeface="Microsoft YaHei"/>
+              </a:rPr>
+              <a:t>ICC2 / Innovus</a:t>
+            </a:r>
+          </a:p>
+        </p:txBody>
+      </p:sp>
+      <p:sp>
+        <p:nvSpPr>
+          <p:cNvPr id="13" name="Rounded Rectangle 12"/>
+          <p:cNvSpPr/>
+          <p:nvPr/>
+        </p:nvSpPr>
+        <p:spPr>
+          <a:xfrm>
+            <a:off x="5577840" y="4251960"/>
+            <a:ext cx="6035040" cy="548640"/>
+          </a:xfrm>
+          <a:prstGeom prst="roundRect">
+            <a:avLst>
+              <a:gd name="adj" fmla="val 12000"/>
+            </a:avLst>
+          </a:prstGeom>
+          <a:solidFill>
+            <a:srgbClr val="CCFBF1"/>
+          </a:solidFill>
+          <a:ln w="19050">
+            <a:solidFill>
+              <a:srgbClr val="0D9488"/>
+            </a:solidFill>
+          </a:ln>
+          <a:effectLst/>
+        </p:spPr>
+        <p:style>
+          <a:lnRef idx="1">
+            <a:schemeClr val="accent1"/>
+          </a:lnRef>
+          <a:fillRef idx="3">
+            <a:schemeClr val="accent1"/>
+          </a:fillRef>
+          <a:effectRef idx="2">
+            <a:schemeClr val="accent1"/>
+          </a:effectRef>
+          <a:fontRef idx="minor">
+            <a:schemeClr val="lt1"/>
+          </a:fontRef>
+        </p:style>
+        <p:txBody>
+          <a:bodyPr rtlCol="0" anchor="ctr" wrap="square" lIns="38100" rIns="38100" tIns="25400" bIns="25400"/>
+          <a:lstStyle/>
+          <a:p>
+            <a:pPr algn="ctr"/>
+            <a:r>
+              <a:rPr sz="1150" b="1">
+                <a:solidFill>
+                  <a:srgbClr val="115E59"/>
+                </a:solidFill>
+                <a:latin typeface="Microsoft YaHei"/>
+                <a:ea typeface="Microsoft YaHei"/>
+                <a:cs typeface="Microsoft YaHei"/>
+              </a:rPr>
+              <a:t>DEF：宏 + PG + blockage</a:t>
+            </a:r>
+          </a:p>
+        </p:txBody>
+      </p:sp>
+      <p:sp>
+        <p:nvSpPr>
+          <p:cNvPr id="14" name="Rounded Rectangle 13"/>
+          <p:cNvSpPr/>
+          <p:nvPr/>
+        </p:nvSpPr>
+        <p:spPr>
+          <a:xfrm>
+            <a:off x="5577840" y="4910328"/>
+            <a:ext cx="6035040" cy="548640"/>
+          </a:xfrm>
+          <a:prstGeom prst="roundRect">
+            <a:avLst>
+              <a:gd name="adj" fmla="val 12000"/>
+            </a:avLst>
+          </a:prstGeom>
+          <a:solidFill>
+            <a:srgbClr val="CCFBF1"/>
+          </a:solidFill>
+          <a:ln w="19050">
+            <a:solidFill>
+              <a:srgbClr val="0D9488"/>
+            </a:solidFill>
+          </a:ln>
+          <a:effectLst/>
+        </p:spPr>
+        <p:style>
+          <a:lnRef idx="1">
+            <a:schemeClr val="accent1"/>
+          </a:lnRef>
+          <a:fillRef idx="3">
+            <a:schemeClr val="accent1"/>
+          </a:fillRef>
+          <a:effectRef idx="2">
+            <a:schemeClr val="accent1"/>
+          </a:effectRef>
+          <a:fontRef idx="minor">
+            <a:schemeClr val="lt1"/>
+          </a:fontRef>
+        </p:style>
+        <p:txBody>
+          <a:bodyPr rtlCol="0" anchor="ctr" wrap="square" lIns="38100" rIns="38100" tIns="25400" bIns="25400"/>
+          <a:lstStyle/>
+          <a:p>
+            <a:pPr algn="ctr"/>
+            <a:r>
+              <a:rPr sz="1150" b="1">
+                <a:solidFill>
+                  <a:srgbClr val="115E59"/>
+                </a:solidFill>
+                <a:latin typeface="Microsoft YaHei"/>
+                <a:ea typeface="Microsoft YaHei"/>
+                <a:cs typeface="Microsoft YaHei"/>
+              </a:rPr>
+              <a:t>Floorplan DB (NDM/OA)</a:t>
+            </a:r>
+          </a:p>
+        </p:txBody>
+      </p:sp>
+      <p:sp>
+        <p:nvSpPr>
+          <p:cNvPr id="15" name="Rounded Rectangle 14"/>
+          <p:cNvSpPr/>
+          <p:nvPr/>
+        </p:nvSpPr>
+        <p:spPr>
+          <a:xfrm>
+            <a:off x="5577840" y="5568696"/>
+            <a:ext cx="6035040" cy="548640"/>
+          </a:xfrm>
+          <a:prstGeom prst="roundRect">
+            <a:avLst>
+              <a:gd name="adj" fmla="val 12000"/>
+            </a:avLst>
+          </a:prstGeom>
+          <a:solidFill>
+            <a:srgbClr val="FEE2E2"/>
+          </a:solidFill>
+          <a:ln w="19050">
+            <a:solidFill>
+              <a:srgbClr val="DC2626"/>
+            </a:solidFill>
+          </a:ln>
+          <a:effectLst/>
+        </p:spPr>
+        <p:style>
+          <a:lnRef idx="1">
+            <a:schemeClr val="accent1"/>
+          </a:lnRef>
+          <a:fillRef idx="3">
+            <a:schemeClr val="accent1"/>
+          </a:fillRef>
+          <a:effectRef idx="2">
+            <a:schemeClr val="accent1"/>
+          </a:effectRef>
+          <a:fontRef idx="minor">
+            <a:schemeClr val="lt1"/>
+          </a:fontRef>
+        </p:style>
+        <p:txBody>
+          <a:bodyPr rtlCol="0" anchor="ctr" wrap="square" lIns="38100" rIns="38100" tIns="25400" bIns="25400"/>
+          <a:lstStyle/>
+          <a:p>
+            <a:pPr algn="ctr"/>
+            <a:r>
+              <a:rPr sz="1150" b="1">
+                <a:solidFill>
+                  <a:srgbClr val="991B1B"/>
+                </a:solidFill>
+                <a:latin typeface="Microsoft YaHei"/>
+                <a:ea typeface="Microsoft YaHei"/>
+                <a:cs typeface="Microsoft YaHei"/>
+              </a:rPr>
+              <a:t>可布线性 / 时序初评</a:t>
+            </a:r>
+          </a:p>
+        </p:txBody>
+      </p:sp>
+      <p:cxnSp>
+        <p:nvCxnSpPr>
+          <p:cNvPr id="16" name="Connector 15"/>
+          <p:cNvCxnSpPr/>
+          <p:nvPr/>
+        </p:nvCxnSpPr>
+        <p:spPr>
+          <a:xfrm>
+            <a:off x="8595360" y="2743200"/>
+            <a:ext cx="777240" cy="45720"/>
+          </a:xfrm>
+          <a:prstGeom prst="line">
+            <a:avLst/>
+          </a:prstGeom>
+          <a:ln w="19050">
+            <a:solidFill>
+              <a:srgbClr val="C7CDD6"/>
+            </a:solidFill>
+            <a:tailEnd type="triangle" w="med" len="med"/>
+          </a:ln>
+          <a:effectLst/>
+        </p:spPr>
+        <p:style>
+          <a:lnRef idx="2">
+            <a:schemeClr val="accent1"/>
+          </a:lnRef>
+          <a:fillRef idx="0">
+            <a:schemeClr val="accent1"/>
+          </a:fillRef>
+          <a:effectRef idx="1">
+            <a:schemeClr val="accent1"/>
+          </a:effectRef>
+          <a:fontRef idx="minor">
+            <a:schemeClr val="tx1"/>
+          </a:fontRef>
+        </p:style>
+      </p:cxnSp>
+      <p:cxnSp>
+        <p:nvCxnSpPr>
+          <p:cNvPr id="17" name="Connector 16"/>
+          <p:cNvCxnSpPr/>
+          <p:nvPr/>
+        </p:nvCxnSpPr>
+        <p:spPr>
+          <a:xfrm flipH="1">
+            <a:off x="8686800" y="3383280"/>
+            <a:ext cx="1783080" cy="822960"/>
+          </a:xfrm>
+          <a:prstGeom prst="line">
+            <a:avLst/>
+          </a:prstGeom>
+          <a:ln w="19050">
+            <a:solidFill>
+              <a:srgbClr val="3A4252"/>
+            </a:solidFill>
+            <a:tailEnd type="triangle" w="med" len="med"/>
+          </a:ln>
+          <a:effectLst/>
+        </p:spPr>
+        <p:style>
+          <a:lnRef idx="2">
+            <a:schemeClr val="accent1"/>
+          </a:lnRef>
+          <a:fillRef idx="0">
+            <a:schemeClr val="accent1"/>
+          </a:fillRef>
+          <a:effectRef idx="1">
+            <a:schemeClr val="accent1"/>
+          </a:effectRef>
+          <a:fontRef idx="minor">
+            <a:schemeClr val="tx1"/>
+          </a:fontRef>
+        </p:style>
+      </p:cxnSp>
+      <p:sp>
+        <p:nvSpPr>
+          <p:cNvPr id="18" name="TextBox 17"/>
           <p:cNvSpPr txBox="1"/>
           <p:nvPr/>
         </p:nvSpPr>
         <p:spPr>
           <a:xfrm>
-            <a:off x="9875520" y="6446520"/>
-            <a:ext cx="2011680" cy="365760"/>
+            <a:off x="5577840" y="1600200"/>
+            <a:ext cx="3291840" cy="365760"/>
           </a:xfrm>
           <a:prstGeom prst="rect">
             <a:avLst/>
@@ -16909,8 +20858,82 @@
           </a:bodyPr>
           <a:lstStyle/>
           <a:p>
+            <a:pPr algn="l"/>
+            <a:r>
+              <a:rPr sz="1200" b="1">
+                <a:solidFill>
+                  <a:srgbClr val="3A4252"/>
+                </a:solidFill>
+                <a:latin typeface="Microsoft YaHei"/>
+                <a:ea typeface="Microsoft YaHei"/>
+                <a:cs typeface="Microsoft YaHei"/>
+              </a:rPr>
+              <a:t>输入</a:t>
+            </a:r>
+          </a:p>
+        </p:txBody>
+      </p:sp>
+      <p:sp>
+        <p:nvSpPr>
+          <p:cNvPr id="19" name="TextBox 18"/>
+          <p:cNvSpPr txBox="1"/>
+          <p:nvPr/>
+        </p:nvSpPr>
+        <p:spPr>
+          <a:xfrm>
+            <a:off x="5577840" y="3931920"/>
+            <a:ext cx="3291840" cy="365760"/>
+          </a:xfrm>
+          <a:prstGeom prst="rect">
+            <a:avLst/>
+          </a:prstGeom>
+          <a:noFill/>
+        </p:spPr>
+        <p:txBody>
+          <a:bodyPr wrap="none" lIns="0" rIns="0" tIns="0" bIns="0">
+            <a:spAutoFit/>
+          </a:bodyPr>
+          <a:lstStyle/>
+          <a:p>
+            <a:pPr algn="l"/>
+            <a:r>
+              <a:rPr sz="1200" b="1">
+                <a:solidFill>
+                  <a:srgbClr val="3A4252"/>
+                </a:solidFill>
+                <a:latin typeface="Microsoft YaHei"/>
+                <a:ea typeface="Microsoft YaHei"/>
+                <a:cs typeface="Microsoft YaHei"/>
+              </a:rPr>
+              <a:t>输出</a:t>
+            </a:r>
+          </a:p>
+        </p:txBody>
+      </p:sp>
+      <p:sp>
+        <p:nvSpPr>
+          <p:cNvPr id="20" name="TextBox 19"/>
+          <p:cNvSpPr txBox="1"/>
+          <p:nvPr/>
+        </p:nvSpPr>
+        <p:spPr>
+          <a:xfrm>
+            <a:off x="9875520" y="6446520"/>
+            <a:ext cx="2011680" cy="365760"/>
+          </a:xfrm>
+          <a:prstGeom prst="rect">
+            <a:avLst/>
+          </a:prstGeom>
+          <a:noFill/>
+        </p:spPr>
+        <p:txBody>
+          <a:bodyPr wrap="none" lIns="0" rIns="0" tIns="0" bIns="0">
+            <a:spAutoFit/>
+          </a:bodyPr>
+          <a:lstStyle/>
+          <a:p>
             <a:pPr algn="r"/>
-            <a:fld id="{B48E2F2A-C2D1-4F1C-9BF3-161CC0F6B043}" type="slidenum">
+            <a:fld id="{4ABC1A06-EAA3-4DCF-A80C-D9205131F43F}" type="slidenum">
               <a:rPr lang="en-US" sz="1000">
                 <a:solidFill>
                   <a:srgbClr val="9AA3B0"/>

</xml_diff>

<commit_message>
③ switch primary from bright blue to deep Tsinghua purple (#5B2C86); free clock role to blue; figures + deck re-rendered
Co-Authored-By: Claude Opus 4.8 <noreply@anthropic.com>
</commit_message>
<xml_diff>
--- a/IC_Backend_Notes/slides/05_Floorplan.pptx
+++ b/IC_Backend_Notes/slides/05_Floorplan.pptx
@@ -171,7 +171,7 @@
             <a:avLst/>
           </a:prstGeom>
           <a:solidFill>
-            <a:srgbClr val="1D4ED8"/>
+            <a:srgbClr val="5B2C86"/>
           </a:solidFill>
           <a:ln>
             <a:noFill/>
@@ -661,7 +661,7 @@
             <a:avLst/>
           </a:prstGeom>
           <a:solidFill>
-            <a:srgbClr val="1D4ED8"/>
+            <a:srgbClr val="5B2C86"/>
           </a:solidFill>
           <a:ln>
             <a:noFill/>
@@ -720,7 +720,7 @@
             <a:r>
               <a:rPr sz="1400" b="1">
                 <a:solidFill>
-                  <a:srgbClr val="1D4ED8"/>
+                  <a:srgbClr val="5B2C86"/>
                 </a:solidFill>
                 <a:latin typeface="Microsoft YaHei"/>
                 <a:ea typeface="Microsoft YaHei"/>
@@ -828,7 +828,7 @@
             <a:avLst/>
           </a:prstGeom>
           <a:solidFill>
-            <a:srgbClr val="1D4ED8"/>
+            <a:srgbClr val="5B2C86"/>
           </a:solidFill>
           <a:ln>
             <a:noFill/>
@@ -1069,7 +1069,7 @@
             <a:r>
               <a:rPr sz="1200" b="1">
                 <a:solidFill>
-                  <a:srgbClr val="1D4ED8"/>
+                  <a:srgbClr val="5B2C86"/>
                 </a:solidFill>
                 <a:latin typeface="Microsoft YaHei"/>
                 <a:ea typeface="Microsoft YaHei"/>
@@ -1255,7 +1255,7 @@
           <a:lstStyle/>
           <a:p>
             <a:pPr algn="r"/>
-            <a:fld id="{53C74F42-B7B0-4985-B475-6F2C860A82DA}" type="slidenum">
+            <a:fld id="{6E8B3E89-C49D-467E-AB94-605CECFD88F8}" type="slidenum">
               <a:rPr lang="en-US" sz="1000">
                 <a:solidFill>
                   <a:srgbClr val="9AA3B0"/>
@@ -1397,7 +1397,7 @@
             <a:r>
               <a:rPr sz="1200" b="1">
                 <a:solidFill>
-                  <a:srgbClr val="1D4ED8"/>
+                  <a:srgbClr val="5B2C86"/>
                 </a:solidFill>
                 <a:latin typeface="Microsoft YaHei"/>
                 <a:ea typeface="Microsoft YaHei"/>
@@ -1541,7 +1541,7 @@
           <a:lstStyle/>
           <a:p>
             <a:pPr algn="r"/>
-            <a:fld id="{DF4D5A3E-B567-42AC-A1AB-DA62ACE1DC73}" type="slidenum">
+            <a:fld id="{E3DD3AB2-0510-410F-B64C-129601EDBD26}" type="slidenum">
               <a:rPr lang="en-US" sz="1000">
                 <a:solidFill>
                   <a:srgbClr val="9AA3B0"/>
@@ -1683,7 +1683,7 @@
             <a:r>
               <a:rPr sz="1200" b="1">
                 <a:solidFill>
-                  <a:srgbClr val="1D4ED8"/>
+                  <a:srgbClr val="5B2C86"/>
                 </a:solidFill>
                 <a:latin typeface="Microsoft YaHei"/>
                 <a:ea typeface="Microsoft YaHei"/>
@@ -1856,11 +1856,11 @@
             </a:avLst>
           </a:prstGeom>
           <a:solidFill>
-            <a:srgbClr val="DBEAFE"/>
+            <a:srgbClr val="ECE5F3"/>
           </a:solidFill>
           <a:ln w="19050">
             <a:solidFill>
-              <a:srgbClr val="1D4ED8"/>
+              <a:srgbClr val="5B2C86"/>
             </a:solidFill>
           </a:ln>
           <a:effectLst/>
@@ -1887,7 +1887,7 @@
             <a:r>
               <a:rPr sz="1300" b="1">
                 <a:solidFill>
-                  <a:srgbClr val="1E3A8A"/>
+                  <a:srgbClr val="3C1C5A"/>
                 </a:solidFill>
                 <a:latin typeface="Microsoft YaHei"/>
                 <a:ea typeface="Microsoft YaHei"/>
@@ -1915,11 +1915,11 @@
             </a:avLst>
           </a:prstGeom>
           <a:solidFill>
-            <a:srgbClr val="DBEAFE"/>
+            <a:srgbClr val="ECE5F3"/>
           </a:solidFill>
           <a:ln w="19050">
             <a:solidFill>
-              <a:srgbClr val="1D4ED8"/>
+              <a:srgbClr val="5B2C86"/>
             </a:solidFill>
           </a:ln>
           <a:effectLst/>
@@ -1946,7 +1946,7 @@
             <a:r>
               <a:rPr sz="1300" b="1">
                 <a:solidFill>
-                  <a:srgbClr val="1E3A8A"/>
+                  <a:srgbClr val="3C1C5A"/>
                 </a:solidFill>
                 <a:latin typeface="Microsoft YaHei"/>
                 <a:ea typeface="Microsoft YaHei"/>
@@ -2151,11 +2151,11 @@
             </a:avLst>
           </a:prstGeom>
           <a:solidFill>
-            <a:srgbClr val="DBEAFE"/>
+            <a:srgbClr val="ECE5F3"/>
           </a:solidFill>
           <a:ln w="19050">
             <a:solidFill>
-              <a:srgbClr val="1D4ED8"/>
+              <a:srgbClr val="5B2C86"/>
             </a:solidFill>
           </a:ln>
           <a:effectLst/>
@@ -2182,7 +2182,7 @@
             <a:r>
               <a:rPr sz="1300" b="1">
                 <a:solidFill>
-                  <a:srgbClr val="1E3A8A"/>
+                  <a:srgbClr val="3C1C5A"/>
                 </a:solidFill>
                 <a:latin typeface="Microsoft YaHei"/>
                 <a:ea typeface="Microsoft YaHei"/>
@@ -2210,11 +2210,11 @@
             </a:avLst>
           </a:prstGeom>
           <a:solidFill>
-            <a:srgbClr val="DBEAFE"/>
+            <a:srgbClr val="ECE5F3"/>
           </a:solidFill>
           <a:ln w="19050">
             <a:solidFill>
-              <a:srgbClr val="1D4ED8"/>
+              <a:srgbClr val="5B2C86"/>
             </a:solidFill>
           </a:ln>
           <a:effectLst/>
@@ -2241,7 +2241,7 @@
             <a:r>
               <a:rPr sz="1300" b="1">
                 <a:solidFill>
-                  <a:srgbClr val="1E3A8A"/>
+                  <a:srgbClr val="3C1C5A"/>
                 </a:solidFill>
                 <a:latin typeface="Microsoft YaHei"/>
                 <a:ea typeface="Microsoft YaHei"/>
@@ -3066,7 +3066,7 @@
           <a:lstStyle/>
           <a:p>
             <a:pPr algn="r"/>
-            <a:fld id="{BD822B1F-EF48-4D65-9049-7C7FBA70B969}" type="slidenum">
+            <a:fld id="{D792C2F3-A87A-4711-949E-FDEAF874B49B}" type="slidenum">
               <a:rPr lang="en-US" sz="1000">
                 <a:solidFill>
                   <a:srgbClr val="9AA3B0"/>
@@ -3208,7 +3208,7 @@
             <a:r>
               <a:rPr sz="1200" b="1">
                 <a:solidFill>
-                  <a:srgbClr val="1D4ED8"/>
+                  <a:srgbClr val="5B2C86"/>
                 </a:solidFill>
                 <a:latin typeface="Microsoft YaHei"/>
                 <a:ea typeface="Microsoft YaHei"/>
@@ -3415,7 +3415,7 @@
           <a:lstStyle/>
           <a:p>
             <a:pPr algn="r"/>
-            <a:fld id="{67541B69-78B2-40D5-825F-742B1E0DF2F2}" type="slidenum">
+            <a:fld id="{05D0599E-13F1-40A8-ADDA-AF14D9309E8E}" type="slidenum">
               <a:rPr lang="en-US" sz="1000">
                 <a:solidFill>
                   <a:srgbClr val="9AA3B0"/>
@@ -3557,7 +3557,7 @@
             <a:r>
               <a:rPr sz="1200" b="1">
                 <a:solidFill>
-                  <a:srgbClr val="1D4ED8"/>
+                  <a:srgbClr val="5B2C86"/>
                 </a:solidFill>
                 <a:latin typeface="Microsoft YaHei"/>
                 <a:ea typeface="Microsoft YaHei"/>
@@ -3633,7 +3633,7 @@
                       </a:solidFill>
                     </a:lnB>
                     <a:solidFill>
-                      <a:srgbClr val="1D4ED8"/>
+                      <a:srgbClr val="5B2C86"/>
                     </a:solidFill>
                   </a:tcPr>
                 </a:tc>
@@ -3678,7 +3678,7 @@
                       </a:solidFill>
                     </a:lnB>
                     <a:solidFill>
-                      <a:srgbClr val="1D4ED8"/>
+                      <a:srgbClr val="5B2C86"/>
                     </a:solidFill>
                   </a:tcPr>
                 </a:tc>
@@ -3723,7 +3723,7 @@
                       </a:solidFill>
                     </a:lnB>
                     <a:solidFill>
-                      <a:srgbClr val="1D4ED8"/>
+                      <a:srgbClr val="5B2C86"/>
                     </a:solidFill>
                   </a:tcPr>
                 </a:tc>
@@ -4303,7 +4303,7 @@
           <a:lstStyle/>
           <a:p>
             <a:pPr algn="r"/>
-            <a:fld id="{0F1FF2F7-0690-46D7-A380-6D4BF8DC4B85}" type="slidenum">
+            <a:fld id="{D17CE609-3FCF-4333-A882-74C6C9C17B38}" type="slidenum">
               <a:rPr lang="en-US" sz="1000">
                 <a:solidFill>
                   <a:srgbClr val="9AA3B0"/>
@@ -4445,7 +4445,7 @@
             <a:r>
               <a:rPr sz="1200" b="1">
                 <a:solidFill>
-                  <a:srgbClr val="1D4ED8"/>
+                  <a:srgbClr val="5B2C86"/>
                 </a:solidFill>
                 <a:latin typeface="Microsoft YaHei"/>
                 <a:ea typeface="Microsoft YaHei"/>
@@ -4631,7 +4631,7 @@
           <a:lstStyle/>
           <a:p>
             <a:pPr algn="r"/>
-            <a:fld id="{3565EDBB-850B-46E4-964E-0F51F58FF39A}" type="slidenum">
+            <a:fld id="{7CF0AA60-7AF4-4269-A445-1D29284019F6}" type="slidenum">
               <a:rPr lang="en-US" sz="1000">
                 <a:solidFill>
                   <a:srgbClr val="9AA3B0"/>
@@ -4773,7 +4773,7 @@
             <a:r>
               <a:rPr sz="1200" b="1">
                 <a:solidFill>
-                  <a:srgbClr val="1D4ED8"/>
+                  <a:srgbClr val="5B2C86"/>
                 </a:solidFill>
                 <a:latin typeface="Microsoft YaHei"/>
                 <a:ea typeface="Microsoft YaHei"/>
@@ -5000,7 +5000,7 @@
           <a:lstStyle/>
           <a:p>
             <a:pPr algn="r"/>
-            <a:fld id="{148FBE15-6AC0-4F62-AF01-8DE4D8B16245}" type="slidenum">
+            <a:fld id="{A956C56B-0251-47FE-8A11-B5C750D71A0C}" type="slidenum">
               <a:rPr lang="en-US" sz="1000">
                 <a:solidFill>
                   <a:srgbClr val="9AA3B0"/>
@@ -5097,7 +5097,7 @@
             <a:avLst/>
           </a:prstGeom>
           <a:solidFill>
-            <a:srgbClr val="1D4ED8"/>
+            <a:srgbClr val="5B2C86"/>
           </a:solidFill>
           <a:ln>
             <a:noFill/>
@@ -5719,7 +5719,7 @@
             <a:r>
               <a:rPr sz="1200" b="1">
                 <a:solidFill>
-                  <a:srgbClr val="1D4ED8"/>
+                  <a:srgbClr val="5B2C86"/>
                 </a:solidFill>
                 <a:latin typeface="Microsoft YaHei"/>
                 <a:ea typeface="Microsoft YaHei"/>
@@ -5955,11 +5955,11 @@
             </a:avLst>
           </a:prstGeom>
           <a:solidFill>
-            <a:srgbClr val="DBEAFE"/>
+            <a:srgbClr val="ECE5F3"/>
           </a:solidFill>
           <a:ln w="19050">
             <a:solidFill>
-              <a:srgbClr val="1D4ED8"/>
+              <a:srgbClr val="5B2C86"/>
             </a:solidFill>
           </a:ln>
           <a:effectLst/>
@@ -5986,7 +5986,7 @@
             <a:r>
               <a:rPr sz="1200" b="1">
                 <a:solidFill>
-                  <a:srgbClr val="1E3A8A"/>
+                  <a:srgbClr val="3C1C5A"/>
                 </a:solidFill>
                 <a:latin typeface="Microsoft YaHei"/>
                 <a:ea typeface="Microsoft YaHei"/>
@@ -6000,7 +6000,7 @@
             <a:r>
               <a:rPr sz="1200" b="1">
                 <a:solidFill>
-                  <a:srgbClr val="1E3A8A"/>
+                  <a:srgbClr val="3C1C5A"/>
                 </a:solidFill>
                 <a:latin typeface="Microsoft YaHei"/>
                 <a:ea typeface="Microsoft YaHei"/>
@@ -6502,7 +6502,7 @@
             <a:r>
               <a:rPr sz="1400" b="1">
                 <a:solidFill>
-                  <a:srgbClr val="1E3A8A"/>
+                  <a:srgbClr val="3C1C5A"/>
                 </a:solidFill>
                 <a:latin typeface="Microsoft YaHei"/>
                 <a:ea typeface="Microsoft YaHei"/>
@@ -6721,7 +6721,7 @@
           <a:lstStyle/>
           <a:p>
             <a:pPr algn="r"/>
-            <a:fld id="{111319D4-A014-4B16-A5D4-89B2D27E35EF}" type="slidenum">
+            <a:fld id="{3586B4F2-0C28-4BE5-A58A-726BD9EBC984}" type="slidenum">
               <a:rPr lang="en-US" sz="1000">
                 <a:solidFill>
                   <a:srgbClr val="9AA3B0"/>
@@ -6863,7 +6863,7 @@
             <a:r>
               <a:rPr sz="1200" b="1">
                 <a:solidFill>
-                  <a:srgbClr val="1D4ED8"/>
+                  <a:srgbClr val="5B2C86"/>
                 </a:solidFill>
                 <a:latin typeface="Microsoft YaHei"/>
                 <a:ea typeface="Microsoft YaHei"/>
@@ -7070,7 +7070,7 @@
           <a:lstStyle/>
           <a:p>
             <a:pPr algn="r"/>
-            <a:fld id="{F05F5638-7A76-4F8D-9513-CAF4681F7ACF}" type="slidenum">
+            <a:fld id="{D2E3B47C-9628-4C22-90B6-48A0DF75C077}" type="slidenum">
               <a:rPr lang="en-US" sz="1000">
                 <a:solidFill>
                   <a:srgbClr val="9AA3B0"/>
@@ -7205,7 +7205,7 @@
             <a:avLst/>
           </a:prstGeom>
           <a:solidFill>
-            <a:srgbClr val="1D4ED8"/>
+            <a:srgbClr val="5B2C86"/>
           </a:solidFill>
           <a:ln>
             <a:noFill/>
@@ -7342,7 +7342,7 @@
             <a:avLst/>
           </a:prstGeom>
           <a:solidFill>
-            <a:srgbClr val="1D4ED8"/>
+            <a:srgbClr val="5B2C86"/>
           </a:solidFill>
           <a:ln>
             <a:noFill/>
@@ -7479,7 +7479,7 @@
             <a:avLst/>
           </a:prstGeom>
           <a:solidFill>
-            <a:srgbClr val="1D4ED8"/>
+            <a:srgbClr val="5B2C86"/>
           </a:solidFill>
           <a:ln>
             <a:noFill/>
@@ -7616,7 +7616,7 @@
             <a:avLst/>
           </a:prstGeom>
           <a:solidFill>
-            <a:srgbClr val="1D4ED8"/>
+            <a:srgbClr val="5B2C86"/>
           </a:solidFill>
           <a:ln>
             <a:noFill/>
@@ -7753,7 +7753,7 @@
             <a:avLst/>
           </a:prstGeom>
           <a:solidFill>
-            <a:srgbClr val="1D4ED8"/>
+            <a:srgbClr val="5B2C86"/>
           </a:solidFill>
           <a:ln>
             <a:noFill/>
@@ -7985,7 +7985,7 @@
           <a:lstStyle/>
           <a:p>
             <a:pPr algn="r"/>
-            <a:fld id="{6ACA0FB2-2845-4399-BABE-DB1C926ED1B3}" type="slidenum">
+            <a:fld id="{A37E75E5-58FD-4A3B-ADEE-9681317FCFB2}" type="slidenum">
               <a:rPr lang="en-US" sz="1000">
                 <a:solidFill>
                   <a:srgbClr val="9AA3B0"/>
@@ -8127,7 +8127,7 @@
             <a:r>
               <a:rPr sz="1200" b="1">
                 <a:solidFill>
-                  <a:srgbClr val="1D4ED8"/>
+                  <a:srgbClr val="5B2C86"/>
                 </a:solidFill>
                 <a:latin typeface="Microsoft YaHei"/>
                 <a:ea typeface="Microsoft YaHei"/>
@@ -8271,7 +8271,7 @@
           <a:lstStyle/>
           <a:p>
             <a:pPr algn="r"/>
-            <a:fld id="{EBB46898-A383-45D0-A462-D94FC6974E7A}" type="slidenum">
+            <a:fld id="{B8768618-3920-42B3-9698-1A64F7412E7A}" type="slidenum">
               <a:rPr lang="en-US" sz="1000">
                 <a:solidFill>
                   <a:srgbClr val="9AA3B0"/>
@@ -8368,7 +8368,7 @@
             <a:avLst/>
           </a:prstGeom>
           <a:solidFill>
-            <a:srgbClr val="1D4ED8"/>
+            <a:srgbClr val="5B2C86"/>
           </a:solidFill>
           <a:ln>
             <a:noFill/>
@@ -9330,7 +9330,7 @@
             <a:r>
               <a:rPr sz="1200" b="1">
                 <a:solidFill>
-                  <a:srgbClr val="1D4ED8"/>
+                  <a:srgbClr val="5B2C86"/>
                 </a:solidFill>
                 <a:latin typeface="Microsoft YaHei"/>
                 <a:ea typeface="Microsoft YaHei"/>
@@ -9474,7 +9474,7 @@
           <a:lstStyle/>
           <a:p>
             <a:pPr algn="r"/>
-            <a:fld id="{8E00E50A-D1FA-4270-A379-E752B4FDBAEA}" type="slidenum">
+            <a:fld id="{B5FBFEED-3149-4F16-9637-4CBDA3944868}" type="slidenum">
               <a:rPr lang="en-US" sz="1000">
                 <a:solidFill>
                   <a:srgbClr val="9AA3B0"/>
@@ -9616,7 +9616,7 @@
             <a:r>
               <a:rPr sz="1200" b="1">
                 <a:solidFill>
-                  <a:srgbClr val="1D4ED8"/>
+                  <a:srgbClr val="5B2C86"/>
                 </a:solidFill>
                 <a:latin typeface="Microsoft YaHei"/>
                 <a:ea typeface="Microsoft YaHei"/>
@@ -9760,7 +9760,7 @@
           <a:lstStyle/>
           <a:p>
             <a:pPr algn="r"/>
-            <a:fld id="{F0A5BEF0-698C-48E8-83B3-8DFE9E5B7595}" type="slidenum">
+            <a:fld id="{7516CB47-EDC7-4A92-8D75-9D045F9CFBC5}" type="slidenum">
               <a:rPr lang="en-US" sz="1000">
                 <a:solidFill>
                   <a:srgbClr val="9AA3B0"/>
@@ -9902,7 +9902,7 @@
             <a:r>
               <a:rPr sz="1200" b="1">
                 <a:solidFill>
-                  <a:srgbClr val="1D4ED8"/>
+                  <a:srgbClr val="5B2C86"/>
                 </a:solidFill>
                 <a:latin typeface="Microsoft YaHei"/>
                 <a:ea typeface="Microsoft YaHei"/>
@@ -10108,7 +10108,7 @@
           <a:lstStyle/>
           <a:p>
             <a:pPr algn="r"/>
-            <a:fld id="{04F41E0A-25D7-49C6-AA9E-5711A05BE535}" type="slidenum">
+            <a:fld id="{2B4405D7-B010-40A3-ABF1-E868526AF826}" type="slidenum">
               <a:rPr lang="en-US" sz="1000">
                 <a:solidFill>
                   <a:srgbClr val="9AA3B0"/>
@@ -10250,7 +10250,7 @@
             <a:r>
               <a:rPr sz="1200" b="1">
                 <a:solidFill>
-                  <a:srgbClr val="1D4ED8"/>
+                  <a:srgbClr val="5B2C86"/>
                 </a:solidFill>
                 <a:latin typeface="Microsoft YaHei"/>
                 <a:ea typeface="Microsoft YaHei"/>
@@ -10326,7 +10326,7 @@
                       </a:solidFill>
                     </a:lnB>
                     <a:solidFill>
-                      <a:srgbClr val="1D4ED8"/>
+                      <a:srgbClr val="5B2C86"/>
                     </a:solidFill>
                   </a:tcPr>
                 </a:tc>
@@ -10371,7 +10371,7 @@
                       </a:solidFill>
                     </a:lnB>
                     <a:solidFill>
-                      <a:srgbClr val="1D4ED8"/>
+                      <a:srgbClr val="5B2C86"/>
                     </a:solidFill>
                   </a:tcPr>
                 </a:tc>
@@ -10416,7 +10416,7 @@
                       </a:solidFill>
                     </a:lnB>
                     <a:solidFill>
-                      <a:srgbClr val="1D4ED8"/>
+                      <a:srgbClr val="5B2C86"/>
                     </a:solidFill>
                   </a:tcPr>
                 </a:tc>
@@ -10996,7 +10996,7 @@
           <a:lstStyle/>
           <a:p>
             <a:pPr algn="r"/>
-            <a:fld id="{B6B3AC91-5145-4ABB-87E2-AF8247D5101D}" type="slidenum">
+            <a:fld id="{CB84C097-F0B3-4055-B8AE-BE2DAE7C9AF6}" type="slidenum">
               <a:rPr lang="en-US" sz="1000">
                 <a:solidFill>
                   <a:srgbClr val="9AA3B0"/>
@@ -11138,7 +11138,7 @@
             <a:r>
               <a:rPr sz="1200" b="1">
                 <a:solidFill>
-                  <a:srgbClr val="1D4ED8"/>
+                  <a:srgbClr val="5B2C86"/>
                 </a:solidFill>
                 <a:latin typeface="Microsoft YaHei"/>
                 <a:ea typeface="Microsoft YaHei"/>
@@ -11213,7 +11213,7 @@
                       </a:solidFill>
                     </a:lnB>
                     <a:solidFill>
-                      <a:srgbClr val="1D4ED8"/>
+                      <a:srgbClr val="5B2C86"/>
                     </a:solidFill>
                   </a:tcPr>
                 </a:tc>
@@ -11258,7 +11258,7 @@
                       </a:solidFill>
                     </a:lnB>
                     <a:solidFill>
-                      <a:srgbClr val="1D4ED8"/>
+                      <a:srgbClr val="5B2C86"/>
                     </a:solidFill>
                   </a:tcPr>
                 </a:tc>
@@ -11842,7 +11842,7 @@
           <a:lstStyle/>
           <a:p>
             <a:pPr algn="r"/>
-            <a:fld id="{B14515C1-5FBD-476F-919B-B911DD859E43}" type="slidenum">
+            <a:fld id="{5A4F3989-2EE1-4AE0-AA94-94982535D6CF}" type="slidenum">
               <a:rPr lang="en-US" sz="1000">
                 <a:solidFill>
                   <a:srgbClr val="9AA3B0"/>
@@ -11984,7 +11984,7 @@
             <a:r>
               <a:rPr sz="1200" b="1">
                 <a:solidFill>
-                  <a:srgbClr val="1D4ED8"/>
+                  <a:srgbClr val="5B2C86"/>
                 </a:solidFill>
                 <a:latin typeface="Microsoft YaHei"/>
                 <a:ea typeface="Microsoft YaHei"/>
@@ -12167,7 +12167,7 @@
           <a:lstStyle/>
           <a:p>
             <a:pPr algn="r"/>
-            <a:fld id="{0EA850DC-56B2-4AF1-8F51-DAC93BF57DFB}" type="slidenum">
+            <a:fld id="{247312BC-9882-4A12-BDF9-7066A999910F}" type="slidenum">
               <a:rPr lang="en-US" sz="1000">
                 <a:solidFill>
                   <a:srgbClr val="9AA3B0"/>
@@ -12309,7 +12309,7 @@
             <a:r>
               <a:rPr sz="1200" b="1">
                 <a:solidFill>
-                  <a:srgbClr val="1D4ED8"/>
+                  <a:srgbClr val="5B2C86"/>
                 </a:solidFill>
                 <a:latin typeface="Microsoft YaHei"/>
                 <a:ea typeface="Microsoft YaHei"/>
@@ -12516,7 +12516,7 @@
           <a:lstStyle/>
           <a:p>
             <a:pPr algn="r"/>
-            <a:fld id="{33D45A6D-6F2A-4824-AFC3-170715536317}" type="slidenum">
+            <a:fld id="{09964746-187C-4D9B-8220-80521EC732ED}" type="slidenum">
               <a:rPr lang="en-US" sz="1000">
                 <a:solidFill>
                   <a:srgbClr val="9AA3B0"/>
@@ -12613,7 +12613,7 @@
             <a:avLst/>
           </a:prstGeom>
           <a:solidFill>
-            <a:srgbClr val="1D4ED8"/>
+            <a:srgbClr val="5B2C86"/>
           </a:solidFill>
           <a:ln>
             <a:noFill/>
@@ -13105,7 +13105,7 @@
             <a:avLst/>
           </a:prstGeom>
           <a:solidFill>
-            <a:srgbClr val="1D4ED8"/>
+            <a:srgbClr val="5B2C86"/>
           </a:solidFill>
           <a:ln>
             <a:noFill/>
@@ -13897,7 +13897,7 @@
             <a:r>
               <a:rPr sz="1200" b="1">
                 <a:solidFill>
-                  <a:srgbClr val="1D4ED8"/>
+                  <a:srgbClr val="5B2C86"/>
                 </a:solidFill>
                 <a:latin typeface="Microsoft YaHei"/>
                 <a:ea typeface="Microsoft YaHei"/>
@@ -14074,11 +14074,11 @@
             </a:avLst>
           </a:prstGeom>
           <a:solidFill>
-            <a:srgbClr val="DBEAFE"/>
+            <a:srgbClr val="ECE5F3"/>
           </a:solidFill>
           <a:ln w="19050">
             <a:solidFill>
-              <a:srgbClr val="1D4ED8"/>
+              <a:srgbClr val="5B2C86"/>
             </a:solidFill>
           </a:ln>
           <a:effectLst/>
@@ -14105,7 +14105,7 @@
             <a:r>
               <a:rPr sz="1200" b="1">
                 <a:solidFill>
-                  <a:srgbClr val="1E3A8A"/>
+                  <a:srgbClr val="3C1C5A"/>
                 </a:solidFill>
                 <a:latin typeface="Microsoft YaHei"/>
                 <a:ea typeface="Microsoft YaHei"/>
@@ -14119,7 +14119,7 @@
             <a:r>
               <a:rPr sz="1200" b="1">
                 <a:solidFill>
-                  <a:srgbClr val="1E3A8A"/>
+                  <a:srgbClr val="3C1C5A"/>
                 </a:solidFill>
                 <a:latin typeface="Microsoft YaHei"/>
                 <a:ea typeface="Microsoft YaHei"/>
@@ -14566,7 +14566,7 @@
           <a:lstStyle/>
           <a:p>
             <a:pPr algn="r"/>
-            <a:fld id="{B66ADE2F-85CA-4958-9D74-89FFC6F6A5B7}" type="slidenum">
+            <a:fld id="{4AF6B916-F1B0-4FFF-A1E8-4137C8D5628F}" type="slidenum">
               <a:rPr lang="en-US" sz="1000">
                 <a:solidFill>
                   <a:srgbClr val="9AA3B0"/>
@@ -14708,7 +14708,7 @@
             <a:r>
               <a:rPr sz="1200" b="1">
                 <a:solidFill>
-                  <a:srgbClr val="1D4ED8"/>
+                  <a:srgbClr val="5B2C86"/>
                 </a:solidFill>
                 <a:latin typeface="Microsoft YaHei"/>
                 <a:ea typeface="Microsoft YaHei"/>
@@ -14784,7 +14784,7 @@
                       </a:solidFill>
                     </a:lnB>
                     <a:solidFill>
-                      <a:srgbClr val="1D4ED8"/>
+                      <a:srgbClr val="5B2C86"/>
                     </a:solidFill>
                   </a:tcPr>
                 </a:tc>
@@ -14829,7 +14829,7 @@
                       </a:solidFill>
                     </a:lnB>
                     <a:solidFill>
-                      <a:srgbClr val="1D4ED8"/>
+                      <a:srgbClr val="5B2C86"/>
                     </a:solidFill>
                   </a:tcPr>
                 </a:tc>
@@ -14874,7 +14874,7 @@
                       </a:solidFill>
                     </a:lnB>
                     <a:solidFill>
-                      <a:srgbClr val="1D4ED8"/>
+                      <a:srgbClr val="5B2C86"/>
                     </a:solidFill>
                   </a:tcPr>
                 </a:tc>
@@ -15591,7 +15591,7 @@
           <a:lstStyle/>
           <a:p>
             <a:pPr algn="r"/>
-            <a:fld id="{E7FC3159-9582-4614-A066-46C9A1D67AA4}" type="slidenum">
+            <a:fld id="{5464346B-76B0-4B9E-B856-DE1BF6EDCE1C}" type="slidenum">
               <a:rPr lang="en-US" sz="1000">
                 <a:solidFill>
                   <a:srgbClr val="9AA3B0"/>
@@ -15733,7 +15733,7 @@
             <a:r>
               <a:rPr sz="1200" b="1">
                 <a:solidFill>
-                  <a:srgbClr val="1D4ED8"/>
+                  <a:srgbClr val="5B2C86"/>
                 </a:solidFill>
                 <a:latin typeface="Microsoft YaHei"/>
                 <a:ea typeface="Microsoft YaHei"/>
@@ -15805,7 +15805,7 @@
             <a:avLst/>
           </a:prstGeom>
           <a:solidFill>
-            <a:srgbClr val="1D4ED8"/>
+            <a:srgbClr val="5B2C86"/>
           </a:solidFill>
           <a:ln>
             <a:noFill/>
@@ -15864,7 +15864,7 @@
             <a:r>
               <a:rPr sz="1500" b="1">
                 <a:solidFill>
-                  <a:srgbClr val="1D4ED8"/>
+                  <a:srgbClr val="5B2C86"/>
                 </a:solidFill>
                 <a:latin typeface="Microsoft YaHei"/>
                 <a:ea typeface="Microsoft YaHei"/>
@@ -16369,7 +16369,7 @@
           <a:lstStyle/>
           <a:p>
             <a:pPr algn="r"/>
-            <a:fld id="{6EBA6E46-ED12-46D4-B6A8-77153A5D5B2F}" type="slidenum">
+            <a:fld id="{7EB78D24-0132-4504-B6A7-ED987E02AFC6}" type="slidenum">
               <a:rPr lang="en-US" sz="1000">
                 <a:solidFill>
                   <a:srgbClr val="9AA3B0"/>
@@ -16466,7 +16466,7 @@
             <a:avLst/>
           </a:prstGeom>
           <a:solidFill>
-            <a:srgbClr val="1D4ED8"/>
+            <a:srgbClr val="5B2C86"/>
           </a:solidFill>
           <a:ln>
             <a:noFill/>
@@ -16833,7 +16833,7 @@
             <a:r>
               <a:rPr sz="1200" b="1">
                 <a:solidFill>
-                  <a:srgbClr val="1D4ED8"/>
+                  <a:srgbClr val="5B2C86"/>
                 </a:solidFill>
                 <a:latin typeface="Microsoft YaHei"/>
                 <a:ea typeface="Microsoft YaHei"/>
@@ -17016,7 +17016,7 @@
           <a:lstStyle/>
           <a:p>
             <a:pPr algn="r"/>
-            <a:fld id="{BF0BA4ED-7E09-450E-A607-78D533EDB2A3}" type="slidenum">
+            <a:fld id="{439DEB9A-04B8-4007-99EB-3A8324BE61FC}" type="slidenum">
               <a:rPr lang="en-US" sz="1000">
                 <a:solidFill>
                   <a:srgbClr val="9AA3B0"/>
@@ -17158,7 +17158,7 @@
             <a:r>
               <a:rPr sz="1200" b="1">
                 <a:solidFill>
-                  <a:srgbClr val="1D4ED8"/>
+                  <a:srgbClr val="5B2C86"/>
                 </a:solidFill>
                 <a:latin typeface="Microsoft YaHei"/>
                 <a:ea typeface="Microsoft YaHei"/>
@@ -17233,7 +17233,7 @@
                       </a:solidFill>
                     </a:lnB>
                     <a:solidFill>
-                      <a:srgbClr val="1D4ED8"/>
+                      <a:srgbClr val="5B2C86"/>
                     </a:solidFill>
                   </a:tcPr>
                 </a:tc>
@@ -17278,7 +17278,7 @@
                       </a:solidFill>
                     </a:lnB>
                     <a:solidFill>
-                      <a:srgbClr val="1D4ED8"/>
+                      <a:srgbClr val="5B2C86"/>
                     </a:solidFill>
                   </a:tcPr>
                 </a:tc>
@@ -17678,7 +17678,7 @@
           <a:lstStyle/>
           <a:p>
             <a:pPr algn="r"/>
-            <a:fld id="{89A49474-FA67-469A-B126-D09C114F6D73}" type="slidenum">
+            <a:fld id="{95EE32A0-7000-4AC4-B316-805DD1951649}" type="slidenum">
               <a:rPr lang="en-US" sz="1000">
                 <a:solidFill>
                   <a:srgbClr val="9AA3B0"/>
@@ -17820,7 +17820,7 @@
             <a:r>
               <a:rPr sz="1200" b="1">
                 <a:solidFill>
-                  <a:srgbClr val="1D4ED8"/>
+                  <a:srgbClr val="5B2C86"/>
                 </a:solidFill>
                 <a:latin typeface="Microsoft YaHei"/>
                 <a:ea typeface="Microsoft YaHei"/>
@@ -18070,11 +18070,11 @@
             </a:avLst>
           </a:prstGeom>
           <a:solidFill>
-            <a:srgbClr val="EDE9FE"/>
+            <a:srgbClr val="DBEAFE"/>
           </a:solidFill>
           <a:ln w="19050">
             <a:solidFill>
-              <a:srgbClr val="6D28D9"/>
+              <a:srgbClr val="2563EB"/>
             </a:solidFill>
           </a:ln>
           <a:effectLst/>
@@ -18101,7 +18101,7 @@
             <a:r>
               <a:rPr sz="1200" b="1">
                 <a:solidFill>
-                  <a:srgbClr val="5B21B6"/>
+                  <a:srgbClr val="1E3A8A"/>
                 </a:solidFill>
                 <a:latin typeface="Microsoft YaHei"/>
                 <a:ea typeface="Microsoft YaHei"/>
@@ -18115,7 +18115,7 @@
             <a:r>
               <a:rPr sz="1200" b="1">
                 <a:solidFill>
-                  <a:srgbClr val="5B21B6"/>
+                  <a:srgbClr val="1E3A8A"/>
                 </a:solidFill>
                 <a:latin typeface="Microsoft YaHei"/>
                 <a:ea typeface="Microsoft YaHei"/>
@@ -18362,11 +18362,11 @@
             </a:avLst>
           </a:prstGeom>
           <a:solidFill>
-            <a:srgbClr val="DBEAFE"/>
+            <a:srgbClr val="ECE5F3"/>
           </a:solidFill>
           <a:ln w="19050">
             <a:solidFill>
-              <a:srgbClr val="1D4ED8"/>
+              <a:srgbClr val="5B2C86"/>
             </a:solidFill>
           </a:ln>
           <a:effectLst/>
@@ -18393,7 +18393,7 @@
             <a:r>
               <a:rPr sz="1200" b="1">
                 <a:solidFill>
-                  <a:srgbClr val="1E3A8A"/>
+                  <a:srgbClr val="3C1C5A"/>
                 </a:solidFill>
                 <a:latin typeface="Microsoft YaHei"/>
                 <a:ea typeface="Microsoft YaHei"/>
@@ -18826,7 +18826,7 @@
           <a:lstStyle/>
           <a:p>
             <a:pPr algn="r"/>
-            <a:fld id="{8EFAB514-9CA8-4D98-AC96-2B31006639CA}" type="slidenum">
+            <a:fld id="{2CA11F63-686F-4876-8644-CB9EEB95071C}" type="slidenum">
               <a:rPr lang="en-US" sz="1000">
                 <a:solidFill>
                   <a:srgbClr val="9AA3B0"/>
@@ -18968,7 +18968,7 @@
             <a:r>
               <a:rPr sz="1200" b="1">
                 <a:solidFill>
-                  <a:srgbClr val="1D4ED8"/>
+                  <a:srgbClr val="5B2C86"/>
                 </a:solidFill>
                 <a:latin typeface="Microsoft YaHei"/>
                 <a:ea typeface="Microsoft YaHei"/>
@@ -19043,7 +19043,7 @@
                       </a:solidFill>
                     </a:lnB>
                     <a:solidFill>
-                      <a:srgbClr val="1D4ED8"/>
+                      <a:srgbClr val="5B2C86"/>
                     </a:solidFill>
                   </a:tcPr>
                 </a:tc>
@@ -19088,7 +19088,7 @@
                       </a:solidFill>
                     </a:lnB>
                     <a:solidFill>
-                      <a:srgbClr val="1D4ED8"/>
+                      <a:srgbClr val="5B2C86"/>
                     </a:solidFill>
                   </a:tcPr>
                 </a:tc>
@@ -19856,7 +19856,7 @@
           <a:lstStyle/>
           <a:p>
             <a:pPr algn="r"/>
-            <a:fld id="{35BB1B18-C49D-42A8-9D90-08A772F588D3}" type="slidenum">
+            <a:fld id="{D98D6138-5AFE-4EFE-8913-0F8A343CF53B}" type="slidenum">
               <a:rPr lang="en-US" sz="1000">
                 <a:solidFill>
                   <a:srgbClr val="9AA3B0"/>
@@ -19998,7 +19998,7 @@
             <a:r>
               <a:rPr sz="1200" b="1">
                 <a:solidFill>
-                  <a:srgbClr val="1D4ED8"/>
+                  <a:srgbClr val="5B2C86"/>
                 </a:solidFill>
                 <a:latin typeface="Microsoft YaHei"/>
                 <a:ea typeface="Microsoft YaHei"/>
@@ -20529,11 +20529,11 @@
             </a:avLst>
           </a:prstGeom>
           <a:solidFill>
-            <a:srgbClr val="1D4ED8"/>
+            <a:srgbClr val="5B2C86"/>
           </a:solidFill>
           <a:ln w="19050">
             <a:solidFill>
-              <a:srgbClr val="1D4ED8"/>
+              <a:srgbClr val="5B2C86"/>
             </a:solidFill>
           </a:ln>
           <a:effectLst/>
@@ -20933,7 +20933,7 @@
           <a:lstStyle/>
           <a:p>
             <a:pPr algn="r"/>
-            <a:fld id="{4ABC1A06-EAA3-4DCF-A80C-D9205131F43F}" type="slidenum">
+            <a:fld id="{42F1067F-1E17-4814-9163-DEA869A7DC1C}" type="slidenum">
               <a:rPr lang="en-US" sz="1000">
                 <a:solidFill>
                   <a:srgbClr val="9AA3B0"/>
@@ -21030,7 +21030,7 @@
             <a:avLst/>
           </a:prstGeom>
           <a:solidFill>
-            <a:srgbClr val="1D4ED8"/>
+            <a:srgbClr val="5B2C86"/>
           </a:solidFill>
           <a:ln>
             <a:noFill/>

</xml_diff>

<commit_message>
② literature-figure pipeline: tools/extract_figs.py (PDF→bitmap figs, gitignored) + citation infra (refs slide + split credit=) — real lit figures slotted in locally with attribution; refs cite DVD Lec6 + Rabaey/Weste-Harris/EDA docs
Co-Authored-By: Claude Opus 4.8 <noreply@anthropic.com>
</commit_message>
<xml_diff>
--- a/IC_Backend_Notes/slides/05_Floorplan.pptx
+++ b/IC_Backend_Notes/slides/05_Floorplan.pptx
@@ -38,6 +38,7 @@
     <p:sldId id="286" r:id="rId37"/>
     <p:sldId id="287" r:id="rId38"/>
     <p:sldId id="288" r:id="rId39"/>
+    <p:sldId id="289" r:id="rId40"/>
   </p:sldIdLst>
   <p:sldSz cx="12191695" cy="6858000" type="screen4x3"/>
   <p:notesSz cx="6858000" cy="9144000"/>
@@ -1255,7 +1256,7 @@
           <a:lstStyle/>
           <a:p>
             <a:pPr algn="r"/>
-            <a:fld id="{6E8B3E89-C49D-467E-AB94-605CECFD88F8}" type="slidenum">
+            <a:fld id="{26468E3A-924E-4B3C-9135-B0B6D8AE1A13}" type="slidenum">
               <a:rPr lang="en-US" sz="1000">
                 <a:solidFill>
                   <a:srgbClr val="9AA3B0"/>
@@ -1541,7 +1542,7 @@
           <a:lstStyle/>
           <a:p>
             <a:pPr algn="r"/>
-            <a:fld id="{E3DD3AB2-0510-410F-B64C-129601EDBD26}" type="slidenum">
+            <a:fld id="{D43EBF63-24FE-4FD3-BC0B-9004F16CADD1}" type="slidenum">
               <a:rPr lang="en-US" sz="1000">
                 <a:solidFill>
                   <a:srgbClr val="9AA3B0"/>
@@ -3066,7 +3067,7 @@
           <a:lstStyle/>
           <a:p>
             <a:pPr algn="r"/>
-            <a:fld id="{D792C2F3-A87A-4711-949E-FDEAF874B49B}" type="slidenum">
+            <a:fld id="{81A47BFB-918C-4777-9765-CE04489C2C35}" type="slidenum">
               <a:rPr lang="en-US" sz="1000">
                 <a:solidFill>
                   <a:srgbClr val="9AA3B0"/>
@@ -3415,7 +3416,7 @@
           <a:lstStyle/>
           <a:p>
             <a:pPr algn="r"/>
-            <a:fld id="{05D0599E-13F1-40A8-ADDA-AF14D9309E8E}" type="slidenum">
+            <a:fld id="{84DB0FB9-2F7C-49C0-AC9F-CD163032F1F3}" type="slidenum">
               <a:rPr lang="en-US" sz="1000">
                 <a:solidFill>
                   <a:srgbClr val="9AA3B0"/>
@@ -4303,7 +4304,7 @@
           <a:lstStyle/>
           <a:p>
             <a:pPr algn="r"/>
-            <a:fld id="{D17CE609-3FCF-4333-A882-74C6C9C17B38}" type="slidenum">
+            <a:fld id="{21BBCAC7-EF4F-4641-B08E-1A16FC3A5E34}" type="slidenum">
               <a:rPr lang="en-US" sz="1000">
                 <a:solidFill>
                   <a:srgbClr val="9AA3B0"/>
@@ -4631,7 +4632,7 @@
           <a:lstStyle/>
           <a:p>
             <a:pPr algn="r"/>
-            <a:fld id="{7CF0AA60-7AF4-4269-A445-1D29284019F6}" type="slidenum">
+            <a:fld id="{060F251C-8434-4703-876A-B167918D7DCE}" type="slidenum">
               <a:rPr lang="en-US" sz="1000">
                 <a:solidFill>
                   <a:srgbClr val="9AA3B0"/>
@@ -5000,7 +5001,7 @@
           <a:lstStyle/>
           <a:p>
             <a:pPr algn="r"/>
-            <a:fld id="{A956C56B-0251-47FE-8A11-B5C750D71A0C}" type="slidenum">
+            <a:fld id="{96CE9CE1-D393-480B-AD59-5A6AE951EB60}" type="slidenum">
               <a:rPr lang="en-US" sz="1000">
                 <a:solidFill>
                   <a:srgbClr val="9AA3B0"/>
@@ -6721,7 +6722,7 @@
           <a:lstStyle/>
           <a:p>
             <a:pPr algn="r"/>
-            <a:fld id="{3586B4F2-0C28-4BE5-A58A-726BD9EBC984}" type="slidenum">
+            <a:fld id="{226F8767-55E7-4A9F-A5B2-F15EF7EC4108}" type="slidenum">
               <a:rPr lang="en-US" sz="1000">
                 <a:solidFill>
                   <a:srgbClr val="9AA3B0"/>
@@ -7070,7 +7071,7 @@
           <a:lstStyle/>
           <a:p>
             <a:pPr algn="r"/>
-            <a:fld id="{D2E3B47C-9628-4C22-90B6-48A0DF75C077}" type="slidenum">
+            <a:fld id="{0A699673-9D98-46B7-A590-88A3DB288D60}" type="slidenum">
               <a:rPr lang="en-US" sz="1000">
                 <a:solidFill>
                   <a:srgbClr val="9AA3B0"/>
@@ -7985,7 +7986,7 @@
           <a:lstStyle/>
           <a:p>
             <a:pPr algn="r"/>
-            <a:fld id="{A37E75E5-58FD-4A3B-ADEE-9681317FCFB2}" type="slidenum">
+            <a:fld id="{5472F832-2FC2-4991-9197-802971B60CBF}" type="slidenum">
               <a:rPr lang="en-US" sz="1000">
                 <a:solidFill>
                   <a:srgbClr val="9AA3B0"/>
@@ -8271,7 +8272,7 @@
           <a:lstStyle/>
           <a:p>
             <a:pPr algn="r"/>
-            <a:fld id="{B8768618-3920-42B3-9698-1A64F7412E7A}" type="slidenum">
+            <a:fld id="{9239AC88-C54A-49A6-B4CA-EAA2A4DD612A}" type="slidenum">
               <a:rPr lang="en-US" sz="1000">
                 <a:solidFill>
                   <a:srgbClr val="9AA3B0"/>
@@ -9474,7 +9475,7 @@
           <a:lstStyle/>
           <a:p>
             <a:pPr algn="r"/>
-            <a:fld id="{B5FBFEED-3149-4F16-9637-4CBDA3944868}" type="slidenum">
+            <a:fld id="{8B3DB672-5CF5-42A2-BD0B-6245BDB1E975}" type="slidenum">
               <a:rPr lang="en-US" sz="1000">
                 <a:solidFill>
                   <a:srgbClr val="9AA3B0"/>
@@ -9760,7 +9761,7 @@
           <a:lstStyle/>
           <a:p>
             <a:pPr algn="r"/>
-            <a:fld id="{7516CB47-EDC7-4A92-8D75-9D045F9CFBC5}" type="slidenum">
+            <a:fld id="{EB4717BE-7470-489C-A5F4-BE58337D4873}" type="slidenum">
               <a:rPr lang="en-US" sz="1000">
                 <a:solidFill>
                   <a:srgbClr val="9AA3B0"/>
@@ -10108,7 +10109,7 @@
           <a:lstStyle/>
           <a:p>
             <a:pPr algn="r"/>
-            <a:fld id="{2B4405D7-B010-40A3-ABF1-E868526AF826}" type="slidenum">
+            <a:fld id="{FFD06EEC-8184-4426-AA8B-97C7BB6AB9AE}" type="slidenum">
               <a:rPr lang="en-US" sz="1000">
                 <a:solidFill>
                   <a:srgbClr val="9AA3B0"/>
@@ -10996,7 +10997,7 @@
           <a:lstStyle/>
           <a:p>
             <a:pPr algn="r"/>
-            <a:fld id="{CB84C097-F0B3-4055-B8AE-BE2DAE7C9AF6}" type="slidenum">
+            <a:fld id="{007F612F-F08C-44C3-B547-51833E9EC33A}" type="slidenum">
               <a:rPr lang="en-US" sz="1000">
                 <a:solidFill>
                   <a:srgbClr val="9AA3B0"/>
@@ -11842,7 +11843,7 @@
           <a:lstStyle/>
           <a:p>
             <a:pPr algn="r"/>
-            <a:fld id="{5A4F3989-2EE1-4AE0-AA94-94982535D6CF}" type="slidenum">
+            <a:fld id="{B2A55598-CCDB-4866-8CB5-102A02DD75C9}" type="slidenum">
               <a:rPr lang="en-US" sz="1000">
                 <a:solidFill>
                   <a:srgbClr val="9AA3B0"/>
@@ -12167,7 +12168,7 @@
           <a:lstStyle/>
           <a:p>
             <a:pPr algn="r"/>
-            <a:fld id="{247312BC-9882-4A12-BDF9-7066A999910F}" type="slidenum">
+            <a:fld id="{C179494A-4AF1-4B17-B296-21E880338D05}" type="slidenum">
               <a:rPr lang="en-US" sz="1000">
                 <a:solidFill>
                   <a:srgbClr val="9AA3B0"/>
@@ -12516,7 +12517,7 @@
           <a:lstStyle/>
           <a:p>
             <a:pPr algn="r"/>
-            <a:fld id="{09964746-187C-4D9B-8220-80521EC732ED}" type="slidenum">
+            <a:fld id="{0485F65C-F555-43A2-AC3B-AF30540AE13C}" type="slidenum">
               <a:rPr lang="en-US" sz="1000">
                 <a:solidFill>
                   <a:srgbClr val="9AA3B0"/>
@@ -14566,7 +14567,7 @@
           <a:lstStyle/>
           <a:p>
             <a:pPr algn="r"/>
-            <a:fld id="{4AF6B916-F1B0-4FFF-A1E8-4137C8D5628F}" type="slidenum">
+            <a:fld id="{1297AC00-AD63-4736-8E04-34C3DDF0BCFC}" type="slidenum">
               <a:rPr lang="en-US" sz="1000">
                 <a:solidFill>
                   <a:srgbClr val="9AA3B0"/>
@@ -15591,7 +15592,7 @@
           <a:lstStyle/>
           <a:p>
             <a:pPr algn="r"/>
-            <a:fld id="{5464346B-76B0-4B9E-B856-DE1BF6EDCE1C}" type="slidenum">
+            <a:fld id="{6B88BED6-1CD5-4CE6-9FC2-6137BDC01FE8}" type="slidenum">
               <a:rPr lang="en-US" sz="1000">
                 <a:solidFill>
                   <a:srgbClr val="9AA3B0"/>
@@ -16369,7 +16370,7 @@
           <a:lstStyle/>
           <a:p>
             <a:pPr algn="r"/>
-            <a:fld id="{7EB78D24-0132-4504-B6A7-ED987E02AFC6}" type="slidenum">
+            <a:fld id="{6B501AC7-CA2B-438B-99B4-D053F610BA99}" type="slidenum">
               <a:rPr lang="en-US" sz="1000">
                 <a:solidFill>
                   <a:srgbClr val="9AA3B0"/>
@@ -16390,6 +16391,310 @@
 </file>
 
 <file path=ppt/slides/slide33.xml><?xml version="1.0" encoding="utf-8"?>
+<p:sld xmlns:a="http://schemas.openxmlformats.org/drawingml/2006/main" xmlns:p="http://schemas.openxmlformats.org/presentationml/2006/main" xmlns:r="http://schemas.openxmlformats.org/officeDocument/2006/relationships">
+  <p:cSld>
+    <p:spTree>
+      <p:nvGrpSpPr>
+        <p:cNvPr id="1" name=""/>
+        <p:cNvGrpSpPr/>
+        <p:nvPr/>
+      </p:nvGrpSpPr>
+      <p:grpSpPr/>
+      <p:sp>
+        <p:nvSpPr>
+          <p:cNvPr id="2" name="TextBox 1"/>
+          <p:cNvSpPr txBox="1"/>
+          <p:nvPr/>
+        </p:nvSpPr>
+        <p:spPr>
+          <a:xfrm>
+            <a:off x="777240" y="384048"/>
+            <a:ext cx="8412480" cy="731520"/>
+          </a:xfrm>
+          <a:prstGeom prst="rect">
+            <a:avLst/>
+          </a:prstGeom>
+          <a:noFill/>
+        </p:spPr>
+        <p:txBody>
+          <a:bodyPr wrap="square" anchor="t" lIns="25400" rIns="25400" tIns="25400" bIns="25400">
+            <a:spAutoFit/>
+          </a:bodyPr>
+          <a:lstStyle/>
+          <a:p>
+            <a:pPr algn="l">
+              <a:spcAft>
+                <a:spcPts val="600"/>
+              </a:spcAft>
+            </a:pPr>
+            <a:r>
+              <a:rPr sz="2800" b="1">
+                <a:solidFill>
+                  <a:srgbClr val="1A1F2B"/>
+                </a:solidFill>
+                <a:latin typeface="Microsoft YaHei"/>
+                <a:ea typeface="Microsoft YaHei"/>
+                <a:cs typeface="Microsoft YaHei"/>
+              </a:rPr>
+              <a:t>参考文献 References</a:t>
+            </a:r>
+          </a:p>
+        </p:txBody>
+      </p:sp>
+      <p:sp>
+        <p:nvSpPr>
+          <p:cNvPr id="3" name="TextBox 2"/>
+          <p:cNvSpPr txBox="1"/>
+          <p:nvPr/>
+        </p:nvSpPr>
+        <p:spPr>
+          <a:xfrm>
+            <a:off x="795528" y="1078992"/>
+            <a:ext cx="8412480" cy="457200"/>
+          </a:xfrm>
+          <a:prstGeom prst="rect">
+            <a:avLst/>
+          </a:prstGeom>
+          <a:noFill/>
+        </p:spPr>
+        <p:txBody>
+          <a:bodyPr wrap="square" anchor="t" lIns="25400" rIns="25400" tIns="25400" bIns="25400">
+            <a:spAutoFit/>
+          </a:bodyPr>
+          <a:lstStyle/>
+          <a:p>
+            <a:pPr algn="l">
+              <a:spcAft>
+                <a:spcPts val="600"/>
+              </a:spcAft>
+            </a:pPr>
+            <a:r>
+              <a:rPr sz="1400" b="0">
+                <a:solidFill>
+                  <a:srgbClr val="3A4252"/>
+                </a:solidFill>
+                <a:latin typeface="Microsoft YaHei"/>
+                <a:ea typeface="Microsoft YaHei"/>
+                <a:cs typeface="Microsoft YaHei"/>
+              </a:rPr>
+              <a:t>本讲内容与图示来源（引用文献插图时图下另标“来源：…”）</a:t>
+            </a:r>
+          </a:p>
+        </p:txBody>
+      </p:sp>
+      <p:sp>
+        <p:nvSpPr>
+          <p:cNvPr id="4" name="TextBox 3"/>
+          <p:cNvSpPr txBox="1"/>
+          <p:nvPr/>
+        </p:nvSpPr>
+        <p:spPr>
+          <a:xfrm>
+            <a:off x="8549640" y="502920"/>
+            <a:ext cx="3063240" cy="365760"/>
+          </a:xfrm>
+          <a:prstGeom prst="rect">
+            <a:avLst/>
+          </a:prstGeom>
+          <a:noFill/>
+        </p:spPr>
+        <p:txBody>
+          <a:bodyPr wrap="square" anchor="t" lIns="25400" rIns="25400" tIns="25400" bIns="25400">
+            <a:spAutoFit/>
+          </a:bodyPr>
+          <a:lstStyle/>
+          <a:p>
+            <a:pPr algn="r">
+              <a:spcAft>
+                <a:spcPts val="600"/>
+              </a:spcAft>
+            </a:pPr>
+            <a:r>
+              <a:rPr sz="1200" b="1">
+                <a:solidFill>
+                  <a:srgbClr val="5B2C86"/>
+                </a:solidFill>
+                <a:latin typeface="Microsoft YaHei"/>
+                <a:ea typeface="Microsoft YaHei"/>
+                <a:cs typeface="Microsoft YaHei"/>
+              </a:rPr>
+              <a:t>第5章 · 工具流程与调试收束</a:t>
+            </a:r>
+          </a:p>
+        </p:txBody>
+      </p:sp>
+      <p:sp>
+        <p:nvSpPr>
+          <p:cNvPr id="5" name="TextBox 4"/>
+          <p:cNvSpPr txBox="1"/>
+          <p:nvPr/>
+        </p:nvSpPr>
+        <p:spPr>
+          <a:xfrm>
+            <a:off x="640080" y="1627632"/>
+            <a:ext cx="10972800" cy="4754880"/>
+          </a:xfrm>
+          <a:prstGeom prst="rect">
+            <a:avLst/>
+          </a:prstGeom>
+          <a:noFill/>
+        </p:spPr>
+        <p:txBody>
+          <a:bodyPr wrap="square" anchor="t" lIns="25400" rIns="25400" tIns="25400" bIns="25400">
+            <a:normAutofit/>
+          </a:bodyPr>
+          <a:lstStyle/>
+          <a:p>
+            <a:pPr algn="l">
+              <a:lnSpc>
+                <a:spcPct val="120000"/>
+              </a:lnSpc>
+              <a:spcAft>
+                <a:spcPts val="900"/>
+              </a:spcAft>
+            </a:pPr>
+            <a:r>
+              <a:rPr sz="1250" b="0">
+                <a:solidFill>
+                  <a:srgbClr val="1A1F2B"/>
+                </a:solidFill>
+                <a:latin typeface="Microsoft YaHei"/>
+                <a:ea typeface="Microsoft YaHei"/>
+                <a:cs typeface="Microsoft YaHei"/>
+              </a:rPr>
+              <a:t>[1]  Adam Teman. Digital VLSI Design (DVD), Lecture 6 — Import Design and Floorplan. Bar-Ilan University, Course 83-612. https://enicslabs.com/academic-courses/dvd-english/</a:t>
+            </a:r>
+          </a:p>
+          <a:p>
+            <a:pPr algn="l">
+              <a:lnSpc>
+                <a:spcPct val="120000"/>
+              </a:lnSpc>
+              <a:spcAft>
+                <a:spcPts val="900"/>
+              </a:spcAft>
+            </a:pPr>
+            <a:r>
+              <a:rPr sz="1250" b="0">
+                <a:solidFill>
+                  <a:srgbClr val="1A1F2B"/>
+                </a:solidFill>
+                <a:latin typeface="Microsoft YaHei"/>
+                <a:ea typeface="Microsoft YaHei"/>
+                <a:cs typeface="Microsoft YaHei"/>
+              </a:rPr>
+              <a:t>[2]  J. M. Rabaey, A. Chandrakasan, B. Nikolić. Digital Integrated Circuits: A Design Perspective. Prentice Hall.</a:t>
+            </a:r>
+          </a:p>
+          <a:p>
+            <a:pPr algn="l">
+              <a:lnSpc>
+                <a:spcPct val="120000"/>
+              </a:lnSpc>
+              <a:spcAft>
+                <a:spcPts val="900"/>
+              </a:spcAft>
+            </a:pPr>
+            <a:r>
+              <a:rPr sz="1250" b="0">
+                <a:solidFill>
+                  <a:srgbClr val="1A1F2B"/>
+                </a:solidFill>
+                <a:latin typeface="Microsoft YaHei"/>
+                <a:ea typeface="Microsoft YaHei"/>
+                <a:cs typeface="Microsoft YaHei"/>
+              </a:rPr>
+              <a:t>[3]  N. H. E. Weste, D. M. Harris. CMOS VLSI Design: A Circuits and Systems Perspective. Addison-Wesley.</a:t>
+            </a:r>
+          </a:p>
+          <a:p>
+            <a:pPr algn="l">
+              <a:lnSpc>
+                <a:spcPct val="120000"/>
+              </a:lnSpc>
+              <a:spcAft>
+                <a:spcPts val="900"/>
+              </a:spcAft>
+            </a:pPr>
+            <a:r>
+              <a:rPr sz="1250" b="0">
+                <a:solidFill>
+                  <a:srgbClr val="1A1F2B"/>
+                </a:solidFill>
+                <a:latin typeface="Microsoft YaHei"/>
+                <a:ea typeface="Microsoft YaHei"/>
+                <a:cs typeface="Microsoft YaHei"/>
+              </a:rPr>
+              <a:t>[4]  IDESA / EPFL — Digital IC design tutorials.</a:t>
+            </a:r>
+          </a:p>
+          <a:p>
+            <a:pPr algn="l">
+              <a:lnSpc>
+                <a:spcPct val="120000"/>
+              </a:lnSpc>
+              <a:spcAft>
+                <a:spcPts val="900"/>
+              </a:spcAft>
+            </a:pPr>
+            <a:r>
+              <a:rPr sz="1250" b="0">
+                <a:solidFill>
+                  <a:srgbClr val="1A1F2B"/>
+                </a:solidFill>
+                <a:latin typeface="Microsoft YaHei"/>
+                <a:ea typeface="Microsoft YaHei"/>
+                <a:cs typeface="Microsoft YaHei"/>
+              </a:rPr>
+              <a:t>[5]  Cadence Innovus User Guide; Synopsys IC Compiler II / Fusion Compiler User Guide（命令与流程参考）.</a:t>
+            </a:r>
+          </a:p>
+        </p:txBody>
+      </p:sp>
+      <p:sp>
+        <p:nvSpPr>
+          <p:cNvPr id="6" name="TextBox 5"/>
+          <p:cNvSpPr txBox="1"/>
+          <p:nvPr/>
+        </p:nvSpPr>
+        <p:spPr>
+          <a:xfrm>
+            <a:off x="9875520" y="6446520"/>
+            <a:ext cx="2011680" cy="365760"/>
+          </a:xfrm>
+          <a:prstGeom prst="rect">
+            <a:avLst/>
+          </a:prstGeom>
+          <a:noFill/>
+        </p:spPr>
+        <p:txBody>
+          <a:bodyPr wrap="none" lIns="0" rIns="0" tIns="0" bIns="0">
+            <a:spAutoFit/>
+          </a:bodyPr>
+          <a:lstStyle/>
+          <a:p>
+            <a:pPr algn="r"/>
+            <a:fld id="{FE4CAB6C-1C20-49E3-85A8-E7F03409DB63}" type="slidenum">
+              <a:rPr lang="en-US" sz="1000">
+                <a:solidFill>
+                  <a:srgbClr val="9AA3B0"/>
+                </a:solidFill>
+                <a:latin typeface="Microsoft YaHei"/>
+              </a:rPr>
+              <a:t>1</a:t>
+            </a:fld>
+          </a:p>
+        </p:txBody>
+      </p:sp>
+    </p:spTree>
+  </p:cSld>
+  <p:clrMapOvr>
+    <a:masterClrMapping/>
+  </p:clrMapOvr>
+</p:sld>
+</file>
+
+<file path=ppt/slides/slide34.xml><?xml version="1.0" encoding="utf-8"?>
 <p:sld xmlns:a="http://schemas.openxmlformats.org/drawingml/2006/main" xmlns:p="http://schemas.openxmlformats.org/presentationml/2006/main" xmlns:r="http://schemas.openxmlformats.org/officeDocument/2006/relationships">
   <p:cSld>
     <p:bg>
@@ -17016,7 +17321,7 @@
           <a:lstStyle/>
           <a:p>
             <a:pPr algn="r"/>
-            <a:fld id="{439DEB9A-04B8-4007-99EB-3A8324BE61FC}" type="slidenum">
+            <a:fld id="{5145B92B-2A45-4134-BD44-9B540D62B311}" type="slidenum">
               <a:rPr lang="en-US" sz="1000">
                 <a:solidFill>
                   <a:srgbClr val="9AA3B0"/>
@@ -17678,7 +17983,7 @@
           <a:lstStyle/>
           <a:p>
             <a:pPr algn="r"/>
-            <a:fld id="{95EE32A0-7000-4AC4-B316-805DD1951649}" type="slidenum">
+            <a:fld id="{43DA38F1-15DD-4B03-B3B1-56E7013AF4A2}" type="slidenum">
               <a:rPr lang="en-US" sz="1000">
                 <a:solidFill>
                   <a:srgbClr val="9AA3B0"/>
@@ -18826,7 +19131,7 @@
           <a:lstStyle/>
           <a:p>
             <a:pPr algn="r"/>
-            <a:fld id="{2CA11F63-686F-4876-8644-CB9EEB95071C}" type="slidenum">
+            <a:fld id="{340FFDBE-4531-44EA-A777-3AE29E63DC81}" type="slidenum">
               <a:rPr lang="en-US" sz="1000">
                 <a:solidFill>
                   <a:srgbClr val="9AA3B0"/>
@@ -19856,7 +20161,7 @@
           <a:lstStyle/>
           <a:p>
             <a:pPr algn="r"/>
-            <a:fld id="{D98D6138-5AFE-4EFE-8913-0F8A343CF53B}" type="slidenum">
+            <a:fld id="{B4D4F3B6-FBE5-47D2-A9B2-E205BCA3D6D6}" type="slidenum">
               <a:rPr lang="en-US" sz="1000">
                 <a:solidFill>
                   <a:srgbClr val="9AA3B0"/>
@@ -20933,7 +21238,7 @@
           <a:lstStyle/>
           <a:p>
             <a:pPr algn="r"/>
-            <a:fld id="{42F1067F-1E17-4814-9163-DEA869A7DC1C}" type="slidenum">
+            <a:fld id="{6FB661B7-BCFE-4D6C-A143-9AC83307BCD0}" type="slidenum">
               <a:rPr lang="en-US" sz="1000">
                 <a:solidFill>
                   <a:srgbClr val="9AA3B0"/>

</xml_diff>

<commit_message>
deck: prose-align to note (1.3/2.1/3.2 bullets->prose, genuine lists/tables kept); de-draft (refs/appendix meta text removed); citations off title pages (cover/close keep only 整理 J.C byline; course source only on refs page)
Co-Authored-By: Claude Opus 4.8 <noreply@anthropic.com>
</commit_message>
<xml_diff>
--- a/IC_Backend_Notes/slides/05_Floorplan.pptx
+++ b/IC_Backend_Notes/slides/05_Floorplan.pptx
@@ -727,7 +727,7 @@
                 <a:ea typeface="Microsoft YaHei"/>
                 <a:cs typeface="Microsoft YaHei"/>
               </a:rPr>
-              <a:t>数字 IC 后端 · 从 RTL 到 GDS · DVD Lecture 6</a:t>
+              <a:t>数字 IC 后端 · 从 RTL 到 GDS</a:t>
             </a:r>
           </a:p>
         </p:txBody>
@@ -935,7 +935,7 @@
                 <a:ea typeface="Microsoft YaHei"/>
                 <a:cs typeface="Microsoft YaHei"/>
               </a:rPr>
-              <a:t>整理 J.C  ·  源自 Digital VLSI Design (DVD), Prof. Adam Teman, Bar-Ilan University (83-612)</a:t>
+              <a:t>整理 J.C</a:t>
             </a:r>
           </a:p>
         </p:txBody>
@@ -1120,7 +1120,7 @@
                 <a:ea typeface="Microsoft YaHei"/>
                 <a:cs typeface="Microsoft YaHei"/>
               </a:rPr>
-              <a:t>▪  几何由外到内：Die ＞ IO/Pad Ring ＞ Core ＞（宏 + 标准单元行）</a:t>
+              <a:t>芯片几何由外到内：晶粒 Die ＞ IO / 焊盘环 ＞ 核心区 Core ＞（宏单元 + 标准单元行）。IO 引脚常由前端、系统或封装侧先提出，但物理设计必须参与评审。</a:t>
             </a:r>
           </a:p>
           <a:p>
@@ -1141,7 +1141,7 @@
                 <a:ea typeface="Microsoft YaHei"/>
                 <a:cs typeface="Microsoft YaHei"/>
               </a:rPr>
-              <a:t>▪  IO 引脚由前端 / 系统 / 封装提出，但物理设计必须参与评审</a:t>
+              <a:t>原因有二：一是 IO 不像逻辑晶体管随工艺快速缩小，IO 单元与焊盘面积非常贵；二是 IO 不只传信号还负责供电，电源 / 地焊盘的数量与位置直接影响 IR 压降与 EM。</a:t>
             </a:r>
           </a:p>
           <a:p>
@@ -1162,70 +1162,7 @@
                 <a:ea typeface="Microsoft YaHei"/>
                 <a:cs typeface="Microsoft YaHei"/>
               </a:rPr>
-              <a:t>▪  原因一：IO 不像逻辑随工艺缩小，IO 单元与焊盘面积非常贵</a:t>
-            </a:r>
-          </a:p>
-          <a:p>
-            <a:pPr algn="l">
-              <a:lnSpc>
-                <a:spcPct val="116000"/>
-              </a:lnSpc>
-              <a:spcAft>
-                <a:spcPts val="800"/>
-              </a:spcAft>
-            </a:pPr>
-            <a:r>
-              <a:rPr sz="1400" b="0">
-                <a:solidFill>
-                  <a:srgbClr val="1A1F2B"/>
-                </a:solidFill>
-                <a:latin typeface="Microsoft YaHei"/>
-                <a:ea typeface="Microsoft YaHei"/>
-                <a:cs typeface="Microsoft YaHei"/>
-              </a:rPr>
-              <a:t>▪  原因二：IO 还负责供电，电源 / 地焊盘的数量与位置直接影响 IR 与 EM</a:t>
-            </a:r>
-          </a:p>
-          <a:p>
-            <a:pPr algn="l">
-              <a:lnSpc>
-                <a:spcPct val="116000"/>
-              </a:lnSpc>
-              <a:spcAft>
-                <a:spcPts val="800"/>
-              </a:spcAft>
-            </a:pPr>
-            <a:r>
-              <a:rPr sz="1400" b="0">
-                <a:solidFill>
-                  <a:srgbClr val="1A1F2B"/>
-                </a:solidFill>
-                <a:latin typeface="Microsoft YaHei"/>
-                <a:ea typeface="Microsoft YaHei"/>
-                <a:cs typeface="Microsoft YaHei"/>
-              </a:rPr>
-              <a:t>▪  核心受限：尺寸由逻辑规模 / 宏 / 布线资源决定 → 优化利用率、宏摆放与布线资源</a:t>
-            </a:r>
-          </a:p>
-          <a:p>
-            <a:pPr algn="l">
-              <a:lnSpc>
-                <a:spcPct val="116000"/>
-              </a:lnSpc>
-              <a:spcAft>
-                <a:spcPts val="800"/>
-              </a:spcAft>
-            </a:pPr>
-            <a:r>
-              <a:rPr sz="1400" b="0">
-                <a:solidFill>
-                  <a:srgbClr val="1A1F2B"/>
-                </a:solidFill>
-                <a:latin typeface="Microsoft YaHei"/>
-                <a:ea typeface="Microsoft YaHei"/>
-                <a:cs typeface="Microsoft YaHei"/>
-              </a:rPr>
-              <a:t>▪  焊盘受限：尺寸由 IO 数 / 焊盘间距 / 封装决定，晶粒不能再小 → 优化 IO 环与封装协同</a:t>
+              <a:t>选尺寸先判断是核心受限还是焊盘受限：核心受限由逻辑规模、宏与布线资源决定芯片大小，重点优化利用率与摆放；焊盘受限由 IO 数量、焊盘间距与封装引脚决定、晶粒已不能再小，重点优化 IO 环与封装协同。</a:t>
             </a:r>
           </a:p>
         </p:txBody>
@@ -1277,7 +1214,7 @@
           <a:lstStyle/>
           <a:p>
             <a:pPr algn="r"/>
-            <a:fld id="{3D9AC620-ED5E-4753-A684-CAC8EB1DCB07}" type="slidenum">
+            <a:fld id="{A6437D06-4038-448D-88CC-81CD360FE3A6}" type="slidenum">
               <a:rPr lang="en-US" sz="1000">
                 <a:solidFill>
                   <a:srgbClr val="9AA3B0"/>
@@ -1563,7 +1500,7 @@
           <a:lstStyle/>
           <a:p>
             <a:pPr algn="r"/>
-            <a:fld id="{C20E49C7-0FE7-43FA-BB5A-12866AC7536E}" type="slidenum">
+            <a:fld id="{DC1887BD-20A1-4BB7-A7F1-CDAF034056A9}" type="slidenum">
               <a:rPr lang="en-US" sz="1000">
                 <a:solidFill>
                   <a:srgbClr val="9AA3B0"/>
@@ -3088,7 +3025,7 @@
           <a:lstStyle/>
           <a:p>
             <a:pPr algn="r"/>
-            <a:fld id="{172B1ABA-8AD7-4260-A0E7-B97972BCC4E7}" type="slidenum">
+            <a:fld id="{E7DDB67B-98E6-407E-9659-875BA88AD062}" type="slidenum">
               <a:rPr lang="en-US" sz="1000">
                 <a:solidFill>
                   <a:srgbClr val="9AA3B0"/>
@@ -3437,7 +3374,7 @@
           <a:lstStyle/>
           <a:p>
             <a:pPr algn="r"/>
-            <a:fld id="{471FD68B-04E4-402F-BE5D-56333875CC88}" type="slidenum">
+            <a:fld id="{B458D3F0-E539-480D-9DA0-1440B81C336E}" type="slidenum">
               <a:rPr lang="en-US" sz="1000">
                 <a:solidFill>
                   <a:srgbClr val="9AA3B0"/>
@@ -4325,7 +4262,7 @@
           <a:lstStyle/>
           <a:p>
             <a:pPr algn="r"/>
-            <a:fld id="{580B34B3-BF07-4A98-870A-5F2DFC691422}" type="slidenum">
+            <a:fld id="{BA55D077-AB17-48C6-9F68-635AA67E0D70}" type="slidenum">
               <a:rPr lang="en-US" sz="1000">
                 <a:solidFill>
                   <a:srgbClr val="9AA3B0"/>
@@ -4674,7 +4611,7 @@
           <a:lstStyle/>
           <a:p>
             <a:pPr algn="r"/>
-            <a:fld id="{7EF33A2B-6EDF-4D5B-BCD0-E74BED0B514A}" type="slidenum">
+            <a:fld id="{2AEB5B36-0C23-4058-AC11-A253FA69472A}" type="slidenum">
               <a:rPr lang="en-US" sz="1000">
                 <a:solidFill>
                   <a:srgbClr val="9AA3B0"/>
@@ -5043,7 +4980,7 @@
           <a:lstStyle/>
           <a:p>
             <a:pPr algn="r"/>
-            <a:fld id="{0D01850F-55DF-4BE3-A9B4-5DC6E2A565D6}" type="slidenum">
+            <a:fld id="{EA3C49F4-F5D8-46B2-8D18-DB5A66ECD251}" type="slidenum">
               <a:rPr lang="en-US" sz="1000">
                 <a:solidFill>
                   <a:srgbClr val="9AA3B0"/>
@@ -6764,7 +6701,7 @@
           <a:lstStyle/>
           <a:p>
             <a:pPr algn="r"/>
-            <a:fld id="{AB900C57-1A24-4407-9C89-0742FD320398}" type="slidenum">
+            <a:fld id="{A9B595E5-F347-4152-A841-EE4F3B1A37B4}" type="slidenum">
               <a:rPr lang="en-US" sz="1000">
                 <a:solidFill>
                   <a:srgbClr val="9AA3B0"/>
@@ -6956,7 +6893,7 @@
                 <a:ea typeface="Microsoft YaHei"/>
                 <a:cs typeface="Microsoft YaHei"/>
               </a:rPr>
-              <a:t>▪  芯片级约束必须映射成模块级约束</a:t>
+              <a:t>芯片级约束必须映射成模块级约束。例如顶层某输入到模块的路径预算为 1.5 ns，模块实现时就要在模块边界建立对应的输入 / 输出延迟、时钟不确定性、负载与驱动单元约束。</a:t>
             </a:r>
           </a:p>
           <a:p>
@@ -6977,7 +6914,7 @@
                 <a:ea typeface="Microsoft YaHei"/>
                 <a:cs typeface="Microsoft YaHei"/>
               </a:rPr>
-              <a:t>▪  示例：顶层某输入到模块的路径预算 1.5 ns，模块实现时要在边界还原它</a:t>
+              <a:t>预算合理时，各模块独立收敛后全芯片才容易收敛；预算不合理时，单个模块看似通过，全芯片仍可能失败。</a:t>
             </a:r>
           </a:p>
           <a:p>
@@ -6998,91 +6935,7 @@
                 <a:ea typeface="Microsoft YaHei"/>
                 <a:cs typeface="Microsoft YaHei"/>
               </a:rPr>
-              <a:t>▪  在模块边界建立输入 / 输出延迟、时钟不确定度、负载与驱动单元约束</a:t>
-            </a:r>
-          </a:p>
-          <a:p>
-            <a:pPr algn="l">
-              <a:lnSpc>
-                <a:spcPct val="116000"/>
-              </a:lnSpc>
-              <a:spcAft>
-                <a:spcPts val="800"/>
-              </a:spcAft>
-            </a:pPr>
-            <a:r>
-              <a:rPr sz="1400" b="0">
-                <a:solidFill>
-                  <a:srgbClr val="1A1F2B"/>
-                </a:solidFill>
-                <a:latin typeface="Microsoft YaHei"/>
-                <a:ea typeface="Microsoft YaHei"/>
-                <a:cs typeface="Microsoft YaHei"/>
-              </a:rPr>
-              <a:t>▪  预算合理 → 各模块独立收敛后，全芯片才容易收敛</a:t>
-            </a:r>
-          </a:p>
-          <a:p>
-            <a:pPr algn="l">
-              <a:lnSpc>
-                <a:spcPct val="116000"/>
-              </a:lnSpc>
-              <a:spcAft>
-                <a:spcPts val="800"/>
-              </a:spcAft>
-            </a:pPr>
-            <a:r>
-              <a:rPr sz="1400" b="0">
-                <a:solidFill>
-                  <a:srgbClr val="1A1F2B"/>
-                </a:solidFill>
-                <a:latin typeface="Microsoft YaHei"/>
-                <a:ea typeface="Microsoft YaHei"/>
-                <a:cs typeface="Microsoft YaHei"/>
-              </a:rPr>
-              <a:t>▪  预算不合理 → 单模块看似通过，全芯片仍可能失败</a:t>
-            </a:r>
-          </a:p>
-          <a:p>
-            <a:pPr algn="l">
-              <a:lnSpc>
-                <a:spcPct val="116000"/>
-              </a:lnSpc>
-              <a:spcAft>
-                <a:spcPts val="800"/>
-              </a:spcAft>
-            </a:pPr>
-            <a:r>
-              <a:rPr sz="1400" b="0">
-                <a:solidFill>
-                  <a:srgbClr val="1A1F2B"/>
-                </a:solidFill>
-                <a:latin typeface="Microsoft YaHei"/>
-                <a:ea typeface="Microsoft YaHei"/>
-                <a:cs typeface="Microsoft YaHei"/>
-              </a:rPr>
-              <a:t>▪  ILM（接口逻辑模型）只保留接口相关逻辑、隐藏模块内部细节</a:t>
-            </a:r>
-          </a:p>
-          <a:p>
-            <a:pPr algn="l">
-              <a:lnSpc>
-                <a:spcPct val="116000"/>
-              </a:lnSpc>
-              <a:spcAft>
-                <a:spcPts val="800"/>
-              </a:spcAft>
-            </a:pPr>
-            <a:r>
-              <a:rPr sz="1400" b="0">
-                <a:solidFill>
-                  <a:srgbClr val="1A1F2B"/>
-                </a:solidFill>
-                <a:latin typeface="Microsoft YaHei"/>
-                <a:ea typeface="Microsoft YaHei"/>
-                <a:cs typeface="Microsoft YaHei"/>
-              </a:rPr>
-              <a:t>▪  ETM（抽取时序模型）也提供抽象时序模型；二者都让全芯片分析更快可控</a:t>
+              <a:t>接口逻辑模型（ILM）保留模块边界附近与接口相关的逻辑、隐藏内部细节；抽取时序模型（ETM）也提供模块的抽象时序模型。二者都让全芯片时序分析更快、更可控。</a:t>
             </a:r>
           </a:p>
         </p:txBody>
@@ -7134,7 +6987,7 @@
           <a:lstStyle/>
           <a:p>
             <a:pPr algn="r"/>
-            <a:fld id="{71AFE404-E83A-428B-861F-6838B02A23B1}" type="slidenum">
+            <a:fld id="{8505DB03-B7EA-46B9-978C-423033855CC0}" type="slidenum">
               <a:rPr lang="en-US" sz="1000">
                 <a:solidFill>
                   <a:srgbClr val="9AA3B0"/>
@@ -8049,7 +7902,7 @@
           <a:lstStyle/>
           <a:p>
             <a:pPr algn="r"/>
-            <a:fld id="{CB1D2EC1-4CB7-4B7F-AF8E-1CC84E9DF10B}" type="slidenum">
+            <a:fld id="{FC64D1D3-9A4C-4594-A8E8-34C4B969DEEE}" type="slidenum">
               <a:rPr lang="en-US" sz="1000">
                 <a:solidFill>
                   <a:srgbClr val="9AA3B0"/>
@@ -8335,7 +8188,7 @@
           <a:lstStyle/>
           <a:p>
             <a:pPr algn="r"/>
-            <a:fld id="{3CD8F268-4DF2-4E9D-A7CE-CFF53D76A45C}" type="slidenum">
+            <a:fld id="{BAE1BC54-A1AD-4E2E-9B2F-050A96434575}" type="slidenum">
               <a:rPr lang="en-US" sz="1000">
                 <a:solidFill>
                   <a:srgbClr val="9AA3B0"/>
@@ -9538,7 +9391,7 @@
           <a:lstStyle/>
           <a:p>
             <a:pPr algn="r"/>
-            <a:fld id="{8758FACF-C825-46E8-B25C-52EB1FF021CA}" type="slidenum">
+            <a:fld id="{CC60E58D-01DF-47B4-A49F-193E3415C135}" type="slidenum">
               <a:rPr lang="en-US" sz="1000">
                 <a:solidFill>
                   <a:srgbClr val="9AA3B0"/>
@@ -9824,7 +9677,7 @@
           <a:lstStyle/>
           <a:p>
             <a:pPr algn="r"/>
-            <a:fld id="{0CAF6D91-E7B7-4D36-B4E3-ECCEA11E811D}" type="slidenum">
+            <a:fld id="{21F99A55-2EDD-4C22-8F03-0942DB56F1DC}" type="slidenum">
               <a:rPr lang="en-US" sz="1000">
                 <a:solidFill>
                   <a:srgbClr val="9AA3B0"/>
@@ -10172,7 +10025,7 @@
           <a:lstStyle/>
           <a:p>
             <a:pPr algn="r"/>
-            <a:fld id="{4A8E33A4-6D26-4A65-BAB0-442046E3E256}" type="slidenum">
+            <a:fld id="{28F9EBC9-206E-4F4D-882F-00645FF684F2}" type="slidenum">
               <a:rPr lang="en-US" sz="1000">
                 <a:solidFill>
                   <a:srgbClr val="9AA3B0"/>
@@ -11060,7 +10913,7 @@
           <a:lstStyle/>
           <a:p>
             <a:pPr algn="r"/>
-            <a:fld id="{8A5FB7A0-A674-4182-87BB-3382791C08EB}" type="slidenum">
+            <a:fld id="{C2F51288-4FBD-4CD1-AFCD-CE91392DA1DF}" type="slidenum">
               <a:rPr lang="en-US" sz="1000">
                 <a:solidFill>
                   <a:srgbClr val="9AA3B0"/>
@@ -12222,7 +12075,7 @@
           <a:lstStyle/>
           <a:p>
             <a:pPr algn="r"/>
-            <a:fld id="{8CB7A4C2-0A44-49BB-A011-E8FA6927E2A8}" type="slidenum">
+            <a:fld id="{C8C694CC-D9CB-4C05-B1FE-B3351571D86F}" type="slidenum">
               <a:rPr lang="en-US" sz="1000">
                 <a:solidFill>
                   <a:srgbClr val="9AA3B0"/>
@@ -12547,7 +12400,7 @@
           <a:lstStyle/>
           <a:p>
             <a:pPr algn="r"/>
-            <a:fld id="{11ED5538-AE99-4B67-9108-1E328FF70A24}" type="slidenum">
+            <a:fld id="{AAC23B0A-657A-4361-A6D3-B26B28489181}" type="slidenum">
               <a:rPr lang="en-US" sz="1000">
                 <a:solidFill>
                   <a:srgbClr val="9AA3B0"/>
@@ -12896,7 +12749,7 @@
           <a:lstStyle/>
           <a:p>
             <a:pPr algn="r"/>
-            <a:fld id="{ADA2650E-A7AB-459C-B8EC-040FDBC0F7E1}" type="slidenum">
+            <a:fld id="{03680C92-1862-4999-B742-A695008D55EC}" type="slidenum">
               <a:rPr lang="en-US" sz="1000">
                 <a:solidFill>
                   <a:srgbClr val="9AA3B0"/>
@@ -14988,7 +14841,7 @@
           <a:lstStyle/>
           <a:p>
             <a:pPr algn="r"/>
-            <a:fld id="{73D875F2-2433-4CDE-9AF5-C3F3014E4147}" type="slidenum">
+            <a:fld id="{6946E410-55CB-4109-91A5-417A03494C32}" type="slidenum">
               <a:rPr lang="en-US" sz="1000">
                 <a:solidFill>
                   <a:srgbClr val="9AA3B0"/>
@@ -16013,7 +15866,7 @@
           <a:lstStyle/>
           <a:p>
             <a:pPr algn="r"/>
-            <a:fld id="{004AF44E-2BD7-47C1-894F-A03D7A3397D6}" type="slidenum">
+            <a:fld id="{7ABA08C2-8E69-4765-8542-96BB29E9CDAB}" type="slidenum">
               <a:rPr lang="en-US" sz="1000">
                 <a:solidFill>
                   <a:srgbClr val="9AA3B0"/>
@@ -16120,7 +15973,7 @@
                 <a:ea typeface="Microsoft YaHei"/>
                 <a:cs typeface="Microsoft YaHei"/>
               </a:rPr>
-              <a:t>选项随版本而异；坑：Innovus margin 四值为 LBRT</a:t>
+              <a:t>选项随工具版本而异；Innovus margin 四值顺序为 L / B / R / T</a:t>
             </a:r>
           </a:p>
         </p:txBody>
@@ -16791,7 +16644,7 @@
           <a:lstStyle/>
           <a:p>
             <a:pPr algn="r"/>
-            <a:fld id="{58A8FCE5-6422-447F-92F4-F423A2DF1237}" type="slidenum">
+            <a:fld id="{44813FB9-E5BA-4CC8-B752-01422A0D0F08}" type="slidenum">
               <a:rPr lang="en-US" sz="1000">
                 <a:solidFill>
                   <a:srgbClr val="9AA3B0"/>
@@ -16898,7 +16751,7 @@
                 <a:ea typeface="Microsoft YaHei"/>
                 <a:cs typeface="Microsoft YaHei"/>
               </a:rPr>
-              <a:t>本讲内容与图示来源（引用文献插图时图下另标“来源：…”）</a:t>
+              <a:t>本讲内容与图示来源</a:t>
             </a:r>
           </a:p>
         </p:txBody>
@@ -17095,7 +16948,7 @@
           <a:lstStyle/>
           <a:p>
             <a:pPr algn="r"/>
-            <a:fld id="{757DA1F4-3B43-496C-96F5-AB9D7B547792}" type="slidenum">
+            <a:fld id="{FE3A6736-2548-4A0B-813C-65BE4D87E753}" type="slidenum">
               <a:rPr lang="en-US" sz="1000">
                 <a:solidFill>
                   <a:srgbClr val="9AA3B0"/>
@@ -17298,7 +17151,7 @@
                 <a:ea typeface="Microsoft YaHei"/>
                 <a:cs typeface="Microsoft YaHei"/>
               </a:rPr>
-              <a:t>下一讲：Placement 标准单元布局（DVD Lecture 7）</a:t>
+              <a:t>下一讲：Placement 标准单元布局</a:t>
             </a:r>
           </a:p>
         </p:txBody>
@@ -17424,7 +17277,7 @@
                 <a:ea typeface="Microsoft YaHei"/>
                 <a:cs typeface="Microsoft YaHei"/>
               </a:rPr>
-              <a:t>整理 J.C  ·  源自 Digital VLSI Design (DVD), Prof. Adam Teman, Bar-Ilan University (83-612)</a:t>
+              <a:t>整理 J.C</a:t>
             </a:r>
           </a:p>
         </p:txBody>
@@ -17763,7 +17616,7 @@
           <a:lstStyle/>
           <a:p>
             <a:pPr algn="r"/>
-            <a:fld id="{F21CFACB-7354-4239-817B-B0520FDEABBB}" type="slidenum">
+            <a:fld id="{46AC6ED3-BDF8-4870-81EA-517355931AAA}" type="slidenum">
               <a:rPr lang="en-US" sz="1000">
                 <a:solidFill>
                   <a:srgbClr val="9AA3B0"/>
@@ -18425,7 +18278,7 @@
           <a:lstStyle/>
           <a:p>
             <a:pPr algn="r"/>
-            <a:fld id="{1652741C-7F6F-4B73-93CB-B5B9C1DC9DA0}" type="slidenum">
+            <a:fld id="{302C7DE5-7754-4686-899F-CD63E7446ED8}" type="slidenum">
               <a:rPr lang="en-US" sz="1000">
                 <a:solidFill>
                   <a:srgbClr val="9AA3B0"/>
@@ -18617,7 +18470,7 @@
                 <a:ea typeface="Microsoft YaHei"/>
                 <a:cs typeface="Microsoft YaHei"/>
               </a:rPr>
-              <a:t>①  映射：netlist（谁连谁）→ floorplan（谁放哪、怎么连、怎么供电）</a:t>
+              <a:t>Floorplan 本质是一个映射：把“谁连谁”的逻辑网表，落成实例、IO、宏单元与电源网络在芯片上如何摆放、连接与供电。</a:t>
             </a:r>
           </a:p>
           <a:p>
@@ -18638,7 +18491,7 @@
                 <a:ea typeface="Microsoft YaHei"/>
                 <a:cs typeface="Microsoft YaHei"/>
               </a:rPr>
-              <a:t>②  同时服务三个目标：减小芯片面积</a:t>
+              <a:t>它要同时服务三个目标——减小芯片面积、减小关键路径延迟、减小布线拥塞。</a:t>
             </a:r>
           </a:p>
           <a:p>
@@ -18659,7 +18512,7 @@
                 <a:ea typeface="Microsoft YaHei"/>
                 <a:cs typeface="Microsoft YaHei"/>
               </a:rPr>
-              <a:t>③  减小关键路径延迟</a:t>
+              <a:t>但三者天然冲突：面积压太紧会拥塞，通道留太宽会浪费面积，电源网格做太强又抢走信号布线资源。</a:t>
             </a:r>
           </a:p>
           <a:p>
@@ -18680,49 +18533,7 @@
                 <a:ea typeface="Microsoft YaHei"/>
                 <a:cs typeface="Microsoft YaHei"/>
               </a:rPr>
-              <a:t>④  减小布线拥塞</a:t>
-            </a:r>
-          </a:p>
-          <a:p>
-            <a:pPr algn="l">
-              <a:lnSpc>
-                <a:spcPct val="116000"/>
-              </a:lnSpc>
-              <a:spcAft>
-                <a:spcPts val="800"/>
-              </a:spcAft>
-            </a:pPr>
-            <a:r>
-              <a:rPr sz="1400" b="0">
-                <a:solidFill>
-                  <a:srgbClr val="1A1F2B"/>
-                </a:solidFill>
-                <a:latin typeface="Microsoft YaHei"/>
-                <a:ea typeface="Microsoft YaHei"/>
-                <a:cs typeface="Microsoft YaHei"/>
-              </a:rPr>
-              <a:t>⑤  三者天然冲突：压面积→拥塞，留宽通道→浪费，强网格→抢信号</a:t>
-            </a:r>
-          </a:p>
-          <a:p>
-            <a:pPr algn="l">
-              <a:lnSpc>
-                <a:spcPct val="116000"/>
-              </a:lnSpc>
-              <a:spcAft>
-                <a:spcPts val="800"/>
-              </a:spcAft>
-            </a:pPr>
-            <a:r>
-              <a:rPr sz="1400" b="0">
-                <a:solidFill>
-                  <a:srgbClr val="1A1F2B"/>
-                </a:solidFill>
-                <a:latin typeface="Microsoft YaHei"/>
-                <a:ea typeface="Microsoft YaHei"/>
-                <a:cs typeface="Microsoft YaHei"/>
-              </a:rPr>
-              <a:t>⑥  因此是面积/时序/拥塞/供电的第一轮工程取舍</a:t>
+              <a:t>因此 Floorplan 是在面积、时序、拥塞与供电可靠性之间做的第一轮工程取舍。</a:t>
             </a:r>
           </a:p>
         </p:txBody>
@@ -19573,7 +19384,7 @@
           <a:lstStyle/>
           <a:p>
             <a:pPr algn="r"/>
-            <a:fld id="{9EE8ABDC-9FF7-4FC8-A1A3-3ACCCF2E6C1B}" type="slidenum">
+            <a:fld id="{165EEA66-F258-45D1-9AC8-12ACD17323C5}" type="slidenum">
               <a:rPr lang="en-US" sz="1000">
                 <a:solidFill>
                   <a:srgbClr val="9AA3B0"/>
@@ -20603,7 +20414,7 @@
           <a:lstStyle/>
           <a:p>
             <a:pPr algn="r"/>
-            <a:fld id="{C010EE06-19D0-407C-89CC-D97F0475598F}" type="slidenum">
+            <a:fld id="{680ECFCD-E8F2-4DC1-B12C-BD5C265540FD}" type="slidenum">
               <a:rPr lang="en-US" sz="1000">
                 <a:solidFill>
                   <a:srgbClr val="9AA3B0"/>
@@ -21680,7 +21491,7 @@
           <a:lstStyle/>
           <a:p>
             <a:pPr algn="r"/>
-            <a:fld id="{D58063B6-B2B4-4C1B-B8C0-479E0D300BBF}" type="slidenum">
+            <a:fld id="{DC11EB09-84D9-4EAD-9608-70D8F8002071}" type="slidenum">
               <a:rPr lang="en-US" sz="1000">
                 <a:solidFill>
                   <a:srgbClr val="9AA3B0"/>

</xml_diff>

<commit_message>
deck: insert real openly-licensed figures (2) — CC0 Intel i9-13900K die shot on 2.1 geometry, CC BY-SA 4.0 wire-bond photo on 3.3; per-figure credit= + refs entries; images redistributable with attribution so committed
Co-Authored-By: Claude Opus 4.8 <noreply@anthropic.com>
</commit_message>
<xml_diff>
--- a/IC_Backend_Notes/slides/05_Floorplan.pptx
+++ b/IC_Backend_Notes/slides/05_Floorplan.pptx
@@ -1169,7 +1169,7 @@
       </p:sp>
       <p:pic>
         <p:nvPicPr>
-          <p:cNvPr id="6" name="Picture 5" descr="f03_geometry.png"/>
+          <p:cNvPr id="6" name="Picture 5" descr="ext_die_i9_cc0.jpg"/>
           <p:cNvPicPr>
             <a:picLocks noChangeAspect="1"/>
           </p:cNvPicPr>
@@ -1183,8 +1183,8 @@
         </p:blipFill>
         <p:spPr>
           <a:xfrm>
-            <a:off x="5681540" y="1554480"/>
-            <a:ext cx="5873359" cy="4800600"/>
+            <a:off x="5486400" y="2512185"/>
+            <a:ext cx="6263640" cy="2885189"/>
           </a:xfrm>
           <a:prstGeom prst="rect">
             <a:avLst/>
@@ -1194,6 +1194,47 @@
       <p:sp>
         <p:nvSpPr>
           <p:cNvPr id="7" name="TextBox 6"/>
+          <p:cNvSpPr txBox="1"/>
+          <p:nvPr/>
+        </p:nvSpPr>
+        <p:spPr>
+          <a:xfrm>
+            <a:off x="5486400" y="6382512"/>
+            <a:ext cx="6263640" cy="274320"/>
+          </a:xfrm>
+          <a:prstGeom prst="rect">
+            <a:avLst/>
+          </a:prstGeom>
+          <a:noFill/>
+        </p:spPr>
+        <p:txBody>
+          <a:bodyPr wrap="square" anchor="t" lIns="25400" rIns="25400" tIns="25400" bIns="25400">
+            <a:spAutoFit/>
+          </a:bodyPr>
+          <a:lstStyle/>
+          <a:p>
+            <a:pPr algn="r">
+              <a:spcAft>
+                <a:spcPts val="600"/>
+              </a:spcAft>
+            </a:pPr>
+            <a:r>
+              <a:rPr sz="900" b="0">
+                <a:solidFill>
+                  <a:srgbClr val="6B7280"/>
+                </a:solidFill>
+                <a:latin typeface="Microsoft YaHei"/>
+                <a:ea typeface="Microsoft YaHei"/>
+                <a:cs typeface="Microsoft YaHei"/>
+              </a:rPr>
+              <a:t>来源：Intel i9-13900K die · Fritzchens Fritz / JmsDoug · CC0 · Wikimedia</a:t>
+            </a:r>
+          </a:p>
+        </p:txBody>
+      </p:sp>
+      <p:sp>
+        <p:nvSpPr>
+          <p:cNvPr id="8" name="TextBox 7"/>
           <p:cNvSpPr txBox="1"/>
           <p:nvPr/>
         </p:nvSpPr>
@@ -1214,7 +1255,7 @@
           <a:lstStyle/>
           <a:p>
             <a:pPr algn="r"/>
-            <a:fld id="{A6437D06-4038-448D-88CC-81CD360FE3A6}" type="slidenum">
+            <a:fld id="{9BD82241-F179-42FA-AC60-F29E6F4D0254}" type="slidenum">
               <a:rPr lang="en-US" sz="1000">
                 <a:solidFill>
                   <a:srgbClr val="9AA3B0"/>
@@ -1500,7 +1541,7 @@
           <a:lstStyle/>
           <a:p>
             <a:pPr algn="r"/>
-            <a:fld id="{DC1887BD-20A1-4BB7-A7F1-CDAF034056A9}" type="slidenum">
+            <a:fld id="{E5A8EF17-8F24-40E8-AEC9-D43609BD5FD7}" type="slidenum">
               <a:rPr lang="en-US" sz="1000">
                 <a:solidFill>
                   <a:srgbClr val="9AA3B0"/>
@@ -3025,7 +3066,7 @@
           <a:lstStyle/>
           <a:p>
             <a:pPr algn="r"/>
-            <a:fld id="{E7DDB67B-98E6-407E-9659-875BA88AD062}" type="slidenum">
+            <a:fld id="{D044295A-3522-4B6A-A9F3-885957409CC4}" type="slidenum">
               <a:rPr lang="en-US" sz="1000">
                 <a:solidFill>
                   <a:srgbClr val="9AA3B0"/>
@@ -3374,7 +3415,7 @@
           <a:lstStyle/>
           <a:p>
             <a:pPr algn="r"/>
-            <a:fld id="{B458D3F0-E539-480D-9DA0-1440B81C336E}" type="slidenum">
+            <a:fld id="{0ABB82C4-7048-40AF-AB5E-FD81468B4F2C}" type="slidenum">
               <a:rPr lang="en-US" sz="1000">
                 <a:solidFill>
                   <a:srgbClr val="9AA3B0"/>
@@ -4262,7 +4303,7 @@
           <a:lstStyle/>
           <a:p>
             <a:pPr algn="r"/>
-            <a:fld id="{BA55D077-AB17-48C6-9F68-635AA67E0D70}" type="slidenum">
+            <a:fld id="{B5383D26-216E-400B-AC23-6852B5697097}" type="slidenum">
               <a:rPr lang="en-US" sz="1000">
                 <a:solidFill>
                   <a:srgbClr val="9AA3B0"/>
@@ -4611,7 +4652,7 @@
           <a:lstStyle/>
           <a:p>
             <a:pPr algn="r"/>
-            <a:fld id="{2AEB5B36-0C23-4058-AC11-A253FA69472A}" type="slidenum">
+            <a:fld id="{33182F35-427C-48D3-8707-2E06E6A6EDF8}" type="slidenum">
               <a:rPr lang="en-US" sz="1000">
                 <a:solidFill>
                   <a:srgbClr val="9AA3B0"/>
@@ -4980,7 +5021,7 @@
           <a:lstStyle/>
           <a:p>
             <a:pPr algn="r"/>
-            <a:fld id="{EA3C49F4-F5D8-46B2-8D18-DB5A66ECD251}" type="slidenum">
+            <a:fld id="{9D3AE567-4CC5-49E8-A7AB-0DAEBA26CC63}" type="slidenum">
               <a:rPr lang="en-US" sz="1000">
                 <a:solidFill>
                   <a:srgbClr val="9AA3B0"/>
@@ -6701,7 +6742,7 @@
           <a:lstStyle/>
           <a:p>
             <a:pPr algn="r"/>
-            <a:fld id="{A9B595E5-F347-4152-A841-EE4F3B1A37B4}" type="slidenum">
+            <a:fld id="{18AC8B10-D58C-4234-AC15-35D31111FB40}" type="slidenum">
               <a:rPr lang="en-US" sz="1000">
                 <a:solidFill>
                   <a:srgbClr val="9AA3B0"/>
@@ -6987,7 +7028,7 @@
           <a:lstStyle/>
           <a:p>
             <a:pPr algn="r"/>
-            <a:fld id="{8505DB03-B7EA-46B9-978C-423033855CC0}" type="slidenum">
+            <a:fld id="{A77B7D21-5A6B-413F-873E-820B6DA93546}" type="slidenum">
               <a:rPr lang="en-US" sz="1000">
                 <a:solidFill>
                   <a:srgbClr val="9AA3B0"/>
@@ -7902,7 +7943,7 @@
           <a:lstStyle/>
           <a:p>
             <a:pPr algn="r"/>
-            <a:fld id="{FC64D1D3-9A4C-4594-A8E8-34C4B969DEEE}" type="slidenum">
+            <a:fld id="{30DBF914-408A-4F77-81E0-F4458FDB6553}" type="slidenum">
               <a:rPr lang="en-US" sz="1000">
                 <a:solidFill>
                   <a:srgbClr val="9AA3B0"/>
@@ -8143,7 +8184,7 @@
       </p:sp>
       <p:pic>
         <p:nvPicPr>
-          <p:cNvPr id="6" name="Picture 5" descr="f13_iopad.png"/>
+          <p:cNvPr id="6" name="Picture 5" descr="ext_wirebond_ccbysa.jpg"/>
           <p:cNvPicPr>
             <a:picLocks noChangeAspect="1"/>
           </p:cNvPicPr>
@@ -8157,8 +8198,8 @@
         </p:blipFill>
         <p:spPr>
           <a:xfrm>
-            <a:off x="5486400" y="1752495"/>
-            <a:ext cx="6263640" cy="4404568"/>
+            <a:off x="5617845" y="1554480"/>
+            <a:ext cx="6000750" cy="4800600"/>
           </a:xfrm>
           <a:prstGeom prst="rect">
             <a:avLst/>
@@ -8168,6 +8209,47 @@
       <p:sp>
         <p:nvSpPr>
           <p:cNvPr id="7" name="TextBox 6"/>
+          <p:cNvSpPr txBox="1"/>
+          <p:nvPr/>
+        </p:nvSpPr>
+        <p:spPr>
+          <a:xfrm>
+            <a:off x="5486400" y="6382512"/>
+            <a:ext cx="6263640" cy="274320"/>
+          </a:xfrm>
+          <a:prstGeom prst="rect">
+            <a:avLst/>
+          </a:prstGeom>
+          <a:noFill/>
+        </p:spPr>
+        <p:txBody>
+          <a:bodyPr wrap="square" anchor="t" lIns="25400" rIns="25400" tIns="25400" bIns="25400">
+            <a:spAutoFit/>
+          </a:bodyPr>
+          <a:lstStyle/>
+          <a:p>
+            <a:pPr algn="r">
+              <a:spcAft>
+                <a:spcPts val="600"/>
+              </a:spcAft>
+            </a:pPr>
+            <a:r>
+              <a:rPr sz="900" b="0">
+                <a:solidFill>
+                  <a:srgbClr val="6B7280"/>
+                </a:solidFill>
+                <a:latin typeface="Microsoft YaHei"/>
+                <a:ea typeface="Microsoft YaHei"/>
+                <a:cs typeface="Microsoft YaHei"/>
+              </a:rPr>
+              <a:t>来源：Wire-bond 实拍 · Mister rf · CC BY-SA 4.0 · Wikimedia</a:t>
+            </a:r>
+          </a:p>
+        </p:txBody>
+      </p:sp>
+      <p:sp>
+        <p:nvSpPr>
+          <p:cNvPr id="8" name="TextBox 7"/>
           <p:cNvSpPr txBox="1"/>
           <p:nvPr/>
         </p:nvSpPr>
@@ -8188,7 +8270,7 @@
           <a:lstStyle/>
           <a:p>
             <a:pPr algn="r"/>
-            <a:fld id="{BAE1BC54-A1AD-4E2E-9B2F-050A96434575}" type="slidenum">
+            <a:fld id="{1C604057-5A15-418D-87BF-45AB069DAB42}" type="slidenum">
               <a:rPr lang="en-US" sz="1000">
                 <a:solidFill>
                   <a:srgbClr val="9AA3B0"/>
@@ -9391,7 +9473,7 @@
           <a:lstStyle/>
           <a:p>
             <a:pPr algn="r"/>
-            <a:fld id="{CC60E58D-01DF-47B4-A49F-193E3415C135}" type="slidenum">
+            <a:fld id="{E376F830-6BD0-44BA-886B-CCD1B4361FA3}" type="slidenum">
               <a:rPr lang="en-US" sz="1000">
                 <a:solidFill>
                   <a:srgbClr val="9AA3B0"/>
@@ -9677,7 +9759,7 @@
           <a:lstStyle/>
           <a:p>
             <a:pPr algn="r"/>
-            <a:fld id="{21F99A55-2EDD-4C22-8F03-0942DB56F1DC}" type="slidenum">
+            <a:fld id="{30FA3A08-6C6D-48EE-93BF-BF7584130D03}" type="slidenum">
               <a:rPr lang="en-US" sz="1000">
                 <a:solidFill>
                   <a:srgbClr val="9AA3B0"/>
@@ -10025,7 +10107,7 @@
           <a:lstStyle/>
           <a:p>
             <a:pPr algn="r"/>
-            <a:fld id="{28F9EBC9-206E-4F4D-882F-00645FF684F2}" type="slidenum">
+            <a:fld id="{49C8679C-72E1-4C90-9AC0-7D7FE34CF5A7}" type="slidenum">
               <a:rPr lang="en-US" sz="1000">
                 <a:solidFill>
                   <a:srgbClr val="9AA3B0"/>
@@ -10913,7 +10995,7 @@
           <a:lstStyle/>
           <a:p>
             <a:pPr algn="r"/>
-            <a:fld id="{C2F51288-4FBD-4CD1-AFCD-CE91392DA1DF}" type="slidenum">
+            <a:fld id="{0379B74E-C0F6-4891-AE43-5BB99B72C32E}" type="slidenum">
               <a:rPr lang="en-US" sz="1000">
                 <a:solidFill>
                   <a:srgbClr val="9AA3B0"/>
@@ -12075,7 +12157,7 @@
           <a:lstStyle/>
           <a:p>
             <a:pPr algn="r"/>
-            <a:fld id="{C8C694CC-D9CB-4C05-B1FE-B3351571D86F}" type="slidenum">
+            <a:fld id="{9B5B171F-B756-4BB6-8FCB-19E278B2448C}" type="slidenum">
               <a:rPr lang="en-US" sz="1000">
                 <a:solidFill>
                   <a:srgbClr val="9AA3B0"/>
@@ -12400,7 +12482,7 @@
           <a:lstStyle/>
           <a:p>
             <a:pPr algn="r"/>
-            <a:fld id="{AAC23B0A-657A-4361-A6D3-B26B28489181}" type="slidenum">
+            <a:fld id="{5E17964D-0113-456E-BB79-A0935991E0A9}" type="slidenum">
               <a:rPr lang="en-US" sz="1000">
                 <a:solidFill>
                   <a:srgbClr val="9AA3B0"/>
@@ -12749,7 +12831,7 @@
           <a:lstStyle/>
           <a:p>
             <a:pPr algn="r"/>
-            <a:fld id="{03680C92-1862-4999-B742-A695008D55EC}" type="slidenum">
+            <a:fld id="{B8D8BCE6-AE97-4AAB-A1E7-2208C89B1836}" type="slidenum">
               <a:rPr lang="en-US" sz="1000">
                 <a:solidFill>
                   <a:srgbClr val="9AA3B0"/>
@@ -14841,7 +14923,7 @@
           <a:lstStyle/>
           <a:p>
             <a:pPr algn="r"/>
-            <a:fld id="{6946E410-55CB-4109-91A5-417A03494C32}" type="slidenum">
+            <a:fld id="{BDD35E4A-A932-4066-9FE1-63015412AD55}" type="slidenum">
               <a:rPr lang="en-US" sz="1000">
                 <a:solidFill>
                   <a:srgbClr val="9AA3B0"/>
@@ -15866,7 +15948,7 @@
           <a:lstStyle/>
           <a:p>
             <a:pPr algn="r"/>
-            <a:fld id="{7ABA08C2-8E69-4765-8542-96BB29E9CDAB}" type="slidenum">
+            <a:fld id="{A216D303-1966-4B9B-B5B2-1CCBD056D52D}" type="slidenum">
               <a:rPr lang="en-US" sz="1000">
                 <a:solidFill>
                   <a:srgbClr val="9AA3B0"/>
@@ -16644,7 +16726,7 @@
           <a:lstStyle/>
           <a:p>
             <a:pPr algn="r"/>
-            <a:fld id="{44813FB9-E5BA-4CC8-B752-01422A0D0F08}" type="slidenum">
+            <a:fld id="{CFDD2978-6AD8-4433-9949-9A410E0641B8}" type="slidenum">
               <a:rPr lang="en-US" sz="1000">
                 <a:solidFill>
                   <a:srgbClr val="9AA3B0"/>
@@ -16923,6 +17005,48 @@
               <a:t>[5]  Cadence Innovus User Guide; Synopsys IC Compiler II / Fusion Compiler User Guide（命令与流程参考）.</a:t>
             </a:r>
           </a:p>
+          <a:p>
+            <a:pPr algn="l">
+              <a:lnSpc>
+                <a:spcPct val="120000"/>
+              </a:lnSpc>
+              <a:spcAft>
+                <a:spcPts val="900"/>
+              </a:spcAft>
+            </a:pPr>
+            <a:r>
+              <a:rPr sz="1250" b="0">
+                <a:solidFill>
+                  <a:srgbClr val="1A1F2B"/>
+                </a:solidFill>
+                <a:latin typeface="Microsoft YaHei"/>
+                <a:ea typeface="Microsoft YaHei"/>
+                <a:cs typeface="Microsoft YaHei"/>
+              </a:rPr>
+              <a:t>[6]  图（2.1）Intel Core i9-13900K labelled die shot — Fritzchens Fritz / JmsDoug, CC0 公有领域, via Wikimedia Commons.</a:t>
+            </a:r>
+          </a:p>
+          <a:p>
+            <a:pPr algn="l">
+              <a:lnSpc>
+                <a:spcPct val="120000"/>
+              </a:lnSpc>
+              <a:spcAft>
+                <a:spcPts val="900"/>
+              </a:spcAft>
+            </a:pPr>
+            <a:r>
+              <a:rPr sz="1250" b="0">
+                <a:solidFill>
+                  <a:srgbClr val="1A1F2B"/>
+                </a:solidFill>
+                <a:latin typeface="Microsoft YaHei"/>
+                <a:ea typeface="Microsoft YaHei"/>
+                <a:cs typeface="Microsoft YaHei"/>
+              </a:rPr>
+              <a:t>[7]  图（3.3）Aluminium wire-bonding close-up — Mister rf, CC BY-SA 4.0, via Wikimedia Commons.</a:t>
+            </a:r>
+          </a:p>
         </p:txBody>
       </p:sp>
       <p:sp>
@@ -16948,7 +17072,7 @@
           <a:lstStyle/>
           <a:p>
             <a:pPr algn="r"/>
-            <a:fld id="{FE3A6736-2548-4A0B-813C-65BE4D87E753}" type="slidenum">
+            <a:fld id="{BD16CF65-0420-4E2E-83D2-1B20CC94E72D}" type="slidenum">
               <a:rPr lang="en-US" sz="1000">
                 <a:solidFill>
                   <a:srgbClr val="9AA3B0"/>
@@ -17616,7 +17740,7 @@
           <a:lstStyle/>
           <a:p>
             <a:pPr algn="r"/>
-            <a:fld id="{46AC6ED3-BDF8-4870-81EA-517355931AAA}" type="slidenum">
+            <a:fld id="{CE42CB06-061C-4DA1-8A71-81E891051E2A}" type="slidenum">
               <a:rPr lang="en-US" sz="1000">
                 <a:solidFill>
                   <a:srgbClr val="9AA3B0"/>
@@ -18278,7 +18402,7 @@
           <a:lstStyle/>
           <a:p>
             <a:pPr algn="r"/>
-            <a:fld id="{302C7DE5-7754-4686-899F-CD63E7446ED8}" type="slidenum">
+            <a:fld id="{07025B46-5593-428B-A395-32EC186647A6}" type="slidenum">
               <a:rPr lang="en-US" sz="1000">
                 <a:solidFill>
                   <a:srgbClr val="9AA3B0"/>
@@ -19384,7 +19508,7 @@
           <a:lstStyle/>
           <a:p>
             <a:pPr algn="r"/>
-            <a:fld id="{165EEA66-F258-45D1-9AC8-12ACD17323C5}" type="slidenum">
+            <a:fld id="{B80A505C-4FF4-4180-AF6E-03D3154A4628}" type="slidenum">
               <a:rPr lang="en-US" sz="1000">
                 <a:solidFill>
                   <a:srgbClr val="9AA3B0"/>
@@ -20414,7 +20538,7 @@
           <a:lstStyle/>
           <a:p>
             <a:pPr algn="r"/>
-            <a:fld id="{680ECFCD-E8F2-4DC1-B12C-BD5C265540FD}" type="slidenum">
+            <a:fld id="{97E3993F-E5B1-410F-91ED-E652B83A68E5}" type="slidenum">
               <a:rPr lang="en-US" sz="1000">
                 <a:solidFill>
                   <a:srgbClr val="9AA3B0"/>
@@ -21491,7 +21615,7 @@
           <a:lstStyle/>
           <a:p>
             <a:pPr algn="r"/>
-            <a:fld id="{DC11EB09-84D9-4EAD-9608-70D8F8002071}" type="slidenum">
+            <a:fld id="{7D707039-B7DA-4103-8CFE-8E185F170045}" type="slidenum">
               <a:rPr lang="en-US" sz="1000">
                 <a:solidFill>
                   <a:srgbClr val="9AA3B0"/>

</xml_diff>

<commit_message>
deck: per-slide OA figure search -> 3 more openly-licensed real figures (1.1 Intel 80486DX2 die CC BY 3.0; 4.1 Bitfury top-metal power grid CC BY 3.0; 4.2 WACA-UNet IR-drop map CC BY 4.0); per-figure credit + refs entries; refs preview shrink-to-fit + reusable OA-search workflow
All images license-verified on source page; redistributable with attribution. Slides 2.2/2.4/2.6/3.2/4.7 keep drawn schematics (OA real figures scarce or schematic teaches principle better).

Co-Authored-By: Claude Opus 4.8 <noreply@anthropic.com>
</commit_message>
<xml_diff>
--- a/IC_Backend_Notes/slides/05_Floorplan.pptx
+++ b/IC_Backend_Notes/slides/05_Floorplan.pptx
@@ -1255,7 +1255,7 @@
           <a:lstStyle/>
           <a:p>
             <a:pPr algn="r"/>
-            <a:fld id="{9BD82241-F179-42FA-AC60-F29E6F4D0254}" type="slidenum">
+            <a:fld id="{8D9AC73B-3779-41B9-B05A-0292D943A81B}" type="slidenum">
               <a:rPr lang="en-US" sz="1000">
                 <a:solidFill>
                   <a:srgbClr val="9AA3B0"/>
@@ -1541,7 +1541,7 @@
           <a:lstStyle/>
           <a:p>
             <a:pPr algn="r"/>
-            <a:fld id="{E5A8EF17-8F24-40E8-AEC9-D43609BD5FD7}" type="slidenum">
+            <a:fld id="{D6B2CC82-306B-4FD9-8693-34F425358B28}" type="slidenum">
               <a:rPr lang="en-US" sz="1000">
                 <a:solidFill>
                   <a:srgbClr val="9AA3B0"/>
@@ -3066,7 +3066,7 @@
           <a:lstStyle/>
           <a:p>
             <a:pPr algn="r"/>
-            <a:fld id="{D044295A-3522-4B6A-A9F3-885957409CC4}" type="slidenum">
+            <a:fld id="{FD2171DB-AC36-4510-AA79-B02E6FE434E5}" type="slidenum">
               <a:rPr lang="en-US" sz="1000">
                 <a:solidFill>
                   <a:srgbClr val="9AA3B0"/>
@@ -3415,7 +3415,7 @@
           <a:lstStyle/>
           <a:p>
             <a:pPr algn="r"/>
-            <a:fld id="{0ABB82C4-7048-40AF-AB5E-FD81468B4F2C}" type="slidenum">
+            <a:fld id="{C1FAE399-EE9E-47EC-B57F-6FDC0EDD29F5}" type="slidenum">
               <a:rPr lang="en-US" sz="1000">
                 <a:solidFill>
                   <a:srgbClr val="9AA3B0"/>
@@ -4303,7 +4303,7 @@
           <a:lstStyle/>
           <a:p>
             <a:pPr algn="r"/>
-            <a:fld id="{B5383D26-216E-400B-AC23-6852B5697097}" type="slidenum">
+            <a:fld id="{6D3C1CDF-E65E-4021-BBAB-0C88A51DF74A}" type="slidenum">
               <a:rPr lang="en-US" sz="1000">
                 <a:solidFill>
                   <a:srgbClr val="9AA3B0"/>
@@ -4652,7 +4652,7 @@
           <a:lstStyle/>
           <a:p>
             <a:pPr algn="r"/>
-            <a:fld id="{33182F35-427C-48D3-8707-2E06E6A6EDF8}" type="slidenum">
+            <a:fld id="{06C38842-2BB9-40E0-A19C-BE6EBD0719C6}" type="slidenum">
               <a:rPr lang="en-US" sz="1000">
                 <a:solidFill>
                   <a:srgbClr val="9AA3B0"/>
@@ -5021,7 +5021,7 @@
           <a:lstStyle/>
           <a:p>
             <a:pPr algn="r"/>
-            <a:fld id="{9D3AE567-4CC5-49E8-A7AB-0DAEBA26CC63}" type="slidenum">
+            <a:fld id="{821460AE-D0F9-4173-A2B6-D0E6EFFD972D}" type="slidenum">
               <a:rPr lang="en-US" sz="1000">
                 <a:solidFill>
                   <a:srgbClr val="9AA3B0"/>
@@ -6742,7 +6742,7 @@
           <a:lstStyle/>
           <a:p>
             <a:pPr algn="r"/>
-            <a:fld id="{18AC8B10-D58C-4234-AC15-35D31111FB40}" type="slidenum">
+            <a:fld id="{19DDB01F-B288-4A2D-A5C3-2A7690D1F795}" type="slidenum">
               <a:rPr lang="en-US" sz="1000">
                 <a:solidFill>
                   <a:srgbClr val="9AA3B0"/>
@@ -7028,7 +7028,7 @@
           <a:lstStyle/>
           <a:p>
             <a:pPr algn="r"/>
-            <a:fld id="{A77B7D21-5A6B-413F-873E-820B6DA93546}" type="slidenum">
+            <a:fld id="{B79FCC7F-B67F-471B-9628-72121FAE80FC}" type="slidenum">
               <a:rPr lang="en-US" sz="1000">
                 <a:solidFill>
                   <a:srgbClr val="9AA3B0"/>
@@ -7943,7 +7943,7 @@
           <a:lstStyle/>
           <a:p>
             <a:pPr algn="r"/>
-            <a:fld id="{30DBF914-408A-4F77-81E0-F4458FDB6553}" type="slidenum">
+            <a:fld id="{D03DBFA8-BB6A-4563-BF98-066FB1D27943}" type="slidenum">
               <a:rPr lang="en-US" sz="1000">
                 <a:solidFill>
                   <a:srgbClr val="9AA3B0"/>
@@ -8270,7 +8270,7 @@
           <a:lstStyle/>
           <a:p>
             <a:pPr algn="r"/>
-            <a:fld id="{1C604057-5A15-418D-87BF-45AB069DAB42}" type="slidenum">
+            <a:fld id="{5DAC4248-A2CD-49B4-97D9-EE00592469BF}" type="slidenum">
               <a:rPr lang="en-US" sz="1000">
                 <a:solidFill>
                   <a:srgbClr val="9AA3B0"/>
@@ -9421,14 +9421,14 @@
                 <a:ea typeface="Microsoft YaHei"/>
                 <a:cs typeface="Microsoft YaHei"/>
               </a:rPr>
-              <a:t>因此电源规划从 floorplan 阶段就开始，而不是等布线之后再补救。</a:t>
+              <a:t>因此电源规划从 floorplan 阶段就开始，而不是等布线之后再补救。右图是一颗真实芯片的顶层金属，几乎整层都用于供电网。</a:t>
             </a:r>
           </a:p>
         </p:txBody>
       </p:sp>
       <p:pic>
         <p:nvPicPr>
-          <p:cNvPr id="6" name="Picture 5" descr="f08_power.png"/>
+          <p:cNvPr id="6" name="Picture 5" descr="ext_pdn_bitfury_ccby.jpg"/>
           <p:cNvPicPr>
             <a:picLocks noChangeAspect="1"/>
           </p:cNvPicPr>
@@ -9442,8 +9442,8 @@
         </p:blipFill>
         <p:spPr>
           <a:xfrm>
-            <a:off x="5486400" y="1676348"/>
-            <a:ext cx="6263640" cy="4556863"/>
+            <a:off x="6221120" y="1554480"/>
+            <a:ext cx="4794199" cy="4800600"/>
           </a:xfrm>
           <a:prstGeom prst="rect">
             <a:avLst/>
@@ -9453,6 +9453,47 @@
       <p:sp>
         <p:nvSpPr>
           <p:cNvPr id="7" name="TextBox 6"/>
+          <p:cNvSpPr txBox="1"/>
+          <p:nvPr/>
+        </p:nvSpPr>
+        <p:spPr>
+          <a:xfrm>
+            <a:off x="5486400" y="6382512"/>
+            <a:ext cx="6263640" cy="274320"/>
+          </a:xfrm>
+          <a:prstGeom prst="rect">
+            <a:avLst/>
+          </a:prstGeom>
+          <a:noFill/>
+        </p:spPr>
+        <p:txBody>
+          <a:bodyPr wrap="square" anchor="t" lIns="25400" rIns="25400" tIns="25400" bIns="25400">
+            <a:spAutoFit/>
+          </a:bodyPr>
+          <a:lstStyle/>
+          <a:p>
+            <a:pPr algn="r">
+              <a:spcAft>
+                <a:spcPts val="600"/>
+              </a:spcAft>
+            </a:pPr>
+            <a:r>
+              <a:rPr sz="900" b="0">
+                <a:solidFill>
+                  <a:srgbClr val="6B7280"/>
+                </a:solidFill>
+                <a:latin typeface="Microsoft YaHei"/>
+                <a:ea typeface="Microsoft YaHei"/>
+                <a:cs typeface="Microsoft YaHei"/>
+              </a:rPr>
+              <a:t>来源：Bitfury 55nm 顶层金属供电网 · ZeptoBars · CC BY 3.0 · Wikimedia</a:t>
+            </a:r>
+          </a:p>
+        </p:txBody>
+      </p:sp>
+      <p:sp>
+        <p:nvSpPr>
+          <p:cNvPr id="8" name="TextBox 7"/>
           <p:cNvSpPr txBox="1"/>
           <p:nvPr/>
         </p:nvSpPr>
@@ -9473,7 +9514,7 @@
           <a:lstStyle/>
           <a:p>
             <a:pPr algn="r"/>
-            <a:fld id="{E376F830-6BD0-44BA-886B-CCD1B4361FA3}" type="slidenum">
+            <a:fld id="{150CD64C-9BA4-45E2-BD6E-A3A64EAA5185}" type="slidenum">
               <a:rPr lang="en-US" sz="1000">
                 <a:solidFill>
                   <a:srgbClr val="9AA3B0"/>
@@ -9714,7 +9755,7 @@
       </p:sp>
       <p:pic>
         <p:nvPicPr>
-          <p:cNvPr id="6" name="Picture 5" descr="f09_irem.png"/>
+          <p:cNvPr id="6" name="Picture 5" descr="ext_irdrop_waca_ccby.png"/>
           <p:cNvPicPr>
             <a:picLocks noChangeAspect="1"/>
           </p:cNvPicPr>
@@ -9728,8 +9769,8 @@
         </p:blipFill>
         <p:spPr>
           <a:xfrm>
-            <a:off x="5486400" y="1740229"/>
-            <a:ext cx="6263640" cy="4429101"/>
+            <a:off x="5564074" y="1554480"/>
+            <a:ext cx="6108290" cy="4800600"/>
           </a:xfrm>
           <a:prstGeom prst="rect">
             <a:avLst/>
@@ -9739,6 +9780,47 @@
       <p:sp>
         <p:nvSpPr>
           <p:cNvPr id="7" name="TextBox 6"/>
+          <p:cNvSpPr txBox="1"/>
+          <p:nvPr/>
+        </p:nvSpPr>
+        <p:spPr>
+          <a:xfrm>
+            <a:off x="5486400" y="6382512"/>
+            <a:ext cx="6263640" cy="274320"/>
+          </a:xfrm>
+          <a:prstGeom prst="rect">
+            <a:avLst/>
+          </a:prstGeom>
+          <a:noFill/>
+        </p:spPr>
+        <p:txBody>
+          <a:bodyPr wrap="square" anchor="t" lIns="25400" rIns="25400" tIns="25400" bIns="25400">
+            <a:spAutoFit/>
+          </a:bodyPr>
+          <a:lstStyle/>
+          <a:p>
+            <a:pPr algn="r">
+              <a:spcAft>
+                <a:spcPts val="600"/>
+              </a:spcAft>
+            </a:pPr>
+            <a:r>
+              <a:rPr sz="900" b="0">
+                <a:solidFill>
+                  <a:srgbClr val="6B7280"/>
+                </a:solidFill>
+                <a:latin typeface="Microsoft YaHei"/>
+                <a:ea typeface="Microsoft YaHei"/>
+                <a:cs typeface="Microsoft YaHei"/>
+              </a:rPr>
+              <a:t>来源：IR drop map · WACA-UNet, Seo et al. · arXiv:2507.19197 · CC BY 4.0</a:t>
+            </a:r>
+          </a:p>
+        </p:txBody>
+      </p:sp>
+      <p:sp>
+        <p:nvSpPr>
+          <p:cNvPr id="8" name="TextBox 7"/>
           <p:cNvSpPr txBox="1"/>
           <p:nvPr/>
         </p:nvSpPr>
@@ -9759,7 +9841,7 @@
           <a:lstStyle/>
           <a:p>
             <a:pPr algn="r"/>
-            <a:fld id="{30FA3A08-6C6D-48EE-93BF-BF7584130D03}" type="slidenum">
+            <a:fld id="{EFED2FEB-97DE-42FC-9067-3D84FE831C0F}" type="slidenum">
               <a:rPr lang="en-US" sz="1000">
                 <a:solidFill>
                   <a:srgbClr val="9AA3B0"/>
@@ -10107,7 +10189,7 @@
           <a:lstStyle/>
           <a:p>
             <a:pPr algn="r"/>
-            <a:fld id="{49C8679C-72E1-4C90-9AC0-7D7FE34CF5A7}" type="slidenum">
+            <a:fld id="{BD918C2C-03E4-4FD3-AF0F-47D8E0F2A300}" type="slidenum">
               <a:rPr lang="en-US" sz="1000">
                 <a:solidFill>
                   <a:srgbClr val="9AA3B0"/>
@@ -10995,7 +11077,7 @@
           <a:lstStyle/>
           <a:p>
             <a:pPr algn="r"/>
-            <a:fld id="{0379B74E-C0F6-4891-AE43-5BB99B72C32E}" type="slidenum">
+            <a:fld id="{5AB9D1F9-209F-4FA5-B9B2-313428FDA173}" type="slidenum">
               <a:rPr lang="en-US" sz="1000">
                 <a:solidFill>
                   <a:srgbClr val="9AA3B0"/>
@@ -12157,7 +12239,7 @@
           <a:lstStyle/>
           <a:p>
             <a:pPr algn="r"/>
-            <a:fld id="{9B5B171F-B756-4BB6-8FCB-19E278B2448C}" type="slidenum">
+            <a:fld id="{D6759BC0-5E36-40D0-BFC1-6D8002376A63}" type="slidenum">
               <a:rPr lang="en-US" sz="1000">
                 <a:solidFill>
                   <a:srgbClr val="9AA3B0"/>
@@ -12482,7 +12564,7 @@
           <a:lstStyle/>
           <a:p>
             <a:pPr algn="r"/>
-            <a:fld id="{5E17964D-0113-456E-BB79-A0935991E0A9}" type="slidenum">
+            <a:fld id="{58BDEFD6-8396-4FF9-ACF7-4439AB0D9084}" type="slidenum">
               <a:rPr lang="en-US" sz="1000">
                 <a:solidFill>
                   <a:srgbClr val="9AA3B0"/>
@@ -12831,7 +12913,7 @@
           <a:lstStyle/>
           <a:p>
             <a:pPr algn="r"/>
-            <a:fld id="{B8D8BCE6-AE97-4AAB-A1E7-2208C89B1836}" type="slidenum">
+            <a:fld id="{5C384DAF-1907-49A3-80CA-3BB7958EBB6B}" type="slidenum">
               <a:rPr lang="en-US" sz="1000">
                 <a:solidFill>
                   <a:srgbClr val="9AA3B0"/>
@@ -14923,7 +15005,7 @@
           <a:lstStyle/>
           <a:p>
             <a:pPr algn="r"/>
-            <a:fld id="{BDD35E4A-A932-4066-9FE1-63015412AD55}" type="slidenum">
+            <a:fld id="{E9DB13BF-8425-436A-B03D-2A7EBC4F81C1}" type="slidenum">
               <a:rPr lang="en-US" sz="1000">
                 <a:solidFill>
                   <a:srgbClr val="9AA3B0"/>
@@ -15948,7 +16030,7 @@
           <a:lstStyle/>
           <a:p>
             <a:pPr algn="r"/>
-            <a:fld id="{A216D303-1966-4B9B-B5B2-1CCBD056D52D}" type="slidenum">
+            <a:fld id="{862D3ACA-4FFB-4DA2-A17F-4D03F7CAA875}" type="slidenum">
               <a:rPr lang="en-US" sz="1000">
                 <a:solidFill>
                   <a:srgbClr val="9AA3B0"/>
@@ -16726,7 +16808,7 @@
           <a:lstStyle/>
           <a:p>
             <a:pPr algn="r"/>
-            <a:fld id="{CFDD2978-6AD8-4433-9949-9A410E0641B8}" type="slidenum">
+            <a:fld id="{F43C85B6-972E-4E85-9A11-567488B7E6EF}" type="slidenum">
               <a:rPr lang="en-US" sz="1000">
                 <a:solidFill>
                   <a:srgbClr val="9AA3B0"/>
@@ -16888,7 +16970,7 @@
         <p:spPr>
           <a:xfrm>
             <a:off x="640080" y="1627632"/>
-            <a:ext cx="10972800" cy="4754880"/>
+            <a:ext cx="5486400" cy="4754880"/>
           </a:xfrm>
           <a:prstGeom prst="rect">
             <a:avLst/>
@@ -16903,14 +16985,14 @@
           <a:p>
             <a:pPr algn="l">
               <a:lnSpc>
-                <a:spcPct val="120000"/>
+                <a:spcPct val="118000"/>
               </a:lnSpc>
               <a:spcAft>
-                <a:spcPts val="900"/>
-              </a:spcAft>
-            </a:pPr>
-            <a:r>
-              <a:rPr sz="1250" b="0">
+                <a:spcPts val="800"/>
+              </a:spcAft>
+            </a:pPr>
+            <a:r>
+              <a:rPr sz="1200" b="0">
                 <a:solidFill>
                   <a:srgbClr val="1A1F2B"/>
                 </a:solidFill>
@@ -16918,20 +17000,20 @@
                 <a:ea typeface="Microsoft YaHei"/>
                 <a:cs typeface="Microsoft YaHei"/>
               </a:rPr>
-              <a:t>[1]  Adam Teman. Digital VLSI Design (DVD), Lecture 6 — Import Design and Floorplan. Bar-Ilan University, Course 83-612. https://enicslabs.com/academic-courses/dvd-english/</a:t>
+              <a:t>[1]  Adam Teman. Digital VLSI Design (DVD), Lecture 6 — Import Design and Floorplan. Bar-Ilan University (83-612). enicslabs.com/academic-courses/dvd-english</a:t>
             </a:r>
           </a:p>
           <a:p>
             <a:pPr algn="l">
               <a:lnSpc>
-                <a:spcPct val="120000"/>
+                <a:spcPct val="118000"/>
               </a:lnSpc>
               <a:spcAft>
-                <a:spcPts val="900"/>
-              </a:spcAft>
-            </a:pPr>
-            <a:r>
-              <a:rPr sz="1250" b="0">
+                <a:spcPts val="800"/>
+              </a:spcAft>
+            </a:pPr>
+            <a:r>
+              <a:rPr sz="1200" b="0">
                 <a:solidFill>
                   <a:srgbClr val="1A1F2B"/>
                 </a:solidFill>
@@ -16945,14 +17027,14 @@
           <a:p>
             <a:pPr algn="l">
               <a:lnSpc>
-                <a:spcPct val="120000"/>
+                <a:spcPct val="118000"/>
               </a:lnSpc>
               <a:spcAft>
-                <a:spcPts val="900"/>
-              </a:spcAft>
-            </a:pPr>
-            <a:r>
-              <a:rPr sz="1250" b="0">
+                <a:spcPts val="800"/>
+              </a:spcAft>
+            </a:pPr>
+            <a:r>
+              <a:rPr sz="1200" b="0">
                 <a:solidFill>
                   <a:srgbClr val="1A1F2B"/>
                 </a:solidFill>
@@ -16966,14 +17048,14 @@
           <a:p>
             <a:pPr algn="l">
               <a:lnSpc>
-                <a:spcPct val="120000"/>
+                <a:spcPct val="118000"/>
               </a:lnSpc>
               <a:spcAft>
-                <a:spcPts val="900"/>
-              </a:spcAft>
-            </a:pPr>
-            <a:r>
-              <a:rPr sz="1250" b="0">
+                <a:spcPts val="800"/>
+              </a:spcAft>
+            </a:pPr>
+            <a:r>
+              <a:rPr sz="1200" b="0">
                 <a:solidFill>
                   <a:srgbClr val="1A1F2B"/>
                 </a:solidFill>
@@ -16987,14 +17069,14 @@
           <a:p>
             <a:pPr algn="l">
               <a:lnSpc>
-                <a:spcPct val="120000"/>
+                <a:spcPct val="118000"/>
               </a:lnSpc>
               <a:spcAft>
-                <a:spcPts val="900"/>
-              </a:spcAft>
-            </a:pPr>
-            <a:r>
-              <a:rPr sz="1250" b="0">
+                <a:spcPts val="800"/>
+              </a:spcAft>
+            </a:pPr>
+            <a:r>
+              <a:rPr sz="1200" b="0">
                 <a:solidFill>
                   <a:srgbClr val="1A1F2B"/>
                 </a:solidFill>
@@ -17002,20 +17084,43 @@
                 <a:ea typeface="Microsoft YaHei"/>
                 <a:cs typeface="Microsoft YaHei"/>
               </a:rPr>
-              <a:t>[5]  Cadence Innovus User Guide; Synopsys IC Compiler II / Fusion Compiler User Guide（命令与流程参考）.</a:t>
-            </a:r>
-          </a:p>
+              <a:t>[5]  Cadence Innovus / Synopsys ICC2 / Fusion Compiler User Guides（命令与流程参考）.</a:t>
+            </a:r>
+          </a:p>
+        </p:txBody>
+      </p:sp>
+      <p:sp>
+        <p:nvSpPr>
+          <p:cNvPr id="6" name="TextBox 5"/>
+          <p:cNvSpPr txBox="1"/>
+          <p:nvPr/>
+        </p:nvSpPr>
+        <p:spPr>
+          <a:xfrm>
+            <a:off x="6309360" y="1627632"/>
+            <a:ext cx="5486400" cy="4754880"/>
+          </a:xfrm>
+          <a:prstGeom prst="rect">
+            <a:avLst/>
+          </a:prstGeom>
+          <a:noFill/>
+        </p:spPr>
+        <p:txBody>
+          <a:bodyPr wrap="square" anchor="t" lIns="25400" rIns="25400" tIns="25400" bIns="25400">
+            <a:normAutofit/>
+          </a:bodyPr>
+          <a:lstStyle/>
           <a:p>
             <a:pPr algn="l">
               <a:lnSpc>
-                <a:spcPct val="120000"/>
+                <a:spcPct val="118000"/>
               </a:lnSpc>
               <a:spcAft>
-                <a:spcPts val="900"/>
-              </a:spcAft>
-            </a:pPr>
-            <a:r>
-              <a:rPr sz="1250" b="0">
+                <a:spcPts val="800"/>
+              </a:spcAft>
+            </a:pPr>
+            <a:r>
+              <a:rPr sz="1200" b="0">
                 <a:solidFill>
                   <a:srgbClr val="1A1F2B"/>
                 </a:solidFill>
@@ -17023,20 +17128,20 @@
                 <a:ea typeface="Microsoft YaHei"/>
                 <a:cs typeface="Microsoft YaHei"/>
               </a:rPr>
-              <a:t>[6]  图（2.1）Intel Core i9-13900K labelled die shot — Fritzchens Fritz / JmsDoug, CC0 公有领域, via Wikimedia Commons.</a:t>
+              <a:t>[6]  图 1.1 Intel 80486DX2 die — Smial, CC BY 3.0, Wikimedia Commons.</a:t>
             </a:r>
           </a:p>
           <a:p>
             <a:pPr algn="l">
               <a:lnSpc>
-                <a:spcPct val="120000"/>
+                <a:spcPct val="118000"/>
               </a:lnSpc>
               <a:spcAft>
-                <a:spcPts val="900"/>
-              </a:spcAft>
-            </a:pPr>
-            <a:r>
-              <a:rPr sz="1250" b="0">
+                <a:spcPts val="800"/>
+              </a:spcAft>
+            </a:pPr>
+            <a:r>
+              <a:rPr sz="1200" b="0">
                 <a:solidFill>
                   <a:srgbClr val="1A1F2B"/>
                 </a:solidFill>
@@ -17044,14 +17149,77 @@
                 <a:ea typeface="Microsoft YaHei"/>
                 <a:cs typeface="Microsoft YaHei"/>
               </a:rPr>
-              <a:t>[7]  图（3.3）Aluminium wire-bonding close-up — Mister rf, CC BY-SA 4.0, via Wikimedia Commons.</a:t>
-            </a:r>
-          </a:p>
-        </p:txBody>
-      </p:sp>
-      <p:sp>
-        <p:nvSpPr>
-          <p:cNvPr id="6" name="TextBox 5"/>
+              <a:t>[7]  图 2.1 Intel Core i9-13900K die shot — Fritzchens Fritz / JmsDoug, CC0, Wikimedia Commons.</a:t>
+            </a:r>
+          </a:p>
+          <a:p>
+            <a:pPr algn="l">
+              <a:lnSpc>
+                <a:spcPct val="118000"/>
+              </a:lnSpc>
+              <a:spcAft>
+                <a:spcPts val="800"/>
+              </a:spcAft>
+            </a:pPr>
+            <a:r>
+              <a:rPr sz="1200" b="0">
+                <a:solidFill>
+                  <a:srgbClr val="1A1F2B"/>
+                </a:solidFill>
+                <a:latin typeface="Microsoft YaHei"/>
+                <a:ea typeface="Microsoft YaHei"/>
+                <a:cs typeface="Microsoft YaHei"/>
+              </a:rPr>
+              <a:t>[8]  图 3.3 Wire-bonding close-up — Mister rf, CC BY-SA 4.0, Wikimedia Commons.</a:t>
+            </a:r>
+          </a:p>
+          <a:p>
+            <a:pPr algn="l">
+              <a:lnSpc>
+                <a:spcPct val="118000"/>
+              </a:lnSpc>
+              <a:spcAft>
+                <a:spcPts val="800"/>
+              </a:spcAft>
+            </a:pPr>
+            <a:r>
+              <a:rPr sz="1200" b="0">
+                <a:solidFill>
+                  <a:srgbClr val="1A1F2B"/>
+                </a:solidFill>
+                <a:latin typeface="Microsoft YaHei"/>
+                <a:ea typeface="Microsoft YaHei"/>
+                <a:cs typeface="Microsoft YaHei"/>
+              </a:rPr>
+              <a:t>[9]  图 4.1 Bitfury 顶层金属供电网 — ZeptoBars, CC BY 3.0, Wikimedia Commons.</a:t>
+            </a:r>
+          </a:p>
+          <a:p>
+            <a:pPr algn="l">
+              <a:lnSpc>
+                <a:spcPct val="118000"/>
+              </a:lnSpc>
+              <a:spcAft>
+                <a:spcPts val="800"/>
+              </a:spcAft>
+            </a:pPr>
+            <a:r>
+              <a:rPr sz="1200" b="0">
+                <a:solidFill>
+                  <a:srgbClr val="1A1F2B"/>
+                </a:solidFill>
+                <a:latin typeface="Microsoft YaHei"/>
+                <a:ea typeface="Microsoft YaHei"/>
+                <a:cs typeface="Microsoft YaHei"/>
+              </a:rPr>
+              <a:t>[10]  图 4.2 Static IR-drop map — Seo et al. (WACA-UNet), arXiv:2507.19197, CC BY 4.0.</a:t>
+            </a:r>
+          </a:p>
+        </p:txBody>
+      </p:sp>
+      <p:sp>
+        <p:nvSpPr>
+          <p:cNvPr id="7" name="TextBox 6"/>
           <p:cNvSpPr txBox="1"/>
           <p:nvPr/>
         </p:nvSpPr>
@@ -17072,7 +17240,7 @@
           <a:lstStyle/>
           <a:p>
             <a:pPr algn="r"/>
-            <a:fld id="{BD16CF65-0420-4E2E-83D2-1B20CC94E72D}" type="slidenum">
+            <a:fld id="{B8A48CF9-80C1-403A-8FA5-6494CD0EE803}" type="slidenum">
               <a:rPr lang="en-US" sz="1000">
                 <a:solidFill>
                   <a:srgbClr val="9AA3B0"/>
@@ -17555,8 +17723,8 @@
         </p:nvSpPr>
         <p:spPr>
           <a:xfrm>
-            <a:off x="640080" y="1600200"/>
-            <a:ext cx="10972800" cy="4846320"/>
+            <a:off x="640080" y="1572768"/>
+            <a:ext cx="4754880" cy="4937760"/>
           </a:xfrm>
           <a:prstGeom prst="rect">
             <a:avLst/>
@@ -17571,14 +17739,14 @@
           <a:p>
             <a:pPr algn="l">
               <a:lnSpc>
-                <a:spcPct val="125000"/>
+                <a:spcPct val="116000"/>
               </a:lnSpc>
               <a:spcAft>
-                <a:spcPts val="1000"/>
-              </a:spcAft>
-            </a:pPr>
-            <a:r>
-              <a:rPr sz="1500" b="0">
+                <a:spcPts val="800"/>
+              </a:spcAft>
+            </a:pPr>
+            <a:r>
+              <a:rPr sz="1400" b="0">
                 <a:solidFill>
                   <a:srgbClr val="1A1F2B"/>
                 </a:solidFill>
@@ -17592,14 +17760,14 @@
           <a:p>
             <a:pPr algn="l">
               <a:lnSpc>
-                <a:spcPct val="125000"/>
+                <a:spcPct val="116000"/>
               </a:lnSpc>
               <a:spcAft>
-                <a:spcPts val="1000"/>
-              </a:spcAft>
-            </a:pPr>
-            <a:r>
-              <a:rPr sz="1500" b="0">
+                <a:spcPts val="800"/>
+              </a:spcAft>
+            </a:pPr>
+            <a:r>
+              <a:rPr sz="1400" b="0">
                 <a:solidFill>
                   <a:srgbClr val="1A1F2B"/>
                 </a:solidFill>
@@ -17607,20 +17775,20 @@
                 <a:ea typeface="Microsoft YaHei"/>
                 <a:cs typeface="Microsoft YaHei"/>
               </a:rPr>
-              <a:t>▪  Floorplan 把这张逻辑网表落成可实现的物理骨架，是从逻辑世界进入物理世界的第一层承诺</a:t>
+              <a:t>▪  Floorplan 把它落成可实现的物理骨架——从逻辑世界进入物理世界的第一层承诺</a:t>
             </a:r>
           </a:p>
           <a:p>
             <a:pPr algn="l">
               <a:lnSpc>
-                <a:spcPct val="125000"/>
+                <a:spcPct val="116000"/>
               </a:lnSpc>
               <a:spcAft>
-                <a:spcPts val="1000"/>
-              </a:spcAft>
-            </a:pPr>
-            <a:r>
-              <a:rPr sz="1500" b="0">
+                <a:spcPts val="800"/>
+              </a:spcAft>
+            </a:pPr>
+            <a:r>
+              <a:rPr sz="1400" b="0">
                 <a:solidFill>
                   <a:srgbClr val="1A1F2B"/>
                 </a:solidFill>
@@ -17628,20 +17796,20 @@
                 <a:ea typeface="Microsoft YaHei"/>
                 <a:cs typeface="Microsoft YaHei"/>
               </a:rPr>
-              <a:t>▪  骨架至少包括：晶粒 die 边界与核心区 core，IO / 焊盘 / 凸点的大致位置</a:t>
+              <a:t>▪  骨架含：晶粒 die / 核心区 core，IO / 焊盘 / 凸点的大致位置</a:t>
             </a:r>
           </a:p>
           <a:p>
             <a:pPr algn="l">
               <a:lnSpc>
-                <a:spcPct val="125000"/>
+                <a:spcPct val="116000"/>
               </a:lnSpc>
               <a:spcAft>
-                <a:spcPts val="1000"/>
-              </a:spcAft>
-            </a:pPr>
-            <a:r>
-              <a:rPr sz="1500" b="0">
+                <a:spcPts val="800"/>
+              </a:spcAft>
+            </a:pPr>
+            <a:r>
+              <a:rPr sz="1400" b="0">
                 <a:solidFill>
                   <a:srgbClr val="1A1F2B"/>
                 </a:solidFill>
@@ -17655,14 +17823,14 @@
           <a:p>
             <a:pPr algn="l">
               <a:lnSpc>
-                <a:spcPct val="125000"/>
+                <a:spcPct val="116000"/>
               </a:lnSpc>
               <a:spcAft>
-                <a:spcPts val="1000"/>
-              </a:spcAft>
-            </a:pPr>
-            <a:r>
-              <a:rPr sz="1500" b="0">
+                <a:spcPts val="800"/>
+              </a:spcAft>
+            </a:pPr>
+            <a:r>
+              <a:rPr sz="1400" b="0">
                 <a:solidFill>
                   <a:srgbClr val="1A1F2B"/>
                 </a:solidFill>
@@ -17670,20 +17838,20 @@
                 <a:ea typeface="Microsoft YaHei"/>
                 <a:cs typeface="Microsoft YaHei"/>
               </a:rPr>
-              <a:t>▪  电源环 / 条带 / 网格 / 供电轨，以及阻挡 / 留边 / 区域约束等物理约束</a:t>
+              <a:t>▪  电源环 / 条带 / 网格 / 供电轨，阻挡 / 留边 / 区域约束等物理约束</a:t>
             </a:r>
           </a:p>
           <a:p>
             <a:pPr algn="l">
               <a:lnSpc>
-                <a:spcPct val="125000"/>
+                <a:spcPct val="116000"/>
               </a:lnSpc>
               <a:spcAft>
-                <a:spcPts val="1000"/>
-              </a:spcAft>
-            </a:pPr>
-            <a:r>
-              <a:rPr sz="1500" b="0">
+                <a:spcPts val="800"/>
+              </a:spcAft>
+            </a:pPr>
+            <a:r>
+              <a:rPr sz="1400" b="0">
                 <a:solidFill>
                   <a:srgbClr val="1A1F2B"/>
                 </a:solidFill>
@@ -17691,35 +17859,79 @@
                 <a:ea typeface="Microsoft YaHei"/>
                 <a:cs typeface="Microsoft YaHei"/>
               </a:rPr>
-              <a:t>▪  后续布局、CTS、布线与电源签核都沿这个骨架继续细化</a:t>
-            </a:r>
-          </a:p>
-          <a:p>
-            <a:pPr algn="l">
-              <a:lnSpc>
-                <a:spcPct val="125000"/>
-              </a:lnSpc>
-              <a:spcAft>
-                <a:spcPts val="1000"/>
-              </a:spcAft>
-            </a:pPr>
-            <a:r>
-              <a:rPr sz="1500" b="0">
-                <a:solidFill>
-                  <a:srgbClr val="1A1F2B"/>
-                </a:solidFill>
-                <a:latin typeface="Microsoft YaHei"/>
-                <a:ea typeface="Microsoft YaHei"/>
-                <a:cs typeface="Microsoft YaHei"/>
-              </a:rPr>
-              <a:t>▪  此阶段改动成本低，签核阶段再改则可能牵一发而动全身</a:t>
-            </a:r>
-          </a:p>
-        </p:txBody>
-      </p:sp>
-      <p:sp>
-        <p:nvSpPr>
-          <p:cNvPr id="6" name="TextBox 5"/>
+              <a:t>▪  下游布局 / CTS / 布线 / 签核都沿此骨架细化；此阶段改成本低，签核再改则牵一发而动全身</a:t>
+            </a:r>
+          </a:p>
+        </p:txBody>
+      </p:sp>
+      <p:pic>
+        <p:nvPicPr>
+          <p:cNvPr id="6" name="Picture 5" descr="ext_die_486_ccby.jpg"/>
+          <p:cNvPicPr>
+            <a:picLocks noChangeAspect="1"/>
+          </p:cNvPicPr>
+          <p:nvPr/>
+        </p:nvPicPr>
+        <p:blipFill>
+          <a:blip r:embed="rId2"/>
+          <a:stretch>
+            <a:fillRect/>
+          </a:stretch>
+        </p:blipFill>
+        <p:spPr>
+          <a:xfrm>
+            <a:off x="5486400" y="2125797"/>
+            <a:ext cx="6263640" cy="3657965"/>
+          </a:xfrm>
+          <a:prstGeom prst="rect">
+            <a:avLst/>
+          </a:prstGeom>
+        </p:spPr>
+      </p:pic>
+      <p:sp>
+        <p:nvSpPr>
+          <p:cNvPr id="7" name="TextBox 6"/>
+          <p:cNvSpPr txBox="1"/>
+          <p:nvPr/>
+        </p:nvSpPr>
+        <p:spPr>
+          <a:xfrm>
+            <a:off x="5486400" y="6382512"/>
+            <a:ext cx="6263640" cy="274320"/>
+          </a:xfrm>
+          <a:prstGeom prst="rect">
+            <a:avLst/>
+          </a:prstGeom>
+          <a:noFill/>
+        </p:spPr>
+        <p:txBody>
+          <a:bodyPr wrap="square" anchor="t" lIns="25400" rIns="25400" tIns="25400" bIns="25400">
+            <a:spAutoFit/>
+          </a:bodyPr>
+          <a:lstStyle/>
+          <a:p>
+            <a:pPr algn="r">
+              <a:spcAft>
+                <a:spcPts val="600"/>
+              </a:spcAft>
+            </a:pPr>
+            <a:r>
+              <a:rPr sz="900" b="0">
+                <a:solidFill>
+                  <a:srgbClr val="6B7280"/>
+                </a:solidFill>
+                <a:latin typeface="Microsoft YaHei"/>
+                <a:ea typeface="Microsoft YaHei"/>
+                <a:cs typeface="Microsoft YaHei"/>
+              </a:rPr>
+              <a:t>来源：Intel 80486DX2 die（功能块标注）· Smial · CC BY 3.0 · Wikimedia</a:t>
+            </a:r>
+          </a:p>
+        </p:txBody>
+      </p:sp>
+      <p:sp>
+        <p:nvSpPr>
+          <p:cNvPr id="8" name="TextBox 7"/>
           <p:cNvSpPr txBox="1"/>
           <p:nvPr/>
         </p:nvSpPr>
@@ -17740,7 +17952,7 @@
           <a:lstStyle/>
           <a:p>
             <a:pPr algn="r"/>
-            <a:fld id="{CE42CB06-061C-4DA1-8A71-81E891051E2A}" type="slidenum">
+            <a:fld id="{BD9210C9-080A-4EE7-B132-1F339F407D8A}" type="slidenum">
               <a:rPr lang="en-US" sz="1000">
                 <a:solidFill>
                   <a:srgbClr val="9AA3B0"/>
@@ -18402,7 +18614,7 @@
           <a:lstStyle/>
           <a:p>
             <a:pPr algn="r"/>
-            <a:fld id="{07025B46-5593-428B-A395-32EC186647A6}" type="slidenum">
+            <a:fld id="{33E3DE75-8222-4E2F-9183-60B209580E96}" type="slidenum">
               <a:rPr lang="en-US" sz="1000">
                 <a:solidFill>
                   <a:srgbClr val="9AA3B0"/>
@@ -19508,7 +19720,7 @@
           <a:lstStyle/>
           <a:p>
             <a:pPr algn="r"/>
-            <a:fld id="{B80A505C-4FF4-4180-AF6E-03D3154A4628}" type="slidenum">
+            <a:fld id="{EC0696B9-B25B-4DFF-8610-A627F29C962A}" type="slidenum">
               <a:rPr lang="en-US" sz="1000">
                 <a:solidFill>
                   <a:srgbClr val="9AA3B0"/>
@@ -20538,7 +20750,7 @@
           <a:lstStyle/>
           <a:p>
             <a:pPr algn="r"/>
-            <a:fld id="{97E3993F-E5B1-410F-91ED-E652B83A68E5}" type="slidenum">
+            <a:fld id="{7AC00E5B-DDA4-4599-A00E-328CDD540C76}" type="slidenum">
               <a:rPr lang="en-US" sz="1000">
                 <a:solidFill>
                   <a:srgbClr val="9AA3B0"/>
@@ -21615,7 +21827,7 @@
           <a:lstStyle/>
           <a:p>
             <a:pPr algn="r"/>
-            <a:fld id="{7D707039-B7DA-4103-8CFE-8E185F170045}" type="slidenum">
+            <a:fld id="{07B92D92-06B8-4F6E-B094-BAC4AE3A21E6}" type="slidenum">
               <a:rPr lang="en-US" sz="1000">
                 <a:solidFill>
                   <a:srgbClr val="9AA3B0"/>

</xml_diff>